<commit_message>
Mid-term report: fill Kartik's NetID (kp3932) and Arya's name
The team name and Arya's NetID are still placeholders: they are not recorded anywhere in the repos.

Co-Authored-By: Claude Opus 5.5 <noreply@anthropic.com>
</commit_message>
<xml_diff>
--- a/runs/Midterm_Report.pptx
+++ b/runs/Midterm_Report.pptx
@@ -110,17 +110,17 @@
   <p:extLst>
     <p:ext uri="{521415D9-36F7-43E2-AB2F-B90AF26B5E84}">
       <p14:sectionLst xmlns:p14="http://schemas.microsoft.com/office/powerpoint/2010/main">
-        <p14:section name="Title" id="{e28ea805-af8e-8f04-8b55-27502e4815fd}">
+        <p14:section name="Title" id="{524538f0-b4ed-ccf9-2c8f-62224ff27cc0}">
           <p14:sldIdLst>
             <p14:sldId id="256"/>
           </p14:sldIdLst>
         </p14:section>
-        <p14:section name="Problem" id="{6c848e42-1863-6999-57e5-7b06803d7a67}">
+        <p14:section name="Problem" id="{410b14d3-a8f5-14c7-c871-cde02a8ba013}">
           <p14:sldIdLst>
             <p14:sldId id="257"/>
           </p14:sldIdLst>
         </p14:section>
-        <p14:section name="Method" id="{600c5060-5902-296d-7b13-4329809da538}">
+        <p14:section name="Method" id="{a9afb5d8-d92b-0ab3-bd22-48745021e0d7}">
           <p14:sldIdLst>
             <p14:sldId id="258"/>
             <p14:sldId id="259"/>
@@ -1590,7 +1590,7 @@
                   <a:schemeClr val="accent5"/>
                 </a:solidFill>
               </a:rPr>
-              <a:t>Kartik Parameshwaran ([NetID1])</a:t>
+              <a:t>Kartik Parameshwaran (kp3932)</a:t>
             </a:r>
             <a:endParaRPr lang="en-US" sz="2000" dirty="0"/>
           </a:p>
@@ -1607,7 +1607,7 @@
                   <a:schemeClr val="accent5"/>
                 </a:solidFill>
               </a:rPr>
-              <a:t>[Arya’s full name] ([NetID2])</a:t>
+              <a:t>Arya Mapari ([NetID2])</a:t>
             </a:r>
             <a:endParaRPr lang="en-US" sz="2000" dirty="0"/>
           </a:p>

</xml_diff>

<commit_message>
Mid-term report: plain step-by-step method, clearer problem, corrected references
Following Arya's review: the problem slide names the three hard parts (accuracy vs. steps, the last
metre, dead ends); method 1 says step by step what the robot works out before moving (what AnyLoc
proposes and SuperGlue confirms), method 2 how it moves; NetVLAD (not used) replaced by VLAD, RANSAC
added, each reference says what it is used for; Arya Kishor on the title slide.

Co-Authored-By: Claude Opus 5.5 <noreply@anthropic.com>
</commit_message>
<xml_diff>
--- a/runs/Midterm_Report.pptx
+++ b/runs/Midterm_Report.pptx
@@ -110,17 +110,17 @@
   <p:extLst>
     <p:ext uri="{521415D9-36F7-43E2-AB2F-B90AF26B5E84}">
       <p14:sectionLst xmlns:p14="http://schemas.microsoft.com/office/powerpoint/2010/main">
-        <p14:section name="Title" id="{524538f0-b4ed-ccf9-2c8f-62224ff27cc0}">
+        <p14:section name="Title" id="{8e510d6a-0548-d931-6219-5b8c5c0c8af4}">
           <p14:sldIdLst>
             <p14:sldId id="256"/>
           </p14:sldIdLst>
         </p14:section>
-        <p14:section name="Problem" id="{410b14d3-a8f5-14c7-c871-cde02a8ba013}">
+        <p14:section name="Problem" id="{25bc8843-b9fc-4437-267c-9b422f25dee3}">
           <p14:sldIdLst>
             <p14:sldId id="257"/>
           </p14:sldIdLst>
         </p14:section>
-        <p14:section name="Method" id="{a9afb5d8-d92b-0ab3-bd22-48745021e0d7}">
+        <p14:section name="Method" id="{931b2af5-f374-bf13-5ed2-6aab52cf4ce6}">
           <p14:sldIdLst>
             <p14:sldId id="258"/>
             <p14:sldId id="259"/>
@@ -618,7 +618,7 @@
           <a:p>
             <a:r>
               <a:rPr lang="en-US" dirty="0"/>
-              <a:t>The task: camera-only navigation to a goal given by four photos, using a prior set of exploration photos, scored on distance, heading and SPL. Our solution builds on SPTM’s topological memory of photos, with AnyLoc (DINOv2 + VLAD) for place recognition and SuperPoint + SuperGlue for geometric checks and measured angles.</a:t>
+              <a:t>The robot only sees camera images, has four photos of the goal and the photos of three earlier drives. It must check in within 0.2 m and 20 degrees, and SPL rewards few steps. The hard parts are the trade-off between checking carefully and saving steps, lining up exactly in the last metre, and dead ends that cost many steps to back out of.</a:t>
             </a:r>
             <a:endParaRPr lang="en-US" dirty="0"/>
           </a:p>
@@ -706,7 +706,7 @@
           <a:p>
             <a:r>
               <a:rPr lang="en-US" dirty="0"/>
-              <a:t>Before the first move (none of this costs steps): a topological graph of the exploration photos (SPTM style), shortcuts between drives verified geometrically, a metric map from a vanishing-point compass, SuperGlue rotations and loop closures, and the goal node chosen by matching the four goal photos. Online, each decision: localise with AnyLoc, plan with Dijkstra, move by the measured angle to the next waypoint photo (or the learned L network), and finish with a last-metre controller that matches the goal photos directly.</a:t>
+              <a:t>Before moving: build a graph of the exploration photos, add shortcut links where AnyLoc proposes and SuperGlue confirms the same place, place every photo in metres to cost the links in steps, pick the goal photo by matching the four goal photos, and compute the cheapest route to it with Dijkstra.</a:t>
             </a:r>
             <a:endParaRPr lang="en-US" dirty="0"/>
           </a:p>
@@ -794,7 +794,7 @@
           <a:p>
             <a:r>
               <a:rPr lang="en-US" dirty="0"/>
-              <a:t>Five ideas on top of the pipeline, each added after a measured failure. The picture is a local test maze run with the exact mid-term code; only locally can the true path be drawn, since the server never reveals the robot’s position. The three photos show the idea end to end: the goal photo the robot is given, the exploration photo it picked as the goal node before moving, and its own camera when it checked in 2 cm from the goal. The knot at the top left is about 1,700 steps that got no closer to the goal: following the L network, undoing recorded moves and searching for a waypoint, the same kind of waste that cost the mid-term its SPL points.</a:t>
+              <a:t>Every move: find the closest exploration photo, take the route from it, steer to a waypoint photo by the angle SuperGlue and the essential matrix give, undo recorded moves to back out along a drive, check the route photos or re-plan when stuck, and in the last metre line up with the goal photos and check in only after three strong readings. The picture is a local test maze with the same code; the server never reveals the robot’s true path.</a:t>
             </a:r>
             <a:endParaRPr lang="en-US" dirty="0"/>
           </a:p>
@@ -1607,7 +1607,7 @@
                   <a:schemeClr val="accent5"/>
                 </a:solidFill>
               </a:rPr>
-              <a:t>Arya Mapari ([NetID2])</a:t>
+              <a:t>Arya Kishor ([NetID2])</a:t>
             </a:r>
             <a:endParaRPr lang="en-US" sz="2000" dirty="0"/>
           </a:p>
@@ -1801,24 +1801,170 @@
       </p:sp>
       <p:sp>
         <p:nvSpPr>
-          <p:cNvPr id="4" name="fact 1 circle"/>
+          <p:cNvPr id="4" name="problem description"/>
+          <p:cNvSpPr txBox="1"/>
+          <p:nvPr/>
+        </p:nvSpPr>
+        <p:spPr>
+          <a:xfrm>
+            <a:off x="548640" y="1371600"/>
+            <a:ext cx="6400800" cy="2514600"/>
+          </a:xfrm>
+          <a:prstGeom prst="rect">
+            <a:avLst/>
+          </a:prstGeom>
+          <a:noFill/>
+          <a:ln/>
+        </p:spPr>
+        <p:txBody>
+          <a:bodyPr wrap="square" lIns="0" tIns="0" rIns="0" bIns="0" rtlCol="0" anchor="t"/>
+          <a:lstStyle/>
+          <a:p>
+            <a:pPr indent="0" marL="0">
+              <a:spcAft>
+                <a:spcPts val="500"/>
+              </a:spcAft>
+              <a:buNone/>
+            </a:pPr>
+            <a:r>
+              <a:rPr lang="en-US" sz="1350" dirty="0">
+                <a:solidFill>
+                  <a:schemeClr val="tx2"/>
+                </a:solidFill>
+              </a:rPr>
+              <a:t>The robot is placed in a maze it has never seen and has to drive to a goal spot and check in there. It is never told its position and has no map. All it has is:</a:t>
+            </a:r>
+            <a:endParaRPr lang="en-US" sz="1350" dirty="0"/>
+          </a:p>
+          <a:p>
+            <a:pPr marL="342900" indent="-342900">
+              <a:spcAft>
+                <a:spcPts val="500"/>
+              </a:spcAft>
+              <a:buSzPct val="100000"/>
+              <a:buChar char="•"/>
+            </a:pPr>
+            <a:r>
+              <a:rPr lang="en-US" sz="1350" dirty="0">
+                <a:solidFill>
+                  <a:schemeClr val="tx2"/>
+                </a:solidFill>
+              </a:rPr>
+              <a:t>its own 320 × 240 camera image after every move (no bump sensor),</a:t>
+            </a:r>
+            <a:endParaRPr lang="en-US" sz="1350" dirty="0"/>
+          </a:p>
+          <a:p>
+            <a:pPr marL="342900" indent="-342900">
+              <a:spcAft>
+                <a:spcPts val="500"/>
+              </a:spcAft>
+              <a:buSzPct val="100000"/>
+              <a:buChar char="•"/>
+            </a:pPr>
+            <a:r>
+              <a:rPr lang="en-US" sz="1350" dirty="0">
+                <a:solidFill>
+                  <a:schemeClr val="tx2"/>
+                </a:solidFill>
+              </a:rPr>
+              <a:t>four photos taken at the goal spot (front, left, back, right),</a:t>
+            </a:r>
+            <a:endParaRPr lang="en-US" sz="1350" dirty="0"/>
+          </a:p>
+          <a:p>
+            <a:pPr marL="342900" indent="-342900">
+              <a:spcAft>
+                <a:spcPts val="500"/>
+              </a:spcAft>
+              <a:buSzPct val="100000"/>
+              <a:buChar char="•"/>
+            </a:pPr>
+            <a:r>
+              <a:rPr lang="en-US" sz="1350" dirty="0">
+                <a:solidFill>
+                  <a:schemeClr val="tx2"/>
+                </a:solidFill>
+              </a:rPr>
+              <a:t>the photos of three earlier exploration drives through the same maze, each labelled with the move made after it.</a:t>
+            </a:r>
+            <a:endParaRPr lang="en-US" sz="1350" dirty="0"/>
+          </a:p>
+          <a:p>
+            <a:pPr indent="0" marL="0">
+              <a:spcAft>
+                <a:spcPts val="500"/>
+              </a:spcAft>
+              <a:buNone/>
+            </a:pPr>
+            <a:r>
+              <a:rPr lang="en-US" sz="1350" dirty="0">
+                <a:solidFill>
+                  <a:schemeClr val="tx2"/>
+                </a:solidFill>
+              </a:rPr>
+              <a:t>A check-in only counts within 0.2 m and 20° of the goal. Points come from distance, heading and SPL (shortest path ÷ steps taken), so every extra step costs points.</a:t>
+            </a:r>
+            <a:endParaRPr lang="en-US" sz="1350" dirty="0"/>
+          </a:p>
+        </p:txBody>
+      </p:sp>
+      <p:sp>
+        <p:nvSpPr>
+          <p:cNvPr id="5" name="hard heading"/>
+          <p:cNvSpPr txBox="1"/>
+          <p:nvPr/>
+        </p:nvSpPr>
+        <p:spPr>
+          <a:xfrm>
+            <a:off x="548640" y="3611880"/>
+            <a:ext cx="6400800" cy="292608"/>
+          </a:xfrm>
+          <a:prstGeom prst="rect">
+            <a:avLst/>
+          </a:prstGeom>
+          <a:noFill/>
+          <a:ln/>
+        </p:spPr>
+        <p:txBody>
+          <a:bodyPr wrap="square" lIns="0" tIns="0" rIns="0" bIns="0" rtlCol="0" anchor="ctr"/>
+          <a:lstStyle/>
+          <a:p>
+            <a:pPr indent="0" marL="0">
+              <a:buNone/>
+            </a:pPr>
+            <a:r>
+              <a:rPr lang="en-US" sz="1500" b="1" dirty="0">
+                <a:solidFill>
+                  <a:schemeClr val="accent2"/>
+                </a:solidFill>
+              </a:rPr>
+              <a:t>What makes it hard</a:t>
+            </a:r>
+            <a:endParaRPr lang="en-US" sz="1500" dirty="0"/>
+          </a:p>
+        </p:txBody>
+      </p:sp>
+      <p:sp>
+        <p:nvSpPr>
+          <p:cNvPr id="6" name="difficulty 1 circle"/>
           <p:cNvSpPr/>
           <p:nvPr/>
         </p:nvSpPr>
         <p:spPr>
           <a:xfrm>
-            <a:off x="548640" y="1481328"/>
-            <a:ext cx="329184" cy="329184"/>
+            <a:off x="548640" y="4023360"/>
+            <a:ext cx="292608" cy="292608"/>
           </a:xfrm>
           <a:prstGeom prst="ellipse">
             <a:avLst/>
           </a:prstGeom>
           <a:solidFill>
-            <a:schemeClr val="accent1"/>
+            <a:schemeClr val="accent2"/>
           </a:solidFill>
           <a:ln w="12700">
             <a:solidFill>
-              <a:schemeClr val="accent1"/>
+              <a:schemeClr val="accent2"/>
             </a:solidFill>
             <a:prstDash val="solid"/>
           </a:ln>
@@ -1826,14 +1972,14 @@
       </p:sp>
       <p:sp>
         <p:nvSpPr>
-          <p:cNvPr id="5" name="fact 1 number"/>
+          <p:cNvPr id="7" name="difficulty 1 number"/>
           <p:cNvSpPr txBox="1"/>
           <p:nvPr/>
         </p:nvSpPr>
         <p:spPr>
           <a:xfrm>
-            <a:off x="548640" y="1481328"/>
-            <a:ext cx="329184" cy="329184"/>
+            <a:off x="548640" y="4023360"/>
+            <a:ext cx="292608" cy="292608"/>
           </a:xfrm>
           <a:prstGeom prst="rect">
             <a:avLst/>
@@ -1862,14 +2008,14 @@
       </p:sp>
       <p:sp>
         <p:nvSpPr>
-          <p:cNvPr id="6" name="fact 1 text"/>
+          <p:cNvPr id="8" name="difficulty 1 text"/>
           <p:cNvSpPr txBox="1"/>
           <p:nvPr/>
         </p:nvSpPr>
         <p:spPr>
           <a:xfrm>
-            <a:off x="1051560" y="1463040"/>
-            <a:ext cx="5897880" cy="868680"/>
+            <a:off x="978408" y="4005072"/>
+            <a:ext cx="5971032" cy="672084"/>
           </a:xfrm>
           <a:prstGeom prst="rect">
             <a:avLst/>
@@ -1882,88 +2028,51 @@
           <a:lstStyle/>
           <a:p>
             <a:pPr indent="0" marL="0">
-              <a:spcAft>
-                <a:spcPts val="200"/>
-              </a:spcAft>
-              <a:buNone/>
-            </a:pPr>
-            <a:r>
-              <a:rPr lang="en-US" sz="1500" b="1" dirty="0">
+              <a:buNone/>
+            </a:pPr>
+            <a:r>
+              <a:rPr lang="en-US" sz="1350" b="1" dirty="0">
                 <a:solidFill>
                   <a:schemeClr val="tx1"/>
                 </a:solidFill>
               </a:rPr>
-              <a:t>The goal</a:t>
-            </a:r>
-            <a:endParaRPr lang="en-US" sz="1500" dirty="0"/>
-          </a:p>
-          <a:p>
-            <a:pPr indent="0" marL="0">
-              <a:spcAft>
-                <a:spcPts val="200"/>
-              </a:spcAft>
-              <a:buNone/>
-            </a:pPr>
-            <a:r>
-              <a:rPr lang="en-US" sz="1500" dirty="0">
+              <a:t>Accuracy vs. number of steps. </a:t>
+            </a:r>
+            <a:pPr indent="0" marL="0">
+              <a:buNone/>
+            </a:pPr>
+            <a:r>
+              <a:rPr lang="en-US" sz="1350" dirty="0">
                 <a:solidFill>
                   <a:schemeClr val="tx2"/>
                 </a:solidFill>
               </a:rPr>
-              <a:t>A robot starts in an unknown maze and must reach a goal it knows only from </a:t>
-            </a:r>
-            <a:pPr indent="0" marL="0">
-              <a:spcAft>
-                <a:spcPts val="200"/>
-              </a:spcAft>
-              <a:buNone/>
-            </a:pPr>
-            <a:r>
-              <a:rPr lang="en-US" sz="1500" b="1" dirty="0">
-                <a:solidFill>
-                  <a:schemeClr val="tx2"/>
-                </a:solidFill>
-              </a:rPr>
-              <a:t>four photos</a:t>
-            </a:r>
-            <a:pPr indent="0" marL="0">
-              <a:spcAft>
-                <a:spcPts val="200"/>
-              </a:spcAft>
-              <a:buNone/>
-            </a:pPr>
-            <a:r>
-              <a:rPr lang="en-US" sz="1500" dirty="0">
-                <a:solidFill>
-                  <a:schemeClr val="tx2"/>
-                </a:solidFill>
-              </a:rPr>
-              <a:t> taken there (front, left, back, right).</a:t>
-            </a:r>
-            <a:endParaRPr lang="en-US" sz="1500" dirty="0"/>
-          </a:p>
-        </p:txBody>
-      </p:sp>
-      <p:sp>
-        <p:nvSpPr>
-          <p:cNvPr id="7" name="fact 2 circle"/>
+              <a:t>Checking more carefully where it is (turning to look, planning again) avoids getting lost, but every move counts against SPL, and a fast move on a wrong guess wastes even more.</a:t>
+            </a:r>
+            <a:endParaRPr lang="en-US" sz="1350" dirty="0"/>
+          </a:p>
+        </p:txBody>
+      </p:sp>
+      <p:sp>
+        <p:nvSpPr>
+          <p:cNvPr id="9" name="difficulty 2 circle"/>
           <p:cNvSpPr/>
           <p:nvPr/>
         </p:nvSpPr>
         <p:spPr>
           <a:xfrm>
-            <a:off x="548640" y="2414016"/>
-            <a:ext cx="329184" cy="329184"/>
+            <a:off x="548640" y="4841748"/>
+            <a:ext cx="292608" cy="292608"/>
           </a:xfrm>
           <a:prstGeom prst="ellipse">
             <a:avLst/>
           </a:prstGeom>
           <a:solidFill>
-            <a:schemeClr val="accent1"/>
+            <a:schemeClr val="accent2"/>
           </a:solidFill>
           <a:ln w="12700">
             <a:solidFill>
-              <a:schemeClr val="accent1"/>
+              <a:schemeClr val="accent2"/>
             </a:solidFill>
             <a:prstDash val="solid"/>
           </a:ln>
@@ -1971,14 +2080,14 @@
       </p:sp>
       <p:sp>
         <p:nvSpPr>
-          <p:cNvPr id="8" name="fact 2 number"/>
+          <p:cNvPr id="10" name="difficulty 2 number"/>
           <p:cNvSpPr txBox="1"/>
           <p:nvPr/>
         </p:nvSpPr>
         <p:spPr>
           <a:xfrm>
-            <a:off x="548640" y="2414016"/>
-            <a:ext cx="329184" cy="329184"/>
+            <a:off x="548640" y="4841748"/>
+            <a:ext cx="292608" cy="292608"/>
           </a:xfrm>
           <a:prstGeom prst="rect">
             <a:avLst/>
@@ -2007,14 +2116,14 @@
       </p:sp>
       <p:sp>
         <p:nvSpPr>
-          <p:cNvPr id="9" name="fact 2 text"/>
+          <p:cNvPr id="11" name="difficulty 2 text"/>
           <p:cNvSpPr txBox="1"/>
           <p:nvPr/>
         </p:nvSpPr>
         <p:spPr>
           <a:xfrm>
-            <a:off x="1051560" y="2395728"/>
-            <a:ext cx="5897880" cy="868680"/>
+            <a:off x="978408" y="4823460"/>
+            <a:ext cx="5971032" cy="466344"/>
           </a:xfrm>
           <a:prstGeom prst="rect">
             <a:avLst/>
@@ -2027,88 +2136,51 @@
           <a:lstStyle/>
           <a:p>
             <a:pPr indent="0" marL="0">
-              <a:spcAft>
-                <a:spcPts val="200"/>
-              </a:spcAft>
-              <a:buNone/>
-            </a:pPr>
-            <a:r>
-              <a:rPr lang="en-US" sz="1500" b="1" dirty="0">
+              <a:buNone/>
+            </a:pPr>
+            <a:r>
+              <a:rPr lang="en-US" sz="1350" b="1" dirty="0">
                 <a:solidFill>
                   <a:schemeClr val="tx1"/>
                 </a:solidFill>
               </a:rPr>
-              <a:t>What it sees</a:t>
-            </a:r>
-            <a:endParaRPr lang="en-US" sz="1500" dirty="0"/>
-          </a:p>
-          <a:p>
-            <a:pPr indent="0" marL="0">
-              <a:spcAft>
-                <a:spcPts val="200"/>
-              </a:spcAft>
-              <a:buNone/>
-            </a:pPr>
-            <a:r>
-              <a:rPr lang="en-US" sz="1500" dirty="0">
+              <a:t>The last metre. </a:t>
+            </a:r>
+            <a:pPr indent="0" marL="0">
+              <a:buNone/>
+            </a:pPr>
+            <a:r>
+              <a:rPr lang="en-US" sz="1350" dirty="0">
                 <a:solidFill>
                   <a:schemeClr val="tx2"/>
                 </a:solidFill>
               </a:rPr>
-              <a:t>Only its own </a:t>
-            </a:r>
-            <a:pPr indent="0" marL="0">
-              <a:spcAft>
-                <a:spcPts val="200"/>
-              </a:spcAft>
-              <a:buNone/>
-            </a:pPr>
-            <a:r>
-              <a:rPr lang="en-US" sz="1500" b="1" dirty="0">
-                <a:solidFill>
-                  <a:schemeClr val="tx2"/>
-                </a:solidFill>
-              </a:rPr>
-              <a:t>320 × 240 camera frame</a:t>
-            </a:r>
-            <a:pPr indent="0" marL="0">
-              <a:spcAft>
-                <a:spcPts val="200"/>
-              </a:spcAft>
-              <a:buNone/>
-            </a:pPr>
-            <a:r>
-              <a:rPr lang="en-US" sz="1500" dirty="0">
-                <a:solidFill>
-                  <a:schemeClr val="tx2"/>
-                </a:solidFill>
-              </a:rPr>
-              <a:t>: no position, no map, no collision signal.</a:t>
-            </a:r>
-            <a:endParaRPr lang="en-US" sz="1500" dirty="0"/>
-          </a:p>
-        </p:txBody>
-      </p:sp>
-      <p:sp>
-        <p:nvSpPr>
-          <p:cNvPr id="10" name="fact 3 circle"/>
+              <a:t>The photo map only gets the robot near the goal. Checking in within 0.2 m and 20° needs it to line up with the goal photos themselves.</a:t>
+            </a:r>
+            <a:endParaRPr lang="en-US" sz="1350" dirty="0"/>
+          </a:p>
+        </p:txBody>
+      </p:sp>
+      <p:sp>
+        <p:nvSpPr>
+          <p:cNvPr id="12" name="difficulty 3 circle"/>
           <p:cNvSpPr/>
           <p:nvPr/>
         </p:nvSpPr>
         <p:spPr>
           <a:xfrm>
-            <a:off x="548640" y="3346704"/>
-            <a:ext cx="329184" cy="329184"/>
+            <a:off x="548640" y="5454396"/>
+            <a:ext cx="292608" cy="292608"/>
           </a:xfrm>
           <a:prstGeom prst="ellipse">
             <a:avLst/>
           </a:prstGeom>
           <a:solidFill>
-            <a:schemeClr val="accent1"/>
+            <a:schemeClr val="accent2"/>
           </a:solidFill>
           <a:ln w="12700">
             <a:solidFill>
-              <a:schemeClr val="accent1"/>
+              <a:schemeClr val="accent2"/>
             </a:solidFill>
             <a:prstDash val="solid"/>
           </a:ln>
@@ -2116,14 +2188,14 @@
       </p:sp>
       <p:sp>
         <p:nvSpPr>
-          <p:cNvPr id="11" name="fact 3 number"/>
+          <p:cNvPr id="13" name="difficulty 3 number"/>
           <p:cNvSpPr txBox="1"/>
           <p:nvPr/>
         </p:nvSpPr>
         <p:spPr>
           <a:xfrm>
-            <a:off x="548640" y="3346704"/>
-            <a:ext cx="329184" cy="329184"/>
+            <a:off x="548640" y="5454396"/>
+            <a:ext cx="292608" cy="292608"/>
           </a:xfrm>
           <a:prstGeom prst="rect">
             <a:avLst/>
@@ -2152,14 +2224,14 @@
       </p:sp>
       <p:sp>
         <p:nvSpPr>
-          <p:cNvPr id="12" name="fact 3 text"/>
+          <p:cNvPr id="14" name="difficulty 3 text"/>
           <p:cNvSpPr txBox="1"/>
           <p:nvPr/>
         </p:nvSpPr>
         <p:spPr>
           <a:xfrm>
-            <a:off x="1051560" y="3328416"/>
-            <a:ext cx="5897880" cy="868680"/>
+            <a:off x="978408" y="5436108"/>
+            <a:ext cx="5971032" cy="672084"/>
           </a:xfrm>
           <a:prstGeom prst="rect">
             <a:avLst/>
@@ -2172,286 +2244,41 @@
           <a:lstStyle/>
           <a:p>
             <a:pPr indent="0" marL="0">
-              <a:spcAft>
-                <a:spcPts val="200"/>
-              </a:spcAft>
-              <a:buNone/>
-            </a:pPr>
-            <a:r>
-              <a:rPr lang="en-US" sz="1500" b="1" dirty="0">
+              <a:buNone/>
+            </a:pPr>
+            <a:r>
+              <a:rPr lang="en-US" sz="1350" b="1" dirty="0">
                 <a:solidFill>
                   <a:schemeClr val="tx1"/>
                 </a:solidFill>
               </a:rPr>
-              <a:t>What it may study</a:t>
-            </a:r>
-            <a:endParaRPr lang="en-US" sz="1500" dirty="0"/>
-          </a:p>
-          <a:p>
-            <a:pPr indent="0" marL="0">
-              <a:spcAft>
-                <a:spcPts val="200"/>
-              </a:spcAft>
-              <a:buNone/>
-            </a:pPr>
-            <a:r>
-              <a:rPr lang="en-US" sz="1500" dirty="0">
+              <a:t>Dead ends. </a:t>
+            </a:r>
+            <a:pPr indent="0" marL="0">
+              <a:buNone/>
+            </a:pPr>
+            <a:r>
+              <a:rPr lang="en-US" sz="1350" dirty="0">
                 <a:solidFill>
                   <a:schemeClr val="tx2"/>
                 </a:solidFill>
               </a:rPr>
-              <a:t>Before the run, the frames of </a:t>
-            </a:r>
-            <a:pPr indent="0" marL="0">
-              <a:spcAft>
-                <a:spcPts val="200"/>
-              </a:spcAft>
-              <a:buNone/>
-            </a:pPr>
-            <a:r>
-              <a:rPr lang="en-US" sz="1500" b="1" dirty="0">
-                <a:solidFill>
-                  <a:schemeClr val="tx2"/>
-                </a:solidFill>
-              </a:rPr>
-              <a:t>three earlier exploration drives</a:t>
-            </a:r>
-            <a:pPr indent="0" marL="0">
-              <a:spcAft>
-                <a:spcPts val="200"/>
-              </a:spcAft>
-              <a:buNone/>
-            </a:pPr>
-            <a:r>
-              <a:rPr lang="en-US" sz="1500" dirty="0">
-                <a:solidFill>
-                  <a:schemeClr val="tx2"/>
-                </a:solidFill>
-              </a:rPr>
-              <a:t> through the same maze, each labelled with the move made after it.</a:t>
-            </a:r>
-            <a:endParaRPr lang="en-US" sz="1500" dirty="0"/>
-          </a:p>
-        </p:txBody>
-      </p:sp>
-      <p:sp>
-        <p:nvSpPr>
-          <p:cNvPr id="13" name="fact 4 circle"/>
+              <a:t>The maze and the exploration drives have dead ends and loops. A route along a drive can lead into one, and backing up along a drive took 36% of our mid-term steps.</a:t>
+            </a:r>
+            <a:endParaRPr lang="en-US" sz="1350" dirty="0"/>
+          </a:p>
+        </p:txBody>
+      </p:sp>
+      <p:sp>
+        <p:nvSpPr>
+          <p:cNvPr id="15" name="references card"/>
           <p:cNvSpPr/>
           <p:nvPr/>
         </p:nvSpPr>
         <p:spPr>
           <a:xfrm>
-            <a:off x="548640" y="4279392"/>
-            <a:ext cx="329184" cy="329184"/>
-          </a:xfrm>
-          <a:prstGeom prst="ellipse">
-            <a:avLst/>
-          </a:prstGeom>
-          <a:solidFill>
-            <a:schemeClr val="accent1"/>
-          </a:solidFill>
-          <a:ln w="12700">
-            <a:solidFill>
-              <a:schemeClr val="accent1"/>
-            </a:solidFill>
-            <a:prstDash val="solid"/>
-          </a:ln>
-        </p:spPr>
-      </p:sp>
-      <p:sp>
-        <p:nvSpPr>
-          <p:cNvPr id="14" name="fact 4 number"/>
-          <p:cNvSpPr txBox="1"/>
-          <p:nvPr/>
-        </p:nvSpPr>
-        <p:spPr>
-          <a:xfrm>
-            <a:off x="548640" y="4279392"/>
-            <a:ext cx="329184" cy="329184"/>
-          </a:xfrm>
-          <a:prstGeom prst="rect">
-            <a:avLst/>
-          </a:prstGeom>
-          <a:noFill/>
-          <a:ln/>
-        </p:spPr>
-        <p:txBody>
-          <a:bodyPr wrap="square" lIns="0" tIns="0" rIns="0" bIns="0" rtlCol="0" anchor="ctr"/>
-          <a:lstStyle/>
-          <a:p>
-            <a:pPr algn="ctr" indent="0" marL="0">
-              <a:buNone/>
-            </a:pPr>
-            <a:r>
-              <a:rPr lang="en-US" sz="1300" b="1" dirty="0">
-                <a:solidFill>
-                  <a:schemeClr val="bg1"/>
-                </a:solidFill>
-              </a:rPr>
-              <a:t>4</a:t>
-            </a:r>
-            <a:endParaRPr lang="en-US" sz="1300" dirty="0"/>
-          </a:p>
-        </p:txBody>
-      </p:sp>
-      <p:sp>
-        <p:nvSpPr>
-          <p:cNvPr id="15" name="fact 4 text"/>
-          <p:cNvSpPr txBox="1"/>
-          <p:nvPr/>
-        </p:nvSpPr>
-        <p:spPr>
-          <a:xfrm>
-            <a:off x="1051560" y="4261104"/>
-            <a:ext cx="5897880" cy="868680"/>
-          </a:xfrm>
-          <a:prstGeom prst="rect">
-            <a:avLst/>
-          </a:prstGeom>
-          <a:noFill/>
-          <a:ln/>
-        </p:spPr>
-        <p:txBody>
-          <a:bodyPr wrap="square" lIns="0" tIns="0" rIns="0" bIns="0" rtlCol="0" anchor="t"/>
-          <a:lstStyle/>
-          <a:p>
-            <a:pPr indent="0" marL="0">
-              <a:spcAft>
-                <a:spcPts val="200"/>
-              </a:spcAft>
-              <a:buNone/>
-            </a:pPr>
-            <a:r>
-              <a:rPr lang="en-US" sz="1500" b="1" dirty="0">
-                <a:solidFill>
-                  <a:schemeClr val="tx1"/>
-                </a:solidFill>
-              </a:rPr>
-              <a:t>How it scores</a:t>
-            </a:r>
-            <a:endParaRPr lang="en-US" sz="1500" dirty="0"/>
-          </a:p>
-          <a:p>
-            <a:pPr indent="0" marL="0">
-              <a:spcAft>
-                <a:spcPts val="200"/>
-              </a:spcAft>
-              <a:buNone/>
-            </a:pPr>
-            <a:r>
-              <a:rPr lang="en-US" sz="1500" dirty="0">
-                <a:solidFill>
-                  <a:schemeClr val="tx2"/>
-                </a:solidFill>
-              </a:rPr>
-              <a:t>Only by </a:t>
-            </a:r>
-            <a:pPr indent="0" marL="0">
-              <a:spcAft>
-                <a:spcPts val="200"/>
-              </a:spcAft>
-              <a:buNone/>
-            </a:pPr>
-            <a:r>
-              <a:rPr lang="en-US" sz="1500" b="1" dirty="0">
-                <a:solidFill>
-                  <a:schemeClr val="tx2"/>
-                </a:solidFill>
-              </a:rPr>
-              <a:t>checking in within 0.2 m and 20°</a:t>
-            </a:r>
-            <a:pPr indent="0" marL="0">
-              <a:spcAft>
-                <a:spcPts val="200"/>
-              </a:spcAft>
-              <a:buNone/>
-            </a:pPr>
-            <a:r>
-              <a:rPr lang="en-US" sz="1500" dirty="0">
-                <a:solidFill>
-                  <a:schemeClr val="tx2"/>
-                </a:solidFill>
-              </a:rPr>
-              <a:t> of the goal pose; points come from distance, heading and path efficiency (SPL).</a:t>
-            </a:r>
-            <a:endParaRPr lang="en-US" sz="1500" dirty="0"/>
-          </a:p>
-        </p:txBody>
-      </p:sp>
-      <p:sp>
-        <p:nvSpPr>
-          <p:cNvPr id="16" name="conclusion callout"/>
-          <p:cNvSpPr/>
-          <p:nvPr/>
-        </p:nvSpPr>
-        <p:spPr>
-          <a:xfrm>
-            <a:off x="548640" y="5303520"/>
-            <a:ext cx="6400800" cy="960120"/>
-          </a:xfrm>
-          <a:prstGeom prst="roundRect">
-            <a:avLst>
-              <a:gd name="adj" fmla="val 11429"/>
-            </a:avLst>
-          </a:prstGeom>
-          <a:solidFill>
-            <a:schemeClr val="accent5"/>
-          </a:solidFill>
-          <a:ln w="12700">
-            <a:solidFill>
-              <a:schemeClr val="accent5"/>
-            </a:solidFill>
-            <a:prstDash val="solid"/>
-          </a:ln>
-        </p:spPr>
-      </p:sp>
-      <p:sp>
-        <p:nvSpPr>
-          <p:cNvPr id="17" name="conclusion"/>
-          <p:cNvSpPr txBox="1"/>
-          <p:nvPr/>
-        </p:nvSpPr>
-        <p:spPr>
-          <a:xfrm>
-            <a:off x="777240" y="5303520"/>
-            <a:ext cx="5989320" cy="960120"/>
-          </a:xfrm>
-          <a:prstGeom prst="rect">
-            <a:avLst/>
-          </a:prstGeom>
-          <a:noFill/>
-          <a:ln/>
-        </p:spPr>
-        <p:txBody>
-          <a:bodyPr wrap="square" lIns="0" tIns="0" rIns="0" bIns="0" rtlCol="0" anchor="ctr"/>
-          <a:lstStyle/>
-          <a:p>
-            <a:pPr indent="0" marL="0">
-              <a:buNone/>
-            </a:pPr>
-            <a:r>
-              <a:rPr lang="en-US" sz="1600" b="1" dirty="0">
-                <a:solidFill>
-                  <a:schemeClr val="accent1"/>
-                </a:solidFill>
-              </a:rPr>
-              <a:t>So: work out where you are and where the goal is from pixels alone, then get there in as few steps as possible.</a:t>
-            </a:r>
-            <a:endParaRPr lang="en-US" sz="1600" dirty="0"/>
-          </a:p>
-        </p:txBody>
-      </p:sp>
-      <p:sp>
-        <p:nvSpPr>
-          <p:cNvPr id="18" name="references card"/>
-          <p:cNvSpPr/>
-          <p:nvPr/>
-        </p:nvSpPr>
-        <p:spPr>
-          <a:xfrm>
-            <a:off x="7315200" y="1463040"/>
-            <a:ext cx="4343400" cy="4800600"/>
+            <a:off x="7315200" y="1371600"/>
+            <a:ext cx="4343400" cy="4892040"/>
           </a:xfrm>
           <a:prstGeom prst="roundRect">
             <a:avLst>
@@ -2471,14 +2298,14 @@
       </p:sp>
       <p:sp>
         <p:nvSpPr>
-          <p:cNvPr id="19" name="references title"/>
+          <p:cNvPr id="16" name="references title"/>
           <p:cNvSpPr txBox="1"/>
           <p:nvPr/>
         </p:nvSpPr>
         <p:spPr>
           <a:xfrm>
-            <a:off x="7589520" y="1645920"/>
-            <a:ext cx="3840480" cy="411480"/>
+            <a:off x="7543800" y="1481328"/>
+            <a:ext cx="3931920" cy="365760"/>
           </a:xfrm>
           <a:prstGeom prst="rect">
             <a:avLst/>
@@ -2494,27 +2321,27 @@
               <a:buNone/>
             </a:pPr>
             <a:r>
-              <a:rPr lang="en-US" sz="1700" b="1" dirty="0">
+              <a:rPr lang="en-US" sz="1400" b="1" dirty="0">
                 <a:solidFill>
                   <a:schemeClr val="tx1"/>
                 </a:solidFill>
               </a:rPr>
-              <a:t>References</a:t>
-            </a:r>
-            <a:endParaRPr lang="en-US" sz="1700" dirty="0"/>
-          </a:p>
-        </p:txBody>
-      </p:sp>
-      <p:sp>
-        <p:nvSpPr>
-          <p:cNvPr id="20" name="references list"/>
+              <a:t>References (and what we use them for)</a:t>
+            </a:r>
+            <a:endParaRPr lang="en-US" sz="1400" dirty="0"/>
+          </a:p>
+        </p:txBody>
+      </p:sp>
+      <p:sp>
+        <p:nvSpPr>
+          <p:cNvPr id="17" name="references list"/>
           <p:cNvSpPr txBox="1"/>
           <p:nvPr/>
         </p:nvSpPr>
         <p:spPr>
           <a:xfrm>
-            <a:off x="7589520" y="2103120"/>
-            <a:ext cx="3886200" cy="4069080"/>
+            <a:off x="7543800" y="1901952"/>
+            <a:ext cx="3977640" cy="4251960"/>
           </a:xfrm>
           <a:prstGeom prst="rect">
             <a:avLst/>
@@ -2528,154 +2355,291 @@
           <a:p>
             <a:pPr marL="342900" indent="-342900">
               <a:spcAft>
-                <a:spcPts val="500"/>
+                <a:spcPts val="300"/>
               </a:spcAft>
               <a:buSzPct val="100000"/>
               <a:buFont typeface="+mj-lt"/>
               <a:buAutoNum type="arabicPeriod" startAt="1"/>
             </a:pPr>
             <a:r>
-              <a:rPr lang="en-US" sz="1200" dirty="0">
+              <a:rPr lang="en-US" sz="1000" dirty="0">
                 <a:solidFill>
                   <a:schemeClr val="tx2"/>
                 </a:solidFill>
               </a:rPr>
-              <a:t>Savinov et al., SPTM: Semi-Parametric Topological Memory for Navigation, ICLR 2018</a:t>
-            </a:r>
-            <a:endParaRPr lang="en-US" sz="1200" dirty="0"/>
+              <a:t>Savinov et al., Semi-Parametric Topological Memory for Navigation (SPTM), ICLR 2018</a:t>
+            </a:r>
+            <a:pPr indent="0" marL="0">
+              <a:spcAft>
+                <a:spcPts val="300"/>
+              </a:spcAft>
+              <a:buNone/>
+            </a:pPr>
+            <a:r>
+              <a:rPr lang="en-US" sz="1000" i="1" dirty="0">
+                <a:solidFill>
+                  <a:schemeClr val="accent1"/>
+                </a:solidFill>
+              </a:rPr>
+              <a:t>. Used for the photo map, and our place (R) and motion (L) networks.</a:t>
+            </a:r>
+            <a:endParaRPr lang="en-US" sz="1000" dirty="0"/>
           </a:p>
           <a:p>
             <a:pPr marL="342900" indent="-342900">
               <a:spcAft>
-                <a:spcPts val="500"/>
+                <a:spcPts val="300"/>
               </a:spcAft>
               <a:buSzPct val="100000"/>
               <a:buFont typeface="+mj-lt"/>
               <a:buAutoNum type="arabicPeriod" startAt="1"/>
             </a:pPr>
             <a:r>
-              <a:rPr lang="en-US" sz="1200" dirty="0">
+              <a:rPr lang="en-US" sz="1000" dirty="0">
                 <a:solidFill>
                   <a:schemeClr val="tx2"/>
                 </a:solidFill>
               </a:rPr>
               <a:t>Keetha et al., AnyLoc: Towards Universal Visual Place Recognition, IEEE RA-L 2023</a:t>
             </a:r>
-            <a:endParaRPr lang="en-US" sz="1200" dirty="0"/>
+            <a:pPr indent="0" marL="0">
+              <a:spcAft>
+                <a:spcPts val="300"/>
+              </a:spcAft>
+              <a:buNone/>
+            </a:pPr>
+            <a:r>
+              <a:rPr lang="en-US" sz="1000" i="1" dirty="0">
+                <a:solidFill>
+                  <a:schemeClr val="accent1"/>
+                </a:solidFill>
+              </a:rPr>
+              <a:t>. Used for finding exploration photos that look like the camera image.</a:t>
+            </a:r>
+            <a:endParaRPr lang="en-US" sz="1000" dirty="0"/>
           </a:p>
           <a:p>
             <a:pPr marL="342900" indent="-342900">
               <a:spcAft>
-                <a:spcPts val="500"/>
+                <a:spcPts val="300"/>
               </a:spcAft>
               <a:buSzPct val="100000"/>
               <a:buFont typeface="+mj-lt"/>
               <a:buAutoNum type="arabicPeriod" startAt="1"/>
             </a:pPr>
             <a:r>
-              <a:rPr lang="en-US" sz="1200" dirty="0">
+              <a:rPr lang="en-US" sz="1000" dirty="0">
                 <a:solidFill>
                   <a:schemeClr val="tx2"/>
                 </a:solidFill>
               </a:rPr>
               <a:t>Oquab et al., DINOv2: Learning Robust Visual Features without Supervision, TMLR 2024</a:t>
             </a:r>
-            <a:endParaRPr lang="en-US" sz="1200" dirty="0"/>
+            <a:pPr indent="0" marL="0">
+              <a:spcAft>
+                <a:spcPts val="300"/>
+              </a:spcAft>
+              <a:buNone/>
+            </a:pPr>
+            <a:r>
+              <a:rPr lang="en-US" sz="1000" i="1" dirty="0">
+                <a:solidFill>
+                  <a:schemeClr val="accent1"/>
+                </a:solidFill>
+              </a:rPr>
+              <a:t>. Used for the image features AnyLoc uses.</a:t>
+            </a:r>
+            <a:endParaRPr lang="en-US" sz="1000" dirty="0"/>
           </a:p>
           <a:p>
             <a:pPr marL="342900" indent="-342900">
               <a:spcAft>
-                <a:spcPts val="500"/>
+                <a:spcPts val="300"/>
               </a:spcAft>
               <a:buSzPct val="100000"/>
               <a:buFont typeface="+mj-lt"/>
               <a:buAutoNum type="arabicPeriod" startAt="1"/>
             </a:pPr>
             <a:r>
-              <a:rPr lang="en-US" sz="1200" dirty="0">
+              <a:rPr lang="en-US" sz="1000" dirty="0">
                 <a:solidFill>
                   <a:schemeClr val="tx2"/>
                 </a:solidFill>
               </a:rPr>
-              <a:t>Arandjelović et al., NetVLAD: CNN Architecture for Weakly Supervised Place Recognition, CVPR 2016</a:t>
-            </a:r>
-            <a:endParaRPr lang="en-US" sz="1200" dirty="0"/>
+              <a:t>Jégou et al., Aggregating Local Descriptors into a Compact Image Representation (VLAD), CVPR 2010</a:t>
+            </a:r>
+            <a:pPr indent="0" marL="0">
+              <a:spcAft>
+                <a:spcPts val="300"/>
+              </a:spcAft>
+              <a:buNone/>
+            </a:pPr>
+            <a:r>
+              <a:rPr lang="en-US" sz="1000" i="1" dirty="0">
+                <a:solidFill>
+                  <a:schemeClr val="accent1"/>
+                </a:solidFill>
+              </a:rPr>
+              <a:t>. Used for how AnyLoc sums those features.</a:t>
+            </a:r>
+            <a:endParaRPr lang="en-US" sz="1000" dirty="0"/>
           </a:p>
           <a:p>
             <a:pPr marL="342900" indent="-342900">
               <a:spcAft>
-                <a:spcPts val="500"/>
+                <a:spcPts val="300"/>
               </a:spcAft>
               <a:buSzPct val="100000"/>
               <a:buFont typeface="+mj-lt"/>
               <a:buAutoNum type="arabicPeriod" startAt="1"/>
             </a:pPr>
             <a:r>
-              <a:rPr lang="en-US" sz="1200" dirty="0">
+              <a:rPr lang="en-US" sz="1000" dirty="0">
                 <a:solidFill>
                   <a:schemeClr val="tx2"/>
                 </a:solidFill>
               </a:rPr>
               <a:t>DeTone et al., SuperPoint: Self-Supervised Interest Point Detection and Description, CVPR Workshops 2018</a:t>
             </a:r>
-            <a:endParaRPr lang="en-US" sz="1200" dirty="0"/>
+            <a:pPr indent="0" marL="0">
+              <a:spcAft>
+                <a:spcPts val="300"/>
+              </a:spcAft>
+              <a:buNone/>
+            </a:pPr>
+            <a:r>
+              <a:rPr lang="en-US" sz="1000" i="1" dirty="0">
+                <a:solidFill>
+                  <a:schemeClr val="accent1"/>
+                </a:solidFill>
+              </a:rPr>
+              <a:t>. Used for keypoints in each photo.</a:t>
+            </a:r>
+            <a:endParaRPr lang="en-US" sz="1000" dirty="0"/>
           </a:p>
           <a:p>
             <a:pPr marL="342900" indent="-342900">
               <a:spcAft>
-                <a:spcPts val="500"/>
+                <a:spcPts val="300"/>
               </a:spcAft>
               <a:buSzPct val="100000"/>
               <a:buFont typeface="+mj-lt"/>
               <a:buAutoNum type="arabicPeriod" startAt="1"/>
             </a:pPr>
             <a:r>
-              <a:rPr lang="en-US" sz="1200" dirty="0">
+              <a:rPr lang="en-US" sz="1000" dirty="0">
                 <a:solidFill>
                   <a:schemeClr val="tx2"/>
                 </a:solidFill>
               </a:rPr>
               <a:t>Sarlin et al., SuperGlue: Learning Feature Matching with Graph Neural Networks, CVPR 2020</a:t>
             </a:r>
-            <a:endParaRPr lang="en-US" sz="1200" dirty="0"/>
+            <a:pPr indent="0" marL="0">
+              <a:spcAft>
+                <a:spcPts val="300"/>
+              </a:spcAft>
+              <a:buNone/>
+            </a:pPr>
+            <a:r>
+              <a:rPr lang="en-US" sz="1000" i="1" dirty="0">
+                <a:solidFill>
+                  <a:schemeClr val="accent1"/>
+                </a:solidFill>
+              </a:rPr>
+              <a:t>. Used for matching keypoints between two photos.</a:t>
+            </a:r>
+            <a:endParaRPr lang="en-US" sz="1000" dirty="0"/>
           </a:p>
           <a:p>
             <a:pPr marL="342900" indent="-342900">
               <a:spcAft>
-                <a:spcPts val="500"/>
+                <a:spcPts val="300"/>
               </a:spcAft>
               <a:buSzPct val="100000"/>
               <a:buFont typeface="+mj-lt"/>
               <a:buAutoNum type="arabicPeriod" startAt="1"/>
             </a:pPr>
             <a:r>
-              <a:rPr lang="en-US" sz="1200" dirty="0">
+              <a:rPr lang="en-US" sz="1000" dirty="0">
                 <a:solidFill>
                   <a:schemeClr val="tx2"/>
                 </a:solidFill>
               </a:rPr>
               <a:t>Nistér, An Efficient Solution to the Five-Point Relative Pose Problem, IEEE TPAMI 2004</a:t>
             </a:r>
-            <a:endParaRPr lang="en-US" sz="1200" dirty="0"/>
+            <a:pPr indent="0" marL="0">
+              <a:spcAft>
+                <a:spcPts val="300"/>
+              </a:spcAft>
+              <a:buNone/>
+            </a:pPr>
+            <a:r>
+              <a:rPr lang="en-US" sz="1000" i="1" dirty="0">
+                <a:solidFill>
+                  <a:schemeClr val="accent1"/>
+                </a:solidFill>
+              </a:rPr>
+              <a:t>. Used for the turning angle between two views (OpenCV findEssentialMat).</a:t>
+            </a:r>
+            <a:endParaRPr lang="en-US" sz="1000" dirty="0"/>
           </a:p>
           <a:p>
             <a:pPr marL="342900" indent="-342900">
               <a:spcAft>
-                <a:spcPts val="500"/>
+                <a:spcPts val="300"/>
               </a:spcAft>
               <a:buSzPct val="100000"/>
               <a:buFont typeface="+mj-lt"/>
               <a:buAutoNum type="arabicPeriod" startAt="1"/>
             </a:pPr>
             <a:r>
-              <a:rPr lang="en-US" sz="1200" dirty="0">
+              <a:rPr lang="en-US" sz="1000" dirty="0">
                 <a:solidFill>
                   <a:schemeClr val="tx2"/>
                 </a:solidFill>
               </a:rPr>
-              <a:t>Tools: PyTorch, OpenCV (RANSAC, LSD lines), NetworkX (Dijkstra), the course’s vis-nav SDK and simulator</a:t>
-            </a:r>
-            <a:endParaRPr lang="en-US" sz="1200" dirty="0"/>
+              <a:t>Fischler and Bolles, Random Sample Consensus (RANSAC), Communications of the ACM 1981</a:t>
+            </a:r>
+            <a:pPr indent="0" marL="0">
+              <a:spcAft>
+                <a:spcPts val="300"/>
+              </a:spcAft>
+              <a:buNone/>
+            </a:pPr>
+            <a:r>
+              <a:rPr lang="en-US" sz="1000" i="1" dirty="0">
+                <a:solidFill>
+                  <a:schemeClr val="accent1"/>
+                </a:solidFill>
+              </a:rPr>
+              <a:t>. Used for removing wrong matches.</a:t>
+            </a:r>
+            <a:endParaRPr lang="en-US" sz="1000" dirty="0"/>
+          </a:p>
+          <a:p>
+            <a:pPr marL="342900" indent="-342900">
+              <a:spcAft>
+                <a:spcPts val="300"/>
+              </a:spcAft>
+              <a:buSzPct val="100000"/>
+              <a:buFont typeface="+mj-lt"/>
+              <a:buAutoNum type="arabicPeriod" startAt="1"/>
+            </a:pPr>
+            <a:r>
+              <a:rPr lang="en-US" sz="1000" dirty="0">
+                <a:solidFill>
+                  <a:schemeClr val="tx2"/>
+                </a:solidFill>
+              </a:rPr>
+              <a:t>Tools: PyTorch, OpenCV, NetworkX (Dijkstra) and the course’s vis-nav SDK</a:t>
+            </a:r>
+            <a:pPr indent="0" marL="0">
+              <a:spcAft>
+                <a:spcPts val="300"/>
+              </a:spcAft>
+              <a:buNone/>
+            </a:pPr>
+            <a:endParaRPr lang="en-US" sz="1000" dirty="0"/>
           </a:p>
         </p:txBody>
       </p:sp>
@@ -2817,7 +2781,7 @@
                   <a:schemeClr val="tx1"/>
                 </a:solidFill>
               </a:rPr>
-              <a:t>Method (1/2): the pipeline</a:t>
+              <a:t>Method (1/2): what the robot works out before it moves</a:t>
             </a:r>
             <a:endParaRPr lang="en-US" sz="3000" dirty="0"/>
           </a:p>
@@ -2825,104 +2789,50 @@
       </p:sp>
       <p:sp>
         <p:nvSpPr>
-          <p:cNvPr id="4" name="lane 1 label pill"/>
+          <p:cNvPr id="4" name="before intro"/>
+          <p:cNvSpPr txBox="1"/>
+          <p:nvPr/>
+        </p:nvSpPr>
+        <p:spPr>
+          <a:xfrm>
+            <a:off x="548640" y="1371600"/>
+            <a:ext cx="7132320" cy="320040"/>
+          </a:xfrm>
+          <a:prstGeom prst="rect">
+            <a:avLst/>
+          </a:prstGeom>
+          <a:noFill/>
+          <a:ln/>
+        </p:spPr>
+        <p:txBody>
+          <a:bodyPr wrap="square" lIns="0" tIns="0" rIns="0" bIns="0" rtlCol="0" anchor="ctr"/>
+          <a:lstStyle/>
+          <a:p>
+            <a:pPr indent="0" marL="0">
+              <a:buNone/>
+            </a:pPr>
+            <a:r>
+              <a:rPr lang="en-US" sz="1400" i="1" dirty="0">
+                <a:solidFill>
+                  <a:schemeClr val="tx2"/>
+                </a:solidFill>
+              </a:rPr>
+              <a:t>Before its first move the robot studies the exploration photos. None of this costs steps.</a:t>
+            </a:r>
+            <a:endParaRPr lang="en-US" sz="1400" dirty="0"/>
+          </a:p>
+        </p:txBody>
+      </p:sp>
+      <p:sp>
+        <p:nvSpPr>
+          <p:cNvPr id="5" name="before step 1 circle"/>
           <p:cNvSpPr/>
           <p:nvPr/>
         </p:nvSpPr>
         <p:spPr>
           <a:xfrm>
-            <a:off x="548640" y="1417320"/>
-            <a:ext cx="5120640" cy="347472"/>
-          </a:xfrm>
-          <a:prstGeom prst="roundRect">
-            <a:avLst>
-              <a:gd name="adj" fmla="val 50000"/>
-            </a:avLst>
-          </a:prstGeom>
-          <a:solidFill>
-            <a:schemeClr val="accent5"/>
-          </a:solidFill>
-          <a:ln w="12700">
-            <a:solidFill>
-              <a:schemeClr val="accent5"/>
-            </a:solidFill>
-            <a:prstDash val="solid"/>
-          </a:ln>
-        </p:spPr>
-      </p:sp>
-      <p:sp>
-        <p:nvSpPr>
-          <p:cNvPr id="5" name="lane 1 label"/>
-          <p:cNvSpPr txBox="1"/>
-          <p:nvPr/>
-        </p:nvSpPr>
-        <p:spPr>
-          <a:xfrm>
-            <a:off x="731520" y="1417320"/>
-            <a:ext cx="4754880" cy="347472"/>
-          </a:xfrm>
-          <a:prstGeom prst="rect">
-            <a:avLst/>
-          </a:prstGeom>
-          <a:noFill/>
-          <a:ln/>
-        </p:spPr>
-        <p:txBody>
-          <a:bodyPr wrap="square" lIns="0" tIns="0" rIns="0" bIns="0" rtlCol="0" anchor="ctr"/>
-          <a:lstStyle/>
-          <a:p>
-            <a:pPr indent="0" marL="0">
-              <a:buNone/>
-            </a:pPr>
-            <a:r>
-              <a:rPr lang="en-US" sz="1300" b="1" dirty="0">
-                <a:solidFill>
-                  <a:schemeClr val="accent1"/>
-                </a:solidFill>
-              </a:rPr>
-              <a:t>Before the first move: no steps spent</a:t>
-            </a:r>
-            <a:endParaRPr lang="en-US" sz="1300" dirty="0"/>
-          </a:p>
-        </p:txBody>
-      </p:sp>
-      <p:sp>
-        <p:nvSpPr>
-          <p:cNvPr id="6" name="lane 1 card 1"/>
-          <p:cNvSpPr/>
-          <p:nvPr/>
-        </p:nvSpPr>
-        <p:spPr>
-          <a:xfrm>
-            <a:off x="548640" y="1920240"/>
-            <a:ext cx="3493008" cy="1645920"/>
-          </a:xfrm>
-          <a:prstGeom prst="roundRect">
-            <a:avLst>
-              <a:gd name="adj" fmla="val 6667"/>
-            </a:avLst>
-          </a:prstGeom>
-          <a:solidFill>
-            <a:schemeClr val="bg2"/>
-          </a:solidFill>
-          <a:ln w="12700">
-            <a:solidFill>
-              <a:schemeClr val="bg2"/>
-            </a:solidFill>
-            <a:prstDash val="solid"/>
-          </a:ln>
-        </p:spPr>
-      </p:sp>
-      <p:sp>
-        <p:nvSpPr>
-          <p:cNvPr id="7" name="lane 1 step 1 circle"/>
-          <p:cNvSpPr/>
-          <p:nvPr/>
-        </p:nvSpPr>
-        <p:spPr>
-          <a:xfrm>
-            <a:off x="749808" y="2075688"/>
-            <a:ext cx="329184" cy="329184"/>
+            <a:off x="548640" y="1874520"/>
+            <a:ext cx="292608" cy="292608"/>
           </a:xfrm>
           <a:prstGeom prst="ellipse">
             <a:avLst/>
@@ -2940,14 +2850,14 @@
       </p:sp>
       <p:sp>
         <p:nvSpPr>
-          <p:cNvPr id="8" name="lane 1 step 1 number"/>
+          <p:cNvPr id="6" name="before step 1 number"/>
           <p:cNvSpPr txBox="1"/>
           <p:nvPr/>
         </p:nvSpPr>
         <p:spPr>
           <a:xfrm>
-            <a:off x="749808" y="2075688"/>
-            <a:ext cx="329184" cy="329184"/>
+            <a:off x="548640" y="1874520"/>
+            <a:ext cx="292608" cy="292608"/>
           </a:xfrm>
           <a:prstGeom prst="rect">
             <a:avLst/>
@@ -2976,61 +2886,36 @@
       </p:sp>
       <p:sp>
         <p:nvSpPr>
-          <p:cNvPr id="9" name="lane 1 title 1"/>
+          <p:cNvPr id="7" name="before step 1 text"/>
           <p:cNvSpPr txBox="1"/>
           <p:nvPr/>
         </p:nvSpPr>
         <p:spPr>
           <a:xfrm>
-            <a:off x="1188720" y="2075688"/>
-            <a:ext cx="2651760" cy="329184"/>
-          </a:xfrm>
-          <a:prstGeom prst="rect">
-            <a:avLst/>
-          </a:prstGeom>
-          <a:noFill/>
-          <a:ln/>
-        </p:spPr>
-        <p:txBody>
-          <a:bodyPr wrap="square" lIns="0" tIns="0" rIns="0" bIns="0" rtlCol="0" anchor="ctr"/>
-          <a:lstStyle/>
-          <a:p>
-            <a:pPr indent="0" marL="0">
-              <a:buNone/>
-            </a:pPr>
-            <a:r>
-              <a:rPr lang="en-US" sz="1700" b="1" dirty="0">
+            <a:off x="978408" y="1856232"/>
+            <a:ext cx="6702552" cy="481584"/>
+          </a:xfrm>
+          <a:prstGeom prst="rect">
+            <a:avLst/>
+          </a:prstGeom>
+          <a:noFill/>
+          <a:ln/>
+        </p:spPr>
+        <p:txBody>
+          <a:bodyPr wrap="square" lIns="0" tIns="0" rIns="0" bIns="0" rtlCol="0" anchor="t"/>
+          <a:lstStyle/>
+          <a:p>
+            <a:pPr indent="0" marL="0">
+              <a:buNone/>
+            </a:pPr>
+            <a:r>
+              <a:rPr lang="en-US" sz="1400" b="1" dirty="0">
                 <a:solidFill>
                   <a:schemeClr val="tx1"/>
                 </a:solidFill>
               </a:rPr>
-              <a:t>Photo graph</a:t>
-            </a:r>
-            <a:endParaRPr lang="en-US" sz="1700" dirty="0"/>
-          </a:p>
-        </p:txBody>
-      </p:sp>
-      <p:sp>
-        <p:nvSpPr>
-          <p:cNvPr id="10" name="lane 1 text 1"/>
-          <p:cNvSpPr txBox="1"/>
-          <p:nvPr/>
-        </p:nvSpPr>
-        <p:spPr>
-          <a:xfrm>
-            <a:off x="749808" y="2542032"/>
-            <a:ext cx="3108960" cy="960120"/>
-          </a:xfrm>
-          <a:prstGeom prst="rect">
-            <a:avLst/>
-          </a:prstGeom>
-          <a:noFill/>
-          <a:ln/>
-        </p:spPr>
-        <p:txBody>
-          <a:bodyPr wrap="square" lIns="0" tIns="0" rIns="0" bIns="0" rtlCol="0" anchor="t"/>
-          <a:lstStyle/>
-          <a:p>
+              <a:t>Photo map. </a:t>
+            </a:r>
             <a:pPr indent="0" marL="0">
               <a:buNone/>
             </a:pPr>
@@ -3040,7 +2925,7 @@
                   <a:schemeClr val="tx2"/>
                 </a:solidFill>
               </a:rPr>
-              <a:t>One node per exploration photo; edges join consecutive photos, plus shortcuts AnyLoc proposes and SuperGlue confirms.</a:t>
+              <a:t>Every exploration photo becomes a node. Photos taken one after another on the same drive are linked, because the robot drove from one to the next.</a:t>
             </a:r>
             <a:endParaRPr lang="en-US" sz="1400" dirty="0"/>
           </a:p>
@@ -3048,66 +2933,14 @@
       </p:sp>
       <p:sp>
         <p:nvSpPr>
-          <p:cNvPr id="11" name="lane 1 arrow 1"/>
+          <p:cNvPr id="8" name="before step 2 circle"/>
           <p:cNvSpPr/>
           <p:nvPr/>
         </p:nvSpPr>
         <p:spPr>
           <a:xfrm>
-            <a:off x="4032504" y="2633472"/>
-            <a:ext cx="292608" cy="219456"/>
-          </a:xfrm>
-          <a:prstGeom prst="rightArrow">
-            <a:avLst/>
-          </a:prstGeom>
-          <a:solidFill>
-            <a:schemeClr val="accent3"/>
-          </a:solidFill>
-          <a:ln w="12700">
-            <a:solidFill>
-              <a:schemeClr val="accent3"/>
-            </a:solidFill>
-            <a:prstDash val="solid"/>
-          </a:ln>
-        </p:spPr>
-      </p:sp>
-      <p:sp>
-        <p:nvSpPr>
-          <p:cNvPr id="12" name="lane 1 card 2"/>
-          <p:cNvSpPr/>
-          <p:nvPr/>
-        </p:nvSpPr>
-        <p:spPr>
-          <a:xfrm>
-            <a:off x="4334256" y="1920240"/>
-            <a:ext cx="3493008" cy="1645920"/>
-          </a:xfrm>
-          <a:prstGeom prst="roundRect">
-            <a:avLst>
-              <a:gd name="adj" fmla="val 6667"/>
-            </a:avLst>
-          </a:prstGeom>
-          <a:solidFill>
-            <a:schemeClr val="bg2"/>
-          </a:solidFill>
-          <a:ln w="12700">
-            <a:solidFill>
-              <a:schemeClr val="bg2"/>
-            </a:solidFill>
-            <a:prstDash val="solid"/>
-          </a:ln>
-        </p:spPr>
-      </p:sp>
-      <p:sp>
-        <p:nvSpPr>
-          <p:cNvPr id="13" name="lane 1 step 2 circle"/>
-          <p:cNvSpPr/>
-          <p:nvPr/>
-        </p:nvSpPr>
-        <p:spPr>
-          <a:xfrm>
-            <a:off x="4535424" y="2075688"/>
-            <a:ext cx="329184" cy="329184"/>
+            <a:off x="548640" y="2538984"/>
+            <a:ext cx="292608" cy="292608"/>
           </a:xfrm>
           <a:prstGeom prst="ellipse">
             <a:avLst/>
@@ -3125,14 +2958,14 @@
       </p:sp>
       <p:sp>
         <p:nvSpPr>
-          <p:cNvPr id="14" name="lane 1 step 2 number"/>
+          <p:cNvPr id="9" name="before step 2 number"/>
           <p:cNvSpPr txBox="1"/>
           <p:nvPr/>
         </p:nvSpPr>
         <p:spPr>
           <a:xfrm>
-            <a:off x="4535424" y="2075688"/>
-            <a:ext cx="329184" cy="329184"/>
+            <a:off x="548640" y="2538984"/>
+            <a:ext cx="292608" cy="292608"/>
           </a:xfrm>
           <a:prstGeom prst="rect">
             <a:avLst/>
@@ -3161,61 +2994,36 @@
       </p:sp>
       <p:sp>
         <p:nvSpPr>
-          <p:cNvPr id="15" name="lane 1 title 2"/>
+          <p:cNvPr id="10" name="before step 2 text"/>
           <p:cNvSpPr txBox="1"/>
           <p:nvPr/>
         </p:nvSpPr>
         <p:spPr>
           <a:xfrm>
-            <a:off x="4974336" y="2075688"/>
-            <a:ext cx="2651760" cy="329184"/>
-          </a:xfrm>
-          <a:prstGeom prst="rect">
-            <a:avLst/>
-          </a:prstGeom>
-          <a:noFill/>
-          <a:ln/>
-        </p:spPr>
-        <p:txBody>
-          <a:bodyPr wrap="square" lIns="0" tIns="0" rIns="0" bIns="0" rtlCol="0" anchor="ctr"/>
-          <a:lstStyle/>
-          <a:p>
-            <a:pPr indent="0" marL="0">
-              <a:buNone/>
-            </a:pPr>
-            <a:r>
-              <a:rPr lang="en-US" sz="1700" b="1" dirty="0">
+            <a:off x="978408" y="2520696"/>
+            <a:ext cx="6702552" cy="1121664"/>
+          </a:xfrm>
+          <a:prstGeom prst="rect">
+            <a:avLst/>
+          </a:prstGeom>
+          <a:noFill/>
+          <a:ln/>
+        </p:spPr>
+        <p:txBody>
+          <a:bodyPr wrap="square" lIns="0" tIns="0" rIns="0" bIns="0" rtlCol="0" anchor="t"/>
+          <a:lstStyle/>
+          <a:p>
+            <a:pPr indent="0" marL="0">
+              <a:buNone/>
+            </a:pPr>
+            <a:r>
+              <a:rPr lang="en-US" sz="1400" b="1" dirty="0">
                 <a:solidFill>
                   <a:schemeClr val="tx1"/>
                 </a:solidFill>
               </a:rPr>
-              <a:t>Metric map</a:t>
-            </a:r>
-            <a:endParaRPr lang="en-US" sz="1700" dirty="0"/>
-          </a:p>
-        </p:txBody>
-      </p:sp>
-      <p:sp>
-        <p:nvSpPr>
-          <p:cNvPr id="16" name="lane 1 text 2"/>
-          <p:cNvSpPr txBox="1"/>
-          <p:nvPr/>
-        </p:nvSpPr>
-        <p:spPr>
-          <a:xfrm>
-            <a:off x="4535424" y="2542032"/>
-            <a:ext cx="3108960" cy="960120"/>
-          </a:xfrm>
-          <a:prstGeom prst="rect">
-            <a:avLst/>
-          </a:prstGeom>
-          <a:noFill/>
-          <a:ln/>
-        </p:spPr>
-        <p:txBody>
-          <a:bodyPr wrap="square" lIns="0" tIns="0" rIns="0" bIns="0" rtlCol="0" anchor="t"/>
-          <a:lstStyle/>
-          <a:p>
+              <a:t>Where the drives meet again. </a:t>
+            </a:r>
             <a:pPr indent="0" marL="0">
               <a:buNone/>
             </a:pPr>
@@ -3225,7 +3033,7 @@
                   <a:schemeClr val="tx2"/>
                 </a:solidFill>
               </a:rPr>
-              <a:t>A vanishing-point compass, SuperGlue rotations and loop closures place every photo; edges cost steps.</a:t>
+              <a:t>AnyLoc (DINOv2 features + VLAD) compares every photo with the photos taken at other times (on another drive, or much later on the same drive) and proposes pairs that look like the same place. SuperGlue then matches keypoints between the two photos of each pair, and the pair is kept only if the matches fit one camera motion (RANSAC) for 8 or more pairs in a row. Each kept pair becomes a shortcut link.</a:t>
             </a:r>
             <a:endParaRPr lang="en-US" sz="1400" dirty="0"/>
           </a:p>
@@ -3233,66 +3041,14 @@
       </p:sp>
       <p:sp>
         <p:nvSpPr>
-          <p:cNvPr id="17" name="lane 1 arrow 2"/>
+          <p:cNvPr id="11" name="before step 3 circle"/>
           <p:cNvSpPr/>
           <p:nvPr/>
         </p:nvSpPr>
         <p:spPr>
           <a:xfrm>
-            <a:off x="7818120" y="2633472"/>
-            <a:ext cx="292608" cy="219456"/>
-          </a:xfrm>
-          <a:prstGeom prst="rightArrow">
-            <a:avLst/>
-          </a:prstGeom>
-          <a:solidFill>
-            <a:schemeClr val="accent3"/>
-          </a:solidFill>
-          <a:ln w="12700">
-            <a:solidFill>
-              <a:schemeClr val="accent3"/>
-            </a:solidFill>
-            <a:prstDash val="solid"/>
-          </a:ln>
-        </p:spPr>
-      </p:sp>
-      <p:sp>
-        <p:nvSpPr>
-          <p:cNvPr id="18" name="lane 1 card 3"/>
-          <p:cNvSpPr/>
-          <p:nvPr/>
-        </p:nvSpPr>
-        <p:spPr>
-          <a:xfrm>
-            <a:off x="8119872" y="1920240"/>
-            <a:ext cx="3493008" cy="1645920"/>
-          </a:xfrm>
-          <a:prstGeom prst="roundRect">
-            <a:avLst>
-              <a:gd name="adj" fmla="val 6667"/>
-            </a:avLst>
-          </a:prstGeom>
-          <a:solidFill>
-            <a:schemeClr val="bg2"/>
-          </a:solidFill>
-          <a:ln w="12700">
-            <a:solidFill>
-              <a:schemeClr val="bg2"/>
-            </a:solidFill>
-            <a:prstDash val="solid"/>
-          </a:ln>
-        </p:spPr>
-      </p:sp>
-      <p:sp>
-        <p:nvSpPr>
-          <p:cNvPr id="19" name="lane 1 step 3 circle"/>
-          <p:cNvSpPr/>
-          <p:nvPr/>
-        </p:nvSpPr>
-        <p:spPr>
-          <a:xfrm>
-            <a:off x="8321040" y="2075688"/>
-            <a:ext cx="329184" cy="329184"/>
+            <a:off x="548640" y="3843528"/>
+            <a:ext cx="292608" cy="292608"/>
           </a:xfrm>
           <a:prstGeom prst="ellipse">
             <a:avLst/>
@@ -3310,14 +3066,14 @@
       </p:sp>
       <p:sp>
         <p:nvSpPr>
-          <p:cNvPr id="20" name="lane 1 step 3 number"/>
+          <p:cNvPr id="12" name="before step 3 number"/>
           <p:cNvSpPr txBox="1"/>
           <p:nvPr/>
         </p:nvSpPr>
         <p:spPr>
           <a:xfrm>
-            <a:off x="8321040" y="2075688"/>
-            <a:ext cx="329184" cy="329184"/>
+            <a:off x="548640" y="3843528"/>
+            <a:ext cx="292608" cy="292608"/>
           </a:xfrm>
           <a:prstGeom prst="rect">
             <a:avLst/>
@@ -3346,61 +3102,36 @@
       </p:sp>
       <p:sp>
         <p:nvSpPr>
-          <p:cNvPr id="21" name="lane 1 title 3"/>
+          <p:cNvPr id="13" name="before step 3 text"/>
           <p:cNvSpPr txBox="1"/>
           <p:nvPr/>
         </p:nvSpPr>
         <p:spPr>
           <a:xfrm>
-            <a:off x="8759952" y="2075688"/>
-            <a:ext cx="2651760" cy="329184"/>
-          </a:xfrm>
-          <a:prstGeom prst="rect">
-            <a:avLst/>
-          </a:prstGeom>
-          <a:noFill/>
-          <a:ln/>
-        </p:spPr>
-        <p:txBody>
-          <a:bodyPr wrap="square" lIns="0" tIns="0" rIns="0" bIns="0" rtlCol="0" anchor="ctr"/>
-          <a:lstStyle/>
-          <a:p>
-            <a:pPr indent="0" marL="0">
-              <a:buNone/>
-            </a:pPr>
-            <a:r>
-              <a:rPr lang="en-US" sz="1700" b="1" dirty="0">
+            <a:off x="978408" y="3825240"/>
+            <a:ext cx="6702552" cy="694944"/>
+          </a:xfrm>
+          <a:prstGeom prst="rect">
+            <a:avLst/>
+          </a:prstGeom>
+          <a:noFill/>
+          <a:ln/>
+        </p:spPr>
+        <p:txBody>
+          <a:bodyPr wrap="square" lIns="0" tIns="0" rIns="0" bIns="0" rtlCol="0" anchor="t"/>
+          <a:lstStyle/>
+          <a:p>
+            <a:pPr indent="0" marL="0">
+              <a:buNone/>
+            </a:pPr>
+            <a:r>
+              <a:rPr lang="en-US" sz="1400" b="1" dirty="0">
                 <a:solidFill>
                   <a:schemeClr val="tx1"/>
                 </a:solidFill>
               </a:rPr>
-              <a:t>Goal photo</a:t>
-            </a:r>
-            <a:endParaRPr lang="en-US" sz="1700" dirty="0"/>
-          </a:p>
-        </p:txBody>
-      </p:sp>
-      <p:sp>
-        <p:nvSpPr>
-          <p:cNvPr id="22" name="lane 1 text 3"/>
-          <p:cNvSpPr txBox="1"/>
-          <p:nvPr/>
-        </p:nvSpPr>
-        <p:spPr>
-          <a:xfrm>
-            <a:off x="8321040" y="2542032"/>
-            <a:ext cx="3108960" cy="960120"/>
-          </a:xfrm>
-          <a:prstGeom prst="rect">
-            <a:avLst/>
-          </a:prstGeom>
-          <a:noFill/>
-          <a:ln/>
-        </p:spPr>
-        <p:txBody>
-          <a:bodyPr wrap="square" lIns="0" tIns="0" rIns="0" bIns="0" rtlCol="0" anchor="t"/>
-          <a:lstStyle/>
-          <a:p>
+              <a:t>Distances. </a:t>
+            </a:r>
             <a:pPr indent="0" marL="0">
               <a:buNone/>
             </a:pPr>
@@ -3410,7 +3141,7 @@
                   <a:schemeClr val="tx2"/>
                 </a:solidFill>
               </a:rPr>
-              <a:t>The 4 goal photos against AnyLoc’s top 64 candidates each; the strongest SuperGlue match is the goal node.</a:t>
+              <a:t>Lines on the walls give a compass direction, SuperGlue gives the turn between neighbouring photos, and the links close the loops. This places every photo in metres, so each link gets a cost in steps.</a:t>
             </a:r>
             <a:endParaRPr lang="en-US" sz="1400" dirty="0"/>
           </a:p>
@@ -3418,26 +3149,24 @@
       </p:sp>
       <p:sp>
         <p:nvSpPr>
-          <p:cNvPr id="23" name="lane 2 label pill"/>
+          <p:cNvPr id="14" name="before step 4 circle"/>
           <p:cNvSpPr/>
           <p:nvPr/>
         </p:nvSpPr>
         <p:spPr>
           <a:xfrm>
-            <a:off x="548640" y="3840480"/>
-            <a:ext cx="5120640" cy="347472"/>
-          </a:xfrm>
-          <a:prstGeom prst="roundRect">
-            <a:avLst>
-              <a:gd name="adj" fmla="val 50000"/>
-            </a:avLst>
+            <a:off x="548640" y="4721352"/>
+            <a:ext cx="292608" cy="292608"/>
+          </a:xfrm>
+          <a:prstGeom prst="ellipse">
+            <a:avLst/>
           </a:prstGeom>
           <a:solidFill>
-            <a:schemeClr val="accent6"/>
+            <a:schemeClr val="accent1"/>
           </a:solidFill>
           <a:ln w="12700">
             <a:solidFill>
-              <a:schemeClr val="accent6"/>
+              <a:schemeClr val="accent1"/>
             </a:solidFill>
             <a:prstDash val="solid"/>
           </a:ln>
@@ -3445,14 +3174,14 @@
       </p:sp>
       <p:sp>
         <p:nvSpPr>
-          <p:cNvPr id="24" name="lane 2 label"/>
+          <p:cNvPr id="15" name="before step 4 number"/>
           <p:cNvSpPr txBox="1"/>
           <p:nvPr/>
         </p:nvSpPr>
         <p:spPr>
           <a:xfrm>
-            <a:off x="731520" y="3840480"/>
-            <a:ext cx="4754880" cy="347472"/>
+            <a:off x="548640" y="4721352"/>
+            <a:ext cx="292608" cy="292608"/>
           </a:xfrm>
           <a:prstGeom prst="rect">
             <a:avLst/>
@@ -3464,16 +3193,16 @@
           <a:bodyPr wrap="square" lIns="0" tIns="0" rIns="0" bIns="0" rtlCol="0" anchor="ctr"/>
           <a:lstStyle/>
           <a:p>
-            <a:pPr indent="0" marL="0">
+            <a:pPr algn="ctr" indent="0" marL="0">
               <a:buNone/>
             </a:pPr>
             <a:r>
               <a:rPr lang="en-US" sz="1300" b="1" dirty="0">
                 <a:solidFill>
-                  <a:schemeClr val="accent2"/>
-                </a:solidFill>
-              </a:rPr>
-              <a:t>Every decision: one camera frame in, one move out</a:t>
+                  <a:schemeClr val="bg1"/>
+                </a:solidFill>
+              </a:rPr>
+              <a:t>4</a:t>
             </a:r>
             <a:endParaRPr lang="en-US" sz="1300" dirty="0"/>
           </a:p>
@@ -3481,26 +3210,71 @@
       </p:sp>
       <p:sp>
         <p:nvSpPr>
-          <p:cNvPr id="25" name="lane 2 card 1"/>
+          <p:cNvPr id="16" name="before step 4 text"/>
+          <p:cNvSpPr txBox="1"/>
+          <p:nvPr/>
+        </p:nvSpPr>
+        <p:spPr>
+          <a:xfrm>
+            <a:off x="978408" y="4703064"/>
+            <a:ext cx="6702552" cy="694944"/>
+          </a:xfrm>
+          <a:prstGeom prst="rect">
+            <a:avLst/>
+          </a:prstGeom>
+          <a:noFill/>
+          <a:ln/>
+        </p:spPr>
+        <p:txBody>
+          <a:bodyPr wrap="square" lIns="0" tIns="0" rIns="0" bIns="0" rtlCol="0" anchor="t"/>
+          <a:lstStyle/>
+          <a:p>
+            <a:pPr indent="0" marL="0">
+              <a:buNone/>
+            </a:pPr>
+            <a:r>
+              <a:rPr lang="en-US" sz="1400" b="1" dirty="0">
+                <a:solidFill>
+                  <a:schemeClr val="tx1"/>
+                </a:solidFill>
+              </a:rPr>
+              <a:t>The goal. </a:t>
+            </a:r>
+            <a:pPr indent="0" marL="0">
+              <a:buNone/>
+            </a:pPr>
+            <a:r>
+              <a:rPr lang="en-US" sz="1400" dirty="0">
+                <a:solidFill>
+                  <a:schemeClr val="tx2"/>
+                </a:solidFill>
+              </a:rPr>
+              <a:t>Each of the 4 goal photos is compared with the 64 exploration photos AnyLoc finds most similar. The exploration photo with the most SuperGlue matches becomes the goal node.</a:t>
+            </a:r>
+            <a:endParaRPr lang="en-US" sz="1400" dirty="0"/>
+          </a:p>
+        </p:txBody>
+      </p:sp>
+      <p:sp>
+        <p:nvSpPr>
+          <p:cNvPr id="17" name="before step 5 circle"/>
           <p:cNvSpPr/>
           <p:nvPr/>
         </p:nvSpPr>
         <p:spPr>
           <a:xfrm>
-            <a:off x="548640" y="4343400"/>
-            <a:ext cx="2551176" cy="1920240"/>
-          </a:xfrm>
-          <a:prstGeom prst="roundRect">
-            <a:avLst>
-              <a:gd name="adj" fmla="val 5714"/>
-            </a:avLst>
+            <a:off x="548640" y="5599176"/>
+            <a:ext cx="292608" cy="292608"/>
+          </a:xfrm>
+          <a:prstGeom prst="ellipse">
+            <a:avLst/>
           </a:prstGeom>
           <a:solidFill>
-            <a:schemeClr val="accent6"/>
+            <a:schemeClr val="accent1"/>
           </a:solidFill>
           <a:ln w="12700">
             <a:solidFill>
-              <a:schemeClr val="accent6"/>
+              <a:schemeClr val="accent1"/>
             </a:solidFill>
             <a:prstDash val="solid"/>
           </a:ln>
@@ -3508,39 +3282,14 @@
       </p:sp>
       <p:sp>
         <p:nvSpPr>
-          <p:cNvPr id="26" name="lane 2 step 1 circle"/>
-          <p:cNvSpPr/>
-          <p:nvPr/>
-        </p:nvSpPr>
-        <p:spPr>
-          <a:xfrm>
-            <a:off x="731520" y="4498848"/>
-            <a:ext cx="329184" cy="329184"/>
-          </a:xfrm>
-          <a:prstGeom prst="ellipse">
-            <a:avLst/>
-          </a:prstGeom>
-          <a:solidFill>
-            <a:schemeClr val="accent2"/>
-          </a:solidFill>
-          <a:ln w="12700">
-            <a:solidFill>
-              <a:schemeClr val="accent2"/>
-            </a:solidFill>
-            <a:prstDash val="solid"/>
-          </a:ln>
-        </p:spPr>
-      </p:sp>
-      <p:sp>
-        <p:nvSpPr>
-          <p:cNvPr id="27" name="lane 2 step 1 number"/>
+          <p:cNvPr id="18" name="before step 5 number"/>
           <p:cNvSpPr txBox="1"/>
           <p:nvPr/>
         </p:nvSpPr>
         <p:spPr>
           <a:xfrm>
-            <a:off x="731520" y="4498848"/>
-            <a:ext cx="329184" cy="329184"/>
+            <a:off x="548640" y="5599176"/>
+            <a:ext cx="292608" cy="292608"/>
           </a:xfrm>
           <a:prstGeom prst="rect">
             <a:avLst/>
@@ -3561,7 +3310,7 @@
                   <a:schemeClr val="bg1"/>
                 </a:solidFill>
               </a:rPr>
-              <a:t>1</a:t>
+              <a:t>5</a:t>
             </a:r>
             <a:endParaRPr lang="en-US" sz="1300" dirty="0"/>
           </a:p>
@@ -3569,14 +3318,85 @@
       </p:sp>
       <p:sp>
         <p:nvSpPr>
-          <p:cNvPr id="28" name="lane 2 title 1"/>
+          <p:cNvPr id="19" name="before step 5 text"/>
           <p:cNvSpPr txBox="1"/>
           <p:nvPr/>
         </p:nvSpPr>
         <p:spPr>
           <a:xfrm>
-            <a:off x="1170432" y="4498848"/>
-            <a:ext cx="1828800" cy="329184"/>
+            <a:off x="978408" y="5580888"/>
+            <a:ext cx="6702552" cy="481584"/>
+          </a:xfrm>
+          <a:prstGeom prst="rect">
+            <a:avLst/>
+          </a:prstGeom>
+          <a:noFill/>
+          <a:ln/>
+        </p:spPr>
+        <p:txBody>
+          <a:bodyPr wrap="square" lIns="0" tIns="0" rIns="0" bIns="0" rtlCol="0" anchor="t"/>
+          <a:lstStyle/>
+          <a:p>
+            <a:pPr indent="0" marL="0">
+              <a:buNone/>
+            </a:pPr>
+            <a:r>
+              <a:rPr lang="en-US" sz="1400" b="1" dirty="0">
+                <a:solidFill>
+                  <a:schemeClr val="tx1"/>
+                </a:solidFill>
+              </a:rPr>
+              <a:t>The route. </a:t>
+            </a:r>
+            <a:pPr indent="0" marL="0">
+              <a:buNone/>
+            </a:pPr>
+            <a:r>
+              <a:rPr lang="en-US" sz="1400" dirty="0">
+                <a:solidFill>
+                  <a:schemeClr val="tx2"/>
+                </a:solidFill>
+              </a:rPr>
+              <a:t>Dijkstra finds the cheapest route, in steps, from every photo to the goal node.</a:t>
+            </a:r>
+            <a:endParaRPr lang="en-US" sz="1400" dirty="0"/>
+          </a:p>
+        </p:txBody>
+      </p:sp>
+      <p:pic>
+        <p:nvPicPr>
+          <p:cNvPr id="20" name="goal example 1" descr="Local maze 25: goal photo it is given">    </p:cNvPr>
+          <p:cNvPicPr>
+            <a:picLocks noChangeAspect="1"/>
+          </p:cNvPicPr>
+          <p:nvPr/>
+        </p:nvPicPr>
+        <p:blipFill>
+          <a:blip r:embed="rId1"/>
+          <a:stretch>
+            <a:fillRect/>
+          </a:stretch>
+        </p:blipFill>
+        <p:spPr>
+          <a:xfrm>
+            <a:off x="8366760" y="1417320"/>
+            <a:ext cx="2697480" cy="2020824"/>
+          </a:xfrm>
+          <a:prstGeom prst="rect">
+            <a:avLst/>
+          </a:prstGeom>
+        </p:spPr>
+      </p:pic>
+      <p:sp>
+        <p:nvSpPr>
+          <p:cNvPr id="21" name="goal example label 1"/>
+          <p:cNvSpPr txBox="1"/>
+          <p:nvPr/>
+        </p:nvSpPr>
+        <p:spPr>
+          <a:xfrm>
+            <a:off x="8366760" y="3474720"/>
+            <a:ext cx="3108960" cy="256032"/>
           </a:xfrm>
           <a:prstGeom prst="rect">
             <a:avLst/>
@@ -3592,605 +3412,110 @@
               <a:buNone/>
             </a:pPr>
             <a:r>
-              <a:rPr lang="en-US" sz="1700" b="1" dirty="0">
+              <a:rPr lang="en-US" sz="1150" b="1" dirty="0">
                 <a:solidFill>
                   <a:schemeClr val="tx1"/>
                 </a:solidFill>
               </a:rPr>
-              <a:t>Localise</a:t>
-            </a:r>
-            <a:endParaRPr lang="en-US" sz="1700" dirty="0"/>
-          </a:p>
-        </p:txBody>
-      </p:sp>
-      <p:sp>
-        <p:nvSpPr>
-          <p:cNvPr id="29" name="lane 2 text 1"/>
+              <a:t>Goal photo it is given</a:t>
+            </a:r>
+            <a:endParaRPr lang="en-US" sz="1150" dirty="0"/>
+          </a:p>
+        </p:txBody>
+      </p:sp>
+      <p:pic>
+        <p:nvPicPr>
+          <p:cNvPr id="22" name="goal example 2" descr="Local maze 25: exploration photo it picks as the goal (step 4)">    </p:cNvPr>
+          <p:cNvPicPr>
+            <a:picLocks noChangeAspect="1"/>
+          </p:cNvPicPr>
+          <p:nvPr/>
+        </p:nvPicPr>
+        <p:blipFill>
+          <a:blip r:embed="rId2"/>
+          <a:stretch>
+            <a:fillRect/>
+          </a:stretch>
+        </p:blipFill>
+        <p:spPr>
+          <a:xfrm>
+            <a:off x="8366760" y="3794760"/>
+            <a:ext cx="2697480" cy="2020824"/>
+          </a:xfrm>
+          <a:prstGeom prst="rect">
+            <a:avLst/>
+          </a:prstGeom>
+        </p:spPr>
+      </p:pic>
+      <p:sp>
+        <p:nvSpPr>
+          <p:cNvPr id="23" name="goal example label 2"/>
           <p:cNvSpPr txBox="1"/>
           <p:nvPr/>
         </p:nvSpPr>
         <p:spPr>
           <a:xfrm>
-            <a:off x="731520" y="4965192"/>
-            <a:ext cx="2212848" cy="1234440"/>
-          </a:xfrm>
-          <a:prstGeom prst="rect">
-            <a:avLst/>
-          </a:prstGeom>
-          <a:noFill/>
-          <a:ln/>
-        </p:spPr>
-        <p:txBody>
-          <a:bodyPr wrap="square" lIns="0" tIns="0" rIns="0" bIns="0" rtlCol="0" anchor="t"/>
-          <a:lstStyle/>
-          <a:p>
-            <a:pPr indent="0" marL="0">
-              <a:buNone/>
-            </a:pPr>
-            <a:r>
-              <a:rPr lang="en-US" sz="1400" dirty="0">
+            <a:off x="8366760" y="5852160"/>
+            <a:ext cx="3108960" cy="256032"/>
+          </a:xfrm>
+          <a:prstGeom prst="rect">
+            <a:avLst/>
+          </a:prstGeom>
+          <a:noFill/>
+          <a:ln/>
+        </p:spPr>
+        <p:txBody>
+          <a:bodyPr wrap="square" lIns="0" tIns="0" rIns="0" bIns="0" rtlCol="0" anchor="ctr"/>
+          <a:lstStyle/>
+          <a:p>
+            <a:pPr indent="0" marL="0">
+              <a:buNone/>
+            </a:pPr>
+            <a:r>
+              <a:rPr lang="en-US" sz="1150" b="1" dirty="0">
+                <a:solidFill>
+                  <a:schemeClr val="tx1"/>
+                </a:solidFill>
+              </a:rPr>
+              <a:t>Exploration photo it picks as the goal (step 4)</a:t>
+            </a:r>
+            <a:endParaRPr lang="en-US" sz="1150" dirty="0"/>
+          </a:p>
+        </p:txBody>
+      </p:sp>
+      <p:sp>
+        <p:nvSpPr>
+          <p:cNvPr id="24" name="goal example caption"/>
+          <p:cNvSpPr txBox="1"/>
+          <p:nvPr/>
+        </p:nvSpPr>
+        <p:spPr>
+          <a:xfrm>
+            <a:off x="8366760" y="6035040"/>
+            <a:ext cx="3108960" cy="256032"/>
+          </a:xfrm>
+          <a:prstGeom prst="rect">
+            <a:avLst/>
+          </a:prstGeom>
+          <a:noFill/>
+          <a:ln/>
+        </p:spPr>
+        <p:txBody>
+          <a:bodyPr wrap="square" lIns="0" tIns="0" rIns="0" bIns="0" rtlCol="0" anchor="ctr"/>
+          <a:lstStyle/>
+          <a:p>
+            <a:pPr indent="0" marL="0">
+              <a:buNone/>
+            </a:pPr>
+            <a:r>
+              <a:rPr lang="en-US" sz="1050" i="1" dirty="0">
                 <a:solidFill>
                   <a:schemeClr val="tx2"/>
                 </a:solidFill>
               </a:rPr>
-              <a:t>AnyLoc match near the last node; a far jump needs 3 frames and SuperGlue.</a:t>
-            </a:r>
-            <a:endParaRPr lang="en-US" sz="1400" dirty="0"/>
-          </a:p>
-        </p:txBody>
-      </p:sp>
-      <p:sp>
-        <p:nvSpPr>
-          <p:cNvPr id="30" name="lane 2 arrow 1"/>
-          <p:cNvSpPr/>
-          <p:nvPr/>
-        </p:nvSpPr>
-        <p:spPr>
-          <a:xfrm>
-            <a:off x="3095244" y="5193792"/>
-            <a:ext cx="292608" cy="219456"/>
-          </a:xfrm>
-          <a:prstGeom prst="rightArrow">
-            <a:avLst/>
-          </a:prstGeom>
-          <a:solidFill>
-            <a:schemeClr val="accent3"/>
-          </a:solidFill>
-          <a:ln w="12700">
-            <a:solidFill>
-              <a:schemeClr val="accent3"/>
-            </a:solidFill>
-            <a:prstDash val="solid"/>
-          </a:ln>
-        </p:spPr>
-      </p:sp>
-      <p:sp>
-        <p:nvSpPr>
-          <p:cNvPr id="31" name="lane 2 card 2"/>
-          <p:cNvSpPr/>
-          <p:nvPr/>
-        </p:nvSpPr>
-        <p:spPr>
-          <a:xfrm>
-            <a:off x="3383280" y="4343400"/>
-            <a:ext cx="2551176" cy="1920240"/>
-          </a:xfrm>
-          <a:prstGeom prst="roundRect">
-            <a:avLst>
-              <a:gd name="adj" fmla="val 5714"/>
-            </a:avLst>
-          </a:prstGeom>
-          <a:solidFill>
-            <a:schemeClr val="accent6"/>
-          </a:solidFill>
-          <a:ln w="12700">
-            <a:solidFill>
-              <a:schemeClr val="accent6"/>
-            </a:solidFill>
-            <a:prstDash val="solid"/>
-          </a:ln>
-        </p:spPr>
-      </p:sp>
-      <p:sp>
-        <p:nvSpPr>
-          <p:cNvPr id="32" name="lane 2 step 2 circle"/>
-          <p:cNvSpPr/>
-          <p:nvPr/>
-        </p:nvSpPr>
-        <p:spPr>
-          <a:xfrm>
-            <a:off x="3566160" y="4498848"/>
-            <a:ext cx="329184" cy="329184"/>
-          </a:xfrm>
-          <a:prstGeom prst="ellipse">
-            <a:avLst/>
-          </a:prstGeom>
-          <a:solidFill>
-            <a:schemeClr val="accent2"/>
-          </a:solidFill>
-          <a:ln w="12700">
-            <a:solidFill>
-              <a:schemeClr val="accent2"/>
-            </a:solidFill>
-            <a:prstDash val="solid"/>
-          </a:ln>
-        </p:spPr>
-      </p:sp>
-      <p:sp>
-        <p:nvSpPr>
-          <p:cNvPr id="33" name="lane 2 step 2 number"/>
-          <p:cNvSpPr txBox="1"/>
-          <p:nvPr/>
-        </p:nvSpPr>
-        <p:spPr>
-          <a:xfrm>
-            <a:off x="3566160" y="4498848"/>
-            <a:ext cx="329184" cy="329184"/>
-          </a:xfrm>
-          <a:prstGeom prst="rect">
-            <a:avLst/>
-          </a:prstGeom>
-          <a:noFill/>
-          <a:ln/>
-        </p:spPr>
-        <p:txBody>
-          <a:bodyPr wrap="square" lIns="0" tIns="0" rIns="0" bIns="0" rtlCol="0" anchor="ctr"/>
-          <a:lstStyle/>
-          <a:p>
-            <a:pPr algn="ctr" indent="0" marL="0">
-              <a:buNone/>
-            </a:pPr>
-            <a:r>
-              <a:rPr lang="en-US" sz="1300" b="1" dirty="0">
-                <a:solidFill>
-                  <a:schemeClr val="bg1"/>
-                </a:solidFill>
-              </a:rPr>
-              <a:t>2</a:t>
-            </a:r>
-            <a:endParaRPr lang="en-US" sz="1300" dirty="0"/>
-          </a:p>
-        </p:txBody>
-      </p:sp>
-      <p:sp>
-        <p:nvSpPr>
-          <p:cNvPr id="34" name="lane 2 title 2"/>
-          <p:cNvSpPr txBox="1"/>
-          <p:nvPr/>
-        </p:nvSpPr>
-        <p:spPr>
-          <a:xfrm>
-            <a:off x="4005072" y="4498848"/>
-            <a:ext cx="1828800" cy="329184"/>
-          </a:xfrm>
-          <a:prstGeom prst="rect">
-            <a:avLst/>
-          </a:prstGeom>
-          <a:noFill/>
-          <a:ln/>
-        </p:spPr>
-        <p:txBody>
-          <a:bodyPr wrap="square" lIns="0" tIns="0" rIns="0" bIns="0" rtlCol="0" anchor="ctr"/>
-          <a:lstStyle/>
-          <a:p>
-            <a:pPr indent="0" marL="0">
-              <a:buNone/>
-            </a:pPr>
-            <a:r>
-              <a:rPr lang="en-US" sz="1700" b="1" dirty="0">
-                <a:solidFill>
-                  <a:schemeClr val="tx1"/>
-                </a:solidFill>
-              </a:rPr>
-              <a:t>Plan</a:t>
-            </a:r>
-            <a:endParaRPr lang="en-US" sz="1700" dirty="0"/>
-          </a:p>
-        </p:txBody>
-      </p:sp>
-      <p:sp>
-        <p:nvSpPr>
-          <p:cNvPr id="35" name="lane 2 text 2"/>
-          <p:cNvSpPr txBox="1"/>
-          <p:nvPr/>
-        </p:nvSpPr>
-        <p:spPr>
-          <a:xfrm>
-            <a:off x="3566160" y="4965192"/>
-            <a:ext cx="2212848" cy="1234440"/>
-          </a:xfrm>
-          <a:prstGeom prst="rect">
-            <a:avLst/>
-          </a:prstGeom>
-          <a:noFill/>
-          <a:ln/>
-        </p:spPr>
-        <p:txBody>
-          <a:bodyPr wrap="square" lIns="0" tIns="0" rIns="0" bIns="0" rtlCol="0" anchor="t"/>
-          <a:lstStyle/>
-          <a:p>
-            <a:pPr indent="0" marL="0">
-              <a:buNone/>
-            </a:pPr>
-            <a:r>
-              <a:rPr lang="en-US" sz="1400" dirty="0">
-                <a:solidFill>
-                  <a:schemeClr val="tx2"/>
-                </a:solidFill>
-              </a:rPr>
-              <a:t>Dijkstra to the goal node; a stalled stretch is re-planned.</a:t>
-            </a:r>
-            <a:endParaRPr lang="en-US" sz="1400" dirty="0"/>
-          </a:p>
-        </p:txBody>
-      </p:sp>
-      <p:sp>
-        <p:nvSpPr>
-          <p:cNvPr id="36" name="lane 2 arrow 2"/>
-          <p:cNvSpPr/>
-          <p:nvPr/>
-        </p:nvSpPr>
-        <p:spPr>
-          <a:xfrm>
-            <a:off x="5929884" y="5193792"/>
-            <a:ext cx="292608" cy="219456"/>
-          </a:xfrm>
-          <a:prstGeom prst="rightArrow">
-            <a:avLst/>
-          </a:prstGeom>
-          <a:solidFill>
-            <a:schemeClr val="accent3"/>
-          </a:solidFill>
-          <a:ln w="12700">
-            <a:solidFill>
-              <a:schemeClr val="accent3"/>
-            </a:solidFill>
-            <a:prstDash val="solid"/>
-          </a:ln>
-        </p:spPr>
-      </p:sp>
-      <p:sp>
-        <p:nvSpPr>
-          <p:cNvPr id="37" name="lane 2 card 3"/>
-          <p:cNvSpPr/>
-          <p:nvPr/>
-        </p:nvSpPr>
-        <p:spPr>
-          <a:xfrm>
-            <a:off x="6217920" y="4343400"/>
-            <a:ext cx="2551176" cy="1920240"/>
-          </a:xfrm>
-          <a:prstGeom prst="roundRect">
-            <a:avLst>
-              <a:gd name="adj" fmla="val 5714"/>
-            </a:avLst>
-          </a:prstGeom>
-          <a:solidFill>
-            <a:schemeClr val="accent6"/>
-          </a:solidFill>
-          <a:ln w="12700">
-            <a:solidFill>
-              <a:schemeClr val="accent6"/>
-            </a:solidFill>
-            <a:prstDash val="solid"/>
-          </a:ln>
-        </p:spPr>
-      </p:sp>
-      <p:sp>
-        <p:nvSpPr>
-          <p:cNvPr id="38" name="lane 2 step 3 circle"/>
-          <p:cNvSpPr/>
-          <p:nvPr/>
-        </p:nvSpPr>
-        <p:spPr>
-          <a:xfrm>
-            <a:off x="6400800" y="4498848"/>
-            <a:ext cx="329184" cy="329184"/>
-          </a:xfrm>
-          <a:prstGeom prst="ellipse">
-            <a:avLst/>
-          </a:prstGeom>
-          <a:solidFill>
-            <a:schemeClr val="accent2"/>
-          </a:solidFill>
-          <a:ln w="12700">
-            <a:solidFill>
-              <a:schemeClr val="accent2"/>
-            </a:solidFill>
-            <a:prstDash val="solid"/>
-          </a:ln>
-        </p:spPr>
-      </p:sp>
-      <p:sp>
-        <p:nvSpPr>
-          <p:cNvPr id="39" name="lane 2 step 3 number"/>
-          <p:cNvSpPr txBox="1"/>
-          <p:nvPr/>
-        </p:nvSpPr>
-        <p:spPr>
-          <a:xfrm>
-            <a:off x="6400800" y="4498848"/>
-            <a:ext cx="329184" cy="329184"/>
-          </a:xfrm>
-          <a:prstGeom prst="rect">
-            <a:avLst/>
-          </a:prstGeom>
-          <a:noFill/>
-          <a:ln/>
-        </p:spPr>
-        <p:txBody>
-          <a:bodyPr wrap="square" lIns="0" tIns="0" rIns="0" bIns="0" rtlCol="0" anchor="ctr"/>
-          <a:lstStyle/>
-          <a:p>
-            <a:pPr algn="ctr" indent="0" marL="0">
-              <a:buNone/>
-            </a:pPr>
-            <a:r>
-              <a:rPr lang="en-US" sz="1300" b="1" dirty="0">
-                <a:solidFill>
-                  <a:schemeClr val="bg1"/>
-                </a:solidFill>
-              </a:rPr>
-              <a:t>3</a:t>
-            </a:r>
-            <a:endParaRPr lang="en-US" sz="1300" dirty="0"/>
-          </a:p>
-        </p:txBody>
-      </p:sp>
-      <p:sp>
-        <p:nvSpPr>
-          <p:cNvPr id="40" name="lane 2 title 3"/>
-          <p:cNvSpPr txBox="1"/>
-          <p:nvPr/>
-        </p:nvSpPr>
-        <p:spPr>
-          <a:xfrm>
-            <a:off x="6839712" y="4498848"/>
-            <a:ext cx="1828800" cy="329184"/>
-          </a:xfrm>
-          <a:prstGeom prst="rect">
-            <a:avLst/>
-          </a:prstGeom>
-          <a:noFill/>
-          <a:ln/>
-        </p:spPr>
-        <p:txBody>
-          <a:bodyPr wrap="square" lIns="0" tIns="0" rIns="0" bIns="0" rtlCol="0" anchor="ctr"/>
-          <a:lstStyle/>
-          <a:p>
-            <a:pPr indent="0" marL="0">
-              <a:buNone/>
-            </a:pPr>
-            <a:r>
-              <a:rPr lang="en-US" sz="1700" b="1" dirty="0">
-                <a:solidFill>
-                  <a:schemeClr val="tx1"/>
-                </a:solidFill>
-              </a:rPr>
-              <a:t>Move</a:t>
-            </a:r>
-            <a:endParaRPr lang="en-US" sz="1700" dirty="0"/>
-          </a:p>
-        </p:txBody>
-      </p:sp>
-      <p:sp>
-        <p:nvSpPr>
-          <p:cNvPr id="41" name="lane 2 text 3"/>
-          <p:cNvSpPr txBox="1"/>
-          <p:nvPr/>
-        </p:nvSpPr>
-        <p:spPr>
-          <a:xfrm>
-            <a:off x="6400800" y="4965192"/>
-            <a:ext cx="2212848" cy="1234440"/>
-          </a:xfrm>
-          <a:prstGeom prst="rect">
-            <a:avLst/>
-          </a:prstGeom>
-          <a:noFill/>
-          <a:ln/>
-        </p:spPr>
-        <p:txBody>
-          <a:bodyPr wrap="square" lIns="0" tIns="0" rIns="0" bIns="0" rtlCol="0" anchor="t"/>
-          <a:lstStyle/>
-          <a:p>
-            <a:pPr indent="0" marL="0">
-              <a:buNone/>
-            </a:pPr>
-            <a:r>
-              <a:rPr lang="en-US" sz="1400" dirty="0">
-                <a:solidFill>
-                  <a:schemeClr val="tx2"/>
-                </a:solidFill>
-              </a:rPr>
-              <a:t>Turn by the essential-matrix yaw to the next waypoint photo, else the L network; undo moves to back up.</a:t>
-            </a:r>
-            <a:endParaRPr lang="en-US" sz="1400" dirty="0"/>
-          </a:p>
-        </p:txBody>
-      </p:sp>
-      <p:sp>
-        <p:nvSpPr>
-          <p:cNvPr id="42" name="lane 2 arrow 3"/>
-          <p:cNvSpPr/>
-          <p:nvPr/>
-        </p:nvSpPr>
-        <p:spPr>
-          <a:xfrm>
-            <a:off x="8764524" y="5193792"/>
-            <a:ext cx="292608" cy="219456"/>
-          </a:xfrm>
-          <a:prstGeom prst="rightArrow">
-            <a:avLst/>
-          </a:prstGeom>
-          <a:solidFill>
-            <a:schemeClr val="accent3"/>
-          </a:solidFill>
-          <a:ln w="12700">
-            <a:solidFill>
-              <a:schemeClr val="accent3"/>
-            </a:solidFill>
-            <a:prstDash val="solid"/>
-          </a:ln>
-        </p:spPr>
-      </p:sp>
-      <p:sp>
-        <p:nvSpPr>
-          <p:cNvPr id="43" name="lane 2 card 4"/>
-          <p:cNvSpPr/>
-          <p:nvPr/>
-        </p:nvSpPr>
-        <p:spPr>
-          <a:xfrm>
-            <a:off x="9052560" y="4343400"/>
-            <a:ext cx="2551176" cy="1920240"/>
-          </a:xfrm>
-          <a:prstGeom prst="roundRect">
-            <a:avLst>
-              <a:gd name="adj" fmla="val 5714"/>
-            </a:avLst>
-          </a:prstGeom>
-          <a:solidFill>
-            <a:schemeClr val="accent6"/>
-          </a:solidFill>
-          <a:ln w="12700">
-            <a:solidFill>
-              <a:schemeClr val="accent6"/>
-            </a:solidFill>
-            <a:prstDash val="solid"/>
-          </a:ln>
-        </p:spPr>
-      </p:sp>
-      <p:sp>
-        <p:nvSpPr>
-          <p:cNvPr id="44" name="lane 2 step 4 circle"/>
-          <p:cNvSpPr/>
-          <p:nvPr/>
-        </p:nvSpPr>
-        <p:spPr>
-          <a:xfrm>
-            <a:off x="9235440" y="4498848"/>
-            <a:ext cx="329184" cy="329184"/>
-          </a:xfrm>
-          <a:prstGeom prst="ellipse">
-            <a:avLst/>
-          </a:prstGeom>
-          <a:solidFill>
-            <a:schemeClr val="accent2"/>
-          </a:solidFill>
-          <a:ln w="12700">
-            <a:solidFill>
-              <a:schemeClr val="accent2"/>
-            </a:solidFill>
-            <a:prstDash val="solid"/>
-          </a:ln>
-        </p:spPr>
-      </p:sp>
-      <p:sp>
-        <p:nvSpPr>
-          <p:cNvPr id="45" name="lane 2 step 4 number"/>
-          <p:cNvSpPr txBox="1"/>
-          <p:nvPr/>
-        </p:nvSpPr>
-        <p:spPr>
-          <a:xfrm>
-            <a:off x="9235440" y="4498848"/>
-            <a:ext cx="329184" cy="329184"/>
-          </a:xfrm>
-          <a:prstGeom prst="rect">
-            <a:avLst/>
-          </a:prstGeom>
-          <a:noFill/>
-          <a:ln/>
-        </p:spPr>
-        <p:txBody>
-          <a:bodyPr wrap="square" lIns="0" tIns="0" rIns="0" bIns="0" rtlCol="0" anchor="ctr"/>
-          <a:lstStyle/>
-          <a:p>
-            <a:pPr algn="ctr" indent="0" marL="0">
-              <a:buNone/>
-            </a:pPr>
-            <a:r>
-              <a:rPr lang="en-US" sz="1300" b="1" dirty="0">
-                <a:solidFill>
-                  <a:schemeClr val="bg1"/>
-                </a:solidFill>
-              </a:rPr>
-              <a:t>4</a:t>
-            </a:r>
-            <a:endParaRPr lang="en-US" sz="1300" dirty="0"/>
-          </a:p>
-        </p:txBody>
-      </p:sp>
-      <p:sp>
-        <p:nvSpPr>
-          <p:cNvPr id="46" name="lane 2 title 4"/>
-          <p:cNvSpPr txBox="1"/>
-          <p:nvPr/>
-        </p:nvSpPr>
-        <p:spPr>
-          <a:xfrm>
-            <a:off x="9674352" y="4498848"/>
-            <a:ext cx="1828800" cy="329184"/>
-          </a:xfrm>
-          <a:prstGeom prst="rect">
-            <a:avLst/>
-          </a:prstGeom>
-          <a:noFill/>
-          <a:ln/>
-        </p:spPr>
-        <p:txBody>
-          <a:bodyPr wrap="square" lIns="0" tIns="0" rIns="0" bIns="0" rtlCol="0" anchor="ctr"/>
-          <a:lstStyle/>
-          <a:p>
-            <a:pPr indent="0" marL="0">
-              <a:buNone/>
-            </a:pPr>
-            <a:r>
-              <a:rPr lang="en-US" sz="1700" b="1" dirty="0">
-                <a:solidFill>
-                  <a:schemeClr val="tx1"/>
-                </a:solidFill>
-              </a:rPr>
-              <a:t>Last metre</a:t>
-            </a:r>
-            <a:endParaRPr lang="en-US" sz="1700" dirty="0"/>
-          </a:p>
-        </p:txBody>
-      </p:sp>
-      <p:sp>
-        <p:nvSpPr>
-          <p:cNvPr id="47" name="lane 2 text 4"/>
-          <p:cNvSpPr txBox="1"/>
-          <p:nvPr/>
-        </p:nvSpPr>
-        <p:spPr>
-          <a:xfrm>
-            <a:off x="9235440" y="4965192"/>
-            <a:ext cx="2212848" cy="1234440"/>
-          </a:xfrm>
-          <a:prstGeom prst="rect">
-            <a:avLst/>
-          </a:prstGeom>
-          <a:noFill/>
-          <a:ln/>
-        </p:spPr>
-        <p:txBody>
-          <a:bodyPr wrap="square" lIns="0" tIns="0" rIns="0" bIns="0" rtlCol="0" anchor="t"/>
-          <a:lstStyle/>
-          <a:p>
-            <a:pPr indent="0" marL="0">
-              <a:buNone/>
-            </a:pPr>
-            <a:r>
-              <a:rPr lang="en-US" sz="1400" dirty="0">
-                <a:solidFill>
-                  <a:schemeClr val="tx2"/>
-                </a:solidFill>
-              </a:rPr>
-              <a:t>Match the goal photos, line up and creep; check in only on 35+ inliers, 3 readings in a row.</a:t>
-            </a:r>
-            <a:endParaRPr lang="en-US" sz="1400" dirty="0"/>
+              <a:t>Example from local test maze 25</a:t>
+            </a:r>
+            <a:endParaRPr lang="en-US" sz="1050" dirty="0"/>
           </a:p>
         </p:txBody>
       </p:sp>
@@ -4332,273 +3657,58 @@
                   <a:schemeClr val="tx1"/>
                 </a:solidFill>
               </a:rPr>
-              <a:t>Method (2/2): what keeps it on track</a:t>
+              <a:t>Method (2/2): how the robot moves</a:t>
             </a:r>
             <a:endParaRPr lang="en-US" sz="3000" dirty="0"/>
           </a:p>
         </p:txBody>
       </p:sp>
-      <p:pic>
-        <p:nvPicPr>
-          <p:cNvPr id="4" name="maze 25 true path" descr="Top view of local maze 25: the robot’s true path from the start to the goal ring, coloured by time from blue to red, with a knot at the top left where it made no progress for a while">    </p:cNvPr>
-          <p:cNvPicPr>
-            <a:picLocks noChangeAspect="1"/>
-          </p:cNvPicPr>
-          <p:nvPr/>
-        </p:nvPicPr>
-        <p:blipFill>
-          <a:blip r:embed="rId1"/>
-          <a:stretch>
-            <a:fillRect/>
-          </a:stretch>
-        </p:blipFill>
-        <p:spPr>
-          <a:xfrm>
-            <a:off x="548640" y="1417320"/>
-            <a:ext cx="4023360" cy="4023360"/>
-          </a:xfrm>
-          <a:prstGeom prst="rect">
-            <a:avLst/>
-          </a:prstGeom>
-        </p:spPr>
-      </p:pic>
-      <p:sp>
-        <p:nvSpPr>
-          <p:cNvPr id="5" name="maze 25 caption"/>
+      <p:sp>
+        <p:nvSpPr>
+          <p:cNvPr id="4" name="moving intro"/>
           <p:cNvSpPr txBox="1"/>
           <p:nvPr/>
         </p:nvSpPr>
         <p:spPr>
           <a:xfrm>
-            <a:off x="548640" y="5532120"/>
-            <a:ext cx="4023360" cy="822960"/>
-          </a:xfrm>
-          <a:prstGeom prst="rect">
-            <a:avLst/>
-          </a:prstGeom>
-          <a:noFill/>
-          <a:ln/>
-        </p:spPr>
-        <p:txBody>
-          <a:bodyPr wrap="square" lIns="0" tIns="0" rIns="0" bIns="0" rtlCol="0" anchor="t"/>
-          <a:lstStyle/>
-          <a:p>
-            <a:pPr indent="0" marL="0">
-              <a:buNone/>
-            </a:pPr>
-            <a:r>
-              <a:rPr lang="en-US" sz="1050" b="1" dirty="0">
-                <a:solidFill>
-                  <a:schemeClr val="tx1"/>
-                </a:solidFill>
-              </a:rPr>
-              <a:t>Local maze 25, the exact mid-term code, </a:t>
-            </a:r>
-            <a:pPr indent="0" marL="0">
-              <a:buNone/>
-            </a:pPr>
-            <a:r>
-              <a:rPr lang="en-US" sz="1050" dirty="0">
+            <a:off x="548640" y="1371600"/>
+            <a:ext cx="7132320" cy="320040"/>
+          </a:xfrm>
+          <a:prstGeom prst="rect">
+            <a:avLst/>
+          </a:prstGeom>
+          <a:noFill/>
+          <a:ln/>
+        </p:spPr>
+        <p:txBody>
+          <a:bodyPr wrap="square" lIns="0" tIns="0" rIns="0" bIns="0" rtlCol="0" anchor="ctr"/>
+          <a:lstStyle/>
+          <a:p>
+            <a:pPr indent="0" marL="0">
+              <a:buNone/>
+            </a:pPr>
+            <a:r>
+              <a:rPr lang="en-US" sz="1400" i="1" dirty="0">
                 <a:solidFill>
                   <a:schemeClr val="tx2"/>
                 </a:solidFill>
               </a:rPr>
-              <a:t>replayed on the simulator’s true poses. Colour = time, blue at the start to red at the check-in: 6/10, 2,965 steps, 0.02 m from the goal. The knot at top left is about 1,700 steps that got no closer to the goal (following, undoing and searching), the same kind of loss as in the mid-term.</a:t>
-            </a:r>
-            <a:endParaRPr lang="en-US" sz="1050" dirty="0"/>
-          </a:p>
-        </p:txBody>
-      </p:sp>
-      <p:pic>
-        <p:nvPicPr>
-          <p:cNvPr id="6" name="maze 25 photo 1" descr="Maze 25: the goal photo it was given">    </p:cNvPr>
-          <p:cNvPicPr>
-            <a:picLocks noChangeAspect="1"/>
-          </p:cNvPicPr>
-          <p:nvPr/>
-        </p:nvPicPr>
-        <p:blipFill>
-          <a:blip r:embed="rId2"/>
-          <a:stretch>
-            <a:fillRect/>
-          </a:stretch>
-        </p:blipFill>
-        <p:spPr>
-          <a:xfrm>
-            <a:off x="4800600" y="1417320"/>
-            <a:ext cx="1828800" cy="1371600"/>
-          </a:xfrm>
-          <a:prstGeom prst="rect">
-            <a:avLst/>
-          </a:prstGeom>
-        </p:spPr>
-      </p:pic>
-      <p:sp>
-        <p:nvSpPr>
-          <p:cNvPr id="7" name="maze 25 photo label 1"/>
-          <p:cNvSpPr txBox="1"/>
-          <p:nvPr/>
-        </p:nvSpPr>
-        <p:spPr>
-          <a:xfrm>
-            <a:off x="4800600" y="2807208"/>
-            <a:ext cx="2011680" cy="219456"/>
-          </a:xfrm>
-          <a:prstGeom prst="rect">
-            <a:avLst/>
-          </a:prstGeom>
-          <a:noFill/>
-          <a:ln/>
-        </p:spPr>
-        <p:txBody>
-          <a:bodyPr wrap="square" lIns="0" tIns="0" rIns="0" bIns="0" rtlCol="0" anchor="ctr"/>
-          <a:lstStyle/>
-          <a:p>
-            <a:pPr indent="0" marL="0">
-              <a:buNone/>
-            </a:pPr>
-            <a:r>
-              <a:rPr lang="en-US" sz="1050" b="1" dirty="0">
-                <a:solidFill>
-                  <a:schemeClr val="tx1"/>
-                </a:solidFill>
-              </a:rPr>
-              <a:t>1. Goal photo (given)</a:t>
-            </a:r>
-            <a:endParaRPr lang="en-US" sz="1050" dirty="0"/>
-          </a:p>
-        </p:txBody>
-      </p:sp>
-      <p:pic>
-        <p:nvPicPr>
-          <p:cNvPr id="8" name="maze 25 photo 2" descr="Maze 25: the exploration photo the agent picked as the goal node">    </p:cNvPr>
-          <p:cNvPicPr>
-            <a:picLocks noChangeAspect="1"/>
-          </p:cNvPicPr>
-          <p:nvPr/>
-        </p:nvPicPr>
-        <p:blipFill>
-          <a:blip r:embed="rId3"/>
-          <a:stretch>
-            <a:fillRect/>
-          </a:stretch>
-        </p:blipFill>
-        <p:spPr>
-          <a:xfrm>
-            <a:off x="4800600" y="3044952"/>
-            <a:ext cx="1828800" cy="1371600"/>
-          </a:xfrm>
-          <a:prstGeom prst="rect">
-            <a:avLst/>
-          </a:prstGeom>
-        </p:spPr>
-      </p:pic>
-      <p:sp>
-        <p:nvSpPr>
-          <p:cNvPr id="9" name="maze 25 photo label 2"/>
-          <p:cNvSpPr txBox="1"/>
-          <p:nvPr/>
-        </p:nvSpPr>
-        <p:spPr>
-          <a:xfrm>
-            <a:off x="4800600" y="4434840"/>
-            <a:ext cx="2011680" cy="219456"/>
-          </a:xfrm>
-          <a:prstGeom prst="rect">
-            <a:avLst/>
-          </a:prstGeom>
-          <a:noFill/>
-          <a:ln/>
-        </p:spPr>
-        <p:txBody>
-          <a:bodyPr wrap="square" lIns="0" tIns="0" rIns="0" bIns="0" rtlCol="0" anchor="ctr"/>
-          <a:lstStyle/>
-          <a:p>
-            <a:pPr indent="0" marL="0">
-              <a:buNone/>
-            </a:pPr>
-            <a:r>
-              <a:rPr lang="en-US" sz="1050" b="1" dirty="0">
-                <a:solidFill>
-                  <a:schemeClr val="tx1"/>
-                </a:solidFill>
-              </a:rPr>
-              <a:t>2. Map photo picked as the goal</a:t>
-            </a:r>
-            <a:endParaRPr lang="en-US" sz="1050" dirty="0"/>
-          </a:p>
-        </p:txBody>
-      </p:sp>
-      <p:pic>
-        <p:nvPicPr>
-          <p:cNvPr id="10" name="maze 25 photo 3" descr="Maze 25: the robot’s camera view when it checked in">    </p:cNvPr>
-          <p:cNvPicPr>
-            <a:picLocks noChangeAspect="1"/>
-          </p:cNvPicPr>
-          <p:nvPr/>
-        </p:nvPicPr>
-        <p:blipFill>
-          <a:blip r:embed="rId4"/>
-          <a:stretch>
-            <a:fillRect/>
-          </a:stretch>
-        </p:blipFill>
-        <p:spPr>
-          <a:xfrm>
-            <a:off x="4800600" y="4672584"/>
-            <a:ext cx="1828800" cy="1371600"/>
-          </a:xfrm>
-          <a:prstGeom prst="rect">
-            <a:avLst/>
-          </a:prstGeom>
-        </p:spPr>
-      </p:pic>
-      <p:sp>
-        <p:nvSpPr>
-          <p:cNvPr id="11" name="maze 25 photo label 3"/>
-          <p:cNvSpPr txBox="1"/>
-          <p:nvPr/>
-        </p:nvSpPr>
-        <p:spPr>
-          <a:xfrm>
-            <a:off x="4800600" y="6062472"/>
-            <a:ext cx="2011680" cy="219456"/>
-          </a:xfrm>
-          <a:prstGeom prst="rect">
-            <a:avLst/>
-          </a:prstGeom>
-          <a:noFill/>
-          <a:ln/>
-        </p:spPr>
-        <p:txBody>
-          <a:bodyPr wrap="square" lIns="0" tIns="0" rIns="0" bIns="0" rtlCol="0" anchor="ctr"/>
-          <a:lstStyle/>
-          <a:p>
-            <a:pPr indent="0" marL="0">
-              <a:buNone/>
-            </a:pPr>
-            <a:r>
-              <a:rPr lang="en-US" sz="1050" b="1" dirty="0">
-                <a:solidFill>
-                  <a:schemeClr val="tx1"/>
-                </a:solidFill>
-              </a:rPr>
-              <a:t>3. Camera at check-in (0.02 m)</a:t>
-            </a:r>
-            <a:endParaRPr lang="en-US" sz="1050" dirty="0"/>
-          </a:p>
-        </p:txBody>
-      </p:sp>
-      <p:sp>
-        <p:nvSpPr>
-          <p:cNvPr id="12" name="key idea 1 circle"/>
+              <a:t>Then it repeats these steps for every move until it checks in.</a:t>
+            </a:r>
+            <a:endParaRPr lang="en-US" sz="1400" dirty="0"/>
+          </a:p>
+        </p:txBody>
+      </p:sp>
+      <p:sp>
+        <p:nvSpPr>
+          <p:cNvPr id="5" name="moving step 1 circle"/>
           <p:cNvSpPr/>
           <p:nvPr/>
         </p:nvSpPr>
         <p:spPr>
           <a:xfrm>
-            <a:off x="7040880" y="1472184"/>
-            <a:ext cx="310896" cy="310896"/>
+            <a:off x="548640" y="1828800"/>
+            <a:ext cx="292608" cy="292608"/>
           </a:xfrm>
           <a:prstGeom prst="ellipse">
             <a:avLst/>
@@ -4616,14 +3726,14 @@
       </p:sp>
       <p:sp>
         <p:nvSpPr>
-          <p:cNvPr id="13" name="key idea 1 number"/>
+          <p:cNvPr id="6" name="moving step 1 number"/>
           <p:cNvSpPr txBox="1"/>
           <p:nvPr/>
         </p:nvSpPr>
         <p:spPr>
           <a:xfrm>
-            <a:off x="7040880" y="1472184"/>
-            <a:ext cx="310896" cy="310896"/>
+            <a:off x="548640" y="1828800"/>
+            <a:ext cx="292608" cy="292608"/>
           </a:xfrm>
           <a:prstGeom prst="rect">
             <a:avLst/>
@@ -4652,14 +3762,14 @@
       </p:sp>
       <p:sp>
         <p:nvSpPr>
-          <p:cNvPr id="14" name="key idea 1"/>
+          <p:cNvPr id="7" name="moving step 1 text"/>
           <p:cNvSpPr txBox="1"/>
           <p:nvPr/>
         </p:nvSpPr>
         <p:spPr>
           <a:xfrm>
-            <a:off x="7498080" y="1463040"/>
-            <a:ext cx="4160520" cy="740664"/>
+            <a:off x="978408" y="1810512"/>
+            <a:ext cx="6702552" cy="649224"/>
           </a:xfrm>
           <a:prstGeom prst="rect">
             <a:avLst/>
@@ -4675,38 +3785,38 @@
               <a:buNone/>
             </a:pPr>
             <a:r>
-              <a:rPr lang="en-US" sz="1450" b="1" dirty="0">
+              <a:rPr lang="en-US" sz="1300" b="1" dirty="0">
                 <a:solidFill>
                   <a:schemeClr val="tx1"/>
                 </a:solidFill>
               </a:rPr>
-              <a:t>Think when confused. </a:t>
-            </a:r>
-            <a:pPr indent="0" marL="0">
-              <a:buNone/>
-            </a:pPr>
-            <a:r>
-              <a:rPr lang="en-US" sz="1450" dirty="0">
+              <a:t>Where am I? </a:t>
+            </a:r>
+            <a:pPr indent="0" marL="0">
+              <a:buNone/>
+            </a:pPr>
+            <a:r>
+              <a:rPr lang="en-US" sz="1300" dirty="0">
                 <a:solidFill>
                   <a:schemeClr val="tx2"/>
                 </a:solidFill>
               </a:rPr>
-              <a:t>Three decisions on the same photo: SuperGlue checks the next 5 route photos. It costs time, not steps.</a:t>
-            </a:r>
-            <a:endParaRPr lang="en-US" sz="1450" dirty="0"/>
-          </a:p>
-        </p:txBody>
-      </p:sp>
-      <p:sp>
-        <p:nvSpPr>
-          <p:cNvPr id="15" name="key idea 2 circle"/>
+              <a:t>It compares the camera image with the exploration photos near its last position (AnyLoc). A jump to a far part of the map is believed only if 3 images in a row agree and SuperGlue confirms the match.</a:t>
+            </a:r>
+            <a:endParaRPr lang="en-US" sz="1300" dirty="0"/>
+          </a:p>
+        </p:txBody>
+      </p:sp>
+      <p:sp>
+        <p:nvSpPr>
+          <p:cNvPr id="8" name="moving step 2 circle"/>
           <p:cNvSpPr/>
           <p:nvPr/>
         </p:nvSpPr>
         <p:spPr>
           <a:xfrm>
-            <a:off x="7040880" y="2395728"/>
-            <a:ext cx="310896" cy="310896"/>
+            <a:off x="548640" y="2606040"/>
+            <a:ext cx="292608" cy="292608"/>
           </a:xfrm>
           <a:prstGeom prst="ellipse">
             <a:avLst/>
@@ -4724,14 +3834,14 @@
       </p:sp>
       <p:sp>
         <p:nvSpPr>
-          <p:cNvPr id="16" name="key idea 2 number"/>
+          <p:cNvPr id="9" name="moving step 2 number"/>
           <p:cNvSpPr txBox="1"/>
           <p:nvPr/>
         </p:nvSpPr>
         <p:spPr>
           <a:xfrm>
-            <a:off x="7040880" y="2395728"/>
-            <a:ext cx="310896" cy="310896"/>
+            <a:off x="548640" y="2606040"/>
+            <a:ext cx="292608" cy="292608"/>
           </a:xfrm>
           <a:prstGeom prst="rect">
             <a:avLst/>
@@ -4760,14 +3870,14 @@
       </p:sp>
       <p:sp>
         <p:nvSpPr>
-          <p:cNvPr id="17" name="key idea 2"/>
+          <p:cNvPr id="10" name="moving step 2 text"/>
           <p:cNvSpPr txBox="1"/>
           <p:nvPr/>
         </p:nvSpPr>
         <p:spPr>
           <a:xfrm>
-            <a:off x="7498080" y="2386584"/>
-            <a:ext cx="4160520" cy="740664"/>
+            <a:off x="978408" y="2587752"/>
+            <a:ext cx="6702552" cy="451104"/>
           </a:xfrm>
           <a:prstGeom prst="rect">
             <a:avLst/>
@@ -4783,38 +3893,38 @@
               <a:buNone/>
             </a:pPr>
             <a:r>
-              <a:rPr lang="en-US" sz="1450" b="1" dirty="0">
+              <a:rPr lang="en-US" sz="1300" b="1" dirty="0">
                 <a:solidFill>
                   <a:schemeClr val="tx1"/>
                 </a:solidFill>
               </a:rPr>
-              <a:t>Measured steering. </a:t>
-            </a:r>
-            <a:pPr indent="0" marL="0">
-              <a:buNone/>
-            </a:pPr>
-            <a:r>
-              <a:rPr lang="en-US" sz="1450" dirty="0">
+              <a:t>Where next? </a:t>
+            </a:r>
+            <a:pPr indent="0" marL="0">
+              <a:buNone/>
+            </a:pPr>
+            <a:r>
+              <a:rPr lang="en-US" sz="1300" dirty="0">
                 <a:solidFill>
                   <a:schemeClr val="tx2"/>
                 </a:solidFill>
               </a:rPr>
-              <a:t>Yaw from the essential matrix between the live view and the waypoint photo; it keeps control down to 30 inliers.</a:t>
-            </a:r>
-            <a:endParaRPr lang="en-US" sz="1450" dirty="0"/>
-          </a:p>
-        </p:txBody>
-      </p:sp>
-      <p:sp>
-        <p:nvSpPr>
-          <p:cNvPr id="18" name="key idea 3 circle"/>
+              <a:t>It looks up the route from that photo and picks a waypoint photo a few steps ahead on it.</a:t>
+            </a:r>
+            <a:endParaRPr lang="en-US" sz="1300" dirty="0"/>
+          </a:p>
+        </p:txBody>
+      </p:sp>
+      <p:sp>
+        <p:nvSpPr>
+          <p:cNvPr id="11" name="moving step 3 circle"/>
           <p:cNvSpPr/>
           <p:nvPr/>
         </p:nvSpPr>
         <p:spPr>
           <a:xfrm>
-            <a:off x="7040880" y="3319272"/>
-            <a:ext cx="310896" cy="310896"/>
+            <a:off x="548640" y="3185160"/>
+            <a:ext cx="292608" cy="292608"/>
           </a:xfrm>
           <a:prstGeom prst="ellipse">
             <a:avLst/>
@@ -4832,14 +3942,14 @@
       </p:sp>
       <p:sp>
         <p:nvSpPr>
-          <p:cNvPr id="19" name="key idea 3 number"/>
+          <p:cNvPr id="12" name="moving step 3 number"/>
           <p:cNvSpPr txBox="1"/>
           <p:nvPr/>
         </p:nvSpPr>
         <p:spPr>
           <a:xfrm>
-            <a:off x="7040880" y="3319272"/>
-            <a:ext cx="310896" cy="310896"/>
+            <a:off x="548640" y="3185160"/>
+            <a:ext cx="292608" cy="292608"/>
           </a:xfrm>
           <a:prstGeom prst="rect">
             <a:avLst/>
@@ -4868,14 +3978,14 @@
       </p:sp>
       <p:sp>
         <p:nvSpPr>
-          <p:cNvPr id="20" name="key idea 3"/>
+          <p:cNvPr id="13" name="moving step 3 text"/>
           <p:cNvSpPr txBox="1"/>
           <p:nvPr/>
         </p:nvSpPr>
         <p:spPr>
           <a:xfrm>
-            <a:off x="7498080" y="3310128"/>
-            <a:ext cx="4160520" cy="512064"/>
+            <a:off x="978408" y="3166872"/>
+            <a:ext cx="6702552" cy="847344"/>
           </a:xfrm>
           <a:prstGeom prst="rect">
             <a:avLst/>
@@ -4891,38 +4001,38 @@
               <a:buNone/>
             </a:pPr>
             <a:r>
-              <a:rPr lang="en-US" sz="1450" b="1" dirty="0">
+              <a:rPr lang="en-US" sz="1300" b="1" dirty="0">
                 <a:solidFill>
                   <a:schemeClr val="tx1"/>
                 </a:solidFill>
               </a:rPr>
-              <a:t>No repeated detours. </a:t>
-            </a:r>
-            <a:pPr indent="0" marL="0">
-              <a:buNone/>
-            </a:pPr>
-            <a:r>
-              <a:rPr lang="en-US" sz="1450" dirty="0">
+              <a:t>Turn and drive. </a:t>
+            </a:r>
+            <a:pPr indent="0" marL="0">
+              <a:buNone/>
+            </a:pPr>
+            <a:r>
+              <a:rPr lang="en-US" sz="1300" dirty="0">
                 <a:solidFill>
                   <a:schemeClr val="tx2"/>
                 </a:solidFill>
               </a:rPr>
-              <a:t>A stretch that stalls gets costlier once, then the route is re-planned.</a:t>
-            </a:r>
-            <a:endParaRPr lang="en-US" sz="1450" dirty="0"/>
-          </a:p>
-        </p:txBody>
-      </p:sp>
-      <p:sp>
-        <p:nvSpPr>
-          <p:cNvPr id="21" name="key idea 4 circle"/>
+              <a:t>SuperGlue matches the camera image with the waypoint photo, and the essential matrix between them gives the angle to turn. It turns by that angle, then drives forward. If the waypoint is not in view it turns on the spot to find it; if nothing matches, the L network picks the move.</a:t>
+            </a:r>
+            <a:endParaRPr lang="en-US" sz="1300" dirty="0"/>
+          </a:p>
+        </p:txBody>
+      </p:sp>
+      <p:sp>
+        <p:nvSpPr>
+          <p:cNvPr id="14" name="moving step 4 circle"/>
           <p:cNvSpPr/>
           <p:nvPr/>
         </p:nvSpPr>
         <p:spPr>
           <a:xfrm>
-            <a:off x="7040880" y="4014216"/>
-            <a:ext cx="310896" cy="310896"/>
+            <a:off x="548640" y="4160520"/>
+            <a:ext cx="292608" cy="292608"/>
           </a:xfrm>
           <a:prstGeom prst="ellipse">
             <a:avLst/>
@@ -4940,14 +4050,14 @@
       </p:sp>
       <p:sp>
         <p:nvSpPr>
-          <p:cNvPr id="22" name="key idea 4 number"/>
+          <p:cNvPr id="15" name="moving step 4 number"/>
           <p:cNvSpPr txBox="1"/>
           <p:nvPr/>
         </p:nvSpPr>
         <p:spPr>
           <a:xfrm>
-            <a:off x="7040880" y="4014216"/>
-            <a:ext cx="310896" cy="310896"/>
+            <a:off x="548640" y="4160520"/>
+            <a:ext cx="292608" cy="292608"/>
           </a:xfrm>
           <a:prstGeom prst="rect">
             <a:avLst/>
@@ -4976,14 +4086,14 @@
       </p:sp>
       <p:sp>
         <p:nvSpPr>
-          <p:cNvPr id="23" name="key idea 4"/>
+          <p:cNvPr id="16" name="moving step 4 text"/>
           <p:cNvSpPr txBox="1"/>
           <p:nvPr/>
         </p:nvSpPr>
         <p:spPr>
           <a:xfrm>
-            <a:off x="7498080" y="4005072"/>
-            <a:ext cx="4160520" cy="969264"/>
+            <a:off x="978408" y="4142232"/>
+            <a:ext cx="6702552" cy="451104"/>
           </a:xfrm>
           <a:prstGeom prst="rect">
             <a:avLst/>
@@ -4999,38 +4109,38 @@
               <a:buNone/>
             </a:pPr>
             <a:r>
-              <a:rPr lang="en-US" sz="1450" b="1" dirty="0">
+              <a:rPr lang="en-US" sz="1300" b="1" dirty="0">
                 <a:solidFill>
                   <a:schemeClr val="tx1"/>
                 </a:solidFill>
               </a:rPr>
-              <a:t>Robust goal choice. </a:t>
-            </a:r>
-            <a:pPr indent="0" marL="0">
-              <a:buNone/>
-            </a:pPr>
-            <a:r>
-              <a:rPr lang="en-US" sz="1450" dirty="0">
+              <a:t>Backing out. </a:t>
+            </a:r>
+            <a:pPr indent="0" marL="0">
+              <a:buNone/>
+            </a:pPr>
+            <a:r>
+              <a:rPr lang="en-US" sz="1300" dirty="0">
                 <a:solidFill>
                   <a:schemeClr val="tx2"/>
                 </a:solidFill>
               </a:rPr>
-              <a:t>Each goal photo is checked against AnyLoc’s top 64 map photos; the strongest SuperGlue match is the goal node (photo 2). Wrong goal in 1 of 13 test mazes, down from 4 of 13.</a:t>
-            </a:r>
-            <a:endParaRPr lang="en-US" sz="1450" dirty="0"/>
-          </a:p>
-        </p:txBody>
-      </p:sp>
-      <p:sp>
-        <p:nvSpPr>
-          <p:cNvPr id="24" name="key idea 5 circle"/>
+              <a:t>When the route runs back along a drive, for example out of a dead end, it undoes the recorded moves in reverse: a recorded left turn is undone by turning right.</a:t>
+            </a:r>
+            <a:endParaRPr lang="en-US" sz="1300" dirty="0"/>
+          </a:p>
+        </p:txBody>
+      </p:sp>
+      <p:sp>
+        <p:nvSpPr>
+          <p:cNvPr id="17" name="moving step 5 circle"/>
           <p:cNvSpPr/>
           <p:nvPr/>
         </p:nvSpPr>
         <p:spPr>
           <a:xfrm>
-            <a:off x="7040880" y="5166360"/>
-            <a:ext cx="310896" cy="310896"/>
+            <a:off x="548640" y="4739640"/>
+            <a:ext cx="292608" cy="292608"/>
           </a:xfrm>
           <a:prstGeom prst="ellipse">
             <a:avLst/>
@@ -5048,14 +4158,14 @@
       </p:sp>
       <p:sp>
         <p:nvSpPr>
-          <p:cNvPr id="25" name="key idea 5 number"/>
+          <p:cNvPr id="18" name="moving step 5 number"/>
           <p:cNvSpPr txBox="1"/>
           <p:nvPr/>
         </p:nvSpPr>
         <p:spPr>
           <a:xfrm>
-            <a:off x="7040880" y="5166360"/>
-            <a:ext cx="310896" cy="310896"/>
+            <a:off x="548640" y="4739640"/>
+            <a:ext cx="292608" cy="292608"/>
           </a:xfrm>
           <a:prstGeom prst="rect">
             <a:avLst/>
@@ -5084,14 +4194,14 @@
       </p:sp>
       <p:sp>
         <p:nvSpPr>
-          <p:cNvPr id="26" name="key idea 5"/>
+          <p:cNvPr id="19" name="moving step 5 text"/>
           <p:cNvSpPr txBox="1"/>
           <p:nvPr/>
         </p:nvSpPr>
         <p:spPr>
           <a:xfrm>
-            <a:off x="7498080" y="5157216"/>
-            <a:ext cx="4160520" cy="740664"/>
+            <a:off x="978408" y="4721352"/>
+            <a:ext cx="6702552" cy="649224"/>
           </a:xfrm>
           <a:prstGeom prst="rect">
             <a:avLst/>
@@ -5107,25 +4217,193 @@
               <a:buNone/>
             </a:pPr>
             <a:r>
-              <a:rPr lang="en-US" sz="1450" b="1" dirty="0">
+              <a:rPr lang="en-US" sz="1300" b="1" dirty="0">
                 <a:solidFill>
                   <a:schemeClr val="tx1"/>
                 </a:solidFill>
               </a:rPr>
-              <a:t>Safe check-in. </a:t>
-            </a:r>
-            <a:pPr indent="0" marL="0">
-              <a:buNone/>
-            </a:pPr>
-            <a:r>
-              <a:rPr lang="en-US" sz="1450" dirty="0">
+              <a:t>When stuck. </a:t>
+            </a:r>
+            <a:pPr indent="0" marL="0">
+              <a:buNone/>
+            </a:pPr>
+            <a:r>
+              <a:rPr lang="en-US" sz="1300" dirty="0">
                 <a:solidFill>
                   <a:schemeClr val="tx2"/>
                 </a:solidFill>
               </a:rPr>
-              <a:t>Only on 35+ inliers with the goal photo, 3 readings in a row (photo 3). Correct check-ins had 43–122 inliers, wrong ones 21–25.</a:t>
-            </a:r>
-            <a:endParaRPr lang="en-US" sz="1450" dirty="0"/>
+              <a:t>If it believes it is at the same photo for 3 moves, it checks the next 5 route photos with SuperGlue. If it gets no closer for 150 steps, that stretch of the route is made more expensive and the route is planned again.</a:t>
+            </a:r>
+            <a:endParaRPr lang="en-US" sz="1300" dirty="0"/>
+          </a:p>
+        </p:txBody>
+      </p:sp>
+      <p:sp>
+        <p:nvSpPr>
+          <p:cNvPr id="20" name="moving step 6 circle"/>
+          <p:cNvSpPr/>
+          <p:nvPr/>
+        </p:nvSpPr>
+        <p:spPr>
+          <a:xfrm>
+            <a:off x="548640" y="5516880"/>
+            <a:ext cx="292608" cy="292608"/>
+          </a:xfrm>
+          <a:prstGeom prst="ellipse">
+            <a:avLst/>
+          </a:prstGeom>
+          <a:solidFill>
+            <a:schemeClr val="accent1"/>
+          </a:solidFill>
+          <a:ln w="12700">
+            <a:solidFill>
+              <a:schemeClr val="accent1"/>
+            </a:solidFill>
+            <a:prstDash val="solid"/>
+          </a:ln>
+        </p:spPr>
+      </p:sp>
+      <p:sp>
+        <p:nvSpPr>
+          <p:cNvPr id="21" name="moving step 6 number"/>
+          <p:cNvSpPr txBox="1"/>
+          <p:nvPr/>
+        </p:nvSpPr>
+        <p:spPr>
+          <a:xfrm>
+            <a:off x="548640" y="5516880"/>
+            <a:ext cx="292608" cy="292608"/>
+          </a:xfrm>
+          <a:prstGeom prst="rect">
+            <a:avLst/>
+          </a:prstGeom>
+          <a:noFill/>
+          <a:ln/>
+        </p:spPr>
+        <p:txBody>
+          <a:bodyPr wrap="square" lIns="0" tIns="0" rIns="0" bIns="0" rtlCol="0" anchor="ctr"/>
+          <a:lstStyle/>
+          <a:p>
+            <a:pPr algn="ctr" indent="0" marL="0">
+              <a:buNone/>
+            </a:pPr>
+            <a:r>
+              <a:rPr lang="en-US" sz="1300" b="1" dirty="0">
+                <a:solidFill>
+                  <a:schemeClr val="bg1"/>
+                </a:solidFill>
+              </a:rPr>
+              <a:t>6</a:t>
+            </a:r>
+            <a:endParaRPr lang="en-US" sz="1300" dirty="0"/>
+          </a:p>
+        </p:txBody>
+      </p:sp>
+      <p:sp>
+        <p:nvSpPr>
+          <p:cNvPr id="22" name="moving step 6 text"/>
+          <p:cNvSpPr txBox="1"/>
+          <p:nvPr/>
+        </p:nvSpPr>
+        <p:spPr>
+          <a:xfrm>
+            <a:off x="978408" y="5498592"/>
+            <a:ext cx="6702552" cy="649224"/>
+          </a:xfrm>
+          <a:prstGeom prst="rect">
+            <a:avLst/>
+          </a:prstGeom>
+          <a:noFill/>
+          <a:ln/>
+        </p:spPr>
+        <p:txBody>
+          <a:bodyPr wrap="square" lIns="0" tIns="0" rIns="0" bIns="0" rtlCol="0" anchor="t"/>
+          <a:lstStyle/>
+          <a:p>
+            <a:pPr indent="0" marL="0">
+              <a:buNone/>
+            </a:pPr>
+            <a:r>
+              <a:rPr lang="en-US" sz="1300" b="1" dirty="0">
+                <a:solidFill>
+                  <a:schemeClr val="tx1"/>
+                </a:solidFill>
+              </a:rPr>
+              <a:t>The last metre. </a:t>
+            </a:r>
+            <a:pPr indent="0" marL="0">
+              <a:buNone/>
+            </a:pPr>
+            <a:r>
+              <a:rPr lang="en-US" sz="1300" dirty="0">
+                <a:solidFill>
+                  <a:schemeClr val="tx2"/>
+                </a:solidFill>
+              </a:rPr>
+              <a:t>Within 3 photos of the goal it matches the camera image with the 4 goal photos directly. It turns until the front photo lines up, moves until the scene looks the same size, and checks in only after 3 readings in a row with 35 or more matched points.</a:t>
+            </a:r>
+            <a:endParaRPr lang="en-US" sz="1300" dirty="0"/>
+          </a:p>
+        </p:txBody>
+      </p:sp>
+      <p:pic>
+        <p:nvPicPr>
+          <p:cNvPr id="23" name="maze 25 true path" descr="Top view of local maze 25: the robot’s true path from the start to the goal ring, coloured by time from blue to red, with a tangle at the top left where it made no progress for a while">    </p:cNvPr>
+          <p:cNvPicPr>
+            <a:picLocks noChangeAspect="1"/>
+          </p:cNvPicPr>
+          <p:nvPr/>
+        </p:nvPicPr>
+        <p:blipFill>
+          <a:blip r:embed="rId1"/>
+          <a:stretch>
+            <a:fillRect/>
+          </a:stretch>
+        </p:blipFill>
+        <p:spPr>
+          <a:xfrm>
+            <a:off x="8046720" y="1417320"/>
+            <a:ext cx="3611880" cy="3611880"/>
+          </a:xfrm>
+          <a:prstGeom prst="rect">
+            <a:avLst/>
+          </a:prstGeom>
+        </p:spPr>
+      </p:pic>
+      <p:sp>
+        <p:nvSpPr>
+          <p:cNvPr id="24" name="maze 25 caption"/>
+          <p:cNvSpPr txBox="1"/>
+          <p:nvPr/>
+        </p:nvSpPr>
+        <p:spPr>
+          <a:xfrm>
+            <a:off x="8046720" y="5138928"/>
+            <a:ext cx="3611880" cy="1097280"/>
+          </a:xfrm>
+          <a:prstGeom prst="rect">
+            <a:avLst/>
+          </a:prstGeom>
+          <a:noFill/>
+          <a:ln/>
+        </p:spPr>
+        <p:txBody>
+          <a:bodyPr wrap="square" lIns="0" tIns="0" rIns="0" bIns="0" rtlCol="0" anchor="t"/>
+          <a:lstStyle/>
+          <a:p>
+            <a:pPr indent="0" marL="0">
+              <a:buNone/>
+            </a:pPr>
+            <a:r>
+              <a:rPr lang="en-US" sz="1050" dirty="0">
+                <a:solidFill>
+                  <a:schemeClr val="tx2"/>
+                </a:solidFill>
+              </a:rPr>
+              <a:t>Local test maze 25 with the same code, drawn from the simulator’s true positions (blue = start, red = check-in): 6/10, 2,965 steps, 2 cm from the goal. The tangle at the top left is about 1,700 steps that got no closer to the goal.</a:t>
+            </a:r>
+            <a:endParaRPr lang="en-US" sz="1050" dirty="0"/>
           </a:p>
         </p:txBody>
       </p:sp>

</xml_diff>

<commit_message>
Mid-term report: real images, team name and NetIDs
The title slide shows local test maze 25 with the robot's true path (in place of the mid-term
reconstruction). Slide 4 shows two real images: the SuperGlue matches behind a measured turn
(73 matches, 37 degrees) and the goal photo next to the camera at check-in. Method split into
before driving, when it starts, and during the drive. Team 15; NetIDs kp3932 and am16454.

Co-Authored-By: Claude Opus 5.5 <noreply@anthropic.com>
</commit_message>
<xml_diff>
--- a/runs/Midterm_Report.pptx
+++ b/runs/Midterm_Report.pptx
@@ -110,17 +110,17 @@
   <p:extLst>
     <p:ext uri="{521415D9-36F7-43E2-AB2F-B90AF26B5E84}">
       <p14:sectionLst xmlns:p14="http://schemas.microsoft.com/office/powerpoint/2010/main">
-        <p14:section name="Title" id="{8e510d6a-0548-d931-6219-5b8c5c0c8af4}">
+        <p14:section name="Title" id="{b30a61cd-a7e2-d497-1d37-8f018aaad81b}">
           <p14:sldIdLst>
             <p14:sldId id="256"/>
           </p14:sldIdLst>
         </p14:section>
-        <p14:section name="Problem" id="{25bc8843-b9fc-4437-267c-9b422f25dee3}">
+        <p14:section name="Problem" id="{70d53917-678e-10ba-eef6-468518725d86}">
           <p14:sldIdLst>
             <p14:sldId id="257"/>
           </p14:sldIdLst>
         </p14:section>
-        <p14:section name="Method" id="{931b2af5-f374-bf13-5ed2-6aab52cf4ce6}">
+        <p14:section name="Method" id="{956b8587-237a-ded8-7404-7ab48e6641cf}">
           <p14:sldIdLst>
             <p14:sldId id="258"/>
             <p14:sldId id="259"/>
@@ -530,7 +530,7 @@
           <a:p>
             <a:r>
               <a:rPr lang="en-US" dirty="0"/>
-              <a:t>Robot Perception course project, Visual Navigation Challenge: mid-term report. The picture is the mid-term maze as the robot mapped it, with the route it believed it drove from the start to the check-in.</a:t>
+              <a:t>Robot Perception course project, Visual Navigation Challenge: mid-term report. The picture is local test maze 25 drawn from the simulator’s true positions: the robot’s path from the start (blue) to the check-in (red), with the same code as the mid-term.</a:t>
             </a:r>
             <a:endParaRPr lang="en-US" dirty="0"/>
           </a:p>
@@ -706,7 +706,7 @@
           <a:p>
             <a:r>
               <a:rPr lang="en-US" dirty="0"/>
-              <a:t>Before moving: build a graph of the exploration photos, add shortcut links where AnyLoc proposes and SuperGlue confirms the same place, place every photo in metres to cost the links in steps, pick the goal photo by matching the four goal photos, and compute the cheapest route to it with Dijkstra.</a:t>
+              <a:t>Before driving, from the exploration photos alone and before connecting: build a graph of the photos, add shortcut links where AnyLoc proposes and SuperGlue confirms the same place, and place every photo in metres to cost the links in steps. When it starts, the session hands over the four goal photos: it picks the goal photo by matching them and computes the cheapest route to it with Dijkstra. None of this costs steps.</a:t>
             </a:r>
             <a:endParaRPr lang="en-US" dirty="0"/>
           </a:p>
@@ -794,7 +794,7 @@
           <a:p>
             <a:r>
               <a:rPr lang="en-US" dirty="0"/>
-              <a:t>Every move: find the closest exploration photo, take the route from it, steer to a waypoint photo by the angle SuperGlue and the essential matrix give, undo recorded moves to back out along a drive, check the route photos or re-plan when stuck, and in the last metre line up with the goal photos and check in only after three strong readings. The picture is a local test maze with the same code; the server never reveals the robot’s true path.</a:t>
+              <a:t>During the drive, every move: find the closest exploration photo, take the route from it, steer to a waypoint photo by the angle SuperGlue and the essential matrix give, undo recorded moves to back out along a drive, check the route photos or re-plan when stuck, and in the last metre line up with the goal photos and check in only after three strong readings. The pictures are real images from local test maze 25: the SuperGlue matches the robot uses to measure a turn, and the goal photo next to its camera at the check-in.</a:t>
             </a:r>
             <a:endParaRPr lang="en-US" dirty="0"/>
           </a:p>
@@ -1551,7 +1551,7 @@
                 <a:ea typeface="Cambria" pitchFamily="34" charset="-122"/>
                 <a:cs typeface="Cambria" pitchFamily="34" charset="-120"/>
               </a:rPr>
-              <a:t>[Team Name]</a:t>
+              <a:t>Team 15</a:t>
             </a:r>
             <a:endParaRPr lang="en-US" sz="3000" dirty="0"/>
           </a:p>
@@ -1607,7 +1607,7 @@
                   <a:schemeClr val="accent5"/>
                 </a:solidFill>
               </a:rPr>
-              <a:t>Arya Kishor ([NetID2])</a:t>
+              <a:t>Arya Kishor (am16454)</a:t>
             </a:r>
             <a:endParaRPr lang="en-US" sz="2000" dirty="0"/>
           </a:p>
@@ -1622,7 +1622,7 @@
         <p:spPr>
           <a:xfrm>
             <a:off x="7863840" y="960120"/>
-            <a:ext cx="3794760" cy="4572080"/>
+            <a:ext cx="3794760" cy="4297680"/>
           </a:xfrm>
           <a:prstGeom prst="roundRect">
             <a:avLst>
@@ -1642,7 +1642,7 @@
       </p:sp>
       <p:pic>
         <p:nvPicPr>
-          <p:cNvPr id="7" name="title mid-term map" descr="Top view of the mid-term maze reconstructed from the robot’s own metric map, with the route it believed it drove from the start to the check-in">    </p:cNvPr>
+          <p:cNvPr id="7" name="title maze picture" descr="Top view of local test maze 25 drawn from the simulator’s true positions: the robot’s path from the start to the goal, coloured by time from blue to red">    </p:cNvPr>
           <p:cNvPicPr>
             <a:picLocks noChangeAspect="1"/>
           </p:cNvPicPr>
@@ -1657,7 +1657,7 @@
         <p:spPr>
           <a:xfrm>
             <a:off x="8046720" y="1143000"/>
-            <a:ext cx="3429000" cy="3703400"/>
+            <a:ext cx="3429000" cy="3429000"/>
           </a:xfrm>
           <a:prstGeom prst="rect">
             <a:avLst/>
@@ -1672,7 +1672,7 @@
         </p:nvSpPr>
         <p:spPr>
           <a:xfrm>
-            <a:off x="8046720" y="4892120"/>
+            <a:off x="8046720" y="4617720"/>
             <a:ext cx="3429000" cy="548640"/>
           </a:xfrm>
           <a:prstGeom prst="rect">
@@ -1694,7 +1694,7 @@
                   <a:schemeClr val="accent5"/>
                 </a:solidFill>
               </a:rPr>
-              <a:t>The mid-term maze as the robot mapped it: its route from start to check-in (own map, not to scale)</a:t>
+              <a:t>Local test maze 25: the robot’s true path from start to goal, with the mid-term code</a:t>
             </a:r>
             <a:endParaRPr lang="en-US" sz="1050" dirty="0"/>
           </a:p>
@@ -2781,7 +2781,7 @@
                   <a:schemeClr val="tx1"/>
                 </a:solidFill>
               </a:rPr>
-              <a:t>Method (1/2): what the robot works out before it moves</a:t>
+              <a:t>Method (1/2): before driving, and when it starts</a:t>
             </a:r>
             <a:endParaRPr lang="en-US" sz="3000" dirty="0"/>
           </a:p>
@@ -2789,14 +2789,41 @@
       </p:sp>
       <p:sp>
         <p:nvSpPr>
-          <p:cNvPr id="4" name="before intro"/>
+          <p:cNvPr id="4" name="phase 1 label pill"/>
+          <p:cNvSpPr/>
+          <p:nvPr/>
+        </p:nvSpPr>
+        <p:spPr>
+          <a:xfrm>
+            <a:off x="548640" y="1371600"/>
+            <a:ext cx="7132320" cy="347472"/>
+          </a:xfrm>
+          <a:prstGeom prst="roundRect">
+            <a:avLst>
+              <a:gd name="adj" fmla="val 50000"/>
+            </a:avLst>
+          </a:prstGeom>
+          <a:solidFill>
+            <a:schemeClr val="accent5"/>
+          </a:solidFill>
+          <a:ln w="12700">
+            <a:solidFill>
+              <a:schemeClr val="accent5"/>
+            </a:solidFill>
+            <a:prstDash val="solid"/>
+          </a:ln>
+        </p:spPr>
+      </p:sp>
+      <p:sp>
+        <p:nvSpPr>
+          <p:cNvPr id="5" name="phase 1 label"/>
           <p:cNvSpPr txBox="1"/>
           <p:nvPr/>
         </p:nvSpPr>
         <p:spPr>
           <a:xfrm>
-            <a:off x="548640" y="1371600"/>
-            <a:ext cx="7132320" cy="320040"/>
+            <a:off x="731520" y="1371600"/>
+            <a:ext cx="6766560" cy="347472"/>
           </a:xfrm>
           <a:prstGeom prst="rect">
             <a:avLst/>
@@ -2812,20 +2839,20 @@
               <a:buNone/>
             </a:pPr>
             <a:r>
-              <a:rPr lang="en-US" sz="1400" i="1" dirty="0">
-                <a:solidFill>
-                  <a:schemeClr val="tx2"/>
-                </a:solidFill>
-              </a:rPr>
-              <a:t>Before its first move the robot studies the exploration photos. None of this costs steps.</a:t>
-            </a:r>
-            <a:endParaRPr lang="en-US" sz="1400" dirty="0"/>
-          </a:p>
-        </p:txBody>
-      </p:sp>
-      <p:sp>
-        <p:nvSpPr>
-          <p:cNvPr id="5" name="before step 1 circle"/>
+              <a:rPr lang="en-US" sz="1300" b="1" dirty="0">
+                <a:solidFill>
+                  <a:schemeClr val="accent1"/>
+                </a:solidFill>
+              </a:rPr>
+              <a:t>Before driving: from the exploration photos only, before connecting (no steps)</a:t>
+            </a:r>
+            <a:endParaRPr lang="en-US" sz="1300" dirty="0"/>
+          </a:p>
+        </p:txBody>
+      </p:sp>
+      <p:sp>
+        <p:nvSpPr>
+          <p:cNvPr id="6" name="before step 1 circle"/>
           <p:cNvSpPr/>
           <p:nvPr/>
         </p:nvSpPr>
@@ -2850,7 +2877,7 @@
       </p:sp>
       <p:sp>
         <p:nvSpPr>
-          <p:cNvPr id="6" name="before step 1 number"/>
+          <p:cNvPr id="7" name="before step 1 number"/>
           <p:cNvSpPr txBox="1"/>
           <p:nvPr/>
         </p:nvSpPr>
@@ -2886,14 +2913,14 @@
       </p:sp>
       <p:sp>
         <p:nvSpPr>
-          <p:cNvPr id="7" name="before step 1 text"/>
+          <p:cNvPr id="8" name="before step 1 text"/>
           <p:cNvSpPr txBox="1"/>
           <p:nvPr/>
         </p:nvSpPr>
         <p:spPr>
           <a:xfrm>
             <a:off x="978408" y="1856232"/>
-            <a:ext cx="6702552" cy="481584"/>
+            <a:ext cx="6702552" cy="466344"/>
           </a:xfrm>
           <a:prstGeom prst="rect">
             <a:avLst/>
@@ -2909,7 +2936,7 @@
               <a:buNone/>
             </a:pPr>
             <a:r>
-              <a:rPr lang="en-US" sz="1400" b="1" dirty="0">
+              <a:rPr lang="en-US" sz="1350" b="1" dirty="0">
                 <a:solidFill>
                   <a:schemeClr val="tx1"/>
                 </a:solidFill>
@@ -2920,26 +2947,26 @@
               <a:buNone/>
             </a:pPr>
             <a:r>
-              <a:rPr lang="en-US" sz="1400" dirty="0">
+              <a:rPr lang="en-US" sz="1350" dirty="0">
                 <a:solidFill>
                   <a:schemeClr val="tx2"/>
                 </a:solidFill>
               </a:rPr>
               <a:t>Every exploration photo becomes a node. Photos taken one after another on the same drive are linked, because the robot drove from one to the next.</a:t>
             </a:r>
-            <a:endParaRPr lang="en-US" sz="1400" dirty="0"/>
-          </a:p>
-        </p:txBody>
-      </p:sp>
-      <p:sp>
-        <p:nvSpPr>
-          <p:cNvPr id="8" name="before step 2 circle"/>
+            <a:endParaRPr lang="en-US" sz="1350" dirty="0"/>
+          </a:p>
+        </p:txBody>
+      </p:sp>
+      <p:sp>
+        <p:nvSpPr>
+          <p:cNvPr id="9" name="before step 2 circle"/>
           <p:cNvSpPr/>
           <p:nvPr/>
         </p:nvSpPr>
         <p:spPr>
           <a:xfrm>
-            <a:off x="548640" y="2538984"/>
+            <a:off x="548640" y="2478024"/>
             <a:ext cx="292608" cy="292608"/>
           </a:xfrm>
           <a:prstGeom prst="ellipse">
@@ -2958,13 +2985,13 @@
       </p:sp>
       <p:sp>
         <p:nvSpPr>
-          <p:cNvPr id="9" name="before step 2 number"/>
+          <p:cNvPr id="10" name="before step 2 number"/>
           <p:cNvSpPr txBox="1"/>
           <p:nvPr/>
         </p:nvSpPr>
         <p:spPr>
           <a:xfrm>
-            <a:off x="548640" y="2538984"/>
+            <a:off x="548640" y="2478024"/>
             <a:ext cx="292608" cy="292608"/>
           </a:xfrm>
           <a:prstGeom prst="rect">
@@ -2994,14 +3021,14 @@
       </p:sp>
       <p:sp>
         <p:nvSpPr>
-          <p:cNvPr id="10" name="before step 2 text"/>
+          <p:cNvPr id="11" name="before step 2 text"/>
           <p:cNvSpPr txBox="1"/>
           <p:nvPr/>
         </p:nvSpPr>
         <p:spPr>
           <a:xfrm>
-            <a:off x="978408" y="2520696"/>
-            <a:ext cx="6702552" cy="1121664"/>
+            <a:off x="978408" y="2459736"/>
+            <a:ext cx="6702552" cy="1083564"/>
           </a:xfrm>
           <a:prstGeom prst="rect">
             <a:avLst/>
@@ -3017,7 +3044,7 @@
               <a:buNone/>
             </a:pPr>
             <a:r>
-              <a:rPr lang="en-US" sz="1400" b="1" dirty="0">
+              <a:rPr lang="en-US" sz="1350" b="1" dirty="0">
                 <a:solidFill>
                   <a:schemeClr val="tx1"/>
                 </a:solidFill>
@@ -3028,26 +3055,26 @@
               <a:buNone/>
             </a:pPr>
             <a:r>
-              <a:rPr lang="en-US" sz="1400" dirty="0">
+              <a:rPr lang="en-US" sz="1350" dirty="0">
                 <a:solidFill>
                   <a:schemeClr val="tx2"/>
                 </a:solidFill>
               </a:rPr>
               <a:t>AnyLoc (DINOv2 features + VLAD) compares every photo with the photos taken at other times (on another drive, or much later on the same drive) and proposes pairs that look like the same place. SuperGlue then matches keypoints between the two photos of each pair, and the pair is kept only if the matches fit one camera motion (RANSAC) for 8 or more pairs in a row. Each kept pair becomes a shortcut link.</a:t>
             </a:r>
-            <a:endParaRPr lang="en-US" sz="1400" dirty="0"/>
-          </a:p>
-        </p:txBody>
-      </p:sp>
-      <p:sp>
-        <p:nvSpPr>
-          <p:cNvPr id="11" name="before step 3 circle"/>
+            <a:endParaRPr lang="en-US" sz="1350" dirty="0"/>
+          </a:p>
+        </p:txBody>
+      </p:sp>
+      <p:sp>
+        <p:nvSpPr>
+          <p:cNvPr id="12" name="before step 3 circle"/>
           <p:cNvSpPr/>
           <p:nvPr/>
         </p:nvSpPr>
         <p:spPr>
           <a:xfrm>
-            <a:off x="548640" y="3843528"/>
+            <a:off x="548640" y="3698748"/>
             <a:ext cx="292608" cy="292608"/>
           </a:xfrm>
           <a:prstGeom prst="ellipse">
@@ -3066,13 +3093,13 @@
       </p:sp>
       <p:sp>
         <p:nvSpPr>
-          <p:cNvPr id="12" name="before step 3 number"/>
+          <p:cNvPr id="13" name="before step 3 number"/>
           <p:cNvSpPr txBox="1"/>
           <p:nvPr/>
         </p:nvSpPr>
         <p:spPr>
           <a:xfrm>
-            <a:off x="548640" y="3843528"/>
+            <a:off x="548640" y="3698748"/>
             <a:ext cx="292608" cy="292608"/>
           </a:xfrm>
           <a:prstGeom prst="rect">
@@ -3102,14 +3129,14 @@
       </p:sp>
       <p:sp>
         <p:nvSpPr>
-          <p:cNvPr id="13" name="before step 3 text"/>
+          <p:cNvPr id="14" name="before step 3 text"/>
           <p:cNvSpPr txBox="1"/>
           <p:nvPr/>
         </p:nvSpPr>
         <p:spPr>
           <a:xfrm>
-            <a:off x="978408" y="3825240"/>
-            <a:ext cx="6702552" cy="694944"/>
+            <a:off x="978408" y="3680460"/>
+            <a:ext cx="6702552" cy="672084"/>
           </a:xfrm>
           <a:prstGeom prst="rect">
             <a:avLst/>
@@ -3125,7 +3152,7 @@
               <a:buNone/>
             </a:pPr>
             <a:r>
-              <a:rPr lang="en-US" sz="1400" b="1" dirty="0">
+              <a:rPr lang="en-US" sz="1350" b="1" dirty="0">
                 <a:solidFill>
                   <a:schemeClr val="tx1"/>
                 </a:solidFill>
@@ -3136,26 +3163,89 @@
               <a:buNone/>
             </a:pPr>
             <a:r>
-              <a:rPr lang="en-US" sz="1400" dirty="0">
+              <a:rPr lang="en-US" sz="1350" dirty="0">
                 <a:solidFill>
                   <a:schemeClr val="tx2"/>
                 </a:solidFill>
               </a:rPr>
               <a:t>Lines on the walls give a compass direction, SuperGlue gives the turn between neighbouring photos, and the links close the loops. This places every photo in metres, so each link gets a cost in steps.</a:t>
             </a:r>
-            <a:endParaRPr lang="en-US" sz="1400" dirty="0"/>
-          </a:p>
-        </p:txBody>
-      </p:sp>
-      <p:sp>
-        <p:nvSpPr>
-          <p:cNvPr id="14" name="before step 4 circle"/>
+            <a:endParaRPr lang="en-US" sz="1350" dirty="0"/>
+          </a:p>
+        </p:txBody>
+      </p:sp>
+      <p:sp>
+        <p:nvSpPr>
+          <p:cNvPr id="15" name="phase 2 label pill"/>
           <p:cNvSpPr/>
           <p:nvPr/>
         </p:nvSpPr>
         <p:spPr>
           <a:xfrm>
-            <a:off x="548640" y="4721352"/>
+            <a:off x="548640" y="4553712"/>
+            <a:ext cx="7132320" cy="347472"/>
+          </a:xfrm>
+          <a:prstGeom prst="roundRect">
+            <a:avLst>
+              <a:gd name="adj" fmla="val 50000"/>
+            </a:avLst>
+          </a:prstGeom>
+          <a:solidFill>
+            <a:schemeClr val="accent5"/>
+          </a:solidFill>
+          <a:ln w="12700">
+            <a:solidFill>
+              <a:schemeClr val="accent5"/>
+            </a:solidFill>
+            <a:prstDash val="solid"/>
+          </a:ln>
+        </p:spPr>
+      </p:sp>
+      <p:sp>
+        <p:nvSpPr>
+          <p:cNvPr id="16" name="phase 2 label"/>
+          <p:cNvSpPr txBox="1"/>
+          <p:nvPr/>
+        </p:nvSpPr>
+        <p:spPr>
+          <a:xfrm>
+            <a:off x="731520" y="4553712"/>
+            <a:ext cx="6766560" cy="347472"/>
+          </a:xfrm>
+          <a:prstGeom prst="rect">
+            <a:avLst/>
+          </a:prstGeom>
+          <a:noFill/>
+          <a:ln/>
+        </p:spPr>
+        <p:txBody>
+          <a:bodyPr wrap="square" lIns="0" tIns="0" rIns="0" bIns="0" rtlCol="0" anchor="ctr"/>
+          <a:lstStyle/>
+          <a:p>
+            <a:pPr indent="0" marL="0">
+              <a:buNone/>
+            </a:pPr>
+            <a:r>
+              <a:rPr lang="en-US" sz="1300" b="1" dirty="0">
+                <a:solidFill>
+                  <a:schemeClr val="accent1"/>
+                </a:solidFill>
+              </a:rPr>
+              <a:t>When it starts: the four goal photos arrive with the session (still no steps)</a:t>
+            </a:r>
+            <a:endParaRPr lang="en-US" sz="1300" dirty="0"/>
+          </a:p>
+        </p:txBody>
+      </p:sp>
+      <p:sp>
+        <p:nvSpPr>
+          <p:cNvPr id="17" name="start step 1 circle"/>
+          <p:cNvSpPr/>
+          <p:nvPr/>
+        </p:nvSpPr>
+        <p:spPr>
+          <a:xfrm>
+            <a:off x="548640" y="5056632"/>
             <a:ext cx="292608" cy="292608"/>
           </a:xfrm>
           <a:prstGeom prst="ellipse">
@@ -3174,13 +3264,13 @@
       </p:sp>
       <p:sp>
         <p:nvSpPr>
-          <p:cNvPr id="15" name="before step 4 number"/>
+          <p:cNvPr id="18" name="start step 1 number"/>
           <p:cNvSpPr txBox="1"/>
           <p:nvPr/>
         </p:nvSpPr>
         <p:spPr>
           <a:xfrm>
-            <a:off x="548640" y="4721352"/>
+            <a:off x="548640" y="5056632"/>
             <a:ext cx="292608" cy="292608"/>
           </a:xfrm>
           <a:prstGeom prst="rect">
@@ -3210,14 +3300,14 @@
       </p:sp>
       <p:sp>
         <p:nvSpPr>
-          <p:cNvPr id="16" name="before step 4 text"/>
+          <p:cNvPr id="19" name="start step 1 text"/>
           <p:cNvSpPr txBox="1"/>
           <p:nvPr/>
         </p:nvSpPr>
         <p:spPr>
           <a:xfrm>
-            <a:off x="978408" y="4703064"/>
-            <a:ext cx="6702552" cy="694944"/>
+            <a:off x="978408" y="5038344"/>
+            <a:ext cx="6702552" cy="466344"/>
           </a:xfrm>
           <a:prstGeom prst="rect">
             <a:avLst/>
@@ -3233,7 +3323,7 @@
               <a:buNone/>
             </a:pPr>
             <a:r>
-              <a:rPr lang="en-US" sz="1400" b="1" dirty="0">
+              <a:rPr lang="en-US" sz="1350" b="1" dirty="0">
                 <a:solidFill>
                   <a:schemeClr val="tx1"/>
                 </a:solidFill>
@@ -3244,26 +3334,26 @@
               <a:buNone/>
             </a:pPr>
             <a:r>
-              <a:rPr lang="en-US" sz="1400" dirty="0">
+              <a:rPr lang="en-US" sz="1350" dirty="0">
                 <a:solidFill>
                   <a:schemeClr val="tx2"/>
                 </a:solidFill>
               </a:rPr>
               <a:t>Each of the 4 goal photos is compared with the 64 exploration photos AnyLoc finds most similar. The exploration photo with the most SuperGlue matches becomes the goal node.</a:t>
             </a:r>
-            <a:endParaRPr lang="en-US" sz="1400" dirty="0"/>
-          </a:p>
-        </p:txBody>
-      </p:sp>
-      <p:sp>
-        <p:nvSpPr>
-          <p:cNvPr id="17" name="before step 5 circle"/>
+            <a:endParaRPr lang="en-US" sz="1350" dirty="0"/>
+          </a:p>
+        </p:txBody>
+      </p:sp>
+      <p:sp>
+        <p:nvSpPr>
+          <p:cNvPr id="20" name="start step 2 circle"/>
           <p:cNvSpPr/>
           <p:nvPr/>
         </p:nvSpPr>
         <p:spPr>
           <a:xfrm>
-            <a:off x="548640" y="5599176"/>
+            <a:off x="548640" y="5660136"/>
             <a:ext cx="292608" cy="292608"/>
           </a:xfrm>
           <a:prstGeom prst="ellipse">
@@ -3282,13 +3372,13 @@
       </p:sp>
       <p:sp>
         <p:nvSpPr>
-          <p:cNvPr id="18" name="before step 5 number"/>
+          <p:cNvPr id="21" name="start step 2 number"/>
           <p:cNvSpPr txBox="1"/>
           <p:nvPr/>
         </p:nvSpPr>
         <p:spPr>
           <a:xfrm>
-            <a:off x="548640" y="5599176"/>
+            <a:off x="548640" y="5660136"/>
             <a:ext cx="292608" cy="292608"/>
           </a:xfrm>
           <a:prstGeom prst="rect">
@@ -3318,14 +3408,14 @@
       </p:sp>
       <p:sp>
         <p:nvSpPr>
-          <p:cNvPr id="19" name="before step 5 text"/>
+          <p:cNvPr id="22" name="start step 2 text"/>
           <p:cNvSpPr txBox="1"/>
           <p:nvPr/>
         </p:nvSpPr>
         <p:spPr>
           <a:xfrm>
-            <a:off x="978408" y="5580888"/>
-            <a:ext cx="6702552" cy="481584"/>
+            <a:off x="978408" y="5641848"/>
+            <a:ext cx="6702552" cy="260604"/>
           </a:xfrm>
           <a:prstGeom prst="rect">
             <a:avLst/>
@@ -3341,7 +3431,7 @@
               <a:buNone/>
             </a:pPr>
             <a:r>
-              <a:rPr lang="en-US" sz="1400" b="1" dirty="0">
+              <a:rPr lang="en-US" sz="1350" b="1" dirty="0">
                 <a:solidFill>
                   <a:schemeClr val="tx1"/>
                 </a:solidFill>
@@ -3352,20 +3442,20 @@
               <a:buNone/>
             </a:pPr>
             <a:r>
-              <a:rPr lang="en-US" sz="1400" dirty="0">
+              <a:rPr lang="en-US" sz="1350" dirty="0">
                 <a:solidFill>
                   <a:schemeClr val="tx2"/>
                 </a:solidFill>
               </a:rPr>
               <a:t>Dijkstra finds the cheapest route, in steps, from every photo to the goal node.</a:t>
             </a:r>
-            <a:endParaRPr lang="en-US" sz="1400" dirty="0"/>
+            <a:endParaRPr lang="en-US" sz="1350" dirty="0"/>
           </a:p>
         </p:txBody>
       </p:sp>
       <p:pic>
         <p:nvPicPr>
-          <p:cNvPr id="20" name="goal example 1" descr="Local maze 25: goal photo it is given">    </p:cNvPr>
+          <p:cNvPr id="23" name="goal example 1" descr="Local maze 25: goal photo it is given">    </p:cNvPr>
           <p:cNvPicPr>
             <a:picLocks noChangeAspect="1"/>
           </p:cNvPicPr>
@@ -3389,7 +3479,7 @@
       </p:pic>
       <p:sp>
         <p:nvSpPr>
-          <p:cNvPr id="21" name="goal example label 1"/>
+          <p:cNvPr id="24" name="goal example label 1"/>
           <p:cNvSpPr txBox="1"/>
           <p:nvPr/>
         </p:nvSpPr>
@@ -3425,7 +3515,7 @@
       </p:sp>
       <p:pic>
         <p:nvPicPr>
-          <p:cNvPr id="22" name="goal example 2" descr="Local maze 25: exploration photo it picks as the goal (step 4)">    </p:cNvPr>
+          <p:cNvPr id="25" name="goal example 2" descr="Local maze 25: exploration photo it picks as the goal (step 4)">    </p:cNvPr>
           <p:cNvPicPr>
             <a:picLocks noChangeAspect="1"/>
           </p:cNvPicPr>
@@ -3449,7 +3539,7 @@
       </p:pic>
       <p:sp>
         <p:nvSpPr>
-          <p:cNvPr id="23" name="goal example label 2"/>
+          <p:cNvPr id="26" name="goal example label 2"/>
           <p:cNvSpPr txBox="1"/>
           <p:nvPr/>
         </p:nvSpPr>
@@ -3485,7 +3575,7 @@
       </p:sp>
       <p:sp>
         <p:nvSpPr>
-          <p:cNvPr id="24" name="goal example caption"/>
+          <p:cNvPr id="27" name="goal example caption"/>
           <p:cNvSpPr txBox="1"/>
           <p:nvPr/>
         </p:nvSpPr>
@@ -3616,7 +3706,7 @@
             <a:r>
               <a:rPr lang="en-US" sz="1100" b="1" spc="200" kern="0" dirty="0">
                 <a:solidFill>
-                  <a:schemeClr val="accent1"/>
+                  <a:schemeClr val="accent2"/>
                 </a:solidFill>
               </a:rPr>
               <a:t>METHOD  ·  2 OF 2</a:t>
@@ -3657,7 +3747,7 @@
                   <a:schemeClr val="tx1"/>
                 </a:solidFill>
               </a:rPr>
-              <a:t>Method (2/2): how the robot moves</a:t>
+              <a:t>Method (2/2): during the drive</a:t>
             </a:r>
             <a:endParaRPr lang="en-US" sz="3000" dirty="0"/>
           </a:p>
@@ -3665,60 +3755,26 @@
       </p:sp>
       <p:sp>
         <p:nvSpPr>
-          <p:cNvPr id="4" name="moving intro"/>
-          <p:cNvSpPr txBox="1"/>
+          <p:cNvPr id="4" name="phase 3 label pill"/>
+          <p:cNvSpPr/>
           <p:nvPr/>
         </p:nvSpPr>
         <p:spPr>
           <a:xfrm>
             <a:off x="548640" y="1371600"/>
-            <a:ext cx="7132320" cy="320040"/>
-          </a:xfrm>
-          <a:prstGeom prst="rect">
-            <a:avLst/>
-          </a:prstGeom>
-          <a:noFill/>
-          <a:ln/>
-        </p:spPr>
-        <p:txBody>
-          <a:bodyPr wrap="square" lIns="0" tIns="0" rIns="0" bIns="0" rtlCol="0" anchor="ctr"/>
-          <a:lstStyle/>
-          <a:p>
-            <a:pPr indent="0" marL="0">
-              <a:buNone/>
-            </a:pPr>
-            <a:r>
-              <a:rPr lang="en-US" sz="1400" i="1" dirty="0">
-                <a:solidFill>
-                  <a:schemeClr val="tx2"/>
-                </a:solidFill>
-              </a:rPr>
-              <a:t>Then it repeats these steps for every move until it checks in.</a:t>
-            </a:r>
-            <a:endParaRPr lang="en-US" sz="1400" dirty="0"/>
-          </a:p>
-        </p:txBody>
-      </p:sp>
-      <p:sp>
-        <p:nvSpPr>
-          <p:cNvPr id="5" name="moving step 1 circle"/>
-          <p:cNvSpPr/>
-          <p:nvPr/>
-        </p:nvSpPr>
-        <p:spPr>
-          <a:xfrm>
-            <a:off x="548640" y="1828800"/>
-            <a:ext cx="292608" cy="292608"/>
-          </a:xfrm>
-          <a:prstGeom prst="ellipse">
-            <a:avLst/>
+            <a:ext cx="7315200" cy="347472"/>
+          </a:xfrm>
+          <a:prstGeom prst="roundRect">
+            <a:avLst>
+              <a:gd name="adj" fmla="val 50000"/>
+            </a:avLst>
           </a:prstGeom>
           <a:solidFill>
-            <a:schemeClr val="accent1"/>
+            <a:schemeClr val="accent6"/>
           </a:solidFill>
           <a:ln w="12700">
             <a:solidFill>
-              <a:schemeClr val="accent1"/>
+              <a:schemeClr val="accent6"/>
             </a:solidFill>
             <a:prstDash val="solid"/>
           </a:ln>
@@ -3726,107 +3782,60 @@
       </p:sp>
       <p:sp>
         <p:nvSpPr>
-          <p:cNvPr id="6" name="moving step 1 number"/>
+          <p:cNvPr id="5" name="phase 3 label"/>
           <p:cNvSpPr txBox="1"/>
           <p:nvPr/>
         </p:nvSpPr>
         <p:spPr>
           <a:xfrm>
-            <a:off x="548640" y="1828800"/>
+            <a:off x="731520" y="1371600"/>
+            <a:ext cx="6949440" cy="347472"/>
+          </a:xfrm>
+          <a:prstGeom prst="rect">
+            <a:avLst/>
+          </a:prstGeom>
+          <a:noFill/>
+          <a:ln/>
+        </p:spPr>
+        <p:txBody>
+          <a:bodyPr wrap="square" lIns="0" tIns="0" rIns="0" bIns="0" rtlCol="0" anchor="ctr"/>
+          <a:lstStyle/>
+          <a:p>
+            <a:pPr indent="0" marL="0">
+              <a:buNone/>
+            </a:pPr>
+            <a:r>
+              <a:rPr lang="en-US" sz="1300" b="1" dirty="0">
+                <a:solidFill>
+                  <a:schemeClr val="accent2"/>
+                </a:solidFill>
+              </a:rPr>
+              <a:t>During the drive: these steps repeat for every move until it checks in</a:t>
+            </a:r>
+            <a:endParaRPr lang="en-US" sz="1300" dirty="0"/>
+          </a:p>
+        </p:txBody>
+      </p:sp>
+      <p:sp>
+        <p:nvSpPr>
+          <p:cNvPr id="6" name="drive step 1 circle"/>
+          <p:cNvSpPr/>
+          <p:nvPr/>
+        </p:nvSpPr>
+        <p:spPr>
+          <a:xfrm>
+            <a:off x="548640" y="1874520"/>
             <a:ext cx="292608" cy="292608"/>
           </a:xfrm>
-          <a:prstGeom prst="rect">
-            <a:avLst/>
-          </a:prstGeom>
-          <a:noFill/>
-          <a:ln/>
-        </p:spPr>
-        <p:txBody>
-          <a:bodyPr wrap="square" lIns="0" tIns="0" rIns="0" bIns="0" rtlCol="0" anchor="ctr"/>
-          <a:lstStyle/>
-          <a:p>
-            <a:pPr algn="ctr" indent="0" marL="0">
-              <a:buNone/>
-            </a:pPr>
-            <a:r>
-              <a:rPr lang="en-US" sz="1300" b="1" dirty="0">
-                <a:solidFill>
-                  <a:schemeClr val="bg1"/>
-                </a:solidFill>
-              </a:rPr>
-              <a:t>1</a:t>
-            </a:r>
-            <a:endParaRPr lang="en-US" sz="1300" dirty="0"/>
-          </a:p>
-        </p:txBody>
-      </p:sp>
-      <p:sp>
-        <p:nvSpPr>
-          <p:cNvPr id="7" name="moving step 1 text"/>
-          <p:cNvSpPr txBox="1"/>
-          <p:nvPr/>
-        </p:nvSpPr>
-        <p:spPr>
-          <a:xfrm>
-            <a:off x="978408" y="1810512"/>
-            <a:ext cx="6702552" cy="649224"/>
-          </a:xfrm>
-          <a:prstGeom prst="rect">
-            <a:avLst/>
-          </a:prstGeom>
-          <a:noFill/>
-          <a:ln/>
-        </p:spPr>
-        <p:txBody>
-          <a:bodyPr wrap="square" lIns="0" tIns="0" rIns="0" bIns="0" rtlCol="0" anchor="t"/>
-          <a:lstStyle/>
-          <a:p>
-            <a:pPr indent="0" marL="0">
-              <a:buNone/>
-            </a:pPr>
-            <a:r>
-              <a:rPr lang="en-US" sz="1300" b="1" dirty="0">
-                <a:solidFill>
-                  <a:schemeClr val="tx1"/>
-                </a:solidFill>
-              </a:rPr>
-              <a:t>Where am I? </a:t>
-            </a:r>
-            <a:pPr indent="0" marL="0">
-              <a:buNone/>
-            </a:pPr>
-            <a:r>
-              <a:rPr lang="en-US" sz="1300" dirty="0">
-                <a:solidFill>
-                  <a:schemeClr val="tx2"/>
-                </a:solidFill>
-              </a:rPr>
-              <a:t>It compares the camera image with the exploration photos near its last position (AnyLoc). A jump to a far part of the map is believed only if 3 images in a row agree and SuperGlue confirms the match.</a:t>
-            </a:r>
-            <a:endParaRPr lang="en-US" sz="1300" dirty="0"/>
-          </a:p>
-        </p:txBody>
-      </p:sp>
-      <p:sp>
-        <p:nvSpPr>
-          <p:cNvPr id="8" name="moving step 2 circle"/>
-          <p:cNvSpPr/>
-          <p:nvPr/>
-        </p:nvSpPr>
-        <p:spPr>
-          <a:xfrm>
-            <a:off x="548640" y="2606040"/>
-            <a:ext cx="292608" cy="292608"/>
-          </a:xfrm>
           <a:prstGeom prst="ellipse">
             <a:avLst/>
           </a:prstGeom>
           <a:solidFill>
-            <a:schemeClr val="accent1"/>
+            <a:schemeClr val="accent2"/>
           </a:solidFill>
           <a:ln w="12700">
             <a:solidFill>
-              <a:schemeClr val="accent1"/>
+              <a:schemeClr val="accent2"/>
             </a:solidFill>
             <a:prstDash val="solid"/>
           </a:ln>
@@ -3834,13 +3843,13 @@
       </p:sp>
       <p:sp>
         <p:nvSpPr>
-          <p:cNvPr id="9" name="moving step 2 number"/>
+          <p:cNvPr id="7" name="drive step 1 number"/>
           <p:cNvSpPr txBox="1"/>
           <p:nvPr/>
         </p:nvSpPr>
         <p:spPr>
           <a:xfrm>
-            <a:off x="548640" y="2606040"/>
+            <a:off x="548640" y="1874520"/>
             <a:ext cx="292608" cy="292608"/>
           </a:xfrm>
           <a:prstGeom prst="rect">
@@ -3862,7 +3871,7 @@
                   <a:schemeClr val="bg1"/>
                 </a:solidFill>
               </a:rPr>
-              <a:t>2</a:t>
+              <a:t>1</a:t>
             </a:r>
             <a:endParaRPr lang="en-US" sz="1300" dirty="0"/>
           </a:p>
@@ -3870,14 +3879,14 @@
       </p:sp>
       <p:sp>
         <p:nvSpPr>
-          <p:cNvPr id="10" name="moving step 2 text"/>
+          <p:cNvPr id="8" name="drive step 1 text"/>
           <p:cNvSpPr txBox="1"/>
           <p:nvPr/>
         </p:nvSpPr>
         <p:spPr>
           <a:xfrm>
-            <a:off x="978408" y="2587752"/>
-            <a:ext cx="6702552" cy="451104"/>
+            <a:off x="978408" y="1856232"/>
+            <a:ext cx="6885432" cy="649224"/>
           </a:xfrm>
           <a:prstGeom prst="rect">
             <a:avLst/>
@@ -3898,7 +3907,7 @@
                   <a:schemeClr val="tx1"/>
                 </a:solidFill>
               </a:rPr>
-              <a:t>Where next? </a:t>
+              <a:t>Where am I? </a:t>
             </a:r>
             <a:pPr indent="0" marL="0">
               <a:buNone/>
@@ -3909,7 +3918,7 @@
                   <a:schemeClr val="tx2"/>
                 </a:solidFill>
               </a:rPr>
-              <a:t>It looks up the route from that photo and picks a waypoint photo a few steps ahead on it.</a:t>
+              <a:t>It compares the camera image with the exploration photos near its last position (AnyLoc). A jump to a far part of the map is believed only if 3 images in a row agree and SuperGlue confirms the match.</a:t>
             </a:r>
             <a:endParaRPr lang="en-US" sz="1300" dirty="0"/>
           </a:p>
@@ -3917,24 +3926,24 @@
       </p:sp>
       <p:sp>
         <p:nvSpPr>
-          <p:cNvPr id="11" name="moving step 3 circle"/>
+          <p:cNvPr id="9" name="drive step 2 circle"/>
           <p:cNvSpPr/>
           <p:nvPr/>
         </p:nvSpPr>
         <p:spPr>
           <a:xfrm>
-            <a:off x="548640" y="3185160"/>
+            <a:off x="548640" y="2706624"/>
             <a:ext cx="292608" cy="292608"/>
           </a:xfrm>
           <a:prstGeom prst="ellipse">
             <a:avLst/>
           </a:prstGeom>
           <a:solidFill>
-            <a:schemeClr val="accent1"/>
+            <a:schemeClr val="accent2"/>
           </a:solidFill>
           <a:ln w="12700">
             <a:solidFill>
-              <a:schemeClr val="accent1"/>
+              <a:schemeClr val="accent2"/>
             </a:solidFill>
             <a:prstDash val="solid"/>
           </a:ln>
@@ -3942,13 +3951,13 @@
       </p:sp>
       <p:sp>
         <p:nvSpPr>
-          <p:cNvPr id="12" name="moving step 3 number"/>
+          <p:cNvPr id="10" name="drive step 2 number"/>
           <p:cNvSpPr txBox="1"/>
           <p:nvPr/>
         </p:nvSpPr>
         <p:spPr>
           <a:xfrm>
-            <a:off x="548640" y="3185160"/>
+            <a:off x="548640" y="2706624"/>
             <a:ext cx="292608" cy="292608"/>
           </a:xfrm>
           <a:prstGeom prst="rect">
@@ -3970,7 +3979,7 @@
                   <a:schemeClr val="bg1"/>
                 </a:solidFill>
               </a:rPr>
-              <a:t>3</a:t>
+              <a:t>2</a:t>
             </a:r>
             <a:endParaRPr lang="en-US" sz="1300" dirty="0"/>
           </a:p>
@@ -3978,14 +3987,14 @@
       </p:sp>
       <p:sp>
         <p:nvSpPr>
-          <p:cNvPr id="13" name="moving step 3 text"/>
+          <p:cNvPr id="11" name="drive step 2 text"/>
           <p:cNvSpPr txBox="1"/>
           <p:nvPr/>
         </p:nvSpPr>
         <p:spPr>
           <a:xfrm>
-            <a:off x="978408" y="3166872"/>
-            <a:ext cx="6702552" cy="847344"/>
+            <a:off x="978408" y="2688336"/>
+            <a:ext cx="6885432" cy="252984"/>
           </a:xfrm>
           <a:prstGeom prst="rect">
             <a:avLst/>
@@ -4006,7 +4015,7 @@
                   <a:schemeClr val="tx1"/>
                 </a:solidFill>
               </a:rPr>
-              <a:t>Turn and drive. </a:t>
+              <a:t>Where next? </a:t>
             </a:r>
             <a:pPr indent="0" marL="0">
               <a:buNone/>
@@ -4017,7 +4026,7 @@
                   <a:schemeClr val="tx2"/>
                 </a:solidFill>
               </a:rPr>
-              <a:t>SuperGlue matches the camera image with the waypoint photo, and the essential matrix between them gives the angle to turn. It turns by that angle, then drives forward. If the waypoint is not in view it turns on the spot to find it; if nothing matches, the L network picks the move.</a:t>
+              <a:t>It looks up the route from that photo and picks a waypoint photo a few steps ahead.</a:t>
             </a:r>
             <a:endParaRPr lang="en-US" sz="1300" dirty="0"/>
           </a:p>
@@ -4025,24 +4034,24 @@
       </p:sp>
       <p:sp>
         <p:nvSpPr>
-          <p:cNvPr id="14" name="moving step 4 circle"/>
+          <p:cNvPr id="12" name="drive step 3 circle"/>
           <p:cNvSpPr/>
           <p:nvPr/>
         </p:nvSpPr>
         <p:spPr>
           <a:xfrm>
-            <a:off x="548640" y="4160520"/>
+            <a:off x="548640" y="3142488"/>
             <a:ext cx="292608" cy="292608"/>
           </a:xfrm>
           <a:prstGeom prst="ellipse">
             <a:avLst/>
           </a:prstGeom>
           <a:solidFill>
-            <a:schemeClr val="accent1"/>
+            <a:schemeClr val="accent2"/>
           </a:solidFill>
           <a:ln w="12700">
             <a:solidFill>
-              <a:schemeClr val="accent1"/>
+              <a:schemeClr val="accent2"/>
             </a:solidFill>
             <a:prstDash val="solid"/>
           </a:ln>
@@ -4050,13 +4059,13 @@
       </p:sp>
       <p:sp>
         <p:nvSpPr>
-          <p:cNvPr id="15" name="moving step 4 number"/>
+          <p:cNvPr id="13" name="drive step 3 number"/>
           <p:cNvSpPr txBox="1"/>
           <p:nvPr/>
         </p:nvSpPr>
         <p:spPr>
           <a:xfrm>
-            <a:off x="548640" y="4160520"/>
+            <a:off x="548640" y="3142488"/>
             <a:ext cx="292608" cy="292608"/>
           </a:xfrm>
           <a:prstGeom prst="rect">
@@ -4078,7 +4087,7 @@
                   <a:schemeClr val="bg1"/>
                 </a:solidFill>
               </a:rPr>
-              <a:t>4</a:t>
+              <a:t>3</a:t>
             </a:r>
             <a:endParaRPr lang="en-US" sz="1300" dirty="0"/>
           </a:p>
@@ -4086,14 +4095,14 @@
       </p:sp>
       <p:sp>
         <p:nvSpPr>
-          <p:cNvPr id="16" name="moving step 4 text"/>
+          <p:cNvPr id="14" name="drive step 3 text"/>
           <p:cNvSpPr txBox="1"/>
           <p:nvPr/>
         </p:nvSpPr>
         <p:spPr>
           <a:xfrm>
-            <a:off x="978408" y="4142232"/>
-            <a:ext cx="6702552" cy="451104"/>
+            <a:off x="978408" y="3124200"/>
+            <a:ext cx="6885432" cy="847344"/>
           </a:xfrm>
           <a:prstGeom prst="rect">
             <a:avLst/>
@@ -4114,7 +4123,7 @@
                   <a:schemeClr val="tx1"/>
                 </a:solidFill>
               </a:rPr>
-              <a:t>Backing out. </a:t>
+              <a:t>Turn and drive. </a:t>
             </a:r>
             <a:pPr indent="0" marL="0">
               <a:buNone/>
@@ -4125,7 +4134,7 @@
                   <a:schemeClr val="tx2"/>
                 </a:solidFill>
               </a:rPr>
-              <a:t>When the route runs back along a drive, for example out of a dead end, it undoes the recorded moves in reverse: a recorded left turn is undone by turning right.</a:t>
+              <a:t>SuperGlue matches the camera image with the waypoint photo, and the essential matrix between them gives the angle to turn. It turns by that angle, then drives forward. If the waypoint is not in view it turns on the spot to find it; if nothing matches, the L network picks the move.</a:t>
             </a:r>
             <a:endParaRPr lang="en-US" sz="1300" dirty="0"/>
           </a:p>
@@ -4133,24 +4142,24 @@
       </p:sp>
       <p:sp>
         <p:nvSpPr>
-          <p:cNvPr id="17" name="moving step 5 circle"/>
+          <p:cNvPr id="15" name="drive step 4 circle"/>
           <p:cNvSpPr/>
           <p:nvPr/>
         </p:nvSpPr>
         <p:spPr>
           <a:xfrm>
-            <a:off x="548640" y="4739640"/>
+            <a:off x="548640" y="4172712"/>
             <a:ext cx="292608" cy="292608"/>
           </a:xfrm>
           <a:prstGeom prst="ellipse">
             <a:avLst/>
           </a:prstGeom>
           <a:solidFill>
-            <a:schemeClr val="accent1"/>
+            <a:schemeClr val="accent2"/>
           </a:solidFill>
           <a:ln w="12700">
             <a:solidFill>
-              <a:schemeClr val="accent1"/>
+              <a:schemeClr val="accent2"/>
             </a:solidFill>
             <a:prstDash val="solid"/>
           </a:ln>
@@ -4158,13 +4167,13 @@
       </p:sp>
       <p:sp>
         <p:nvSpPr>
-          <p:cNvPr id="18" name="moving step 5 number"/>
+          <p:cNvPr id="16" name="drive step 4 number"/>
           <p:cNvSpPr txBox="1"/>
           <p:nvPr/>
         </p:nvSpPr>
         <p:spPr>
           <a:xfrm>
-            <a:off x="548640" y="4739640"/>
+            <a:off x="548640" y="4172712"/>
             <a:ext cx="292608" cy="292608"/>
           </a:xfrm>
           <a:prstGeom prst="rect">
@@ -4186,7 +4195,7 @@
                   <a:schemeClr val="bg1"/>
                 </a:solidFill>
               </a:rPr>
-              <a:t>5</a:t>
+              <a:t>4</a:t>
             </a:r>
             <a:endParaRPr lang="en-US" sz="1300" dirty="0"/>
           </a:p>
@@ -4194,14 +4203,14 @@
       </p:sp>
       <p:sp>
         <p:nvSpPr>
-          <p:cNvPr id="19" name="moving step 5 text"/>
+          <p:cNvPr id="17" name="drive step 4 text"/>
           <p:cNvSpPr txBox="1"/>
           <p:nvPr/>
         </p:nvSpPr>
         <p:spPr>
           <a:xfrm>
-            <a:off x="978408" y="4721352"/>
-            <a:ext cx="6702552" cy="649224"/>
+            <a:off x="978408" y="4154424"/>
+            <a:ext cx="6885432" cy="451104"/>
           </a:xfrm>
           <a:prstGeom prst="rect">
             <a:avLst/>
@@ -4222,7 +4231,7 @@
                   <a:schemeClr val="tx1"/>
                 </a:solidFill>
               </a:rPr>
-              <a:t>When stuck. </a:t>
+              <a:t>Backing out. </a:t>
             </a:r>
             <a:pPr indent="0" marL="0">
               <a:buNone/>
@@ -4233,7 +4242,7 @@
                   <a:schemeClr val="tx2"/>
                 </a:solidFill>
               </a:rPr>
-              <a:t>If it believes it is at the same photo for 3 moves, it checks the next 5 route photos with SuperGlue. If it gets no closer for 150 steps, that stretch of the route is made more expensive and the route is planned again.</a:t>
+              <a:t>When the route runs back along a drive, for example out of a dead end, it undoes the recorded moves in reverse: a recorded left turn is undone by turning right.</a:t>
             </a:r>
             <a:endParaRPr lang="en-US" sz="1300" dirty="0"/>
           </a:p>
@@ -4241,24 +4250,24 @@
       </p:sp>
       <p:sp>
         <p:nvSpPr>
-          <p:cNvPr id="20" name="moving step 6 circle"/>
+          <p:cNvPr id="18" name="drive step 5 circle"/>
           <p:cNvSpPr/>
           <p:nvPr/>
         </p:nvSpPr>
         <p:spPr>
           <a:xfrm>
-            <a:off x="548640" y="5516880"/>
+            <a:off x="548640" y="4806696"/>
             <a:ext cx="292608" cy="292608"/>
           </a:xfrm>
           <a:prstGeom prst="ellipse">
             <a:avLst/>
           </a:prstGeom>
           <a:solidFill>
-            <a:schemeClr val="accent1"/>
+            <a:schemeClr val="accent2"/>
           </a:solidFill>
           <a:ln w="12700">
             <a:solidFill>
-              <a:schemeClr val="accent1"/>
+              <a:schemeClr val="accent2"/>
             </a:solidFill>
             <a:prstDash val="solid"/>
           </a:ln>
@@ -4266,13 +4275,13 @@
       </p:sp>
       <p:sp>
         <p:nvSpPr>
-          <p:cNvPr id="21" name="moving step 6 number"/>
+          <p:cNvPr id="19" name="drive step 5 number"/>
           <p:cNvSpPr txBox="1"/>
           <p:nvPr/>
         </p:nvSpPr>
         <p:spPr>
           <a:xfrm>
-            <a:off x="548640" y="5516880"/>
+            <a:off x="548640" y="4806696"/>
             <a:ext cx="292608" cy="292608"/>
           </a:xfrm>
           <a:prstGeom prst="rect">
@@ -4294,6 +4303,114 @@
                   <a:schemeClr val="bg1"/>
                 </a:solidFill>
               </a:rPr>
+              <a:t>5</a:t>
+            </a:r>
+            <a:endParaRPr lang="en-US" sz="1300" dirty="0"/>
+          </a:p>
+        </p:txBody>
+      </p:sp>
+      <p:sp>
+        <p:nvSpPr>
+          <p:cNvPr id="20" name="drive step 5 text"/>
+          <p:cNvSpPr txBox="1"/>
+          <p:nvPr/>
+        </p:nvSpPr>
+        <p:spPr>
+          <a:xfrm>
+            <a:off x="978408" y="4788408"/>
+            <a:ext cx="6885432" cy="649224"/>
+          </a:xfrm>
+          <a:prstGeom prst="rect">
+            <a:avLst/>
+          </a:prstGeom>
+          <a:noFill/>
+          <a:ln/>
+        </p:spPr>
+        <p:txBody>
+          <a:bodyPr wrap="square" lIns="0" tIns="0" rIns="0" bIns="0" rtlCol="0" anchor="t"/>
+          <a:lstStyle/>
+          <a:p>
+            <a:pPr indent="0" marL="0">
+              <a:buNone/>
+            </a:pPr>
+            <a:r>
+              <a:rPr lang="en-US" sz="1300" b="1" dirty="0">
+                <a:solidFill>
+                  <a:schemeClr val="tx1"/>
+                </a:solidFill>
+              </a:rPr>
+              <a:t>When stuck. </a:t>
+            </a:r>
+            <a:pPr indent="0" marL="0">
+              <a:buNone/>
+            </a:pPr>
+            <a:r>
+              <a:rPr lang="en-US" sz="1300" dirty="0">
+                <a:solidFill>
+                  <a:schemeClr val="tx2"/>
+                </a:solidFill>
+              </a:rPr>
+              <a:t>If it believes it is at the same photo for 3 moves, it checks the next 5 route photos with SuperGlue. If it gets no closer for 150 steps, that stretch of the route is made more expensive and the route is planned again.</a:t>
+            </a:r>
+            <a:endParaRPr lang="en-US" sz="1300" dirty="0"/>
+          </a:p>
+        </p:txBody>
+      </p:sp>
+      <p:sp>
+        <p:nvSpPr>
+          <p:cNvPr id="21" name="drive step 6 circle"/>
+          <p:cNvSpPr/>
+          <p:nvPr/>
+        </p:nvSpPr>
+        <p:spPr>
+          <a:xfrm>
+            <a:off x="548640" y="5638800"/>
+            <a:ext cx="292608" cy="292608"/>
+          </a:xfrm>
+          <a:prstGeom prst="ellipse">
+            <a:avLst/>
+          </a:prstGeom>
+          <a:solidFill>
+            <a:schemeClr val="accent2"/>
+          </a:solidFill>
+          <a:ln w="12700">
+            <a:solidFill>
+              <a:schemeClr val="accent2"/>
+            </a:solidFill>
+            <a:prstDash val="solid"/>
+          </a:ln>
+        </p:spPr>
+      </p:sp>
+      <p:sp>
+        <p:nvSpPr>
+          <p:cNvPr id="22" name="drive step 6 number"/>
+          <p:cNvSpPr txBox="1"/>
+          <p:nvPr/>
+        </p:nvSpPr>
+        <p:spPr>
+          <a:xfrm>
+            <a:off x="548640" y="5638800"/>
+            <a:ext cx="292608" cy="292608"/>
+          </a:xfrm>
+          <a:prstGeom prst="rect">
+            <a:avLst/>
+          </a:prstGeom>
+          <a:noFill/>
+          <a:ln/>
+        </p:spPr>
+        <p:txBody>
+          <a:bodyPr wrap="square" lIns="0" tIns="0" rIns="0" bIns="0" rtlCol="0" anchor="ctr"/>
+          <a:lstStyle/>
+          <a:p>
+            <a:pPr algn="ctr" indent="0" marL="0">
+              <a:buNone/>
+            </a:pPr>
+            <a:r>
+              <a:rPr lang="en-US" sz="1300" b="1" dirty="0">
+                <a:solidFill>
+                  <a:schemeClr val="bg1"/>
+                </a:solidFill>
+              </a:rPr>
               <a:t>6</a:t>
             </a:r>
             <a:endParaRPr lang="en-US" sz="1300" dirty="0"/>
@@ -4302,14 +4419,14 @@
       </p:sp>
       <p:sp>
         <p:nvSpPr>
-          <p:cNvPr id="22" name="moving step 6 text"/>
+          <p:cNvPr id="23" name="drive step 6 text"/>
           <p:cNvSpPr txBox="1"/>
           <p:nvPr/>
         </p:nvSpPr>
         <p:spPr>
           <a:xfrm>
-            <a:off x="978408" y="5498592"/>
-            <a:ext cx="6702552" cy="649224"/>
+            <a:off x="978408" y="5620512"/>
+            <a:ext cx="6885432" cy="649224"/>
           </a:xfrm>
           <a:prstGeom prst="rect">
             <a:avLst/>
@@ -4349,7 +4466,7 @@
       </p:sp>
       <p:pic>
         <p:nvPicPr>
-          <p:cNvPr id="23" name="maze 25 true path" descr="Top view of local maze 25: the robot’s true path from the start to the goal ring, coloured by time from blue to red, with a tangle at the top left where it made no progress for a while">    </p:cNvPr>
+          <p:cNvPr id="24" name="turn example matches" descr="Two maze photos side by side with green lines joining 20 of the 73 keypoints SuperGlue matched between them">    </p:cNvPr>
           <p:cNvPicPr>
             <a:picLocks noChangeAspect="1"/>
           </p:cNvPicPr>
@@ -4363,8 +4480,8 @@
         </p:blipFill>
         <p:spPr>
           <a:xfrm>
-            <a:off x="8046720" y="1417320"/>
-            <a:ext cx="3611880" cy="3611880"/>
+            <a:off x="8092440" y="1417320"/>
+            <a:ext cx="3566160" cy="924357"/>
           </a:xfrm>
           <a:prstGeom prst="rect">
             <a:avLst/>
@@ -4373,14 +4490,14 @@
       </p:pic>
       <p:sp>
         <p:nvSpPr>
-          <p:cNvPr id="24" name="maze 25 caption"/>
+          <p:cNvPr id="25" name="turn example caption"/>
           <p:cNvSpPr txBox="1"/>
           <p:nvPr/>
         </p:nvSpPr>
         <p:spPr>
           <a:xfrm>
-            <a:off x="8046720" y="5138928"/>
-            <a:ext cx="3611880" cy="1097280"/>
+            <a:off x="8092440" y="2414829"/>
+            <a:ext cx="3566160" cy="731520"/>
           </a:xfrm>
           <a:prstGeom prst="rect">
             <a:avLst/>
@@ -4396,14 +4513,156 @@
               <a:buNone/>
             </a:pPr>
             <a:r>
+              <a:rPr lang="en-US" sz="1050" b="1" dirty="0">
+                <a:solidFill>
+                  <a:schemeClr val="tx1"/>
+                </a:solidFill>
+              </a:rPr>
+              <a:t>Step 3, turn and drive. </a:t>
+            </a:r>
+            <a:pPr indent="0" marL="0">
+              <a:buNone/>
+            </a:pPr>
+            <a:r>
               <a:rPr lang="en-US" sz="1050" dirty="0">
                 <a:solidFill>
                   <a:schemeClr val="tx2"/>
                 </a:solidFill>
               </a:rPr>
-              <a:t>Local test maze 25 with the same code, drawn from the simulator’s true positions (blue = start, red = check-in): 6/10, 2,965 steps, 2 cm from the goal. The tangle at the top left is about 1,700 steps that got no closer to the goal.</a:t>
+              <a:t>SuperGlue matches between the camera image (left) and the waypoint photo (right). The essential matrix from these 73 matches gives the turn: 37°.</a:t>
             </a:r>
             <a:endParaRPr lang="en-US" sz="1050" dirty="0"/>
+          </a:p>
+        </p:txBody>
+      </p:sp>
+      <p:pic>
+        <p:nvPicPr>
+          <p:cNvPr id="26" name="last metre goal photo" descr="The goal photo the robot was given (front view)">    </p:cNvPr>
+          <p:cNvPicPr>
+            <a:picLocks noChangeAspect="1"/>
+          </p:cNvPicPr>
+          <p:nvPr/>
+        </p:nvPicPr>
+        <p:blipFill>
+          <a:blip r:embed="rId2"/>
+          <a:stretch>
+            <a:fillRect/>
+          </a:stretch>
+        </p:blipFill>
+        <p:spPr>
+          <a:xfrm>
+            <a:off x="8092440" y="3393237"/>
+            <a:ext cx="1741932" cy="1306449"/>
+          </a:xfrm>
+          <a:prstGeom prst="rect">
+            <a:avLst/>
+          </a:prstGeom>
+        </p:spPr>
+      </p:pic>
+      <p:pic>
+        <p:nvPicPr>
+          <p:cNvPr id="27" name="last metre camera" descr="The robot’s camera image when it checked in, 2 cm from the goal">    </p:cNvPr>
+          <p:cNvPicPr>
+            <a:picLocks noChangeAspect="1"/>
+          </p:cNvPicPr>
+          <p:nvPr/>
+        </p:nvPicPr>
+        <p:blipFill>
+          <a:blip r:embed="rId3"/>
+          <a:stretch>
+            <a:fillRect/>
+          </a:stretch>
+        </p:blipFill>
+        <p:spPr>
+          <a:xfrm>
+            <a:off x="9916668" y="3393237"/>
+            <a:ext cx="1741932" cy="1306449"/>
+          </a:xfrm>
+          <a:prstGeom prst="rect">
+            <a:avLst/>
+          </a:prstGeom>
+        </p:spPr>
+      </p:pic>
+      <p:sp>
+        <p:nvSpPr>
+          <p:cNvPr id="28" name="last metre caption"/>
+          <p:cNvSpPr txBox="1"/>
+          <p:nvPr/>
+        </p:nvSpPr>
+        <p:spPr>
+          <a:xfrm>
+            <a:off x="8092440" y="4772838"/>
+            <a:ext cx="3566160" cy="640080"/>
+          </a:xfrm>
+          <a:prstGeom prst="rect">
+            <a:avLst/>
+          </a:prstGeom>
+          <a:noFill/>
+          <a:ln/>
+        </p:spPr>
+        <p:txBody>
+          <a:bodyPr wrap="square" lIns="0" tIns="0" rIns="0" bIns="0" rtlCol="0" anchor="t"/>
+          <a:lstStyle/>
+          <a:p>
+            <a:pPr indent="0" marL="0">
+              <a:buNone/>
+            </a:pPr>
+            <a:r>
+              <a:rPr lang="en-US" sz="1050" b="1" dirty="0">
+                <a:solidFill>
+                  <a:schemeClr val="tx1"/>
+                </a:solidFill>
+              </a:rPr>
+              <a:t>Step 6, the last metre. </a:t>
+            </a:r>
+            <a:pPr indent="0" marL="0">
+              <a:buNone/>
+            </a:pPr>
+            <a:r>
+              <a:rPr lang="en-US" sz="1050" dirty="0">
+                <a:solidFill>
+                  <a:schemeClr val="tx2"/>
+                </a:solidFill>
+              </a:rPr>
+              <a:t>The goal photo it was given (left) and its camera when it checked in, 2 cm from the goal (right).</a:t>
+            </a:r>
+            <a:endParaRPr lang="en-US" sz="1050" dirty="0"/>
+          </a:p>
+        </p:txBody>
+      </p:sp>
+      <p:sp>
+        <p:nvSpPr>
+          <p:cNvPr id="29" name="example source"/>
+          <p:cNvSpPr txBox="1"/>
+          <p:nvPr/>
+        </p:nvSpPr>
+        <p:spPr>
+          <a:xfrm>
+            <a:off x="8092440" y="5476926"/>
+            <a:ext cx="3566160" cy="237744"/>
+          </a:xfrm>
+          <a:prstGeom prst="rect">
+            <a:avLst/>
+          </a:prstGeom>
+          <a:noFill/>
+          <a:ln/>
+        </p:spPr>
+        <p:txBody>
+          <a:bodyPr wrap="square" lIns="0" tIns="0" rIns="0" bIns="0" rtlCol="0" anchor="ctr"/>
+          <a:lstStyle/>
+          <a:p>
+            <a:pPr indent="0" marL="0">
+              <a:buNone/>
+            </a:pPr>
+            <a:r>
+              <a:rPr lang="en-US" sz="1000" i="1" dirty="0">
+                <a:solidFill>
+                  <a:schemeClr val="tx2"/>
+                </a:solidFill>
+              </a:rPr>
+              <a:t>Real images from local test maze 25</a:t>
+            </a:r>
+            <a:endParaRPr lang="en-US" sz="1000" dirty="0"/>
           </a:p>
         </p:txBody>
       </p:sp>

</xml_diff>

<commit_message>
Mid-term report: design evidence and the photo-map figure
Step 2 says why a shortcut needs 8 matching pairs in a row; step 4 gives the goal choice result
(12 of 13 test mazes with 64 candidates, 9 with 6); step 6 gives the check-in evidence (correct
43-122 matched points, wrong 21-25). Slide 3 shows maze 25's drives and its 480 shortcut links
(97% join photos in the same corridor). Committed as re-saved in PowerPoint.

Co-Authored-By: Claude Opus 5.5 <noreply@anthropic.com>
</commit_message>
<xml_diff>
--- a/runs/Midterm_Report.pptx
+++ b/runs/Midterm_Report.pptx
@@ -4,15 +4,15 @@
   <p:sldMasterIdLst>
     <p:sldMasterId id="2147483648" r:id="rId1"/>
   </p:sldMasterIdLst>
+  <p:notesMasterIdLst>
+    <p:notesMasterId r:id="rId6"/>
+  </p:notesMasterIdLst>
   <p:sldIdLst>
     <p:sldId id="256" r:id="rId2"/>
     <p:sldId id="257" r:id="rId3"/>
     <p:sldId id="258" r:id="rId4"/>
     <p:sldId id="259" r:id="rId5"/>
   </p:sldIdLst>
-  <p:notesMasterIdLst>
-    <p:notesMasterId r:id="rId6"/>
-  </p:notesMasterIdLst>
   <p:sldSz cx="12192000" cy="6858000"/>
   <p:notesSz cx="6858000" cy="12192000"/>
   <p:defaultTextStyle>
@@ -110,17 +110,17 @@
   <p:extLst>
     <p:ext uri="{521415D9-36F7-43E2-AB2F-B90AF26B5E84}">
       <p14:sectionLst xmlns:p14="http://schemas.microsoft.com/office/powerpoint/2010/main">
-        <p14:section name="Title" id="{b30a61cd-a7e2-d497-1d37-8f018aaad81b}">
+        <p14:section name="Title" id="{5D09B2E9-22C2-EEC4-617A-04613BB975F1}">
           <p14:sldIdLst>
             <p14:sldId id="256"/>
           </p14:sldIdLst>
         </p14:section>
-        <p14:section name="Problem" id="{70d53917-678e-10ba-eef6-468518725d86}">
+        <p14:section name="Problem" id="{9405A032-FD26-9DB6-9788-FF1FC7652EB6}">
           <p14:sldIdLst>
             <p14:sldId id="257"/>
           </p14:sldIdLst>
         </p14:section>
-        <p14:section name="Method" id="{956b8587-237a-ded8-7404-7ab48e6641cf}">
+        <p14:section name="Method" id="{8C2540F0-2F7D-8693-9686-5ACD88002613}">
           <p14:sldIdLst>
             <p14:sldId id="258"/>
             <p14:sldId id="259"/>
@@ -157,234 +157,10 @@
           <a:chExt cx="0" cy="0"/>
         </a:xfrm>
       </p:grpSpPr>
-      <p:sp>
-        <p:nvSpPr>
-          <p:cNvPr id="2" name="Header Placeholder 1"/>
-          <p:cNvSpPr>
-            <a:spLocks noGrp="1"/>
-          </p:cNvSpPr>
-          <p:nvPr>
-            <p:ph type="hdr" sz="quarter"/>
-          </p:nvPr>
-        </p:nvSpPr>
-        <p:spPr>
-          <a:xfrm>
-            <a:off x="0" y="0"/>
-            <a:ext cx="2971800" cy="458788"/>
-          </a:xfrm>
-          <a:prstGeom prst="rect">
-            <a:avLst/>
-          </a:prstGeom>
-        </p:spPr>
-        <p:txBody>
-          <a:bodyPr vert="horz" lIns="91440" tIns="45720" rIns="91440" bIns="45720" rtlCol="0"/>
-          <a:lstStyle>
-            <a:lvl1pPr algn="l">
-              <a:defRPr sz="1200"/>
-            </a:lvl1pPr>
-          </a:lstStyle>
-          <a:p>
-            <a:endParaRPr lang="en-US"/>
-          </a:p>
-        </p:txBody>
-      </p:sp>
-      <p:sp>
-        <p:nvSpPr>
-          <p:cNvPr id="3" name="Date Placeholder 2"/>
-          <p:cNvSpPr>
-            <a:spLocks noGrp="1"/>
-          </p:cNvSpPr>
-          <p:nvPr>
-            <p:ph type="dt" idx="1"/>
-          </p:nvPr>
-        </p:nvSpPr>
-        <p:spPr>
-          <a:xfrm>
-            <a:off x="3884613" y="0"/>
-            <a:ext cx="2971800" cy="458788"/>
-          </a:xfrm>
-          <a:prstGeom prst="rect">
-            <a:avLst/>
-          </a:prstGeom>
-        </p:spPr>
-        <p:txBody>
-          <a:bodyPr vert="horz" lIns="91440" tIns="45720" rIns="91440" bIns="45720" rtlCol="0"/>
-          <a:lstStyle>
-            <a:lvl1pPr algn="r">
-              <a:defRPr sz="1200"/>
-            </a:lvl1pPr>
-          </a:lstStyle>
-          <a:p>
-            <a:fld id="{5282F153-3F37-0F45-9E97-73ACFA13230C}" type="datetimeFigureOut">
-              <a:rPr lang="en-US"/>
-              <a:t>7/23/19</a:t>
-            </a:fld>
-            <a:endParaRPr lang="en-US"/>
-          </a:p>
-        </p:txBody>
-      </p:sp>
-      <p:sp>
-        <p:nvSpPr>
-          <p:cNvPr id="4" name="Slide Image Placeholder 3"/>
-          <p:cNvSpPr>
-            <a:spLocks noGrp="1" noRot="1" noChangeAspect="1"/>
-          </p:cNvSpPr>
-          <p:nvPr>
-            <p:ph type="sldImg" idx="2"/>
-          </p:nvPr>
-        </p:nvSpPr>
-        <p:spPr>
-          <a:xfrm>
-            <a:off x="685800" y="1143000"/>
-            <a:ext cx="5486400" cy="3086100"/>
-          </a:xfrm>
-          <a:prstGeom prst="rect">
-            <a:avLst/>
-          </a:prstGeom>
-          <a:noFill/>
-          <a:ln w="12700">
-            <a:solidFill>
-              <a:prstClr val="black"/>
-            </a:solidFill>
-          </a:ln>
-        </p:spPr>
-        <p:txBody>
-          <a:bodyPr vert="horz" lIns="91440" tIns="45720" rIns="91440" bIns="45720" rtlCol="0" anchor="ctr"/>
-          <a:lstStyle/>
-          <a:p>
-            <a:endParaRPr lang="en-US"/>
-          </a:p>
-        </p:txBody>
-      </p:sp>
-      <p:sp>
-        <p:nvSpPr>
-          <p:cNvPr id="5" name="Notes Placeholder 4"/>
-          <p:cNvSpPr>
-            <a:spLocks noGrp="1"/>
-          </p:cNvSpPr>
-          <p:nvPr>
-            <p:ph type="body" sz="quarter" idx="3"/>
-          </p:nvPr>
-        </p:nvSpPr>
-        <p:spPr>
-          <a:xfrm>
-            <a:off x="685800" y="4400550"/>
-            <a:ext cx="5486400" cy="3600450"/>
-          </a:xfrm>
-          <a:prstGeom prst="rect">
-            <a:avLst/>
-          </a:prstGeom>
-        </p:spPr>
-        <p:txBody>
-          <a:bodyPr vert="horz" lIns="91440" tIns="45720" rIns="91440" bIns="45720" rtlCol="0"/>
-          <a:lstStyle/>
-          <a:p>
-            <a:pPr lvl="0"/>
-            <a:r>
-              <a:rPr lang="en-US"/>
-              <a:t>Click to edit Master text styles</a:t>
-            </a:r>
-          </a:p>
-          <a:p>
-            <a:pPr lvl="1"/>
-            <a:r>
-              <a:rPr lang="en-US"/>
-              <a:t>Second level</a:t>
-            </a:r>
-          </a:p>
-          <a:p>
-            <a:pPr lvl="2"/>
-            <a:r>
-              <a:rPr lang="en-US"/>
-              <a:t>Third level</a:t>
-            </a:r>
-          </a:p>
-          <a:p>
-            <a:pPr lvl="3"/>
-            <a:r>
-              <a:rPr lang="en-US"/>
-              <a:t>Fourth level</a:t>
-            </a:r>
-          </a:p>
-          <a:p>
-            <a:pPr lvl="4"/>
-            <a:r>
-              <a:rPr lang="en-US"/>
-              <a:t>Fifth level</a:t>
-            </a:r>
-          </a:p>
-        </p:txBody>
-      </p:sp>
-      <p:sp>
-        <p:nvSpPr>
-          <p:cNvPr id="6" name="Footer Placeholder 5"/>
-          <p:cNvSpPr>
-            <a:spLocks noGrp="1"/>
-          </p:cNvSpPr>
-          <p:nvPr>
-            <p:ph type="ftr" sz="quarter" idx="4"/>
-          </p:nvPr>
-        </p:nvSpPr>
-        <p:spPr>
-          <a:xfrm>
-            <a:off x="0" y="8685213"/>
-            <a:ext cx="2971800" cy="458787"/>
-          </a:xfrm>
-          <a:prstGeom prst="rect">
-            <a:avLst/>
-          </a:prstGeom>
-        </p:spPr>
-        <p:txBody>
-          <a:bodyPr vert="horz" lIns="91440" tIns="45720" rIns="91440" bIns="45720" rtlCol="0" anchor="b"/>
-          <a:lstStyle>
-            <a:lvl1pPr algn="l">
-              <a:defRPr sz="1200"/>
-            </a:lvl1pPr>
-          </a:lstStyle>
-          <a:p>
-            <a:endParaRPr lang="en-US"/>
-          </a:p>
-        </p:txBody>
-      </p:sp>
-      <p:sp>
-        <p:nvSpPr>
-          <p:cNvPr id="7" name="Slide Number Placeholder 6"/>
-          <p:cNvSpPr>
-            <a:spLocks noGrp="1"/>
-          </p:cNvSpPr>
-          <p:nvPr>
-            <p:ph type="sldNum" sz="quarter" idx="5"/>
-          </p:nvPr>
-        </p:nvSpPr>
-        <p:spPr>
-          <a:xfrm>
-            <a:off x="3884613" y="8685213"/>
-            <a:ext cx="2971800" cy="458787"/>
-          </a:xfrm>
-          <a:prstGeom prst="rect">
-            <a:avLst/>
-          </a:prstGeom>
-        </p:spPr>
-        <p:txBody>
-          <a:bodyPr vert="horz" lIns="91440" tIns="45720" rIns="91440" bIns="45720" rtlCol="0" anchor="b"/>
-          <a:lstStyle>
-            <a:lvl1pPr algn="r">
-              <a:defRPr sz="1200"/>
-            </a:lvl1pPr>
-          </a:lstStyle>
-          <a:p>
-            <a:fld id="{CE5E9CC1-C706-0F49-92D6-E571CC5EEA8F}" type="slidenum">
-              <a:rPr lang="en-US"/>
-              <a:t>‹#›</a:t>
-            </a:fld>
-            <a:endParaRPr lang="en-US"/>
-          </a:p>
-        </p:txBody>
-      </p:sp>
     </p:spTree>
     <p:extLst>
       <p:ext uri="{BB962C8B-B14F-4D97-AF65-F5344CB8AC3E}">
-        <p14:creationId xmlns:p14="http://schemas.microsoft.com/office/powerpoint/2010/main" val="1024086991"/>
+        <p14:creationId xmlns:p14="http://schemas.microsoft.com/office/powerpoint/2010/main" val="791509425"/>
       </p:ext>
     </p:extLst>
   </p:cSld>
@@ -532,7 +308,6 @@
               <a:rPr lang="en-US" dirty="0"/>
               <a:t>Robot Perception course project, Visual Navigation Challenge: mid-term report. The picture is local test maze 25 drawn from the simulator’s true positions: the robot’s path from the start (blue) to the check-in (red), with the same code as the mid-term.</a:t>
             </a:r>
-            <a:endParaRPr lang="en-US" dirty="0"/>
           </a:p>
         </p:txBody>
       </p:sp>
@@ -620,7 +395,6 @@
               <a:rPr lang="en-US" dirty="0"/>
               <a:t>The robot only sees camera images, has four photos of the goal and the photos of three earlier drives. It must check in within 0.2 m and 20 degrees, and SPL rewards few steps. The hard parts are the trade-off between checking carefully and saving steps, lining up exactly in the last metre, and dead ends that cost many steps to back out of.</a:t>
             </a:r>
-            <a:endParaRPr lang="en-US" dirty="0"/>
           </a:p>
         </p:txBody>
       </p:sp>
@@ -706,9 +480,8 @@
           <a:p>
             <a:r>
               <a:rPr lang="en-US" dirty="0"/>
-              <a:t>Before driving, from the exploration photos alone and before connecting: build a graph of the photos, add shortcut links where AnyLoc proposes and SuperGlue confirms the same place, and place every photo in metres to cost the links in steps. When it starts, the session hands over the four goal photos: it picks the goal photo by matching them and computes the cheapest route to it with Dijkstra. None of this costs steps.</a:t>
-            </a:r>
-            <a:endParaRPr lang="en-US" dirty="0"/>
+              <a:t>Before driving, from the exploration photos alone and before connecting: build a graph of the photos, add shortcut links where AnyLoc proposes and SuperGlue confirms the same place, and place every photo in metres to cost the links in steps (the figure shows maze 25: 97% of the 480 links join photos in the same corridor). When it starts, the session hands over the four goal photos: it picks the goal photo by matching them and computes the cheapest route to it with Dijkstra. None of this costs steps.</a:t>
+            </a:r>
           </a:p>
         </p:txBody>
       </p:sp>
@@ -796,7 +569,6 @@
               <a:rPr lang="en-US" dirty="0"/>
               <a:t>During the drive, every move: find the closest exploration photo, take the route from it, steer to a waypoint photo by the angle SuperGlue and the essential matrix give, undo recorded moves to back out along a drive, check the route photos or re-plan when stuck, and in the last metre line up with the goal photos and check in only after three strong readings. The pictures are real images from local test maze 25: the SuperGlue matches the robot uses to measure a turn, and the goal photo next to its camera at the check-in.</a:t>
             </a:r>
-            <a:endParaRPr lang="en-US" dirty="0"/>
           </a:p>
         </p:txBody>
       </p:sp>
@@ -874,6 +646,7 @@
         <a:solidFill>
           <a:schemeClr val="tx1"/>
         </a:solidFill>
+        <a:effectLst/>
       </p:bgPr>
     </p:bg>
     <p:spTree>
@@ -893,9 +666,11 @@
       <p:sp>
         <p:nvSpPr>
           <p:cNvPr id="2" name="Text 0"/>
-          <p:cNvSpPr/>
+          <p:cNvSpPr>
+            <a:spLocks noGrp="1"/>
+          </p:cNvSpPr>
           <p:nvPr>
-            <p:ph idx="100" type="title" hasCustomPrompt="1"/>
+            <p:ph type="title" idx="100" hasCustomPrompt="1"/>
           </p:nvPr>
         </p:nvSpPr>
         <p:spPr>
@@ -912,7 +687,7 @@
         <p:txBody>
           <a:bodyPr wrap="square" rtlCol="0"/>
           <a:lstStyle>
-            <a:lvl1pPr algn="l" indent="0" marL="0">
+            <a:lvl1pPr marL="0" indent="0" algn="l">
               <a:buNone/>
               <a:defRPr lang="en-US" sz="4400" b="1" dirty="0">
                 <a:solidFill>
@@ -922,7 +697,7 @@
             </a:lvl1pPr>
           </a:lstStyle>
           <a:p>
-            <a:pPr algn="l" indent="0" marL="0">
+            <a:pPr marL="0" indent="0" algn="l">
               <a:buNone/>
             </a:pPr>
             <a:endParaRPr lang="en-US" sz="4400" dirty="0"/>
@@ -945,6 +720,7 @@
         <a:solidFill>
           <a:schemeClr val="bg1"/>
         </a:solidFill>
+        <a:effectLst/>
       </p:bgPr>
     </p:bg>
     <p:spTree>
@@ -964,9 +740,11 @@
       <p:sp>
         <p:nvSpPr>
           <p:cNvPr id="2" name="Text 0"/>
-          <p:cNvSpPr/>
+          <p:cNvSpPr>
+            <a:spLocks noGrp="1"/>
+          </p:cNvSpPr>
           <p:nvPr>
-            <p:ph idx="100" type="title" hasCustomPrompt="1"/>
+            <p:ph type="title" idx="100" hasCustomPrompt="1"/>
           </p:nvPr>
         </p:nvSpPr>
         <p:spPr>
@@ -983,7 +761,7 @@
         <p:txBody>
           <a:bodyPr wrap="square" rtlCol="0"/>
           <a:lstStyle>
-            <a:lvl1pPr algn="l" indent="0" marL="0">
+            <a:lvl1pPr marL="0" indent="0" algn="l">
               <a:buNone/>
               <a:defRPr lang="en-US" sz="3000" b="1" dirty="0">
                 <a:solidFill>
@@ -993,7 +771,7 @@
             </a:lvl1pPr>
           </a:lstStyle>
           <a:p>
-            <a:pPr algn="l" indent="0" marL="0">
+            <a:pPr marL="0" indent="0" algn="l">
               <a:buNone/>
             </a:pPr>
             <a:endParaRPr lang="en-US" sz="3000" dirty="0"/>
@@ -1021,11 +799,11 @@
           <a:bodyPr wrap="square" lIns="0" tIns="0" rIns="0" bIns="0" rtlCol="0" anchor="ctr"/>
           <a:lstStyle/>
           <a:p>
-            <a:pPr indent="0" marL="0">
-              <a:buNone/>
-            </a:pPr>
-            <a:r>
-              <a:rPr lang="en-US" sz="900" spc="150" kern="0" dirty="0">
+            <a:pPr marL="0" indent="0">
+              <a:buNone/>
+            </a:pPr>
+            <a:r>
+              <a:rPr lang="en-US" sz="900" kern="0" spc="150" dirty="0">
                 <a:solidFill>
                   <a:schemeClr val="accent3"/>
                 </a:solidFill>
@@ -1056,7 +834,7 @@
           </a:prstGeom>
           <a:extLst>
             <a:ext uri="{C572A759-6A51-4108-AA02-DFA0A04FC94B}">
-              <ma14:wrappingTextBoxFlag xmlns:ma14="http://schemas.microsoft.com/office/mac/drawingml/2011/main" val="0"/>
+              <ma14:wrappingTextBoxFlag xmlns:ma14="http://schemas.microsoft.com/office/mac/drawingml/2011/main" xmlns="" val="0"/>
             </a:ext>
           </a:extLst>
         </p:spPr>
@@ -1074,8 +852,8 @@
           <a:p>
             <a:pPr algn="r"/>
             <a:fld id="{F7021451-1387-4CA6-816F-3879F97B5CBC}" type="slidenum">
-              <a:rPr b="0" lang="en-US"/>
-              <a:t>1003</a:t>
+              <a:rPr lang="en-US" b="0"/>
+              <a:t>‹#›</a:t>
             </a:fld>
             <a:endParaRPr lang="en-US"/>
           </a:p>
@@ -1092,6 +870,11 @@
 <file path=ppt/slideMasters/slideMaster1.xml><?xml version="1.0" encoding="utf-8"?>
 <p:sldMaster xmlns:a="http://schemas.openxmlformats.org/drawingml/2006/main" xmlns:r="http://schemas.openxmlformats.org/officeDocument/2006/relationships" xmlns:p="http://schemas.openxmlformats.org/presentationml/2006/main">
   <p:cSld>
+    <p:bg>
+      <p:bgRef idx="1001">
+        <a:schemeClr val="bg1"/>
+      </p:bgRef>
+    </p:bg>
     <p:spTree>
       <p:nvGrpSpPr>
         <p:cNvPr id="1" name=""/>
@@ -1126,7 +909,7 @@
           </a:prstGeom>
           <a:extLst>
             <a:ext uri="{C572A759-6A51-4108-AA02-DFA0A04FC94B}">
-              <ma14:wrappingTextBoxFlag xmlns:ma14="http://schemas.microsoft.com/office/mac/drawingml/2011/main" val="0"/>
+              <ma14:wrappingTextBoxFlag xmlns:ma14="http://schemas.microsoft.com/office/mac/drawingml/2011/main" xmlns="" val="0"/>
             </a:ext>
           </a:extLst>
         </p:spPr>
@@ -1144,8 +927,8 @@
           <a:p>
             <a:pPr algn="r"/>
             <a:fld id="{F7021451-1387-4CA6-816F-3879F97B5CBC}" type="slidenum">
-              <a:rPr b="0" lang="en-US"/>
-              <a:t>null</a:t>
+              <a:rPr lang="en-US" b="0"/>
+              <a:t>‹#›</a:t>
             </a:fld>
             <a:endParaRPr lang="en-US"/>
           </a:p>
@@ -1451,11 +1234,11 @@
           <a:bodyPr wrap="square" lIns="0" tIns="0" rIns="0" bIns="0" rtlCol="0" anchor="ctr"/>
           <a:lstStyle/>
           <a:p>
-            <a:pPr indent="0" marL="0">
-              <a:buNone/>
-            </a:pPr>
-            <a:r>
-              <a:rPr lang="en-US" sz="1300" spc="200" kern="0" dirty="0">
+            <a:pPr marL="0" indent="0">
+              <a:buNone/>
+            </a:pPr>
+            <a:r>
+              <a:rPr lang="en-US" sz="1300" kern="0" spc="200" dirty="0">
                 <a:solidFill>
                   <a:schemeClr val="accent5"/>
                 </a:solidFill>
@@ -1469,9 +1252,11 @@
       <p:sp>
         <p:nvSpPr>
           <p:cNvPr id="3" name="Text 0"/>
-          <p:cNvSpPr/>
+          <p:cNvSpPr>
+            <a:spLocks noGrp="1"/>
+          </p:cNvSpPr>
           <p:nvPr>
-            <p:ph idx="100" type="title" hasCustomPrompt="1"/>
+            <p:ph type="title" idx="100" hasCustomPrompt="1"/>
           </p:nvPr>
         </p:nvSpPr>
         <p:spPr>
@@ -1489,7 +1274,7 @@
           <a:bodyPr wrap="square" lIns="0" tIns="0" rIns="0" bIns="0" rtlCol="0" anchor="t"/>
           <a:lstStyle/>
           <a:p>
-            <a:pPr algn="l" indent="0" marL="0">
+            <a:pPr marL="0" indent="0" algn="l">
               <a:buNone/>
             </a:pPr>
             <a:r>
@@ -1503,7 +1288,7 @@
             <a:endParaRPr lang="en-US" sz="4400" dirty="0"/>
           </a:p>
           <a:p>
-            <a:pPr algn="l" indent="0" marL="0">
+            <a:pPr marL="0" indent="0" algn="l">
               <a:buNone/>
             </a:pPr>
             <a:r>
@@ -1539,7 +1324,7 @@
           <a:bodyPr wrap="square" lIns="0" tIns="0" rIns="0" bIns="0" rtlCol="0" anchor="ctr"/>
           <a:lstStyle/>
           <a:p>
-            <a:pPr indent="0" marL="0">
+            <a:pPr marL="0" indent="0">
               <a:buNone/>
             </a:pPr>
             <a:r>
@@ -1578,7 +1363,7 @@
           <a:bodyPr wrap="square" lIns="0" tIns="0" rIns="0" bIns="0" rtlCol="0" anchor="ctr"/>
           <a:lstStyle/>
           <a:p>
-            <a:pPr indent="0" marL="0">
+            <a:pPr marL="0" indent="0">
               <a:spcAft>
                 <a:spcPts val="600"/>
               </a:spcAft>
@@ -1595,7 +1380,7 @@
             <a:endParaRPr lang="en-US" sz="2000" dirty="0"/>
           </a:p>
           <a:p>
-            <a:pPr indent="0" marL="0">
+            <a:pPr marL="0" indent="0">
               <a:spcAft>
                 <a:spcPts val="600"/>
               </a:spcAft>
@@ -1642,14 +1427,14 @@
       </p:sp>
       <p:pic>
         <p:nvPicPr>
-          <p:cNvPr id="7" name="title maze picture" descr="Top view of local test maze 25 drawn from the simulator’s true positions: the robot’s path from the start to the goal, coloured by time from blue to red">    </p:cNvPr>
+          <p:cNvPr id="7" name="title maze picture" descr="Top view of local test maze 25 drawn from the simulator’s true positions: the robot’s path from the start to the goal, coloured by time from blue to red"/>
           <p:cNvPicPr>
             <a:picLocks noChangeAspect="1"/>
           </p:cNvPicPr>
           <p:nvPr/>
         </p:nvPicPr>
         <p:blipFill>
-          <a:blip r:embed="rId1"/>
+          <a:blip r:embed="rId3"/>
           <a:stretch>
             <a:fillRect/>
           </a:stretch>
@@ -1685,7 +1470,7 @@
           <a:bodyPr wrap="square" lIns="0" tIns="0" rIns="0" bIns="0" rtlCol="0" anchor="ctr"/>
           <a:lstStyle/>
           <a:p>
-            <a:pPr indent="0" marL="0">
+            <a:pPr marL="0" indent="0">
               <a:buNone/>
             </a:pPr>
             <a:r>
@@ -1746,11 +1531,11 @@
           <a:bodyPr wrap="square" lIns="0" tIns="0" rIns="0" bIns="0" rtlCol="0" anchor="ctr"/>
           <a:lstStyle/>
           <a:p>
-            <a:pPr indent="0" marL="0">
-              <a:buNone/>
-            </a:pPr>
-            <a:r>
-              <a:rPr lang="en-US" sz="1100" b="1" spc="200" kern="0" dirty="0">
+            <a:pPr marL="0" indent="0">
+              <a:buNone/>
+            </a:pPr>
+            <a:r>
+              <a:rPr lang="en-US" sz="1100" b="1" kern="0" spc="200" dirty="0">
                 <a:solidFill>
                   <a:schemeClr val="accent1"/>
                 </a:solidFill>
@@ -1764,9 +1549,11 @@
       <p:sp>
         <p:nvSpPr>
           <p:cNvPr id="3" name="Text 0"/>
-          <p:cNvSpPr/>
+          <p:cNvSpPr>
+            <a:spLocks noGrp="1"/>
+          </p:cNvSpPr>
           <p:nvPr>
-            <p:ph idx="100" type="title" hasCustomPrompt="1"/>
+            <p:ph type="title" idx="100" hasCustomPrompt="1"/>
           </p:nvPr>
         </p:nvSpPr>
         <p:spPr>
@@ -1784,7 +1571,7 @@
           <a:bodyPr wrap="square" lIns="0" tIns="0" rIns="0" bIns="0" rtlCol="0" anchor="ctr"/>
           <a:lstStyle/>
           <a:p>
-            <a:pPr algn="l" indent="0" marL="0">
+            <a:pPr marL="0" indent="0" algn="l">
               <a:buNone/>
             </a:pPr>
             <a:r>
@@ -1820,7 +1607,7 @@
           <a:bodyPr wrap="square" lIns="0" tIns="0" rIns="0" bIns="0" rtlCol="0" anchor="t"/>
           <a:lstStyle/>
           <a:p>
-            <a:pPr indent="0" marL="0">
+            <a:pPr marL="0" indent="0">
               <a:spcAft>
                 <a:spcPts val="500"/>
               </a:spcAft>
@@ -1891,7 +1678,7 @@
             <a:endParaRPr lang="en-US" sz="1350" dirty="0"/>
           </a:p>
           <a:p>
-            <a:pPr indent="0" marL="0">
+            <a:pPr marL="0" indent="0">
               <a:spcAft>
                 <a:spcPts val="500"/>
               </a:spcAft>
@@ -1930,7 +1717,7 @@
           <a:bodyPr wrap="square" lIns="0" tIns="0" rIns="0" bIns="0" rtlCol="0" anchor="ctr"/>
           <a:lstStyle/>
           <a:p>
-            <a:pPr indent="0" marL="0">
+            <a:pPr marL="0" indent="0">
               <a:buNone/>
             </a:pPr>
             <a:r>
@@ -1991,7 +1778,7 @@
           <a:bodyPr wrap="square" lIns="0" tIns="0" rIns="0" bIns="0" rtlCol="0" anchor="ctr"/>
           <a:lstStyle/>
           <a:p>
-            <a:pPr algn="ctr" indent="0" marL="0">
+            <a:pPr marL="0" indent="0" algn="ctr">
               <a:buNone/>
             </a:pPr>
             <a:r>
@@ -2027,7 +1814,7 @@
           <a:bodyPr wrap="square" lIns="0" tIns="0" rIns="0" bIns="0" rtlCol="0" anchor="t"/>
           <a:lstStyle/>
           <a:p>
-            <a:pPr indent="0" marL="0">
+            <a:pPr marL="0" indent="0">
               <a:buNone/>
             </a:pPr>
             <a:r>
@@ -2038,9 +1825,6 @@
               </a:rPr>
               <a:t>Accuracy vs. number of steps. </a:t>
             </a:r>
-            <a:pPr indent="0" marL="0">
-              <a:buNone/>
-            </a:pPr>
             <a:r>
               <a:rPr lang="en-US" sz="1350" dirty="0">
                 <a:solidFill>
@@ -2099,7 +1883,7 @@
           <a:bodyPr wrap="square" lIns="0" tIns="0" rIns="0" bIns="0" rtlCol="0" anchor="ctr"/>
           <a:lstStyle/>
           <a:p>
-            <a:pPr algn="ctr" indent="0" marL="0">
+            <a:pPr marL="0" indent="0" algn="ctr">
               <a:buNone/>
             </a:pPr>
             <a:r>
@@ -2135,7 +1919,7 @@
           <a:bodyPr wrap="square" lIns="0" tIns="0" rIns="0" bIns="0" rtlCol="0" anchor="t"/>
           <a:lstStyle/>
           <a:p>
-            <a:pPr indent="0" marL="0">
+            <a:pPr marL="0" indent="0">
               <a:buNone/>
             </a:pPr>
             <a:r>
@@ -2146,9 +1930,6 @@
               </a:rPr>
               <a:t>The last metre. </a:t>
             </a:r>
-            <a:pPr indent="0" marL="0">
-              <a:buNone/>
-            </a:pPr>
             <a:r>
               <a:rPr lang="en-US" sz="1350" dirty="0">
                 <a:solidFill>
@@ -2207,7 +1988,7 @@
           <a:bodyPr wrap="square" lIns="0" tIns="0" rIns="0" bIns="0" rtlCol="0" anchor="ctr"/>
           <a:lstStyle/>
           <a:p>
-            <a:pPr algn="ctr" indent="0" marL="0">
+            <a:pPr marL="0" indent="0" algn="ctr">
               <a:buNone/>
             </a:pPr>
             <a:r>
@@ -2243,7 +2024,7 @@
           <a:bodyPr wrap="square" lIns="0" tIns="0" rIns="0" bIns="0" rtlCol="0" anchor="t"/>
           <a:lstStyle/>
           <a:p>
-            <a:pPr indent="0" marL="0">
+            <a:pPr marL="0" indent="0">
               <a:buNone/>
             </a:pPr>
             <a:r>
@@ -2254,9 +2035,6 @@
               </a:rPr>
               <a:t>Dead ends. </a:t>
             </a:r>
-            <a:pPr indent="0" marL="0">
-              <a:buNone/>
-            </a:pPr>
             <a:r>
               <a:rPr lang="en-US" sz="1350" dirty="0">
                 <a:solidFill>
@@ -2317,7 +2095,7 @@
           <a:bodyPr wrap="square" lIns="0" tIns="0" rIns="0" bIns="0" rtlCol="0" anchor="ctr"/>
           <a:lstStyle/>
           <a:p>
-            <a:pPr indent="0" marL="0">
+            <a:pPr marL="0" indent="0">
               <a:buNone/>
             </a:pPr>
             <a:r>
@@ -2359,7 +2137,7 @@
               </a:spcAft>
               <a:buSzPct val="100000"/>
               <a:buFont typeface="+mj-lt"/>
-              <a:buAutoNum type="arabicPeriod" startAt="1"/>
+              <a:buAutoNum type="arabicPeriod"/>
             </a:pPr>
             <a:r>
               <a:rPr lang="en-US" sz="1000" dirty="0">
@@ -2369,12 +2147,6 @@
               </a:rPr>
               <a:t>Savinov et al., Semi-Parametric Topological Memory for Navigation (SPTM), ICLR 2018</a:t>
             </a:r>
-            <a:pPr indent="0" marL="0">
-              <a:spcAft>
-                <a:spcPts val="300"/>
-              </a:spcAft>
-              <a:buNone/>
-            </a:pPr>
             <a:r>
               <a:rPr lang="en-US" sz="1000" i="1" dirty="0">
                 <a:solidFill>
@@ -2392,7 +2164,7 @@
               </a:spcAft>
               <a:buSzPct val="100000"/>
               <a:buFont typeface="+mj-lt"/>
-              <a:buAutoNum type="arabicPeriod" startAt="1"/>
+              <a:buAutoNum type="arabicPeriod"/>
             </a:pPr>
             <a:r>
               <a:rPr lang="en-US" sz="1000" dirty="0">
@@ -2402,12 +2174,6 @@
               </a:rPr>
               <a:t>Keetha et al., AnyLoc: Towards Universal Visual Place Recognition, IEEE RA-L 2023</a:t>
             </a:r>
-            <a:pPr indent="0" marL="0">
-              <a:spcAft>
-                <a:spcPts val="300"/>
-              </a:spcAft>
-              <a:buNone/>
-            </a:pPr>
             <a:r>
               <a:rPr lang="en-US" sz="1000" i="1" dirty="0">
                 <a:solidFill>
@@ -2425,7 +2191,7 @@
               </a:spcAft>
               <a:buSzPct val="100000"/>
               <a:buFont typeface="+mj-lt"/>
-              <a:buAutoNum type="arabicPeriod" startAt="1"/>
+              <a:buAutoNum type="arabicPeriod"/>
             </a:pPr>
             <a:r>
               <a:rPr lang="en-US" sz="1000" dirty="0">
@@ -2435,12 +2201,6 @@
               </a:rPr>
               <a:t>Oquab et al., DINOv2: Learning Robust Visual Features without Supervision, TMLR 2024</a:t>
             </a:r>
-            <a:pPr indent="0" marL="0">
-              <a:spcAft>
-                <a:spcPts val="300"/>
-              </a:spcAft>
-              <a:buNone/>
-            </a:pPr>
             <a:r>
               <a:rPr lang="en-US" sz="1000" i="1" dirty="0">
                 <a:solidFill>
@@ -2458,7 +2218,7 @@
               </a:spcAft>
               <a:buSzPct val="100000"/>
               <a:buFont typeface="+mj-lt"/>
-              <a:buAutoNum type="arabicPeriod" startAt="1"/>
+              <a:buAutoNum type="arabicPeriod"/>
             </a:pPr>
             <a:r>
               <a:rPr lang="en-US" sz="1000" dirty="0">
@@ -2468,12 +2228,6 @@
               </a:rPr>
               <a:t>Jégou et al., Aggregating Local Descriptors into a Compact Image Representation (VLAD), CVPR 2010</a:t>
             </a:r>
-            <a:pPr indent="0" marL="0">
-              <a:spcAft>
-                <a:spcPts val="300"/>
-              </a:spcAft>
-              <a:buNone/>
-            </a:pPr>
             <a:r>
               <a:rPr lang="en-US" sz="1000" i="1" dirty="0">
                 <a:solidFill>
@@ -2491,7 +2245,7 @@
               </a:spcAft>
               <a:buSzPct val="100000"/>
               <a:buFont typeface="+mj-lt"/>
-              <a:buAutoNum type="arabicPeriod" startAt="1"/>
+              <a:buAutoNum type="arabicPeriod"/>
             </a:pPr>
             <a:r>
               <a:rPr lang="en-US" sz="1000" dirty="0">
@@ -2501,12 +2255,6 @@
               </a:rPr>
               <a:t>DeTone et al., SuperPoint: Self-Supervised Interest Point Detection and Description, CVPR Workshops 2018</a:t>
             </a:r>
-            <a:pPr indent="0" marL="0">
-              <a:spcAft>
-                <a:spcPts val="300"/>
-              </a:spcAft>
-              <a:buNone/>
-            </a:pPr>
             <a:r>
               <a:rPr lang="en-US" sz="1000" i="1" dirty="0">
                 <a:solidFill>
@@ -2524,7 +2272,7 @@
               </a:spcAft>
               <a:buSzPct val="100000"/>
               <a:buFont typeface="+mj-lt"/>
-              <a:buAutoNum type="arabicPeriod" startAt="1"/>
+              <a:buAutoNum type="arabicPeriod"/>
             </a:pPr>
             <a:r>
               <a:rPr lang="en-US" sz="1000" dirty="0">
@@ -2534,12 +2282,6 @@
               </a:rPr>
               <a:t>Sarlin et al., SuperGlue: Learning Feature Matching with Graph Neural Networks, CVPR 2020</a:t>
             </a:r>
-            <a:pPr indent="0" marL="0">
-              <a:spcAft>
-                <a:spcPts val="300"/>
-              </a:spcAft>
-              <a:buNone/>
-            </a:pPr>
             <a:r>
               <a:rPr lang="en-US" sz="1000" i="1" dirty="0">
                 <a:solidFill>
@@ -2557,7 +2299,7 @@
               </a:spcAft>
               <a:buSzPct val="100000"/>
               <a:buFont typeface="+mj-lt"/>
-              <a:buAutoNum type="arabicPeriod" startAt="1"/>
+              <a:buAutoNum type="arabicPeriod"/>
             </a:pPr>
             <a:r>
               <a:rPr lang="en-US" sz="1000" dirty="0">
@@ -2567,12 +2309,6 @@
               </a:rPr>
               <a:t>Nistér, An Efficient Solution to the Five-Point Relative Pose Problem, IEEE TPAMI 2004</a:t>
             </a:r>
-            <a:pPr indent="0" marL="0">
-              <a:spcAft>
-                <a:spcPts val="300"/>
-              </a:spcAft>
-              <a:buNone/>
-            </a:pPr>
             <a:r>
               <a:rPr lang="en-US" sz="1000" i="1" dirty="0">
                 <a:solidFill>
@@ -2590,7 +2326,7 @@
               </a:spcAft>
               <a:buSzPct val="100000"/>
               <a:buFont typeface="+mj-lt"/>
-              <a:buAutoNum type="arabicPeriod" startAt="1"/>
+              <a:buAutoNum type="arabicPeriod"/>
             </a:pPr>
             <a:r>
               <a:rPr lang="en-US" sz="1000" dirty="0">
@@ -2600,12 +2336,6 @@
               </a:rPr>
               <a:t>Fischler and Bolles, Random Sample Consensus (RANSAC), Communications of the ACM 1981</a:t>
             </a:r>
-            <a:pPr indent="0" marL="0">
-              <a:spcAft>
-                <a:spcPts val="300"/>
-              </a:spcAft>
-              <a:buNone/>
-            </a:pPr>
             <a:r>
               <a:rPr lang="en-US" sz="1000" i="1" dirty="0">
                 <a:solidFill>
@@ -2623,7 +2353,7 @@
               </a:spcAft>
               <a:buSzPct val="100000"/>
               <a:buFont typeface="+mj-lt"/>
-              <a:buAutoNum type="arabicPeriod" startAt="1"/>
+              <a:buAutoNum type="arabicPeriod"/>
             </a:pPr>
             <a:r>
               <a:rPr lang="en-US" sz="1000" dirty="0">
@@ -2633,12 +2363,6 @@
               </a:rPr>
               <a:t>Tools: PyTorch, OpenCV, NetworkX (Dijkstra) and the course’s vis-nav SDK</a:t>
             </a:r>
-            <a:pPr indent="0" marL="0">
-              <a:spcAft>
-                <a:spcPts val="300"/>
-              </a:spcAft>
-              <a:buNone/>
-            </a:pPr>
             <a:endParaRPr lang="en-US" sz="1000" dirty="0"/>
           </a:p>
         </p:txBody>
@@ -2663,7 +2387,7 @@
           </a:prstGeom>
           <a:extLst>
             <a:ext uri="{C572A759-6A51-4108-AA02-DFA0A04FC94B}">
-              <ma14:wrappingTextBoxFlag xmlns:ma14="http://schemas.microsoft.com/office/mac/drawingml/2011/main" val="0"/>
+              <ma14:wrappingTextBoxFlag xmlns:ma14="http://schemas.microsoft.com/office/mac/drawingml/2011/main" xmlns="" val="0"/>
             </a:ext>
           </a:extLst>
         </p:spPr>
@@ -2681,7 +2405,7 @@
           <a:p>
             <a:pPr algn="r"/>
             <a:fld id="{F7021451-1387-4CA6-816F-3879F97B5CBC}" type="slidenum">
-              <a:rPr b="0" lang="en-US"/>
+              <a:rPr lang="en-US" b="0"/>
               <a:t>2</a:t>
             </a:fld>
             <a:endParaRPr lang="en-US"/>
@@ -2734,11 +2458,11 @@
           <a:bodyPr wrap="square" lIns="0" tIns="0" rIns="0" bIns="0" rtlCol="0" anchor="ctr"/>
           <a:lstStyle/>
           <a:p>
-            <a:pPr indent="0" marL="0">
-              <a:buNone/>
-            </a:pPr>
-            <a:r>
-              <a:rPr lang="en-US" sz="1100" b="1" spc="200" kern="0" dirty="0">
+            <a:pPr marL="0" indent="0">
+              <a:buNone/>
+            </a:pPr>
+            <a:r>
+              <a:rPr lang="en-US" sz="1100" b="1" kern="0" spc="200" dirty="0">
                 <a:solidFill>
                   <a:schemeClr val="accent1"/>
                 </a:solidFill>
@@ -2752,9 +2476,11 @@
       <p:sp>
         <p:nvSpPr>
           <p:cNvPr id="3" name="Text 0"/>
-          <p:cNvSpPr/>
+          <p:cNvSpPr>
+            <a:spLocks noGrp="1"/>
+          </p:cNvSpPr>
           <p:nvPr>
-            <p:ph idx="100" type="title" hasCustomPrompt="1"/>
+            <p:ph type="title" idx="100" hasCustomPrompt="1"/>
           </p:nvPr>
         </p:nvSpPr>
         <p:spPr>
@@ -2772,7 +2498,7 @@
           <a:bodyPr wrap="square" lIns="0" tIns="0" rIns="0" bIns="0" rtlCol="0" anchor="ctr"/>
           <a:lstStyle/>
           <a:p>
-            <a:pPr algn="l" indent="0" marL="0">
+            <a:pPr marL="0" indent="0" algn="l">
               <a:buNone/>
             </a:pPr>
             <a:r>
@@ -2835,7 +2561,7 @@
           <a:bodyPr wrap="square" lIns="0" tIns="0" rIns="0" bIns="0" rtlCol="0" anchor="ctr"/>
           <a:lstStyle/>
           <a:p>
-            <a:pPr indent="0" marL="0">
+            <a:pPr marL="0" indent="0">
               <a:buNone/>
             </a:pPr>
             <a:r>
@@ -2896,7 +2622,7 @@
           <a:bodyPr wrap="square" lIns="0" tIns="0" rIns="0" bIns="0" rtlCol="0" anchor="ctr"/>
           <a:lstStyle/>
           <a:p>
-            <a:pPr algn="ctr" indent="0" marL="0">
+            <a:pPr marL="0" indent="0" algn="ctr">
               <a:buNone/>
             </a:pPr>
             <a:r>
@@ -2920,7 +2646,7 @@
         <p:spPr>
           <a:xfrm>
             <a:off x="978408" y="1856232"/>
-            <a:ext cx="6702552" cy="466344"/>
+            <a:ext cx="6702552" cy="451104"/>
           </a:xfrm>
           <a:prstGeom prst="rect">
             <a:avLst/>
@@ -2932,29 +2658,26 @@
           <a:bodyPr wrap="square" lIns="0" tIns="0" rIns="0" bIns="0" rtlCol="0" anchor="t"/>
           <a:lstStyle/>
           <a:p>
-            <a:pPr indent="0" marL="0">
-              <a:buNone/>
-            </a:pPr>
-            <a:r>
-              <a:rPr lang="en-US" sz="1350" b="1" dirty="0">
+            <a:pPr marL="0" indent="0">
+              <a:buNone/>
+            </a:pPr>
+            <a:r>
+              <a:rPr lang="en-US" sz="1300" b="1" dirty="0">
                 <a:solidFill>
                   <a:schemeClr val="tx1"/>
                 </a:solidFill>
               </a:rPr>
               <a:t>Photo map. </a:t>
             </a:r>
-            <a:pPr indent="0" marL="0">
-              <a:buNone/>
-            </a:pPr>
-            <a:r>
-              <a:rPr lang="en-US" sz="1350" dirty="0">
+            <a:r>
+              <a:rPr lang="en-US" sz="1300" dirty="0">
                 <a:solidFill>
                   <a:schemeClr val="tx2"/>
                 </a:solidFill>
               </a:rPr>
               <a:t>Every exploration photo becomes a node. Photos taken one after another on the same drive are linked, because the robot drove from one to the next.</a:t>
             </a:r>
-            <a:endParaRPr lang="en-US" sz="1350" dirty="0"/>
+            <a:endParaRPr lang="en-US" sz="1300" dirty="0"/>
           </a:p>
         </p:txBody>
       </p:sp>
@@ -2966,7 +2689,7 @@
         </p:nvSpPr>
         <p:spPr>
           <a:xfrm>
-            <a:off x="548640" y="2478024"/>
+            <a:off x="548640" y="2435352"/>
             <a:ext cx="292608" cy="292608"/>
           </a:xfrm>
           <a:prstGeom prst="ellipse">
@@ -2991,7 +2714,7 @@
         </p:nvSpPr>
         <p:spPr>
           <a:xfrm>
-            <a:off x="548640" y="2478024"/>
+            <a:off x="548640" y="2435352"/>
             <a:ext cx="292608" cy="292608"/>
           </a:xfrm>
           <a:prstGeom prst="rect">
@@ -3004,7 +2727,7 @@
           <a:bodyPr wrap="square" lIns="0" tIns="0" rIns="0" bIns="0" rtlCol="0" anchor="ctr"/>
           <a:lstStyle/>
           <a:p>
-            <a:pPr algn="ctr" indent="0" marL="0">
+            <a:pPr marL="0" indent="0" algn="ctr">
               <a:buNone/>
             </a:pPr>
             <a:r>
@@ -3027,8 +2750,8 @@
         </p:nvSpPr>
         <p:spPr>
           <a:xfrm>
-            <a:off x="978408" y="2459736"/>
-            <a:ext cx="6702552" cy="1083564"/>
+            <a:off x="978408" y="2417064"/>
+            <a:ext cx="6702552" cy="1243584"/>
           </a:xfrm>
           <a:prstGeom prst="rect">
             <a:avLst/>
@@ -3040,29 +2763,26 @@
           <a:bodyPr wrap="square" lIns="0" tIns="0" rIns="0" bIns="0" rtlCol="0" anchor="t"/>
           <a:lstStyle/>
           <a:p>
-            <a:pPr indent="0" marL="0">
-              <a:buNone/>
-            </a:pPr>
-            <a:r>
-              <a:rPr lang="en-US" sz="1350" b="1" dirty="0">
+            <a:pPr marL="0" indent="0">
+              <a:buNone/>
+            </a:pPr>
+            <a:r>
+              <a:rPr lang="en-US" sz="1300" b="1" dirty="0">
                 <a:solidFill>
                   <a:schemeClr val="tx1"/>
                 </a:solidFill>
               </a:rPr>
               <a:t>Where the drives meet again. </a:t>
             </a:r>
-            <a:pPr indent="0" marL="0">
-              <a:buNone/>
-            </a:pPr>
-            <a:r>
-              <a:rPr lang="en-US" sz="1350" dirty="0">
+            <a:r>
+              <a:rPr lang="en-US" sz="1300" dirty="0">
                 <a:solidFill>
                   <a:schemeClr val="tx2"/>
                 </a:solidFill>
               </a:rPr>
-              <a:t>AnyLoc (DINOv2 features + VLAD) compares every photo with the photos taken at other times (on another drive, or much later on the same drive) and proposes pairs that look like the same place. SuperGlue then matches keypoints between the two photos of each pair, and the pair is kept only if the matches fit one camera motion (RANSAC) for 8 or more pairs in a row. Each kept pair becomes a shortcut link.</a:t>
-            </a:r>
-            <a:endParaRPr lang="en-US" sz="1350" dirty="0"/>
+              <a:t>AnyLoc (DINOv2 features + VLAD) compares every photo with the photos taken at other times (on another drive, or much later on the same drive) and proposes pairs that look like the same place. SuperGlue then matches keypoints between the two photos of each pair, and the pair is kept only if the matches fit one camera motion (RANSAC) for 8 or more pairs in a row (a look-alike wall usually matches for only 1–3 photos in a row). Each kept pair becomes a shortcut link.</a:t>
+            </a:r>
+            <a:endParaRPr lang="en-US" sz="1300" dirty="0"/>
           </a:p>
         </p:txBody>
       </p:sp>
@@ -3074,7 +2794,7 @@
         </p:nvSpPr>
         <p:spPr>
           <a:xfrm>
-            <a:off x="548640" y="3698748"/>
+            <a:off x="548640" y="3788664"/>
             <a:ext cx="292608" cy="292608"/>
           </a:xfrm>
           <a:prstGeom prst="ellipse">
@@ -3099,7 +2819,7 @@
         </p:nvSpPr>
         <p:spPr>
           <a:xfrm>
-            <a:off x="548640" y="3698748"/>
+            <a:off x="548640" y="3788664"/>
             <a:ext cx="292608" cy="292608"/>
           </a:xfrm>
           <a:prstGeom prst="rect">
@@ -3112,7 +2832,7 @@
           <a:bodyPr wrap="square" lIns="0" tIns="0" rIns="0" bIns="0" rtlCol="0" anchor="ctr"/>
           <a:lstStyle/>
           <a:p>
-            <a:pPr algn="ctr" indent="0" marL="0">
+            <a:pPr marL="0" indent="0" algn="ctr">
               <a:buNone/>
             </a:pPr>
             <a:r>
@@ -3135,8 +2855,8 @@
         </p:nvSpPr>
         <p:spPr>
           <a:xfrm>
-            <a:off x="978408" y="3680460"/>
-            <a:ext cx="6702552" cy="672084"/>
+            <a:off x="978408" y="3770376"/>
+            <a:ext cx="6702552" cy="649224"/>
           </a:xfrm>
           <a:prstGeom prst="rect">
             <a:avLst/>
@@ -3148,29 +2868,26 @@
           <a:bodyPr wrap="square" lIns="0" tIns="0" rIns="0" bIns="0" rtlCol="0" anchor="t"/>
           <a:lstStyle/>
           <a:p>
-            <a:pPr indent="0" marL="0">
-              <a:buNone/>
-            </a:pPr>
-            <a:r>
-              <a:rPr lang="en-US" sz="1350" b="1" dirty="0">
+            <a:pPr marL="0" indent="0">
+              <a:buNone/>
+            </a:pPr>
+            <a:r>
+              <a:rPr lang="en-US" sz="1300" b="1" dirty="0">
                 <a:solidFill>
                   <a:schemeClr val="tx1"/>
                 </a:solidFill>
               </a:rPr>
               <a:t>Distances. </a:t>
             </a:r>
-            <a:pPr indent="0" marL="0">
-              <a:buNone/>
-            </a:pPr>
-            <a:r>
-              <a:rPr lang="en-US" sz="1350" dirty="0">
+            <a:r>
+              <a:rPr lang="en-US" sz="1300" dirty="0">
                 <a:solidFill>
                   <a:schemeClr val="tx2"/>
                 </a:solidFill>
               </a:rPr>
               <a:t>Lines on the walls give a compass direction, SuperGlue gives the turn between neighbouring photos, and the links close the loops. This places every photo in metres, so each link gets a cost in steps.</a:t>
             </a:r>
-            <a:endParaRPr lang="en-US" sz="1350" dirty="0"/>
+            <a:endParaRPr lang="en-US" sz="1300" dirty="0"/>
           </a:p>
         </p:txBody>
       </p:sp>
@@ -3182,7 +2899,7 @@
         </p:nvSpPr>
         <p:spPr>
           <a:xfrm>
-            <a:off x="548640" y="4553712"/>
+            <a:off x="548640" y="4593336"/>
             <a:ext cx="7132320" cy="347472"/>
           </a:xfrm>
           <a:prstGeom prst="roundRect">
@@ -3209,7 +2926,7 @@
         </p:nvSpPr>
         <p:spPr>
           <a:xfrm>
-            <a:off x="731520" y="4553712"/>
+            <a:off x="731520" y="4593336"/>
             <a:ext cx="6766560" cy="347472"/>
           </a:xfrm>
           <a:prstGeom prst="rect">
@@ -3222,7 +2939,7 @@
           <a:bodyPr wrap="square" lIns="0" tIns="0" rIns="0" bIns="0" rtlCol="0" anchor="ctr"/>
           <a:lstStyle/>
           <a:p>
-            <a:pPr indent="0" marL="0">
+            <a:pPr marL="0" indent="0">
               <a:buNone/>
             </a:pPr>
             <a:r>
@@ -3245,7 +2962,7 @@
         </p:nvSpPr>
         <p:spPr>
           <a:xfrm>
-            <a:off x="548640" y="5056632"/>
+            <a:off x="548640" y="5050536"/>
             <a:ext cx="292608" cy="292608"/>
           </a:xfrm>
           <a:prstGeom prst="ellipse">
@@ -3270,7 +2987,7 @@
         </p:nvSpPr>
         <p:spPr>
           <a:xfrm>
-            <a:off x="548640" y="5056632"/>
+            <a:off x="548640" y="5050536"/>
             <a:ext cx="292608" cy="292608"/>
           </a:xfrm>
           <a:prstGeom prst="rect">
@@ -3283,7 +3000,7 @@
           <a:bodyPr wrap="square" lIns="0" tIns="0" rIns="0" bIns="0" rtlCol="0" anchor="ctr"/>
           <a:lstStyle/>
           <a:p>
-            <a:pPr algn="ctr" indent="0" marL="0">
+            <a:pPr marL="0" indent="0" algn="ctr">
               <a:buNone/>
             </a:pPr>
             <a:r>
@@ -3306,8 +3023,8 @@
         </p:nvSpPr>
         <p:spPr>
           <a:xfrm>
-            <a:off x="978408" y="5038344"/>
-            <a:ext cx="6702552" cy="466344"/>
+            <a:off x="978408" y="5032248"/>
+            <a:ext cx="6702552" cy="649224"/>
           </a:xfrm>
           <a:prstGeom prst="rect">
             <a:avLst/>
@@ -3319,29 +3036,26 @@
           <a:bodyPr wrap="square" lIns="0" tIns="0" rIns="0" bIns="0" rtlCol="0" anchor="t"/>
           <a:lstStyle/>
           <a:p>
-            <a:pPr indent="0" marL="0">
-              <a:buNone/>
-            </a:pPr>
-            <a:r>
-              <a:rPr lang="en-US" sz="1350" b="1" dirty="0">
+            <a:pPr marL="0" indent="0">
+              <a:buNone/>
+            </a:pPr>
+            <a:r>
+              <a:rPr lang="en-US" sz="1300" b="1" dirty="0">
                 <a:solidFill>
                   <a:schemeClr val="tx1"/>
                 </a:solidFill>
               </a:rPr>
               <a:t>The goal. </a:t>
             </a:r>
-            <a:pPr indent="0" marL="0">
-              <a:buNone/>
-            </a:pPr>
-            <a:r>
-              <a:rPr lang="en-US" sz="1350" dirty="0">
+            <a:r>
+              <a:rPr lang="en-US" sz="1300" dirty="0">
                 <a:solidFill>
                   <a:schemeClr val="tx2"/>
                 </a:solidFill>
               </a:rPr>
-              <a:t>Each of the 4 goal photos is compared with the 64 exploration photos AnyLoc finds most similar. The exploration photo with the most SuperGlue matches becomes the goal node.</a:t>
-            </a:r>
-            <a:endParaRPr lang="en-US" sz="1350" dirty="0"/>
+              <a:t>Each of the 4 goal photos is compared with the 64 exploration photos AnyLoc finds most similar. The exploration photo with the most SuperGlue matches becomes the goal node. Checking 64 candidates instead of 6 picked the right goal in 12 of our 13 test mazes, up from 9.</a:t>
+            </a:r>
+            <a:endParaRPr lang="en-US" sz="1300" dirty="0"/>
           </a:p>
         </p:txBody>
       </p:sp>
@@ -3353,7 +3067,7 @@
         </p:nvSpPr>
         <p:spPr>
           <a:xfrm>
-            <a:off x="548640" y="5660136"/>
+            <a:off x="548640" y="5809488"/>
             <a:ext cx="292608" cy="292608"/>
           </a:xfrm>
           <a:prstGeom prst="ellipse">
@@ -3378,7 +3092,7 @@
         </p:nvSpPr>
         <p:spPr>
           <a:xfrm>
-            <a:off x="548640" y="5660136"/>
+            <a:off x="548640" y="5809488"/>
             <a:ext cx="292608" cy="292608"/>
           </a:xfrm>
           <a:prstGeom prst="rect">
@@ -3391,7 +3105,7 @@
           <a:bodyPr wrap="square" lIns="0" tIns="0" rIns="0" bIns="0" rtlCol="0" anchor="ctr"/>
           <a:lstStyle/>
           <a:p>
-            <a:pPr algn="ctr" indent="0" marL="0">
+            <a:pPr marL="0" indent="0" algn="ctr">
               <a:buNone/>
             </a:pPr>
             <a:r>
@@ -3414,8 +3128,8 @@
         </p:nvSpPr>
         <p:spPr>
           <a:xfrm>
-            <a:off x="978408" y="5641848"/>
-            <a:ext cx="6702552" cy="260604"/>
+            <a:off x="978408" y="5791200"/>
+            <a:ext cx="6702552" cy="252984"/>
           </a:xfrm>
           <a:prstGeom prst="rect">
             <a:avLst/>
@@ -3427,50 +3141,47 @@
           <a:bodyPr wrap="square" lIns="0" tIns="0" rIns="0" bIns="0" rtlCol="0" anchor="t"/>
           <a:lstStyle/>
           <a:p>
-            <a:pPr indent="0" marL="0">
-              <a:buNone/>
-            </a:pPr>
-            <a:r>
-              <a:rPr lang="en-US" sz="1350" b="1" dirty="0">
+            <a:pPr marL="0" indent="0">
+              <a:buNone/>
+            </a:pPr>
+            <a:r>
+              <a:rPr lang="en-US" sz="1300" b="1" dirty="0">
                 <a:solidFill>
                   <a:schemeClr val="tx1"/>
                 </a:solidFill>
               </a:rPr>
               <a:t>The route. </a:t>
             </a:r>
-            <a:pPr indent="0" marL="0">
-              <a:buNone/>
-            </a:pPr>
-            <a:r>
-              <a:rPr lang="en-US" sz="1350" dirty="0">
+            <a:r>
+              <a:rPr lang="en-US" sz="1300" dirty="0">
                 <a:solidFill>
                   <a:schemeClr val="tx2"/>
                 </a:solidFill>
               </a:rPr>
               <a:t>Dijkstra finds the cheapest route, in steps, from every photo to the goal node.</a:t>
             </a:r>
-            <a:endParaRPr lang="en-US" sz="1350" dirty="0"/>
+            <a:endParaRPr lang="en-US" sz="1300" dirty="0"/>
           </a:p>
         </p:txBody>
       </p:sp>
       <p:pic>
         <p:nvPicPr>
-          <p:cNvPr id="23" name="goal example 1" descr="Local maze 25: goal photo it is given">    </p:cNvPr>
+          <p:cNvPr id="23" name="photo map figure" descr="Local test maze 25 with its walls, the three exploration drives at their true positions in blue, green and purple, and the shortcut links the robot found between photos of one place in orange"/>
           <p:cNvPicPr>
             <a:picLocks noChangeAspect="1"/>
           </p:cNvPicPr>
           <p:nvPr/>
         </p:nvPicPr>
         <p:blipFill>
-          <a:blip r:embed="rId1"/>
+          <a:blip r:embed="rId3"/>
           <a:stretch>
             <a:fillRect/>
           </a:stretch>
         </p:blipFill>
         <p:spPr>
           <a:xfrm>
-            <a:off x="8366760" y="1417320"/>
-            <a:ext cx="2697480" cy="2020824"/>
+            <a:off x="8229600" y="1371600"/>
+            <a:ext cx="2514600" cy="2514600"/>
           </a:xfrm>
           <a:prstGeom prst="rect">
             <a:avLst/>
@@ -3479,100 +3190,96 @@
       </p:pic>
       <p:sp>
         <p:nvSpPr>
-          <p:cNvPr id="24" name="goal example label 1"/>
+          <p:cNvPr id="24" name="photo map caption"/>
           <p:cNvSpPr txBox="1"/>
           <p:nvPr/>
         </p:nvSpPr>
         <p:spPr>
           <a:xfrm>
-            <a:off x="8366760" y="3474720"/>
-            <a:ext cx="3108960" cy="256032"/>
-          </a:xfrm>
-          <a:prstGeom prst="rect">
-            <a:avLst/>
-          </a:prstGeom>
-          <a:noFill/>
-          <a:ln/>
-        </p:spPr>
-        <p:txBody>
-          <a:bodyPr wrap="square" lIns="0" tIns="0" rIns="0" bIns="0" rtlCol="0" anchor="ctr"/>
-          <a:lstStyle/>
-          <a:p>
-            <a:pPr indent="0" marL="0">
-              <a:buNone/>
-            </a:pPr>
-            <a:r>
-              <a:rPr lang="en-US" sz="1150" b="1" dirty="0">
+            <a:off x="8229600" y="3941064"/>
+            <a:ext cx="3429000" cy="566928"/>
+          </a:xfrm>
+          <a:prstGeom prst="rect">
+            <a:avLst/>
+          </a:prstGeom>
+          <a:noFill/>
+          <a:ln/>
+        </p:spPr>
+        <p:txBody>
+          <a:bodyPr wrap="square" lIns="0" tIns="0" rIns="0" bIns="0" rtlCol="0" anchor="t"/>
+          <a:lstStyle/>
+          <a:p>
+            <a:pPr marL="0" indent="0">
+              <a:buNone/>
+            </a:pPr>
+            <a:r>
+              <a:rPr lang="en-US" sz="1000" b="1" dirty="0">
                 <a:solidFill>
                   <a:schemeClr val="tx1"/>
                 </a:solidFill>
               </a:rPr>
-              <a:t>Goal photo it is given</a:t>
-            </a:r>
-            <a:endParaRPr lang="en-US" sz="1150" dirty="0"/>
+              <a:t>Steps 1–2 on local test maze 25. </a:t>
+            </a:r>
+            <a:r>
+              <a:rPr lang="en-US" sz="1000" dirty="0">
+                <a:solidFill>
+                  <a:schemeClr val="tx2"/>
+                </a:solidFill>
+              </a:rPr>
+              <a:t>The three drives (blue, green, purple) and the 480 shortcut links the robot found (orange): 466 of them (97%) join photos in the same corridor.</a:t>
+            </a:r>
+            <a:endParaRPr lang="en-US" sz="1000" dirty="0"/>
           </a:p>
         </p:txBody>
       </p:sp>
       <p:pic>
         <p:nvPicPr>
-          <p:cNvPr id="25" name="goal example 2" descr="Local maze 25: exploration photo it picks as the goal (step 4)">    </p:cNvPr>
+          <p:cNvPr id="25" name="goal example 1" descr="Local maze 25: the goal photo it is given"/>
           <p:cNvPicPr>
             <a:picLocks noChangeAspect="1"/>
           </p:cNvPicPr>
           <p:nvPr/>
         </p:nvPicPr>
         <p:blipFill>
-          <a:blip r:embed="rId2"/>
+          <a:blip r:embed="rId4"/>
           <a:stretch>
             <a:fillRect/>
           </a:stretch>
         </p:blipFill>
         <p:spPr>
           <a:xfrm>
-            <a:off x="8366760" y="3794760"/>
-            <a:ext cx="2697480" cy="2020824"/>
+            <a:off x="8229600" y="4572000"/>
+            <a:ext cx="1677924" cy="1258443"/>
           </a:xfrm>
           <a:prstGeom prst="rect">
             <a:avLst/>
           </a:prstGeom>
         </p:spPr>
       </p:pic>
-      <p:sp>
-        <p:nvSpPr>
-          <p:cNvPr id="26" name="goal example label 2"/>
-          <p:cNvSpPr txBox="1"/>
-          <p:nvPr/>
-        </p:nvSpPr>
-        <p:spPr>
-          <a:xfrm>
-            <a:off x="8366760" y="5852160"/>
-            <a:ext cx="3108960" cy="256032"/>
-          </a:xfrm>
-          <a:prstGeom prst="rect">
-            <a:avLst/>
-          </a:prstGeom>
-          <a:noFill/>
-          <a:ln/>
-        </p:spPr>
-        <p:txBody>
-          <a:bodyPr wrap="square" lIns="0" tIns="0" rIns="0" bIns="0" rtlCol="0" anchor="ctr"/>
-          <a:lstStyle/>
-          <a:p>
-            <a:pPr indent="0" marL="0">
-              <a:buNone/>
-            </a:pPr>
-            <a:r>
-              <a:rPr lang="en-US" sz="1150" b="1" dirty="0">
-                <a:solidFill>
-                  <a:schemeClr val="tx1"/>
-                </a:solidFill>
-              </a:rPr>
-              <a:t>Exploration photo it picks as the goal (step 4)</a:t>
-            </a:r>
-            <a:endParaRPr lang="en-US" sz="1150" dirty="0"/>
-          </a:p>
-        </p:txBody>
-      </p:sp>
+      <p:pic>
+        <p:nvPicPr>
+          <p:cNvPr id="26" name="goal example 2" descr="Local maze 25: the exploration photo it picks as the goal"/>
+          <p:cNvPicPr>
+            <a:picLocks noChangeAspect="1"/>
+          </p:cNvPicPr>
+          <p:nvPr/>
+        </p:nvPicPr>
+        <p:blipFill>
+          <a:blip r:embed="rId5"/>
+          <a:stretch>
+            <a:fillRect/>
+          </a:stretch>
+        </p:blipFill>
+        <p:spPr>
+          <a:xfrm>
+            <a:off x="9980676" y="4572000"/>
+            <a:ext cx="1677924" cy="1258443"/>
+          </a:xfrm>
+          <a:prstGeom prst="rect">
+            <a:avLst/>
+          </a:prstGeom>
+        </p:spPr>
+      </p:pic>
       <p:sp>
         <p:nvSpPr>
           <p:cNvPr id="27" name="goal example caption"/>
@@ -3581,37 +3288,45 @@
         </p:nvSpPr>
         <p:spPr>
           <a:xfrm>
-            <a:off x="8366760" y="6035040"/>
-            <a:ext cx="3108960" cy="256032"/>
-          </a:xfrm>
-          <a:prstGeom prst="rect">
-            <a:avLst/>
-          </a:prstGeom>
-          <a:noFill/>
-          <a:ln/>
-        </p:spPr>
-        <p:txBody>
-          <a:bodyPr wrap="square" lIns="0" tIns="0" rIns="0" bIns="0" rtlCol="0" anchor="ctr"/>
-          <a:lstStyle/>
-          <a:p>
-            <a:pPr indent="0" marL="0">
-              <a:buNone/>
-            </a:pPr>
-            <a:r>
-              <a:rPr lang="en-US" sz="1050" i="1" dirty="0">
+            <a:off x="8229600" y="5885307"/>
+            <a:ext cx="3429000" cy="411480"/>
+          </a:xfrm>
+          <a:prstGeom prst="rect">
+            <a:avLst/>
+          </a:prstGeom>
+          <a:noFill/>
+          <a:ln/>
+        </p:spPr>
+        <p:txBody>
+          <a:bodyPr wrap="square" lIns="0" tIns="0" rIns="0" bIns="0" rtlCol="0" anchor="t"/>
+          <a:lstStyle/>
+          <a:p>
+            <a:pPr marL="0" indent="0">
+              <a:buNone/>
+            </a:pPr>
+            <a:r>
+              <a:rPr lang="en-US" sz="1000" b="1" dirty="0">
+                <a:solidFill>
+                  <a:schemeClr val="tx1"/>
+                </a:solidFill>
+              </a:rPr>
+              <a:t>Step 4. </a:t>
+            </a:r>
+            <a:r>
+              <a:rPr lang="en-US" sz="1000" dirty="0">
                 <a:solidFill>
                   <a:schemeClr val="tx2"/>
                 </a:solidFill>
               </a:rPr>
-              <a:t>Example from local test maze 25</a:t>
-            </a:r>
-            <a:endParaRPr lang="en-US" sz="1050" dirty="0"/>
-          </a:p>
-        </p:txBody>
-      </p:sp>
-      <p:sp>
-        <p:nvSpPr>
-          <p:cNvPr id="25" name="Slide Number Placeholder 0"/>
+              <a:t>The goal photo it is given (left) and the exploration photo it picks as the goal node (right).</a:t>
+            </a:r>
+            <a:endParaRPr lang="en-US" sz="1000" dirty="0"/>
+          </a:p>
+        </p:txBody>
+      </p:sp>
+      <p:sp>
+        <p:nvSpPr>
+          <p:cNvPr id="28" name="Slide Number Placeholder 0"/>
           <p:cNvSpPr>
             <a:spLocks noGrp="1"/>
           </p:cNvSpPr>
@@ -3629,7 +3344,7 @@
           </a:prstGeom>
           <a:extLst>
             <a:ext uri="{C572A759-6A51-4108-AA02-DFA0A04FC94B}">
-              <ma14:wrappingTextBoxFlag xmlns:ma14="http://schemas.microsoft.com/office/mac/drawingml/2011/main" val="0"/>
+              <ma14:wrappingTextBoxFlag xmlns:ma14="http://schemas.microsoft.com/office/mac/drawingml/2011/main" xmlns="" val="0"/>
             </a:ext>
           </a:extLst>
         </p:spPr>
@@ -3647,7 +3362,7 @@
           <a:p>
             <a:pPr algn="r"/>
             <a:fld id="{F7021451-1387-4CA6-816F-3879F97B5CBC}" type="slidenum">
-              <a:rPr b="0" lang="en-US"/>
+              <a:rPr lang="en-US" b="0"/>
               <a:t>3</a:t>
             </a:fld>
             <a:endParaRPr lang="en-US"/>
@@ -3700,11 +3415,11 @@
           <a:bodyPr wrap="square" lIns="0" tIns="0" rIns="0" bIns="0" rtlCol="0" anchor="ctr"/>
           <a:lstStyle/>
           <a:p>
-            <a:pPr indent="0" marL="0">
-              <a:buNone/>
-            </a:pPr>
-            <a:r>
-              <a:rPr lang="en-US" sz="1100" b="1" spc="200" kern="0" dirty="0">
+            <a:pPr marL="0" indent="0">
+              <a:buNone/>
+            </a:pPr>
+            <a:r>
+              <a:rPr lang="en-US" sz="1100" b="1" kern="0" spc="200" dirty="0">
                 <a:solidFill>
                   <a:schemeClr val="accent2"/>
                 </a:solidFill>
@@ -3718,9 +3433,11 @@
       <p:sp>
         <p:nvSpPr>
           <p:cNvPr id="3" name="Text 0"/>
-          <p:cNvSpPr/>
+          <p:cNvSpPr>
+            <a:spLocks noGrp="1"/>
+          </p:cNvSpPr>
           <p:nvPr>
-            <p:ph idx="100" type="title" hasCustomPrompt="1"/>
+            <p:ph type="title" idx="100" hasCustomPrompt="1"/>
           </p:nvPr>
         </p:nvSpPr>
         <p:spPr>
@@ -3738,7 +3455,7 @@
           <a:bodyPr wrap="square" lIns="0" tIns="0" rIns="0" bIns="0" rtlCol="0" anchor="ctr"/>
           <a:lstStyle/>
           <a:p>
-            <a:pPr algn="l" indent="0" marL="0">
+            <a:pPr marL="0" indent="0" algn="l">
               <a:buNone/>
             </a:pPr>
             <a:r>
@@ -3801,7 +3518,7 @@
           <a:bodyPr wrap="square" lIns="0" tIns="0" rIns="0" bIns="0" rtlCol="0" anchor="ctr"/>
           <a:lstStyle/>
           <a:p>
-            <a:pPr indent="0" marL="0">
+            <a:pPr marL="0" indent="0">
               <a:buNone/>
             </a:pPr>
             <a:r>
@@ -3862,7 +3579,7 @@
           <a:bodyPr wrap="square" lIns="0" tIns="0" rIns="0" bIns="0" rtlCol="0" anchor="ctr"/>
           <a:lstStyle/>
           <a:p>
-            <a:pPr algn="ctr" indent="0" marL="0">
+            <a:pPr marL="0" indent="0" algn="ctr">
               <a:buNone/>
             </a:pPr>
             <a:r>
@@ -3898,7 +3615,7 @@
           <a:bodyPr wrap="square" lIns="0" tIns="0" rIns="0" bIns="0" rtlCol="0" anchor="t"/>
           <a:lstStyle/>
           <a:p>
-            <a:pPr indent="0" marL="0">
+            <a:pPr marL="0" indent="0">
               <a:buNone/>
             </a:pPr>
             <a:r>
@@ -3909,9 +3626,6 @@
               </a:rPr>
               <a:t>Where am I? </a:t>
             </a:r>
-            <a:pPr indent="0" marL="0">
-              <a:buNone/>
-            </a:pPr>
             <a:r>
               <a:rPr lang="en-US" sz="1300" dirty="0">
                 <a:solidFill>
@@ -3932,7 +3646,7 @@
         </p:nvSpPr>
         <p:spPr>
           <a:xfrm>
-            <a:off x="548640" y="2706624"/>
+            <a:off x="548640" y="2642616"/>
             <a:ext cx="292608" cy="292608"/>
           </a:xfrm>
           <a:prstGeom prst="ellipse">
@@ -3957,7 +3671,7 @@
         </p:nvSpPr>
         <p:spPr>
           <a:xfrm>
-            <a:off x="548640" y="2706624"/>
+            <a:off x="548640" y="2642616"/>
             <a:ext cx="292608" cy="292608"/>
           </a:xfrm>
           <a:prstGeom prst="rect">
@@ -3970,7 +3684,7 @@
           <a:bodyPr wrap="square" lIns="0" tIns="0" rIns="0" bIns="0" rtlCol="0" anchor="ctr"/>
           <a:lstStyle/>
           <a:p>
-            <a:pPr algn="ctr" indent="0" marL="0">
+            <a:pPr marL="0" indent="0" algn="ctr">
               <a:buNone/>
             </a:pPr>
             <a:r>
@@ -3993,7 +3707,7 @@
         </p:nvSpPr>
         <p:spPr>
           <a:xfrm>
-            <a:off x="978408" y="2688336"/>
+            <a:off x="978408" y="2624328"/>
             <a:ext cx="6885432" cy="252984"/>
           </a:xfrm>
           <a:prstGeom prst="rect">
@@ -4006,7 +3720,7 @@
           <a:bodyPr wrap="square" lIns="0" tIns="0" rIns="0" bIns="0" rtlCol="0" anchor="t"/>
           <a:lstStyle/>
           <a:p>
-            <a:pPr indent="0" marL="0">
+            <a:pPr marL="0" indent="0">
               <a:buNone/>
             </a:pPr>
             <a:r>
@@ -4017,9 +3731,6 @@
               </a:rPr>
               <a:t>Where next? </a:t>
             </a:r>
-            <a:pPr indent="0" marL="0">
-              <a:buNone/>
-            </a:pPr>
             <a:r>
               <a:rPr lang="en-US" sz="1300" dirty="0">
                 <a:solidFill>
@@ -4040,7 +3751,7 @@
         </p:nvSpPr>
         <p:spPr>
           <a:xfrm>
-            <a:off x="548640" y="3142488"/>
+            <a:off x="548640" y="3014472"/>
             <a:ext cx="292608" cy="292608"/>
           </a:xfrm>
           <a:prstGeom prst="ellipse">
@@ -4065,7 +3776,7 @@
         </p:nvSpPr>
         <p:spPr>
           <a:xfrm>
-            <a:off x="548640" y="3142488"/>
+            <a:off x="548640" y="3014472"/>
             <a:ext cx="292608" cy="292608"/>
           </a:xfrm>
           <a:prstGeom prst="rect">
@@ -4078,7 +3789,7 @@
           <a:bodyPr wrap="square" lIns="0" tIns="0" rIns="0" bIns="0" rtlCol="0" anchor="ctr"/>
           <a:lstStyle/>
           <a:p>
-            <a:pPr algn="ctr" indent="0" marL="0">
+            <a:pPr marL="0" indent="0" algn="ctr">
               <a:buNone/>
             </a:pPr>
             <a:r>
@@ -4101,7 +3812,7 @@
         </p:nvSpPr>
         <p:spPr>
           <a:xfrm>
-            <a:off x="978408" y="3124200"/>
+            <a:off x="978408" y="2996184"/>
             <a:ext cx="6885432" cy="847344"/>
           </a:xfrm>
           <a:prstGeom prst="rect">
@@ -4114,7 +3825,7 @@
           <a:bodyPr wrap="square" lIns="0" tIns="0" rIns="0" bIns="0" rtlCol="0" anchor="t"/>
           <a:lstStyle/>
           <a:p>
-            <a:pPr indent="0" marL="0">
+            <a:pPr marL="0" indent="0">
               <a:buNone/>
             </a:pPr>
             <a:r>
@@ -4125,9 +3836,6 @@
               </a:rPr>
               <a:t>Turn and drive. </a:t>
             </a:r>
-            <a:pPr indent="0" marL="0">
-              <a:buNone/>
-            </a:pPr>
             <a:r>
               <a:rPr lang="en-US" sz="1300" dirty="0">
                 <a:solidFill>
@@ -4148,7 +3856,7 @@
         </p:nvSpPr>
         <p:spPr>
           <a:xfrm>
-            <a:off x="548640" y="4172712"/>
+            <a:off x="548640" y="3980688"/>
             <a:ext cx="292608" cy="292608"/>
           </a:xfrm>
           <a:prstGeom prst="ellipse">
@@ -4173,7 +3881,7 @@
         </p:nvSpPr>
         <p:spPr>
           <a:xfrm>
-            <a:off x="548640" y="4172712"/>
+            <a:off x="548640" y="3980688"/>
             <a:ext cx="292608" cy="292608"/>
           </a:xfrm>
           <a:prstGeom prst="rect">
@@ -4186,7 +3894,7 @@
           <a:bodyPr wrap="square" lIns="0" tIns="0" rIns="0" bIns="0" rtlCol="0" anchor="ctr"/>
           <a:lstStyle/>
           <a:p>
-            <a:pPr algn="ctr" indent="0" marL="0">
+            <a:pPr marL="0" indent="0" algn="ctr">
               <a:buNone/>
             </a:pPr>
             <a:r>
@@ -4209,7 +3917,7 @@
         </p:nvSpPr>
         <p:spPr>
           <a:xfrm>
-            <a:off x="978408" y="4154424"/>
+            <a:off x="978408" y="3962400"/>
             <a:ext cx="6885432" cy="451104"/>
           </a:xfrm>
           <a:prstGeom prst="rect">
@@ -4222,7 +3930,7 @@
           <a:bodyPr wrap="square" lIns="0" tIns="0" rIns="0" bIns="0" rtlCol="0" anchor="t"/>
           <a:lstStyle/>
           <a:p>
-            <a:pPr indent="0" marL="0">
+            <a:pPr marL="0" indent="0">
               <a:buNone/>
             </a:pPr>
             <a:r>
@@ -4233,9 +3941,6 @@
               </a:rPr>
               <a:t>Backing out. </a:t>
             </a:r>
-            <a:pPr indent="0" marL="0">
-              <a:buNone/>
-            </a:pPr>
             <a:r>
               <a:rPr lang="en-US" sz="1300" dirty="0">
                 <a:solidFill>
@@ -4256,7 +3961,7 @@
         </p:nvSpPr>
         <p:spPr>
           <a:xfrm>
-            <a:off x="548640" y="4806696"/>
+            <a:off x="548640" y="4550664"/>
             <a:ext cx="292608" cy="292608"/>
           </a:xfrm>
           <a:prstGeom prst="ellipse">
@@ -4281,7 +3986,7 @@
         </p:nvSpPr>
         <p:spPr>
           <a:xfrm>
-            <a:off x="548640" y="4806696"/>
+            <a:off x="548640" y="4550664"/>
             <a:ext cx="292608" cy="292608"/>
           </a:xfrm>
           <a:prstGeom prst="rect">
@@ -4294,7 +3999,7 @@
           <a:bodyPr wrap="square" lIns="0" tIns="0" rIns="0" bIns="0" rtlCol="0" anchor="ctr"/>
           <a:lstStyle/>
           <a:p>
-            <a:pPr algn="ctr" indent="0" marL="0">
+            <a:pPr marL="0" indent="0" algn="ctr">
               <a:buNone/>
             </a:pPr>
             <a:r>
@@ -4317,7 +4022,7 @@
         </p:nvSpPr>
         <p:spPr>
           <a:xfrm>
-            <a:off x="978408" y="4788408"/>
+            <a:off x="978408" y="4532376"/>
             <a:ext cx="6885432" cy="649224"/>
           </a:xfrm>
           <a:prstGeom prst="rect">
@@ -4330,7 +4035,7 @@
           <a:bodyPr wrap="square" lIns="0" tIns="0" rIns="0" bIns="0" rtlCol="0" anchor="t"/>
           <a:lstStyle/>
           <a:p>
-            <a:pPr indent="0" marL="0">
+            <a:pPr marL="0" indent="0">
               <a:buNone/>
             </a:pPr>
             <a:r>
@@ -4341,9 +4046,6 @@
               </a:rPr>
               <a:t>When stuck. </a:t>
             </a:r>
-            <a:pPr indent="0" marL="0">
-              <a:buNone/>
-            </a:pPr>
             <a:r>
               <a:rPr lang="en-US" sz="1300" dirty="0">
                 <a:solidFill>
@@ -4364,7 +4066,7 @@
         </p:nvSpPr>
         <p:spPr>
           <a:xfrm>
-            <a:off x="548640" y="5638800"/>
+            <a:off x="548640" y="5318760"/>
             <a:ext cx="292608" cy="292608"/>
           </a:xfrm>
           <a:prstGeom prst="ellipse">
@@ -4389,7 +4091,7 @@
         </p:nvSpPr>
         <p:spPr>
           <a:xfrm>
-            <a:off x="548640" y="5638800"/>
+            <a:off x="548640" y="5318760"/>
             <a:ext cx="292608" cy="292608"/>
           </a:xfrm>
           <a:prstGeom prst="rect">
@@ -4402,7 +4104,7 @@
           <a:bodyPr wrap="square" lIns="0" tIns="0" rIns="0" bIns="0" rtlCol="0" anchor="ctr"/>
           <a:lstStyle/>
           <a:p>
-            <a:pPr algn="ctr" indent="0" marL="0">
+            <a:pPr marL="0" indent="0" algn="ctr">
               <a:buNone/>
             </a:pPr>
             <a:r>
@@ -4425,8 +4127,8 @@
         </p:nvSpPr>
         <p:spPr>
           <a:xfrm>
-            <a:off x="978408" y="5620512"/>
-            <a:ext cx="6885432" cy="649224"/>
+            <a:off x="978408" y="5300472"/>
+            <a:ext cx="6885432" cy="847344"/>
           </a:xfrm>
           <a:prstGeom prst="rect">
             <a:avLst/>
@@ -4438,7 +4140,7 @@
           <a:bodyPr wrap="square" lIns="0" tIns="0" rIns="0" bIns="0" rtlCol="0" anchor="t"/>
           <a:lstStyle/>
           <a:p>
-            <a:pPr indent="0" marL="0">
+            <a:pPr marL="0" indent="0">
               <a:buNone/>
             </a:pPr>
             <a:r>
@@ -4449,16 +4151,13 @@
               </a:rPr>
               <a:t>The last metre. </a:t>
             </a:r>
-            <a:pPr indent="0" marL="0">
-              <a:buNone/>
-            </a:pPr>
             <a:r>
               <a:rPr lang="en-US" sz="1300" dirty="0">
                 <a:solidFill>
                   <a:schemeClr val="tx2"/>
                 </a:solidFill>
               </a:rPr>
-              <a:t>Within 3 photos of the goal it matches the camera image with the 4 goal photos directly. It turns until the front photo lines up, moves until the scene looks the same size, and checks in only after 3 readings in a row with 35 or more matched points.</a:t>
+              <a:t>Within 3 photos of the goal it matches the camera image with the 4 goal photos directly. It turns until the front photo lines up, moves until the scene looks the same size, and checks in only after 3 readings in a row with 35 or more matched points (in our tests, correct check-ins had 43–122 and wrong ones 21–25).</a:t>
             </a:r>
             <a:endParaRPr lang="en-US" sz="1300" dirty="0"/>
           </a:p>
@@ -4466,102 +4165,7 @@
       </p:sp>
       <p:pic>
         <p:nvPicPr>
-          <p:cNvPr id="24" name="turn example matches" descr="Two maze photos side by side with green lines joining 20 of the 73 keypoints SuperGlue matched between them">    </p:cNvPr>
-          <p:cNvPicPr>
-            <a:picLocks noChangeAspect="1"/>
-          </p:cNvPicPr>
-          <p:nvPr/>
-        </p:nvPicPr>
-        <p:blipFill>
-          <a:blip r:embed="rId1"/>
-          <a:stretch>
-            <a:fillRect/>
-          </a:stretch>
-        </p:blipFill>
-        <p:spPr>
-          <a:xfrm>
-            <a:off x="8092440" y="1417320"/>
-            <a:ext cx="3566160" cy="924357"/>
-          </a:xfrm>
-          <a:prstGeom prst="rect">
-            <a:avLst/>
-          </a:prstGeom>
-        </p:spPr>
-      </p:pic>
-      <p:sp>
-        <p:nvSpPr>
-          <p:cNvPr id="25" name="turn example caption"/>
-          <p:cNvSpPr txBox="1"/>
-          <p:nvPr/>
-        </p:nvSpPr>
-        <p:spPr>
-          <a:xfrm>
-            <a:off x="8092440" y="2414829"/>
-            <a:ext cx="3566160" cy="731520"/>
-          </a:xfrm>
-          <a:prstGeom prst="rect">
-            <a:avLst/>
-          </a:prstGeom>
-          <a:noFill/>
-          <a:ln/>
-        </p:spPr>
-        <p:txBody>
-          <a:bodyPr wrap="square" lIns="0" tIns="0" rIns="0" bIns="0" rtlCol="0" anchor="t"/>
-          <a:lstStyle/>
-          <a:p>
-            <a:pPr indent="0" marL="0">
-              <a:buNone/>
-            </a:pPr>
-            <a:r>
-              <a:rPr lang="en-US" sz="1050" b="1" dirty="0">
-                <a:solidFill>
-                  <a:schemeClr val="tx1"/>
-                </a:solidFill>
-              </a:rPr>
-              <a:t>Step 3, turn and drive. </a:t>
-            </a:r>
-            <a:pPr indent="0" marL="0">
-              <a:buNone/>
-            </a:pPr>
-            <a:r>
-              <a:rPr lang="en-US" sz="1050" dirty="0">
-                <a:solidFill>
-                  <a:schemeClr val="tx2"/>
-                </a:solidFill>
-              </a:rPr>
-              <a:t>SuperGlue matches between the camera image (left) and the waypoint photo (right). The essential matrix from these 73 matches gives the turn: 37°.</a:t>
-            </a:r>
-            <a:endParaRPr lang="en-US" sz="1050" dirty="0"/>
-          </a:p>
-        </p:txBody>
-      </p:sp>
-      <p:pic>
-        <p:nvPicPr>
-          <p:cNvPr id="26" name="last metre goal photo" descr="The goal photo the robot was given (front view)">    </p:cNvPr>
-          <p:cNvPicPr>
-            <a:picLocks noChangeAspect="1"/>
-          </p:cNvPicPr>
-          <p:nvPr/>
-        </p:nvPicPr>
-        <p:blipFill>
-          <a:blip r:embed="rId2"/>
-          <a:stretch>
-            <a:fillRect/>
-          </a:stretch>
-        </p:blipFill>
-        <p:spPr>
-          <a:xfrm>
-            <a:off x="8092440" y="3393237"/>
-            <a:ext cx="1741932" cy="1306449"/>
-          </a:xfrm>
-          <a:prstGeom prst="rect">
-            <a:avLst/>
-          </a:prstGeom>
-        </p:spPr>
-      </p:pic>
-      <p:pic>
-        <p:nvPicPr>
-          <p:cNvPr id="27" name="last metre camera" descr="The robot’s camera image when it checked in, 2 cm from the goal">    </p:cNvPr>
+          <p:cNvPr id="24" name="turn example matches" descr="Two maze photos side by side with green lines joining 20 of the 73 keypoints SuperGlue matched between them"/>
           <p:cNvPicPr>
             <a:picLocks noChangeAspect="1"/>
           </p:cNvPicPr>
@@ -4575,6 +4179,98 @@
         </p:blipFill>
         <p:spPr>
           <a:xfrm>
+            <a:off x="8092440" y="1417320"/>
+            <a:ext cx="3566160" cy="924357"/>
+          </a:xfrm>
+          <a:prstGeom prst="rect">
+            <a:avLst/>
+          </a:prstGeom>
+        </p:spPr>
+      </p:pic>
+      <p:sp>
+        <p:nvSpPr>
+          <p:cNvPr id="25" name="turn example caption"/>
+          <p:cNvSpPr txBox="1"/>
+          <p:nvPr/>
+        </p:nvSpPr>
+        <p:spPr>
+          <a:xfrm>
+            <a:off x="8092440" y="2414829"/>
+            <a:ext cx="3566160" cy="731520"/>
+          </a:xfrm>
+          <a:prstGeom prst="rect">
+            <a:avLst/>
+          </a:prstGeom>
+          <a:noFill/>
+          <a:ln/>
+        </p:spPr>
+        <p:txBody>
+          <a:bodyPr wrap="square" lIns="0" tIns="0" rIns="0" bIns="0" rtlCol="0" anchor="t"/>
+          <a:lstStyle/>
+          <a:p>
+            <a:pPr marL="0" indent="0">
+              <a:buNone/>
+            </a:pPr>
+            <a:r>
+              <a:rPr lang="en-US" sz="1050" b="1" dirty="0">
+                <a:solidFill>
+                  <a:schemeClr val="tx1"/>
+                </a:solidFill>
+              </a:rPr>
+              <a:t>Step 3, turn and drive. </a:t>
+            </a:r>
+            <a:r>
+              <a:rPr lang="en-US" sz="1050" dirty="0">
+                <a:solidFill>
+                  <a:schemeClr val="tx2"/>
+                </a:solidFill>
+              </a:rPr>
+              <a:t>SuperGlue matches between the camera image (left) and the waypoint photo (right). The essential matrix from these 73 matches gives the turn: 37°.</a:t>
+            </a:r>
+            <a:endParaRPr lang="en-US" sz="1050" dirty="0"/>
+          </a:p>
+        </p:txBody>
+      </p:sp>
+      <p:pic>
+        <p:nvPicPr>
+          <p:cNvPr id="26" name="last metre goal photo" descr="The goal photo the robot was given (front view)"/>
+          <p:cNvPicPr>
+            <a:picLocks noChangeAspect="1"/>
+          </p:cNvPicPr>
+          <p:nvPr/>
+        </p:nvPicPr>
+        <p:blipFill>
+          <a:blip r:embed="rId4"/>
+          <a:stretch>
+            <a:fillRect/>
+          </a:stretch>
+        </p:blipFill>
+        <p:spPr>
+          <a:xfrm>
+            <a:off x="8092440" y="3393237"/>
+            <a:ext cx="1741932" cy="1306449"/>
+          </a:xfrm>
+          <a:prstGeom prst="rect">
+            <a:avLst/>
+          </a:prstGeom>
+        </p:spPr>
+      </p:pic>
+      <p:pic>
+        <p:nvPicPr>
+          <p:cNvPr id="27" name="last metre camera" descr="The robot’s camera image when it checked in, 2 cm from the goal"/>
+          <p:cNvPicPr>
+            <a:picLocks noChangeAspect="1"/>
+          </p:cNvPicPr>
+          <p:nvPr/>
+        </p:nvPicPr>
+        <p:blipFill>
+          <a:blip r:embed="rId5"/>
+          <a:stretch>
+            <a:fillRect/>
+          </a:stretch>
+        </p:blipFill>
+        <p:spPr>
+          <a:xfrm>
             <a:off x="9916668" y="3393237"/>
             <a:ext cx="1741932" cy="1306449"/>
           </a:xfrm>
@@ -4604,7 +4300,7 @@
           <a:bodyPr wrap="square" lIns="0" tIns="0" rIns="0" bIns="0" rtlCol="0" anchor="t"/>
           <a:lstStyle/>
           <a:p>
-            <a:pPr indent="0" marL="0">
+            <a:pPr marL="0" indent="0">
               <a:buNone/>
             </a:pPr>
             <a:r>
@@ -4615,9 +4311,6 @@
               </a:rPr>
               <a:t>Step 6, the last metre. </a:t>
             </a:r>
-            <a:pPr indent="0" marL="0">
-              <a:buNone/>
-            </a:pPr>
             <a:r>
               <a:rPr lang="en-US" sz="1050" dirty="0">
                 <a:solidFill>
@@ -4651,7 +4344,7 @@
           <a:bodyPr wrap="square" lIns="0" tIns="0" rIns="0" bIns="0" rtlCol="0" anchor="ctr"/>
           <a:lstStyle/>
           <a:p>
-            <a:pPr indent="0" marL="0">
+            <a:pPr marL="0" indent="0">
               <a:buNone/>
             </a:pPr>
             <a:r>
@@ -4668,7 +4361,7 @@
       </p:sp>
       <p:sp>
         <p:nvSpPr>
-          <p:cNvPr id="25" name="Slide Number Placeholder 0"/>
+          <p:cNvPr id="30" name="Slide Number Placeholder 0"/>
           <p:cNvSpPr>
             <a:spLocks noGrp="1"/>
           </p:cNvSpPr>
@@ -4686,7 +4379,7 @@
           </a:prstGeom>
           <a:extLst>
             <a:ext uri="{C572A759-6A51-4108-AA02-DFA0A04FC94B}">
-              <ma14:wrappingTextBoxFlag xmlns:ma14="http://schemas.microsoft.com/office/mac/drawingml/2011/main" val="0"/>
+              <ma14:wrappingTextBoxFlag xmlns:ma14="http://schemas.microsoft.com/office/mac/drawingml/2011/main" xmlns="" val="0"/>
             </a:ext>
           </a:extLst>
         </p:spPr>
@@ -4704,7 +4397,7 @@
           <a:p>
             <a:pPr algn="r"/>
             <a:fld id="{F7021451-1387-4CA6-816F-3879F97B5CBC}" type="slidenum">
-              <a:rPr b="0" lang="en-US"/>
+              <a:rPr lang="en-US" b="0"/>
               <a:t>4</a:t>
             </a:fld>
             <a:endParaRPr lang="en-US"/>
@@ -5012,4 +4705,299 @@
     </a:ext>
   </a:extLst>
 </a:theme>
+</file>
+
+<file path=ppt/theme/theme2.xml><?xml version="1.0" encoding="utf-8"?>
+<a:theme xmlns:a="http://schemas.openxmlformats.org/drawingml/2006/main" name="Office Theme">
+  <a:themeElements>
+    <a:clrScheme name="Office">
+      <a:dk1>
+        <a:sysClr val="windowText" lastClr="000000"/>
+      </a:dk1>
+      <a:lt1>
+        <a:sysClr val="window" lastClr="FFFFFF"/>
+      </a:lt1>
+      <a:dk2>
+        <a:srgbClr val="44546A"/>
+      </a:dk2>
+      <a:lt2>
+        <a:srgbClr val="E7E6E6"/>
+      </a:lt2>
+      <a:accent1>
+        <a:srgbClr val="4472C4"/>
+      </a:accent1>
+      <a:accent2>
+        <a:srgbClr val="ED7D31"/>
+      </a:accent2>
+      <a:accent3>
+        <a:srgbClr val="A5A5A5"/>
+      </a:accent3>
+      <a:accent4>
+        <a:srgbClr val="FFC000"/>
+      </a:accent4>
+      <a:accent5>
+        <a:srgbClr val="5B9BD5"/>
+      </a:accent5>
+      <a:accent6>
+        <a:srgbClr val="70AD47"/>
+      </a:accent6>
+      <a:hlink>
+        <a:srgbClr val="0563C1"/>
+      </a:hlink>
+      <a:folHlink>
+        <a:srgbClr val="954F72"/>
+      </a:folHlink>
+    </a:clrScheme>
+    <a:fontScheme name="Office">
+      <a:majorFont>
+        <a:latin typeface="Calibri Light" panose="020F0302020204030204"/>
+        <a:ea typeface=""/>
+        <a:cs typeface=""/>
+        <a:font script="Jpan" typeface="游ゴシック Light"/>
+        <a:font script="Hang" typeface="맑은 고딕"/>
+        <a:font script="Hans" typeface="等线 Light"/>
+        <a:font script="Hant" typeface="新細明體"/>
+        <a:font script="Arab" typeface="Times New Roman"/>
+        <a:font script="Hebr" typeface="Times New Roman"/>
+        <a:font script="Thai" typeface="Angsana New"/>
+        <a:font script="Ethi" typeface="Nyala"/>
+        <a:font script="Beng" typeface="Vrinda"/>
+        <a:font script="Gujr" typeface="Shruti"/>
+        <a:font script="Khmr" typeface="MoolBoran"/>
+        <a:font script="Knda" typeface="Tunga"/>
+        <a:font script="Guru" typeface="Raavi"/>
+        <a:font script="Cans" typeface="Euphemia"/>
+        <a:font script="Cher" typeface="Plantagenet Cherokee"/>
+        <a:font script="Yiii" typeface="Microsoft Yi Baiti"/>
+        <a:font script="Tibt" typeface="Microsoft Himalaya"/>
+        <a:font script="Thaa" typeface="MV Boli"/>
+        <a:font script="Deva" typeface="Mangal"/>
+        <a:font script="Telu" typeface="Gautami"/>
+        <a:font script="Taml" typeface="Latha"/>
+        <a:font script="Syrc" typeface="Estrangelo Edessa"/>
+        <a:font script="Orya" typeface="Kalinga"/>
+        <a:font script="Mlym" typeface="Kartika"/>
+        <a:font script="Laoo" typeface="DokChampa"/>
+        <a:font script="Sinh" typeface="Iskoola Pota"/>
+        <a:font script="Mong" typeface="Mongolian Baiti"/>
+        <a:font script="Viet" typeface="Times New Roman"/>
+        <a:font script="Uigh" typeface="Microsoft Uighur"/>
+        <a:font script="Geor" typeface="Sylfaen"/>
+        <a:font script="Armn" typeface="Arial"/>
+        <a:font script="Bugi" typeface="Leelawadee UI"/>
+        <a:font script="Bopo" typeface="Microsoft JhengHei"/>
+        <a:font script="Java" typeface="Javanese Text"/>
+        <a:font script="Lisu" typeface="Segoe UI"/>
+        <a:font script="Mymr" typeface="Myanmar Text"/>
+        <a:font script="Nkoo" typeface="Ebrima"/>
+        <a:font script="Olck" typeface="Nirmala UI"/>
+        <a:font script="Osma" typeface="Ebrima"/>
+        <a:font script="Phag" typeface="Phagspa"/>
+        <a:font script="Syrn" typeface="Estrangelo Edessa"/>
+        <a:font script="Syrj" typeface="Estrangelo Edessa"/>
+        <a:font script="Syre" typeface="Estrangelo Edessa"/>
+        <a:font script="Sora" typeface="Nirmala UI"/>
+        <a:font script="Tale" typeface="Microsoft Tai Le"/>
+        <a:font script="Talu" typeface="Microsoft New Tai Lue"/>
+        <a:font script="Tfng" typeface="Ebrima"/>
+      </a:majorFont>
+      <a:minorFont>
+        <a:latin typeface="Calibri" panose="020F0502020204030204"/>
+        <a:ea typeface=""/>
+        <a:cs typeface=""/>
+        <a:font script="Jpan" typeface="游ゴシック"/>
+        <a:font script="Hang" typeface="맑은 고딕"/>
+        <a:font script="Hans" typeface="等线"/>
+        <a:font script="Hant" typeface="新細明體"/>
+        <a:font script="Arab" typeface="Arial"/>
+        <a:font script="Hebr" typeface="Arial"/>
+        <a:font script="Thai" typeface="Cordia New"/>
+        <a:font script="Ethi" typeface="Nyala"/>
+        <a:font script="Beng" typeface="Vrinda"/>
+        <a:font script="Gujr" typeface="Shruti"/>
+        <a:font script="Khmr" typeface="DaunPenh"/>
+        <a:font script="Knda" typeface="Tunga"/>
+        <a:font script="Guru" typeface="Raavi"/>
+        <a:font script="Cans" typeface="Euphemia"/>
+        <a:font script="Cher" typeface="Plantagenet Cherokee"/>
+        <a:font script="Yiii" typeface="Microsoft Yi Baiti"/>
+        <a:font script="Tibt" typeface="Microsoft Himalaya"/>
+        <a:font script="Thaa" typeface="MV Boli"/>
+        <a:font script="Deva" typeface="Mangal"/>
+        <a:font script="Telu" typeface="Gautami"/>
+        <a:font script="Taml" typeface="Latha"/>
+        <a:font script="Syrc" typeface="Estrangelo Edessa"/>
+        <a:font script="Orya" typeface="Kalinga"/>
+        <a:font script="Mlym" typeface="Kartika"/>
+        <a:font script="Laoo" typeface="DokChampa"/>
+        <a:font script="Sinh" typeface="Iskoola Pota"/>
+        <a:font script="Mong" typeface="Mongolian Baiti"/>
+        <a:font script="Viet" typeface="Arial"/>
+        <a:font script="Uigh" typeface="Microsoft Uighur"/>
+        <a:font script="Geor" typeface="Sylfaen"/>
+        <a:font script="Armn" typeface="Arial"/>
+        <a:font script="Bugi" typeface="Leelawadee UI"/>
+        <a:font script="Bopo" typeface="Microsoft JhengHei"/>
+        <a:font script="Java" typeface="Javanese Text"/>
+        <a:font script="Lisu" typeface="Segoe UI"/>
+        <a:font script="Mymr" typeface="Myanmar Text"/>
+        <a:font script="Nkoo" typeface="Ebrima"/>
+        <a:font script="Olck" typeface="Nirmala UI"/>
+        <a:font script="Osma" typeface="Ebrima"/>
+        <a:font script="Phag" typeface="Phagspa"/>
+        <a:font script="Syrn" typeface="Estrangelo Edessa"/>
+        <a:font script="Syrj" typeface="Estrangelo Edessa"/>
+        <a:font script="Syre" typeface="Estrangelo Edessa"/>
+        <a:font script="Sora" typeface="Nirmala UI"/>
+        <a:font script="Tale" typeface="Microsoft Tai Le"/>
+        <a:font script="Talu" typeface="Microsoft New Tai Lue"/>
+        <a:font script="Tfng" typeface="Ebrima"/>
+      </a:minorFont>
+    </a:fontScheme>
+    <a:fmtScheme name="Office">
+      <a:fillStyleLst>
+        <a:solidFill>
+          <a:schemeClr val="phClr"/>
+        </a:solidFill>
+        <a:gradFill rotWithShape="1">
+          <a:gsLst>
+            <a:gs pos="0">
+              <a:schemeClr val="phClr">
+                <a:lumMod val="110000"/>
+                <a:satMod val="105000"/>
+                <a:tint val="67000"/>
+              </a:schemeClr>
+            </a:gs>
+            <a:gs pos="50000">
+              <a:schemeClr val="phClr">
+                <a:lumMod val="105000"/>
+                <a:satMod val="103000"/>
+                <a:tint val="73000"/>
+              </a:schemeClr>
+            </a:gs>
+            <a:gs pos="100000">
+              <a:schemeClr val="phClr">
+                <a:lumMod val="105000"/>
+                <a:satMod val="109000"/>
+                <a:tint val="81000"/>
+              </a:schemeClr>
+            </a:gs>
+          </a:gsLst>
+          <a:lin ang="5400000" scaled="0"/>
+        </a:gradFill>
+        <a:gradFill rotWithShape="1">
+          <a:gsLst>
+            <a:gs pos="0">
+              <a:schemeClr val="phClr">
+                <a:satMod val="103000"/>
+                <a:lumMod val="102000"/>
+                <a:tint val="94000"/>
+              </a:schemeClr>
+            </a:gs>
+            <a:gs pos="50000">
+              <a:schemeClr val="phClr">
+                <a:satMod val="110000"/>
+                <a:lumMod val="100000"/>
+                <a:shade val="100000"/>
+              </a:schemeClr>
+            </a:gs>
+            <a:gs pos="100000">
+              <a:schemeClr val="phClr">
+                <a:lumMod val="99000"/>
+                <a:satMod val="120000"/>
+                <a:shade val="78000"/>
+              </a:schemeClr>
+            </a:gs>
+          </a:gsLst>
+          <a:lin ang="5400000" scaled="0"/>
+        </a:gradFill>
+      </a:fillStyleLst>
+      <a:lnStyleLst>
+        <a:ln w="6350" cap="flat" cmpd="sng" algn="ctr">
+          <a:solidFill>
+            <a:schemeClr val="phClr"/>
+          </a:solidFill>
+          <a:prstDash val="solid"/>
+          <a:miter lim="800000"/>
+        </a:ln>
+        <a:ln w="12700" cap="flat" cmpd="sng" algn="ctr">
+          <a:solidFill>
+            <a:schemeClr val="phClr"/>
+          </a:solidFill>
+          <a:prstDash val="solid"/>
+          <a:miter lim="800000"/>
+        </a:ln>
+        <a:ln w="19050" cap="flat" cmpd="sng" algn="ctr">
+          <a:solidFill>
+            <a:schemeClr val="phClr"/>
+          </a:solidFill>
+          <a:prstDash val="solid"/>
+          <a:miter lim="800000"/>
+        </a:ln>
+      </a:lnStyleLst>
+      <a:effectStyleLst>
+        <a:effectStyle>
+          <a:effectLst/>
+        </a:effectStyle>
+        <a:effectStyle>
+          <a:effectLst/>
+        </a:effectStyle>
+        <a:effectStyle>
+          <a:effectLst>
+            <a:outerShdw blurRad="57150" dist="19050" dir="5400000" algn="ctr" rotWithShape="0">
+              <a:srgbClr val="000000">
+                <a:alpha val="63000"/>
+              </a:srgbClr>
+            </a:outerShdw>
+          </a:effectLst>
+        </a:effectStyle>
+      </a:effectStyleLst>
+      <a:bgFillStyleLst>
+        <a:solidFill>
+          <a:schemeClr val="phClr"/>
+        </a:solidFill>
+        <a:solidFill>
+          <a:schemeClr val="phClr">
+            <a:tint val="95000"/>
+            <a:satMod val="170000"/>
+          </a:schemeClr>
+        </a:solidFill>
+        <a:gradFill rotWithShape="1">
+          <a:gsLst>
+            <a:gs pos="0">
+              <a:schemeClr val="phClr">
+                <a:tint val="93000"/>
+                <a:satMod val="150000"/>
+                <a:shade val="98000"/>
+                <a:lumMod val="102000"/>
+              </a:schemeClr>
+            </a:gs>
+            <a:gs pos="50000">
+              <a:schemeClr val="phClr">
+                <a:tint val="98000"/>
+                <a:satMod val="130000"/>
+                <a:shade val="90000"/>
+                <a:lumMod val="103000"/>
+              </a:schemeClr>
+            </a:gs>
+            <a:gs pos="100000">
+              <a:schemeClr val="phClr">
+                <a:shade val="63000"/>
+                <a:satMod val="120000"/>
+              </a:schemeClr>
+            </a:gs>
+          </a:gsLst>
+          <a:lin ang="5400000" scaled="0"/>
+        </a:gradFill>
+      </a:bgFillStyleLst>
+    </a:fmtScheme>
+  </a:themeElements>
+  <a:objectDefaults/>
+  <a:extraClrSchemeLst/>
+  <a:extLst>
+    <a:ext uri="{05A4C25C-085E-4340-85A3-A5531E510DB2}">
+      <thm15:themeFamily xmlns:thm15="http://schemas.microsoft.com/office/thememl/2012/main" name="Office Theme" id="{62F939B6-93AF-4DB8-9C6B-D6C7DFDC589F}" vid="{4A3C46E8-61CC-4603-A589-7422A47A8E4A}"/>
+    </a:ext>
+  </a:extLst>
+</a:theme>
 </file>
</xml_diff>

<commit_message>
Mid-term report: SPTM named as the core of the method; final check
Slide 3 opens with SPTM (semi-parametric topological memory) as the core, and every step on slides
3-4 says whether it comes from SPTM or was added (e.g. AnyLoc replaces SPTM's R network; SPTM's L
network is the fallback for steering). The SPTM reference says what we use. Final check: 4 slides
as in the template, numbers consistent across slides, no text overlaps, opens in PowerPoint.

Co-Authored-By: Claude Opus 5.5 <noreply@anthropic.com>
</commit_message>
<xml_diff>
--- a/runs/Midterm_Report.pptx
+++ b/runs/Midterm_Report.pptx
@@ -4,15 +4,15 @@
   <p:sldMasterIdLst>
     <p:sldMasterId id="2147483648" r:id="rId1"/>
   </p:sldMasterIdLst>
-  <p:notesMasterIdLst>
-    <p:notesMasterId r:id="rId6"/>
-  </p:notesMasterIdLst>
   <p:sldIdLst>
     <p:sldId id="256" r:id="rId2"/>
     <p:sldId id="257" r:id="rId3"/>
     <p:sldId id="258" r:id="rId4"/>
     <p:sldId id="259" r:id="rId5"/>
   </p:sldIdLst>
+  <p:notesMasterIdLst>
+    <p:notesMasterId r:id="rId6"/>
+  </p:notesMasterIdLst>
   <p:sldSz cx="12192000" cy="6858000"/>
   <p:notesSz cx="6858000" cy="12192000"/>
   <p:defaultTextStyle>
@@ -110,17 +110,17 @@
   <p:extLst>
     <p:ext uri="{521415D9-36F7-43E2-AB2F-B90AF26B5E84}">
       <p14:sectionLst xmlns:p14="http://schemas.microsoft.com/office/powerpoint/2010/main">
-        <p14:section name="Title" id="{5D09B2E9-22C2-EEC4-617A-04613BB975F1}">
+        <p14:section name="Title" id="{c4600a6c-5ed0-f136-cb72-d3f39d5c4a65}">
           <p14:sldIdLst>
             <p14:sldId id="256"/>
           </p14:sldIdLst>
         </p14:section>
-        <p14:section name="Problem" id="{9405A032-FD26-9DB6-9788-FF1FC7652EB6}">
+        <p14:section name="Problem" id="{fc972a00-552a-3fe5-6336-67ecff0decbe}">
           <p14:sldIdLst>
             <p14:sldId id="257"/>
           </p14:sldIdLst>
         </p14:section>
-        <p14:section name="Method" id="{8C2540F0-2F7D-8693-9686-5ACD88002613}">
+        <p14:section name="Method" id="{547b8acd-5d9d-cf46-9006-06c1bb1b8ead}">
           <p14:sldIdLst>
             <p14:sldId id="258"/>
             <p14:sldId id="259"/>
@@ -157,10 +157,234 @@
           <a:chExt cx="0" cy="0"/>
         </a:xfrm>
       </p:grpSpPr>
+      <p:sp>
+        <p:nvSpPr>
+          <p:cNvPr id="2" name="Header Placeholder 1"/>
+          <p:cNvSpPr>
+            <a:spLocks noGrp="1"/>
+          </p:cNvSpPr>
+          <p:nvPr>
+            <p:ph type="hdr" sz="quarter"/>
+          </p:nvPr>
+        </p:nvSpPr>
+        <p:spPr>
+          <a:xfrm>
+            <a:off x="0" y="0"/>
+            <a:ext cx="2971800" cy="458788"/>
+          </a:xfrm>
+          <a:prstGeom prst="rect">
+            <a:avLst/>
+          </a:prstGeom>
+        </p:spPr>
+        <p:txBody>
+          <a:bodyPr vert="horz" lIns="91440" tIns="45720" rIns="91440" bIns="45720" rtlCol="0"/>
+          <a:lstStyle>
+            <a:lvl1pPr algn="l">
+              <a:defRPr sz="1200"/>
+            </a:lvl1pPr>
+          </a:lstStyle>
+          <a:p>
+            <a:endParaRPr lang="en-US"/>
+          </a:p>
+        </p:txBody>
+      </p:sp>
+      <p:sp>
+        <p:nvSpPr>
+          <p:cNvPr id="3" name="Date Placeholder 2"/>
+          <p:cNvSpPr>
+            <a:spLocks noGrp="1"/>
+          </p:cNvSpPr>
+          <p:nvPr>
+            <p:ph type="dt" idx="1"/>
+          </p:nvPr>
+        </p:nvSpPr>
+        <p:spPr>
+          <a:xfrm>
+            <a:off x="3884613" y="0"/>
+            <a:ext cx="2971800" cy="458788"/>
+          </a:xfrm>
+          <a:prstGeom prst="rect">
+            <a:avLst/>
+          </a:prstGeom>
+        </p:spPr>
+        <p:txBody>
+          <a:bodyPr vert="horz" lIns="91440" tIns="45720" rIns="91440" bIns="45720" rtlCol="0"/>
+          <a:lstStyle>
+            <a:lvl1pPr algn="r">
+              <a:defRPr sz="1200"/>
+            </a:lvl1pPr>
+          </a:lstStyle>
+          <a:p>
+            <a:fld id="{5282F153-3F37-0F45-9E97-73ACFA13230C}" type="datetimeFigureOut">
+              <a:rPr lang="en-US"/>
+              <a:t>7/23/19</a:t>
+            </a:fld>
+            <a:endParaRPr lang="en-US"/>
+          </a:p>
+        </p:txBody>
+      </p:sp>
+      <p:sp>
+        <p:nvSpPr>
+          <p:cNvPr id="4" name="Slide Image Placeholder 3"/>
+          <p:cNvSpPr>
+            <a:spLocks noGrp="1" noRot="1" noChangeAspect="1"/>
+          </p:cNvSpPr>
+          <p:nvPr>
+            <p:ph type="sldImg" idx="2"/>
+          </p:nvPr>
+        </p:nvSpPr>
+        <p:spPr>
+          <a:xfrm>
+            <a:off x="685800" y="1143000"/>
+            <a:ext cx="5486400" cy="3086100"/>
+          </a:xfrm>
+          <a:prstGeom prst="rect">
+            <a:avLst/>
+          </a:prstGeom>
+          <a:noFill/>
+          <a:ln w="12700">
+            <a:solidFill>
+              <a:prstClr val="black"/>
+            </a:solidFill>
+          </a:ln>
+        </p:spPr>
+        <p:txBody>
+          <a:bodyPr vert="horz" lIns="91440" tIns="45720" rIns="91440" bIns="45720" rtlCol="0" anchor="ctr"/>
+          <a:lstStyle/>
+          <a:p>
+            <a:endParaRPr lang="en-US"/>
+          </a:p>
+        </p:txBody>
+      </p:sp>
+      <p:sp>
+        <p:nvSpPr>
+          <p:cNvPr id="5" name="Notes Placeholder 4"/>
+          <p:cNvSpPr>
+            <a:spLocks noGrp="1"/>
+          </p:cNvSpPr>
+          <p:nvPr>
+            <p:ph type="body" sz="quarter" idx="3"/>
+          </p:nvPr>
+        </p:nvSpPr>
+        <p:spPr>
+          <a:xfrm>
+            <a:off x="685800" y="4400550"/>
+            <a:ext cx="5486400" cy="3600450"/>
+          </a:xfrm>
+          <a:prstGeom prst="rect">
+            <a:avLst/>
+          </a:prstGeom>
+        </p:spPr>
+        <p:txBody>
+          <a:bodyPr vert="horz" lIns="91440" tIns="45720" rIns="91440" bIns="45720" rtlCol="0"/>
+          <a:lstStyle/>
+          <a:p>
+            <a:pPr lvl="0"/>
+            <a:r>
+              <a:rPr lang="en-US"/>
+              <a:t>Click to edit Master text styles</a:t>
+            </a:r>
+          </a:p>
+          <a:p>
+            <a:pPr lvl="1"/>
+            <a:r>
+              <a:rPr lang="en-US"/>
+              <a:t>Second level</a:t>
+            </a:r>
+          </a:p>
+          <a:p>
+            <a:pPr lvl="2"/>
+            <a:r>
+              <a:rPr lang="en-US"/>
+              <a:t>Third level</a:t>
+            </a:r>
+          </a:p>
+          <a:p>
+            <a:pPr lvl="3"/>
+            <a:r>
+              <a:rPr lang="en-US"/>
+              <a:t>Fourth level</a:t>
+            </a:r>
+          </a:p>
+          <a:p>
+            <a:pPr lvl="4"/>
+            <a:r>
+              <a:rPr lang="en-US"/>
+              <a:t>Fifth level</a:t>
+            </a:r>
+          </a:p>
+        </p:txBody>
+      </p:sp>
+      <p:sp>
+        <p:nvSpPr>
+          <p:cNvPr id="6" name="Footer Placeholder 5"/>
+          <p:cNvSpPr>
+            <a:spLocks noGrp="1"/>
+          </p:cNvSpPr>
+          <p:nvPr>
+            <p:ph type="ftr" sz="quarter" idx="4"/>
+          </p:nvPr>
+        </p:nvSpPr>
+        <p:spPr>
+          <a:xfrm>
+            <a:off x="0" y="8685213"/>
+            <a:ext cx="2971800" cy="458787"/>
+          </a:xfrm>
+          <a:prstGeom prst="rect">
+            <a:avLst/>
+          </a:prstGeom>
+        </p:spPr>
+        <p:txBody>
+          <a:bodyPr vert="horz" lIns="91440" tIns="45720" rIns="91440" bIns="45720" rtlCol="0" anchor="b"/>
+          <a:lstStyle>
+            <a:lvl1pPr algn="l">
+              <a:defRPr sz="1200"/>
+            </a:lvl1pPr>
+          </a:lstStyle>
+          <a:p>
+            <a:endParaRPr lang="en-US"/>
+          </a:p>
+        </p:txBody>
+      </p:sp>
+      <p:sp>
+        <p:nvSpPr>
+          <p:cNvPr id="7" name="Slide Number Placeholder 6"/>
+          <p:cNvSpPr>
+            <a:spLocks noGrp="1"/>
+          </p:cNvSpPr>
+          <p:nvPr>
+            <p:ph type="sldNum" sz="quarter" idx="5"/>
+          </p:nvPr>
+        </p:nvSpPr>
+        <p:spPr>
+          <a:xfrm>
+            <a:off x="3884613" y="8685213"/>
+            <a:ext cx="2971800" cy="458787"/>
+          </a:xfrm>
+          <a:prstGeom prst="rect">
+            <a:avLst/>
+          </a:prstGeom>
+        </p:spPr>
+        <p:txBody>
+          <a:bodyPr vert="horz" lIns="91440" tIns="45720" rIns="91440" bIns="45720" rtlCol="0" anchor="b"/>
+          <a:lstStyle>
+            <a:lvl1pPr algn="r">
+              <a:defRPr sz="1200"/>
+            </a:lvl1pPr>
+          </a:lstStyle>
+          <a:p>
+            <a:fld id="{CE5E9CC1-C706-0F49-92D6-E571CC5EEA8F}" type="slidenum">
+              <a:rPr lang="en-US"/>
+              <a:t>‹#›</a:t>
+            </a:fld>
+            <a:endParaRPr lang="en-US"/>
+          </a:p>
+        </p:txBody>
+      </p:sp>
     </p:spTree>
     <p:extLst>
       <p:ext uri="{BB962C8B-B14F-4D97-AF65-F5344CB8AC3E}">
-        <p14:creationId xmlns:p14="http://schemas.microsoft.com/office/powerpoint/2010/main" val="791509425"/>
+        <p14:creationId xmlns:p14="http://schemas.microsoft.com/office/powerpoint/2010/main" val="1024086991"/>
       </p:ext>
     </p:extLst>
   </p:cSld>
@@ -308,6 +532,7 @@
               <a:rPr lang="en-US" dirty="0"/>
               <a:t>Robot Perception course project, Visual Navigation Challenge: mid-term report. The picture is local test maze 25 drawn from the simulator’s true positions: the robot’s path from the start (blue) to the check-in (red), with the same code as the mid-term.</a:t>
             </a:r>
+            <a:endParaRPr lang="en-US" dirty="0"/>
           </a:p>
         </p:txBody>
       </p:sp>
@@ -395,6 +620,7 @@
               <a:rPr lang="en-US" dirty="0"/>
               <a:t>The robot only sees camera images, has four photos of the goal and the photos of three earlier drives. It must check in within 0.2 m and 20 degrees, and SPL rewards few steps. The hard parts are the trade-off between checking carefully and saving steps, lining up exactly in the last metre, and dead ends that cost many steps to back out of.</a:t>
             </a:r>
+            <a:endParaRPr lang="en-US" dirty="0"/>
           </a:p>
         </p:txBody>
       </p:sp>
@@ -480,8 +706,9 @@
           <a:p>
             <a:r>
               <a:rPr lang="en-US" dirty="0"/>
-              <a:t>Before driving, from the exploration photos alone and before connecting: build a graph of the photos, add shortcut links where AnyLoc proposes and SuperGlue confirms the same place, and place every photo in metres to cost the links in steps (the figure shows maze 25: 97% of the 480 links join photos in the same corridor). When it starts, the session hands over the four goal photos: it picks the goal photo by matching them and computes the cheapest route to it with Dijkstra. None of this costs steps.</a:t>
-            </a:r>
+              <a:t>The core is SPTM: the exploration photos form a graph that is the robot’s memory. Before driving, from the exploration photos alone and before connecting: build that graph, add shortcuts where AnyLoc proposes and SuperGlue confirms the same place, and place every photo in metres to cost the links in steps (the figure shows maze 25: 97% of the 480 links join photos in the same corridor). When it starts, the session hands over the four goal photos: it picks the goal node by matching them and computes the cheapest route to it with Dijkstra. None of this costs steps.</a:t>
+            </a:r>
+            <a:endParaRPr lang="en-US" dirty="0"/>
           </a:p>
         </p:txBody>
       </p:sp>
@@ -567,8 +794,9 @@
           <a:p>
             <a:r>
               <a:rPr lang="en-US" dirty="0"/>
-              <a:t>During the drive, every move: find the closest exploration photo, take the route from it, steer to a waypoint photo by the angle SuperGlue and the essential matrix give, undo recorded moves to back out along a drive, check the route photos or re-plan when stuck, and in the last metre line up with the goal photos and check in only after three strong readings. The pictures are real images from local test maze 25: the SuperGlue matches the robot uses to measure a turn, and the goal photo next to its camera at the check-in.</a:t>
-            </a:r>
+              <a:t>During the drive, every move follows SPTM: localise on the photo graph (with AnyLoc instead of SPTM’s R network), pick the furthest route photo that still looks reachable as the waypoint, and move toward it. We steer by the angle SuperGlue and the essential matrix give, with SPTM’s L network as the fallback, and added backing out along drives, checks when stuck, and a last-metre controller that lines up with the goal photos and checks in only after three strong readings. The pictures are real images from local test maze 25.</a:t>
+            </a:r>
+            <a:endParaRPr lang="en-US" dirty="0"/>
           </a:p>
         </p:txBody>
       </p:sp>
@@ -646,7 +874,6 @@
         <a:solidFill>
           <a:schemeClr val="tx1"/>
         </a:solidFill>
-        <a:effectLst/>
       </p:bgPr>
     </p:bg>
     <p:spTree>
@@ -666,11 +893,9 @@
       <p:sp>
         <p:nvSpPr>
           <p:cNvPr id="2" name="Text 0"/>
-          <p:cNvSpPr>
-            <a:spLocks noGrp="1"/>
-          </p:cNvSpPr>
+          <p:cNvSpPr/>
           <p:nvPr>
-            <p:ph type="title" idx="100" hasCustomPrompt="1"/>
+            <p:ph idx="100" type="title" hasCustomPrompt="1"/>
           </p:nvPr>
         </p:nvSpPr>
         <p:spPr>
@@ -687,7 +912,7 @@
         <p:txBody>
           <a:bodyPr wrap="square" rtlCol="0"/>
           <a:lstStyle>
-            <a:lvl1pPr marL="0" indent="0" algn="l">
+            <a:lvl1pPr algn="l" indent="0" marL="0">
               <a:buNone/>
               <a:defRPr lang="en-US" sz="4400" b="1" dirty="0">
                 <a:solidFill>
@@ -697,7 +922,7 @@
             </a:lvl1pPr>
           </a:lstStyle>
           <a:p>
-            <a:pPr marL="0" indent="0" algn="l">
+            <a:pPr algn="l" indent="0" marL="0">
               <a:buNone/>
             </a:pPr>
             <a:endParaRPr lang="en-US" sz="4400" dirty="0"/>
@@ -720,7 +945,6 @@
         <a:solidFill>
           <a:schemeClr val="bg1"/>
         </a:solidFill>
-        <a:effectLst/>
       </p:bgPr>
     </p:bg>
     <p:spTree>
@@ -740,11 +964,9 @@
       <p:sp>
         <p:nvSpPr>
           <p:cNvPr id="2" name="Text 0"/>
-          <p:cNvSpPr>
-            <a:spLocks noGrp="1"/>
-          </p:cNvSpPr>
+          <p:cNvSpPr/>
           <p:nvPr>
-            <p:ph type="title" idx="100" hasCustomPrompt="1"/>
+            <p:ph idx="100" type="title" hasCustomPrompt="1"/>
           </p:nvPr>
         </p:nvSpPr>
         <p:spPr>
@@ -761,7 +983,7 @@
         <p:txBody>
           <a:bodyPr wrap="square" rtlCol="0"/>
           <a:lstStyle>
-            <a:lvl1pPr marL="0" indent="0" algn="l">
+            <a:lvl1pPr algn="l" indent="0" marL="0">
               <a:buNone/>
               <a:defRPr lang="en-US" sz="3000" b="1" dirty="0">
                 <a:solidFill>
@@ -771,7 +993,7 @@
             </a:lvl1pPr>
           </a:lstStyle>
           <a:p>
-            <a:pPr marL="0" indent="0" algn="l">
+            <a:pPr algn="l" indent="0" marL="0">
               <a:buNone/>
             </a:pPr>
             <a:endParaRPr lang="en-US" sz="3000" dirty="0"/>
@@ -799,11 +1021,11 @@
           <a:bodyPr wrap="square" lIns="0" tIns="0" rIns="0" bIns="0" rtlCol="0" anchor="ctr"/>
           <a:lstStyle/>
           <a:p>
-            <a:pPr marL="0" indent="0">
-              <a:buNone/>
-            </a:pPr>
-            <a:r>
-              <a:rPr lang="en-US" sz="900" kern="0" spc="150" dirty="0">
+            <a:pPr indent="0" marL="0">
+              <a:buNone/>
+            </a:pPr>
+            <a:r>
+              <a:rPr lang="en-US" sz="900" spc="150" kern="0" dirty="0">
                 <a:solidFill>
                   <a:schemeClr val="accent3"/>
                 </a:solidFill>
@@ -834,7 +1056,7 @@
           </a:prstGeom>
           <a:extLst>
             <a:ext uri="{C572A759-6A51-4108-AA02-DFA0A04FC94B}">
-              <ma14:wrappingTextBoxFlag xmlns:ma14="http://schemas.microsoft.com/office/mac/drawingml/2011/main" xmlns="" val="0"/>
+              <ma14:wrappingTextBoxFlag xmlns:ma14="http://schemas.microsoft.com/office/mac/drawingml/2011/main" val="0"/>
             </a:ext>
           </a:extLst>
         </p:spPr>
@@ -852,8 +1074,8 @@
           <a:p>
             <a:pPr algn="r"/>
             <a:fld id="{F7021451-1387-4CA6-816F-3879F97B5CBC}" type="slidenum">
-              <a:rPr lang="en-US" b="0"/>
-              <a:t>‹#›</a:t>
+              <a:rPr b="0" lang="en-US"/>
+              <a:t>1003</a:t>
             </a:fld>
             <a:endParaRPr lang="en-US"/>
           </a:p>
@@ -870,11 +1092,6 @@
 <file path=ppt/slideMasters/slideMaster1.xml><?xml version="1.0" encoding="utf-8"?>
 <p:sldMaster xmlns:a="http://schemas.openxmlformats.org/drawingml/2006/main" xmlns:r="http://schemas.openxmlformats.org/officeDocument/2006/relationships" xmlns:p="http://schemas.openxmlformats.org/presentationml/2006/main">
   <p:cSld>
-    <p:bg>
-      <p:bgRef idx="1001">
-        <a:schemeClr val="bg1"/>
-      </p:bgRef>
-    </p:bg>
     <p:spTree>
       <p:nvGrpSpPr>
         <p:cNvPr id="1" name=""/>
@@ -909,7 +1126,7 @@
           </a:prstGeom>
           <a:extLst>
             <a:ext uri="{C572A759-6A51-4108-AA02-DFA0A04FC94B}">
-              <ma14:wrappingTextBoxFlag xmlns:ma14="http://schemas.microsoft.com/office/mac/drawingml/2011/main" xmlns="" val="0"/>
+              <ma14:wrappingTextBoxFlag xmlns:ma14="http://schemas.microsoft.com/office/mac/drawingml/2011/main" val="0"/>
             </a:ext>
           </a:extLst>
         </p:spPr>
@@ -927,8 +1144,8 @@
           <a:p>
             <a:pPr algn="r"/>
             <a:fld id="{F7021451-1387-4CA6-816F-3879F97B5CBC}" type="slidenum">
-              <a:rPr lang="en-US" b="0"/>
-              <a:t>‹#›</a:t>
+              <a:rPr b="0" lang="en-US"/>
+              <a:t>null</a:t>
             </a:fld>
             <a:endParaRPr lang="en-US"/>
           </a:p>
@@ -1234,11 +1451,11 @@
           <a:bodyPr wrap="square" lIns="0" tIns="0" rIns="0" bIns="0" rtlCol="0" anchor="ctr"/>
           <a:lstStyle/>
           <a:p>
-            <a:pPr marL="0" indent="0">
-              <a:buNone/>
-            </a:pPr>
-            <a:r>
-              <a:rPr lang="en-US" sz="1300" kern="0" spc="200" dirty="0">
+            <a:pPr indent="0" marL="0">
+              <a:buNone/>
+            </a:pPr>
+            <a:r>
+              <a:rPr lang="en-US" sz="1300" spc="200" kern="0" dirty="0">
                 <a:solidFill>
                   <a:schemeClr val="accent5"/>
                 </a:solidFill>
@@ -1252,11 +1469,9 @@
       <p:sp>
         <p:nvSpPr>
           <p:cNvPr id="3" name="Text 0"/>
-          <p:cNvSpPr>
-            <a:spLocks noGrp="1"/>
-          </p:cNvSpPr>
+          <p:cNvSpPr/>
           <p:nvPr>
-            <p:ph type="title" idx="100" hasCustomPrompt="1"/>
+            <p:ph idx="100" type="title" hasCustomPrompt="1"/>
           </p:nvPr>
         </p:nvSpPr>
         <p:spPr>
@@ -1274,7 +1489,7 @@
           <a:bodyPr wrap="square" lIns="0" tIns="0" rIns="0" bIns="0" rtlCol="0" anchor="t"/>
           <a:lstStyle/>
           <a:p>
-            <a:pPr marL="0" indent="0" algn="l">
+            <a:pPr algn="l" indent="0" marL="0">
               <a:buNone/>
             </a:pPr>
             <a:r>
@@ -1288,7 +1503,7 @@
             <a:endParaRPr lang="en-US" sz="4400" dirty="0"/>
           </a:p>
           <a:p>
-            <a:pPr marL="0" indent="0" algn="l">
+            <a:pPr algn="l" indent="0" marL="0">
               <a:buNone/>
             </a:pPr>
             <a:r>
@@ -1324,7 +1539,7 @@
           <a:bodyPr wrap="square" lIns="0" tIns="0" rIns="0" bIns="0" rtlCol="0" anchor="ctr"/>
           <a:lstStyle/>
           <a:p>
-            <a:pPr marL="0" indent="0">
+            <a:pPr indent="0" marL="0">
               <a:buNone/>
             </a:pPr>
             <a:r>
@@ -1363,7 +1578,7 @@
           <a:bodyPr wrap="square" lIns="0" tIns="0" rIns="0" bIns="0" rtlCol="0" anchor="ctr"/>
           <a:lstStyle/>
           <a:p>
-            <a:pPr marL="0" indent="0">
+            <a:pPr indent="0" marL="0">
               <a:spcAft>
                 <a:spcPts val="600"/>
               </a:spcAft>
@@ -1380,7 +1595,7 @@
             <a:endParaRPr lang="en-US" sz="2000" dirty="0"/>
           </a:p>
           <a:p>
-            <a:pPr marL="0" indent="0">
+            <a:pPr indent="0" marL="0">
               <a:spcAft>
                 <a:spcPts val="600"/>
               </a:spcAft>
@@ -1427,14 +1642,14 @@
       </p:sp>
       <p:pic>
         <p:nvPicPr>
-          <p:cNvPr id="7" name="title maze picture" descr="Top view of local test maze 25 drawn from the simulator’s true positions: the robot’s path from the start to the goal, coloured by time from blue to red"/>
+          <p:cNvPr id="7" name="title maze picture" descr="Top view of local test maze 25 drawn from the simulator’s true positions: the robot’s path from the start to the goal, coloured by time from blue to red">    </p:cNvPr>
           <p:cNvPicPr>
             <a:picLocks noChangeAspect="1"/>
           </p:cNvPicPr>
           <p:nvPr/>
         </p:nvPicPr>
         <p:blipFill>
-          <a:blip r:embed="rId3"/>
+          <a:blip r:embed="rId1"/>
           <a:stretch>
             <a:fillRect/>
           </a:stretch>
@@ -1470,7 +1685,7 @@
           <a:bodyPr wrap="square" lIns="0" tIns="0" rIns="0" bIns="0" rtlCol="0" anchor="ctr"/>
           <a:lstStyle/>
           <a:p>
-            <a:pPr marL="0" indent="0">
+            <a:pPr indent="0" marL="0">
               <a:buNone/>
             </a:pPr>
             <a:r>
@@ -1531,11 +1746,11 @@
           <a:bodyPr wrap="square" lIns="0" tIns="0" rIns="0" bIns="0" rtlCol="0" anchor="ctr"/>
           <a:lstStyle/>
           <a:p>
-            <a:pPr marL="0" indent="0">
-              <a:buNone/>
-            </a:pPr>
-            <a:r>
-              <a:rPr lang="en-US" sz="1100" b="1" kern="0" spc="200" dirty="0">
+            <a:pPr indent="0" marL="0">
+              <a:buNone/>
+            </a:pPr>
+            <a:r>
+              <a:rPr lang="en-US" sz="1100" b="1" spc="200" kern="0" dirty="0">
                 <a:solidFill>
                   <a:schemeClr val="accent1"/>
                 </a:solidFill>
@@ -1549,11 +1764,9 @@
       <p:sp>
         <p:nvSpPr>
           <p:cNvPr id="3" name="Text 0"/>
-          <p:cNvSpPr>
-            <a:spLocks noGrp="1"/>
-          </p:cNvSpPr>
+          <p:cNvSpPr/>
           <p:nvPr>
-            <p:ph type="title" idx="100" hasCustomPrompt="1"/>
+            <p:ph idx="100" type="title" hasCustomPrompt="1"/>
           </p:nvPr>
         </p:nvSpPr>
         <p:spPr>
@@ -1571,7 +1784,7 @@
           <a:bodyPr wrap="square" lIns="0" tIns="0" rIns="0" bIns="0" rtlCol="0" anchor="ctr"/>
           <a:lstStyle/>
           <a:p>
-            <a:pPr marL="0" indent="0" algn="l">
+            <a:pPr algn="l" indent="0" marL="0">
               <a:buNone/>
             </a:pPr>
             <a:r>
@@ -1595,7 +1808,7 @@
         <p:spPr>
           <a:xfrm>
             <a:off x="548640" y="1371600"/>
-            <a:ext cx="6400800" cy="2514600"/>
+            <a:ext cx="6400800" cy="2148840"/>
           </a:xfrm>
           <a:prstGeom prst="rect">
             <a:avLst/>
@@ -1607,7 +1820,7 @@
           <a:bodyPr wrap="square" lIns="0" tIns="0" rIns="0" bIns="0" rtlCol="0" anchor="t"/>
           <a:lstStyle/>
           <a:p>
-            <a:pPr marL="0" indent="0">
+            <a:pPr indent="0" marL="0">
               <a:spcAft>
                 <a:spcPts val="500"/>
               </a:spcAft>
@@ -1678,7 +1891,7 @@
             <a:endParaRPr lang="en-US" sz="1350" dirty="0"/>
           </a:p>
           <a:p>
-            <a:pPr marL="0" indent="0">
+            <a:pPr indent="0" marL="0">
               <a:spcAft>
                 <a:spcPts val="500"/>
               </a:spcAft>
@@ -1717,7 +1930,7 @@
           <a:bodyPr wrap="square" lIns="0" tIns="0" rIns="0" bIns="0" rtlCol="0" anchor="ctr"/>
           <a:lstStyle/>
           <a:p>
-            <a:pPr marL="0" indent="0">
+            <a:pPr indent="0" marL="0">
               <a:buNone/>
             </a:pPr>
             <a:r>
@@ -1778,7 +1991,7 @@
           <a:bodyPr wrap="square" lIns="0" tIns="0" rIns="0" bIns="0" rtlCol="0" anchor="ctr"/>
           <a:lstStyle/>
           <a:p>
-            <a:pPr marL="0" indent="0" algn="ctr">
+            <a:pPr algn="ctr" indent="0" marL="0">
               <a:buNone/>
             </a:pPr>
             <a:r>
@@ -1814,7 +2027,7 @@
           <a:bodyPr wrap="square" lIns="0" tIns="0" rIns="0" bIns="0" rtlCol="0" anchor="t"/>
           <a:lstStyle/>
           <a:p>
-            <a:pPr marL="0" indent="0">
+            <a:pPr indent="0" marL="0">
               <a:buNone/>
             </a:pPr>
             <a:r>
@@ -1825,6 +2038,9 @@
               </a:rPr>
               <a:t>Accuracy vs. number of steps. </a:t>
             </a:r>
+            <a:pPr indent="0" marL="0">
+              <a:buNone/>
+            </a:pPr>
             <a:r>
               <a:rPr lang="en-US" sz="1350" dirty="0">
                 <a:solidFill>
@@ -1883,7 +2099,7 @@
           <a:bodyPr wrap="square" lIns="0" tIns="0" rIns="0" bIns="0" rtlCol="0" anchor="ctr"/>
           <a:lstStyle/>
           <a:p>
-            <a:pPr marL="0" indent="0" algn="ctr">
+            <a:pPr algn="ctr" indent="0" marL="0">
               <a:buNone/>
             </a:pPr>
             <a:r>
@@ -1919,7 +2135,7 @@
           <a:bodyPr wrap="square" lIns="0" tIns="0" rIns="0" bIns="0" rtlCol="0" anchor="t"/>
           <a:lstStyle/>
           <a:p>
-            <a:pPr marL="0" indent="0">
+            <a:pPr indent="0" marL="0">
               <a:buNone/>
             </a:pPr>
             <a:r>
@@ -1930,6 +2146,9 @@
               </a:rPr>
               <a:t>The last metre. </a:t>
             </a:r>
+            <a:pPr indent="0" marL="0">
+              <a:buNone/>
+            </a:pPr>
             <a:r>
               <a:rPr lang="en-US" sz="1350" dirty="0">
                 <a:solidFill>
@@ -1988,7 +2207,7 @@
           <a:bodyPr wrap="square" lIns="0" tIns="0" rIns="0" bIns="0" rtlCol="0" anchor="ctr"/>
           <a:lstStyle/>
           <a:p>
-            <a:pPr marL="0" indent="0" algn="ctr">
+            <a:pPr algn="ctr" indent="0" marL="0">
               <a:buNone/>
             </a:pPr>
             <a:r>
@@ -2024,7 +2243,7 @@
           <a:bodyPr wrap="square" lIns="0" tIns="0" rIns="0" bIns="0" rtlCol="0" anchor="t"/>
           <a:lstStyle/>
           <a:p>
-            <a:pPr marL="0" indent="0">
+            <a:pPr indent="0" marL="0">
               <a:buNone/>
             </a:pPr>
             <a:r>
@@ -2035,6 +2254,9 @@
               </a:rPr>
               <a:t>Dead ends. </a:t>
             </a:r>
+            <a:pPr indent="0" marL="0">
+              <a:buNone/>
+            </a:pPr>
             <a:r>
               <a:rPr lang="en-US" sz="1350" dirty="0">
                 <a:solidFill>
@@ -2095,7 +2317,7 @@
           <a:bodyPr wrap="square" lIns="0" tIns="0" rIns="0" bIns="0" rtlCol="0" anchor="ctr"/>
           <a:lstStyle/>
           <a:p>
-            <a:pPr marL="0" indent="0">
+            <a:pPr indent="0" marL="0">
               <a:buNone/>
             </a:pPr>
             <a:r>
@@ -2137,7 +2359,7 @@
               </a:spcAft>
               <a:buSzPct val="100000"/>
               <a:buFont typeface="+mj-lt"/>
-              <a:buAutoNum type="arabicPeriod"/>
+              <a:buAutoNum type="arabicPeriod" startAt="1"/>
             </a:pPr>
             <a:r>
               <a:rPr lang="en-US" sz="1000" dirty="0">
@@ -2147,13 +2369,19 @@
               </a:rPr>
               <a:t>Savinov et al., Semi-Parametric Topological Memory for Navigation (SPTM), ICLR 2018</a:t>
             </a:r>
+            <a:pPr indent="0" marL="0">
+              <a:spcAft>
+                <a:spcPts val="300"/>
+              </a:spcAft>
+              <a:buNone/>
+            </a:pPr>
             <a:r>
               <a:rPr lang="en-US" sz="1000" i="1" dirty="0">
                 <a:solidFill>
                   <a:schemeClr val="accent1"/>
                 </a:solidFill>
               </a:rPr>
-              <a:t>. Used for the photo map, and our place (R) and motion (L) networks.</a:t>
+              <a:t>. Used for the core method: the photo memory graph, localisation, waypoints and its motion (L) network.</a:t>
             </a:r>
             <a:endParaRPr lang="en-US" sz="1000" dirty="0"/>
           </a:p>
@@ -2164,7 +2392,7 @@
               </a:spcAft>
               <a:buSzPct val="100000"/>
               <a:buFont typeface="+mj-lt"/>
-              <a:buAutoNum type="arabicPeriod"/>
+              <a:buAutoNum type="arabicPeriod" startAt="1"/>
             </a:pPr>
             <a:r>
               <a:rPr lang="en-US" sz="1000" dirty="0">
@@ -2174,6 +2402,12 @@
               </a:rPr>
               <a:t>Keetha et al., AnyLoc: Towards Universal Visual Place Recognition, IEEE RA-L 2023</a:t>
             </a:r>
+            <a:pPr indent="0" marL="0">
+              <a:spcAft>
+                <a:spcPts val="300"/>
+              </a:spcAft>
+              <a:buNone/>
+            </a:pPr>
             <a:r>
               <a:rPr lang="en-US" sz="1000" i="1" dirty="0">
                 <a:solidFill>
@@ -2191,7 +2425,7 @@
               </a:spcAft>
               <a:buSzPct val="100000"/>
               <a:buFont typeface="+mj-lt"/>
-              <a:buAutoNum type="arabicPeriod"/>
+              <a:buAutoNum type="arabicPeriod" startAt="1"/>
             </a:pPr>
             <a:r>
               <a:rPr lang="en-US" sz="1000" dirty="0">
@@ -2201,6 +2435,12 @@
               </a:rPr>
               <a:t>Oquab et al., DINOv2: Learning Robust Visual Features without Supervision, TMLR 2024</a:t>
             </a:r>
+            <a:pPr indent="0" marL="0">
+              <a:spcAft>
+                <a:spcPts val="300"/>
+              </a:spcAft>
+              <a:buNone/>
+            </a:pPr>
             <a:r>
               <a:rPr lang="en-US" sz="1000" i="1" dirty="0">
                 <a:solidFill>
@@ -2218,7 +2458,7 @@
               </a:spcAft>
               <a:buSzPct val="100000"/>
               <a:buFont typeface="+mj-lt"/>
-              <a:buAutoNum type="arabicPeriod"/>
+              <a:buAutoNum type="arabicPeriod" startAt="1"/>
             </a:pPr>
             <a:r>
               <a:rPr lang="en-US" sz="1000" dirty="0">
@@ -2228,6 +2468,12 @@
               </a:rPr>
               <a:t>Jégou et al., Aggregating Local Descriptors into a Compact Image Representation (VLAD), CVPR 2010</a:t>
             </a:r>
+            <a:pPr indent="0" marL="0">
+              <a:spcAft>
+                <a:spcPts val="300"/>
+              </a:spcAft>
+              <a:buNone/>
+            </a:pPr>
             <a:r>
               <a:rPr lang="en-US" sz="1000" i="1" dirty="0">
                 <a:solidFill>
@@ -2245,7 +2491,7 @@
               </a:spcAft>
               <a:buSzPct val="100000"/>
               <a:buFont typeface="+mj-lt"/>
-              <a:buAutoNum type="arabicPeriod"/>
+              <a:buAutoNum type="arabicPeriod" startAt="1"/>
             </a:pPr>
             <a:r>
               <a:rPr lang="en-US" sz="1000" dirty="0">
@@ -2255,6 +2501,12 @@
               </a:rPr>
               <a:t>DeTone et al., SuperPoint: Self-Supervised Interest Point Detection and Description, CVPR Workshops 2018</a:t>
             </a:r>
+            <a:pPr indent="0" marL="0">
+              <a:spcAft>
+                <a:spcPts val="300"/>
+              </a:spcAft>
+              <a:buNone/>
+            </a:pPr>
             <a:r>
               <a:rPr lang="en-US" sz="1000" i="1" dirty="0">
                 <a:solidFill>
@@ -2272,7 +2524,7 @@
               </a:spcAft>
               <a:buSzPct val="100000"/>
               <a:buFont typeface="+mj-lt"/>
-              <a:buAutoNum type="arabicPeriod"/>
+              <a:buAutoNum type="arabicPeriod" startAt="1"/>
             </a:pPr>
             <a:r>
               <a:rPr lang="en-US" sz="1000" dirty="0">
@@ -2282,6 +2534,12 @@
               </a:rPr>
               <a:t>Sarlin et al., SuperGlue: Learning Feature Matching with Graph Neural Networks, CVPR 2020</a:t>
             </a:r>
+            <a:pPr indent="0" marL="0">
+              <a:spcAft>
+                <a:spcPts val="300"/>
+              </a:spcAft>
+              <a:buNone/>
+            </a:pPr>
             <a:r>
               <a:rPr lang="en-US" sz="1000" i="1" dirty="0">
                 <a:solidFill>
@@ -2299,7 +2557,7 @@
               </a:spcAft>
               <a:buSzPct val="100000"/>
               <a:buFont typeface="+mj-lt"/>
-              <a:buAutoNum type="arabicPeriod"/>
+              <a:buAutoNum type="arabicPeriod" startAt="1"/>
             </a:pPr>
             <a:r>
               <a:rPr lang="en-US" sz="1000" dirty="0">
@@ -2309,6 +2567,12 @@
               </a:rPr>
               <a:t>Nistér, An Efficient Solution to the Five-Point Relative Pose Problem, IEEE TPAMI 2004</a:t>
             </a:r>
+            <a:pPr indent="0" marL="0">
+              <a:spcAft>
+                <a:spcPts val="300"/>
+              </a:spcAft>
+              <a:buNone/>
+            </a:pPr>
             <a:r>
               <a:rPr lang="en-US" sz="1000" i="1" dirty="0">
                 <a:solidFill>
@@ -2326,7 +2590,7 @@
               </a:spcAft>
               <a:buSzPct val="100000"/>
               <a:buFont typeface="+mj-lt"/>
-              <a:buAutoNum type="arabicPeriod"/>
+              <a:buAutoNum type="arabicPeriod" startAt="1"/>
             </a:pPr>
             <a:r>
               <a:rPr lang="en-US" sz="1000" dirty="0">
@@ -2336,6 +2600,12 @@
               </a:rPr>
               <a:t>Fischler and Bolles, Random Sample Consensus (RANSAC), Communications of the ACM 1981</a:t>
             </a:r>
+            <a:pPr indent="0" marL="0">
+              <a:spcAft>
+                <a:spcPts val="300"/>
+              </a:spcAft>
+              <a:buNone/>
+            </a:pPr>
             <a:r>
               <a:rPr lang="en-US" sz="1000" i="1" dirty="0">
                 <a:solidFill>
@@ -2353,7 +2623,7 @@
               </a:spcAft>
               <a:buSzPct val="100000"/>
               <a:buFont typeface="+mj-lt"/>
-              <a:buAutoNum type="arabicPeriod"/>
+              <a:buAutoNum type="arabicPeriod" startAt="1"/>
             </a:pPr>
             <a:r>
               <a:rPr lang="en-US" sz="1000" dirty="0">
@@ -2363,6 +2633,12 @@
               </a:rPr>
               <a:t>Tools: PyTorch, OpenCV, NetworkX (Dijkstra) and the course’s vis-nav SDK</a:t>
             </a:r>
+            <a:pPr indent="0" marL="0">
+              <a:spcAft>
+                <a:spcPts val="300"/>
+              </a:spcAft>
+              <a:buNone/>
+            </a:pPr>
             <a:endParaRPr lang="en-US" sz="1000" dirty="0"/>
           </a:p>
         </p:txBody>
@@ -2387,7 +2663,7 @@
           </a:prstGeom>
           <a:extLst>
             <a:ext uri="{C572A759-6A51-4108-AA02-DFA0A04FC94B}">
-              <ma14:wrappingTextBoxFlag xmlns:ma14="http://schemas.microsoft.com/office/mac/drawingml/2011/main" xmlns="" val="0"/>
+              <ma14:wrappingTextBoxFlag xmlns:ma14="http://schemas.microsoft.com/office/mac/drawingml/2011/main" val="0"/>
             </a:ext>
           </a:extLst>
         </p:spPr>
@@ -2405,7 +2681,7 @@
           <a:p>
             <a:pPr algn="r"/>
             <a:fld id="{F7021451-1387-4CA6-816F-3879F97B5CBC}" type="slidenum">
-              <a:rPr lang="en-US" b="0"/>
+              <a:rPr b="0" lang="en-US"/>
               <a:t>2</a:t>
             </a:fld>
             <a:endParaRPr lang="en-US"/>
@@ -2458,11 +2734,11 @@
           <a:bodyPr wrap="square" lIns="0" tIns="0" rIns="0" bIns="0" rtlCol="0" anchor="ctr"/>
           <a:lstStyle/>
           <a:p>
-            <a:pPr marL="0" indent="0">
-              <a:buNone/>
-            </a:pPr>
-            <a:r>
-              <a:rPr lang="en-US" sz="1100" b="1" kern="0" spc="200" dirty="0">
+            <a:pPr indent="0" marL="0">
+              <a:buNone/>
+            </a:pPr>
+            <a:r>
+              <a:rPr lang="en-US" sz="1100" b="1" spc="200" kern="0" dirty="0">
                 <a:solidFill>
                   <a:schemeClr val="accent1"/>
                 </a:solidFill>
@@ -2476,11 +2752,9 @@
       <p:sp>
         <p:nvSpPr>
           <p:cNvPr id="3" name="Text 0"/>
-          <p:cNvSpPr>
-            <a:spLocks noGrp="1"/>
-          </p:cNvSpPr>
+          <p:cNvSpPr/>
           <p:nvPr>
-            <p:ph type="title" idx="100" hasCustomPrompt="1"/>
+            <p:ph idx="100" type="title" hasCustomPrompt="1"/>
           </p:nvPr>
         </p:nvSpPr>
         <p:spPr>
@@ -2498,7 +2772,7 @@
           <a:bodyPr wrap="square" lIns="0" tIns="0" rIns="0" bIns="0" rtlCol="0" anchor="ctr"/>
           <a:lstStyle/>
           <a:p>
-            <a:pPr marL="0" indent="0" algn="l">
+            <a:pPr algn="l" indent="0" marL="0">
               <a:buNone/>
             </a:pPr>
             <a:r>
@@ -2515,13 +2789,60 @@
       </p:sp>
       <p:sp>
         <p:nvSpPr>
-          <p:cNvPr id="4" name="phase 1 label pill"/>
+          <p:cNvPr id="4" name="sptm intro"/>
+          <p:cNvSpPr txBox="1"/>
+          <p:nvPr/>
+        </p:nvSpPr>
+        <p:spPr>
+          <a:xfrm>
+            <a:off x="548640" y="1298448"/>
+            <a:ext cx="7132320" cy="566928"/>
+          </a:xfrm>
+          <a:prstGeom prst="rect">
+            <a:avLst/>
+          </a:prstGeom>
+          <a:noFill/>
+          <a:ln/>
+        </p:spPr>
+        <p:txBody>
+          <a:bodyPr wrap="square" lIns="0" tIns="0" rIns="0" bIns="0" rtlCol="0" anchor="t"/>
+          <a:lstStyle/>
+          <a:p>
+            <a:pPr indent="0" marL="0">
+              <a:buNone/>
+            </a:pPr>
+            <a:r>
+              <a:rPr lang="en-US" sz="1250" b="1" dirty="0">
+                <a:solidFill>
+                  <a:schemeClr val="tx1"/>
+                </a:solidFill>
+              </a:rPr>
+              <a:t>The core is SPTM </a:t>
+            </a:r>
+            <a:pPr indent="0" marL="0">
+              <a:buNone/>
+            </a:pPr>
+            <a:r>
+              <a:rPr lang="en-US" sz="1250" dirty="0">
+                <a:solidFill>
+                  <a:schemeClr val="tx2"/>
+                </a:solidFill>
+              </a:rPr>
+              <a:t>(semi-parametric topological memory, Savinov et al. 2018): the exploration photos become a graph that is the robot’s memory, and it localises, plans and moves on that graph photo by photo. Each step says what comes from SPTM and what we added.</a:t>
+            </a:r>
+            <a:endParaRPr lang="en-US" sz="1250" dirty="0"/>
+          </a:p>
+        </p:txBody>
+      </p:sp>
+      <p:sp>
+        <p:nvSpPr>
+          <p:cNvPr id="5" name="phase 1 label pill"/>
           <p:cNvSpPr/>
           <p:nvPr/>
         </p:nvSpPr>
         <p:spPr>
           <a:xfrm>
-            <a:off x="548640" y="1371600"/>
+            <a:off x="548640" y="1938528"/>
             <a:ext cx="7132320" cy="347472"/>
           </a:xfrm>
           <a:prstGeom prst="roundRect">
@@ -2542,13 +2863,13 @@
       </p:sp>
       <p:sp>
         <p:nvSpPr>
-          <p:cNvPr id="5" name="phase 1 label"/>
+          <p:cNvPr id="6" name="phase 1 label"/>
           <p:cNvSpPr txBox="1"/>
           <p:nvPr/>
         </p:nvSpPr>
         <p:spPr>
           <a:xfrm>
-            <a:off x="731520" y="1371600"/>
+            <a:off x="731520" y="1938528"/>
             <a:ext cx="6766560" cy="347472"/>
           </a:xfrm>
           <a:prstGeom prst="rect">
@@ -2561,7 +2882,7 @@
           <a:bodyPr wrap="square" lIns="0" tIns="0" rIns="0" bIns="0" rtlCol="0" anchor="ctr"/>
           <a:lstStyle/>
           <a:p>
-            <a:pPr marL="0" indent="0">
+            <a:pPr indent="0" marL="0">
               <a:buNone/>
             </a:pPr>
             <a:r>
@@ -2578,13 +2899,13 @@
       </p:sp>
       <p:sp>
         <p:nvSpPr>
-          <p:cNvPr id="6" name="before step 1 circle"/>
+          <p:cNvPr id="7" name="before step 1 circle"/>
           <p:cNvSpPr/>
           <p:nvPr/>
         </p:nvSpPr>
         <p:spPr>
           <a:xfrm>
-            <a:off x="548640" y="1874520"/>
+            <a:off x="548640" y="2395728"/>
             <a:ext cx="292608" cy="292608"/>
           </a:xfrm>
           <a:prstGeom prst="ellipse">
@@ -2603,13 +2924,13 @@
       </p:sp>
       <p:sp>
         <p:nvSpPr>
-          <p:cNvPr id="7" name="before step 1 number"/>
+          <p:cNvPr id="8" name="before step 1 number"/>
           <p:cNvSpPr txBox="1"/>
           <p:nvPr/>
         </p:nvSpPr>
         <p:spPr>
           <a:xfrm>
-            <a:off x="548640" y="1874520"/>
+            <a:off x="548640" y="2395728"/>
             <a:ext cx="292608" cy="292608"/>
           </a:xfrm>
           <a:prstGeom prst="rect">
@@ -2622,7 +2943,7 @@
           <a:bodyPr wrap="square" lIns="0" tIns="0" rIns="0" bIns="0" rtlCol="0" anchor="ctr"/>
           <a:lstStyle/>
           <a:p>
-            <a:pPr marL="0" indent="0" algn="ctr">
+            <a:pPr algn="ctr" indent="0" marL="0">
               <a:buNone/>
             </a:pPr>
             <a:r>
@@ -2639,14 +2960,14 @@
       </p:sp>
       <p:sp>
         <p:nvSpPr>
-          <p:cNvPr id="8" name="before step 1 text"/>
+          <p:cNvPr id="9" name="before step 1 text"/>
           <p:cNvSpPr txBox="1"/>
           <p:nvPr/>
         </p:nvSpPr>
         <p:spPr>
           <a:xfrm>
-            <a:off x="978408" y="1856232"/>
-            <a:ext cx="6702552" cy="451104"/>
+            <a:off x="978408" y="2377440"/>
+            <a:ext cx="6702552" cy="435864"/>
           </a:xfrm>
           <a:prstGeom prst="rect">
             <a:avLst/>
@@ -2658,38 +2979,52 @@
           <a:bodyPr wrap="square" lIns="0" tIns="0" rIns="0" bIns="0" rtlCol="0" anchor="t"/>
           <a:lstStyle/>
           <a:p>
-            <a:pPr marL="0" indent="0">
-              <a:buNone/>
-            </a:pPr>
-            <a:r>
-              <a:rPr lang="en-US" sz="1300" b="1" dirty="0">
+            <a:pPr indent="0" marL="0">
+              <a:buNone/>
+            </a:pPr>
+            <a:r>
+              <a:rPr lang="en-US" sz="1250" b="1" dirty="0">
                 <a:solidFill>
                   <a:schemeClr val="tx1"/>
                 </a:solidFill>
               </a:rPr>
-              <a:t>Photo map. </a:t>
-            </a:r>
-            <a:r>
-              <a:rPr lang="en-US" sz="1300" dirty="0">
+              <a:t>Photo map </a:t>
+            </a:r>
+            <a:pPr indent="0" marL="0">
+              <a:buNone/>
+            </a:pPr>
+            <a:r>
+              <a:rPr lang="en-US" sz="1250" i="1" dirty="0">
+                <a:solidFill>
+                  <a:schemeClr val="accent1"/>
+                </a:solidFill>
+              </a:rPr>
+              <a:t>(SPTM’s memory graph). </a:t>
+            </a:r>
+            <a:pPr indent="0" marL="0">
+              <a:buNone/>
+            </a:pPr>
+            <a:r>
+              <a:rPr lang="en-US" sz="1250" dirty="0">
                 <a:solidFill>
                   <a:schemeClr val="tx2"/>
                 </a:solidFill>
               </a:rPr>
-              <a:t>Every exploration photo becomes a node. Photos taken one after another on the same drive are linked, because the robot drove from one to the next.</a:t>
-            </a:r>
-            <a:endParaRPr lang="en-US" sz="1300" dirty="0"/>
-          </a:p>
-        </p:txBody>
-      </p:sp>
-      <p:sp>
-        <p:nvSpPr>
-          <p:cNvPr id="9" name="before step 2 circle"/>
+              <a:t>Every exploration photo becomes a node; photos taken one after another on a drive are linked, because the robot drove from one to the next.</a:t>
+            </a:r>
+            <a:endParaRPr lang="en-US" sz="1250" dirty="0"/>
+          </a:p>
+        </p:txBody>
+      </p:sp>
+      <p:sp>
+        <p:nvSpPr>
+          <p:cNvPr id="10" name="before step 2 circle"/>
           <p:cNvSpPr/>
           <p:nvPr/>
         </p:nvSpPr>
         <p:spPr>
           <a:xfrm>
-            <a:off x="548640" y="2435352"/>
+            <a:off x="548640" y="2941320"/>
             <a:ext cx="292608" cy="292608"/>
           </a:xfrm>
           <a:prstGeom prst="ellipse">
@@ -2708,13 +3043,13 @@
       </p:sp>
       <p:sp>
         <p:nvSpPr>
-          <p:cNvPr id="10" name="before step 2 number"/>
+          <p:cNvPr id="11" name="before step 2 number"/>
           <p:cNvSpPr txBox="1"/>
           <p:nvPr/>
         </p:nvSpPr>
         <p:spPr>
           <a:xfrm>
-            <a:off x="548640" y="2435352"/>
+            <a:off x="548640" y="2941320"/>
             <a:ext cx="292608" cy="292608"/>
           </a:xfrm>
           <a:prstGeom prst="rect">
@@ -2727,7 +3062,7 @@
           <a:bodyPr wrap="square" lIns="0" tIns="0" rIns="0" bIns="0" rtlCol="0" anchor="ctr"/>
           <a:lstStyle/>
           <a:p>
-            <a:pPr marL="0" indent="0" algn="ctr">
+            <a:pPr algn="ctr" indent="0" marL="0">
               <a:buNone/>
             </a:pPr>
             <a:r>
@@ -2744,14 +3079,14 @@
       </p:sp>
       <p:sp>
         <p:nvSpPr>
-          <p:cNvPr id="11" name="before step 2 text"/>
+          <p:cNvPr id="12" name="before step 2 text"/>
           <p:cNvSpPr txBox="1"/>
           <p:nvPr/>
         </p:nvSpPr>
         <p:spPr>
           <a:xfrm>
-            <a:off x="978408" y="2417064"/>
-            <a:ext cx="6702552" cy="1243584"/>
+            <a:off x="978408" y="2923032"/>
+            <a:ext cx="6702552" cy="1007364"/>
           </a:xfrm>
           <a:prstGeom prst="rect">
             <a:avLst/>
@@ -2763,38 +3098,52 @@
           <a:bodyPr wrap="square" lIns="0" tIns="0" rIns="0" bIns="0" rtlCol="0" anchor="t"/>
           <a:lstStyle/>
           <a:p>
-            <a:pPr marL="0" indent="0">
-              <a:buNone/>
-            </a:pPr>
-            <a:r>
-              <a:rPr lang="en-US" sz="1300" b="1" dirty="0">
+            <a:pPr indent="0" marL="0">
+              <a:buNone/>
+            </a:pPr>
+            <a:r>
+              <a:rPr lang="en-US" sz="1250" b="1" dirty="0">
                 <a:solidFill>
                   <a:schemeClr val="tx1"/>
                 </a:solidFill>
               </a:rPr>
-              <a:t>Where the drives meet again. </a:t>
-            </a:r>
-            <a:r>
-              <a:rPr lang="en-US" sz="1300" dirty="0">
+              <a:t>Shortcuts where the drives meet </a:t>
+            </a:r>
+            <a:pPr indent="0" marL="0">
+              <a:buNone/>
+            </a:pPr>
+            <a:r>
+              <a:rPr lang="en-US" sz="1250" i="1" dirty="0">
+                <a:solidFill>
+                  <a:schemeClr val="accent1"/>
+                </a:solidFill>
+              </a:rPr>
+              <a:t>(SPTM; SuperGlue check added). </a:t>
+            </a:r>
+            <a:pPr indent="0" marL="0">
+              <a:buNone/>
+            </a:pPr>
+            <a:r>
+              <a:rPr lang="en-US" sz="1250" dirty="0">
                 <a:solidFill>
                   <a:schemeClr val="tx2"/>
                 </a:solidFill>
               </a:rPr>
-              <a:t>AnyLoc (DINOv2 features + VLAD) compares every photo with the photos taken at other times (on another drive, or much later on the same drive) and proposes pairs that look like the same place. SuperGlue then matches keypoints between the two photos of each pair, and the pair is kept only if the matches fit one camera motion (RANSAC) for 8 or more pairs in a row (a look-alike wall usually matches for only 1–3 photos in a row). Each kept pair becomes a shortcut link.</a:t>
-            </a:r>
-            <a:endParaRPr lang="en-US" sz="1300" dirty="0"/>
-          </a:p>
-        </p:txBody>
-      </p:sp>
-      <p:sp>
-        <p:nvSpPr>
-          <p:cNvPr id="12" name="before step 3 circle"/>
+              <a:t>AnyLoc (DINOv2 features + VLAD) compares every photo with photos taken at other times and proposes pairs that look like the same place. SuperGlue matches keypoints between the two photos, and a pair is kept only if the matches fit one camera motion (RANSAC) for 8 or more pairs in a row (a look-alike wall usually matches for only 1 to 3). Each kept pair becomes a shortcut.</a:t>
+            </a:r>
+            <a:endParaRPr lang="en-US" sz="1250" dirty="0"/>
+          </a:p>
+        </p:txBody>
+      </p:sp>
+      <p:sp>
+        <p:nvSpPr>
+          <p:cNvPr id="13" name="before step 3 circle"/>
           <p:cNvSpPr/>
           <p:nvPr/>
         </p:nvSpPr>
         <p:spPr>
           <a:xfrm>
-            <a:off x="548640" y="3788664"/>
+            <a:off x="548640" y="4058412"/>
             <a:ext cx="292608" cy="292608"/>
           </a:xfrm>
           <a:prstGeom prst="ellipse">
@@ -2813,13 +3162,13 @@
       </p:sp>
       <p:sp>
         <p:nvSpPr>
-          <p:cNvPr id="13" name="before step 3 number"/>
+          <p:cNvPr id="14" name="before step 3 number"/>
           <p:cNvSpPr txBox="1"/>
           <p:nvPr/>
         </p:nvSpPr>
         <p:spPr>
           <a:xfrm>
-            <a:off x="548640" y="3788664"/>
+            <a:off x="548640" y="4058412"/>
             <a:ext cx="292608" cy="292608"/>
           </a:xfrm>
           <a:prstGeom prst="rect">
@@ -2832,7 +3181,7 @@
           <a:bodyPr wrap="square" lIns="0" tIns="0" rIns="0" bIns="0" rtlCol="0" anchor="ctr"/>
           <a:lstStyle/>
           <a:p>
-            <a:pPr marL="0" indent="0" algn="ctr">
+            <a:pPr algn="ctr" indent="0" marL="0">
               <a:buNone/>
             </a:pPr>
             <a:r>
@@ -2849,14 +3198,14 @@
       </p:sp>
       <p:sp>
         <p:nvSpPr>
-          <p:cNvPr id="14" name="before step 3 text"/>
+          <p:cNvPr id="15" name="before step 3 text"/>
           <p:cNvSpPr txBox="1"/>
           <p:nvPr/>
         </p:nvSpPr>
         <p:spPr>
           <a:xfrm>
-            <a:off x="978408" y="3770376"/>
-            <a:ext cx="6702552" cy="649224"/>
+            <a:off x="978408" y="4040124"/>
+            <a:ext cx="6702552" cy="626364"/>
           </a:xfrm>
           <a:prstGeom prst="rect">
             <a:avLst/>
@@ -2868,38 +3217,52 @@
           <a:bodyPr wrap="square" lIns="0" tIns="0" rIns="0" bIns="0" rtlCol="0" anchor="t"/>
           <a:lstStyle/>
           <a:p>
-            <a:pPr marL="0" indent="0">
-              <a:buNone/>
-            </a:pPr>
-            <a:r>
-              <a:rPr lang="en-US" sz="1300" b="1" dirty="0">
+            <a:pPr indent="0" marL="0">
+              <a:buNone/>
+            </a:pPr>
+            <a:r>
+              <a:rPr lang="en-US" sz="1250" b="1" dirty="0">
                 <a:solidFill>
                   <a:schemeClr val="tx1"/>
                 </a:solidFill>
               </a:rPr>
-              <a:t>Distances. </a:t>
-            </a:r>
-            <a:r>
-              <a:rPr lang="en-US" sz="1300" dirty="0">
+              <a:t>Distances </a:t>
+            </a:r>
+            <a:pPr indent="0" marL="0">
+              <a:buNone/>
+            </a:pPr>
+            <a:r>
+              <a:rPr lang="en-US" sz="1250" i="1" dirty="0">
+                <a:solidFill>
+                  <a:schemeClr val="accent1"/>
+                </a:solidFill>
+              </a:rPr>
+              <a:t>(added). </a:t>
+            </a:r>
+            <a:pPr indent="0" marL="0">
+              <a:buNone/>
+            </a:pPr>
+            <a:r>
+              <a:rPr lang="en-US" sz="1250" dirty="0">
                 <a:solidFill>
                   <a:schemeClr val="tx2"/>
                 </a:solidFill>
               </a:rPr>
-              <a:t>Lines on the walls give a compass direction, SuperGlue gives the turn between neighbouring photos, and the links close the loops. This places every photo in metres, so each link gets a cost in steps.</a:t>
-            </a:r>
-            <a:endParaRPr lang="en-US" sz="1300" dirty="0"/>
-          </a:p>
-        </p:txBody>
-      </p:sp>
-      <p:sp>
-        <p:nvSpPr>
-          <p:cNvPr id="15" name="phase 2 label pill"/>
+              <a:t>Lines on the walls give a compass direction, SuperGlue gives the turn between neighbouring photos, and the shortcuts close the loops. This places every photo in metres, so each link costs its steps.</a:t>
+            </a:r>
+            <a:endParaRPr lang="en-US" sz="1250" dirty="0"/>
+          </a:p>
+        </p:txBody>
+      </p:sp>
+      <p:sp>
+        <p:nvSpPr>
+          <p:cNvPr id="16" name="phase 2 label pill"/>
           <p:cNvSpPr/>
           <p:nvPr/>
         </p:nvSpPr>
         <p:spPr>
           <a:xfrm>
-            <a:off x="548640" y="4593336"/>
+            <a:off x="548640" y="4831080"/>
             <a:ext cx="7132320" cy="347472"/>
           </a:xfrm>
           <a:prstGeom prst="roundRect">
@@ -2920,13 +3283,13 @@
       </p:sp>
       <p:sp>
         <p:nvSpPr>
-          <p:cNvPr id="16" name="phase 2 label"/>
+          <p:cNvPr id="17" name="phase 2 label"/>
           <p:cNvSpPr txBox="1"/>
           <p:nvPr/>
         </p:nvSpPr>
         <p:spPr>
           <a:xfrm>
-            <a:off x="731520" y="4593336"/>
+            <a:off x="731520" y="4831080"/>
             <a:ext cx="6766560" cy="347472"/>
           </a:xfrm>
           <a:prstGeom prst="rect">
@@ -2939,7 +3302,7 @@
           <a:bodyPr wrap="square" lIns="0" tIns="0" rIns="0" bIns="0" rtlCol="0" anchor="ctr"/>
           <a:lstStyle/>
           <a:p>
-            <a:pPr marL="0" indent="0">
+            <a:pPr indent="0" marL="0">
               <a:buNone/>
             </a:pPr>
             <a:r>
@@ -2956,13 +3319,13 @@
       </p:sp>
       <p:sp>
         <p:nvSpPr>
-          <p:cNvPr id="17" name="start step 1 circle"/>
+          <p:cNvPr id="18" name="start step 1 circle"/>
           <p:cNvSpPr/>
           <p:nvPr/>
         </p:nvSpPr>
         <p:spPr>
           <a:xfrm>
-            <a:off x="548640" y="5050536"/>
+            <a:off x="548640" y="5288280"/>
             <a:ext cx="292608" cy="292608"/>
           </a:xfrm>
           <a:prstGeom prst="ellipse">
@@ -2981,13 +3344,13 @@
       </p:sp>
       <p:sp>
         <p:nvSpPr>
-          <p:cNvPr id="18" name="start step 1 number"/>
+          <p:cNvPr id="19" name="start step 1 number"/>
           <p:cNvSpPr txBox="1"/>
           <p:nvPr/>
         </p:nvSpPr>
         <p:spPr>
           <a:xfrm>
-            <a:off x="548640" y="5050536"/>
+            <a:off x="548640" y="5288280"/>
             <a:ext cx="292608" cy="292608"/>
           </a:xfrm>
           <a:prstGeom prst="rect">
@@ -3000,7 +3363,7 @@
           <a:bodyPr wrap="square" lIns="0" tIns="0" rIns="0" bIns="0" rtlCol="0" anchor="ctr"/>
           <a:lstStyle/>
           <a:p>
-            <a:pPr marL="0" indent="0" algn="ctr">
+            <a:pPr algn="ctr" indent="0" marL="0">
               <a:buNone/>
             </a:pPr>
             <a:r>
@@ -3017,14 +3380,14 @@
       </p:sp>
       <p:sp>
         <p:nvSpPr>
-          <p:cNvPr id="19" name="start step 1 text"/>
+          <p:cNvPr id="20" name="start step 1 text"/>
           <p:cNvSpPr txBox="1"/>
           <p:nvPr/>
         </p:nvSpPr>
         <p:spPr>
           <a:xfrm>
-            <a:off x="978408" y="5032248"/>
-            <a:ext cx="6702552" cy="649224"/>
+            <a:off x="978408" y="5269992"/>
+            <a:ext cx="6702552" cy="626364"/>
           </a:xfrm>
           <a:prstGeom prst="rect">
             <a:avLst/>
@@ -3036,38 +3399,52 @@
           <a:bodyPr wrap="square" lIns="0" tIns="0" rIns="0" bIns="0" rtlCol="0" anchor="t"/>
           <a:lstStyle/>
           <a:p>
-            <a:pPr marL="0" indent="0">
-              <a:buNone/>
-            </a:pPr>
-            <a:r>
-              <a:rPr lang="en-US" sz="1300" b="1" dirty="0">
+            <a:pPr indent="0" marL="0">
+              <a:buNone/>
+            </a:pPr>
+            <a:r>
+              <a:rPr lang="en-US" sz="1250" b="1" dirty="0">
                 <a:solidFill>
                   <a:schemeClr val="tx1"/>
                 </a:solidFill>
               </a:rPr>
-              <a:t>The goal. </a:t>
-            </a:r>
-            <a:r>
-              <a:rPr lang="en-US" sz="1300" dirty="0">
+              <a:t>The goal node </a:t>
+            </a:r>
+            <a:pPr indent="0" marL="0">
+              <a:buNone/>
+            </a:pPr>
+            <a:r>
+              <a:rPr lang="en-US" sz="1250" i="1" dirty="0">
+                <a:solidFill>
+                  <a:schemeClr val="accent1"/>
+                </a:solidFill>
+              </a:rPr>
+              <a:t>(SPTM; 64-candidate check added). </a:t>
+            </a:r>
+            <a:pPr indent="0" marL="0">
+              <a:buNone/>
+            </a:pPr>
+            <a:r>
+              <a:rPr lang="en-US" sz="1250" dirty="0">
                 <a:solidFill>
                   <a:schemeClr val="tx2"/>
                 </a:solidFill>
               </a:rPr>
-              <a:t>Each of the 4 goal photos is compared with the 64 exploration photos AnyLoc finds most similar. The exploration photo with the most SuperGlue matches becomes the goal node. Checking 64 candidates instead of 6 picked the right goal in 12 of our 13 test mazes, up from 9.</a:t>
-            </a:r>
-            <a:endParaRPr lang="en-US" sz="1300" dirty="0"/>
-          </a:p>
-        </p:txBody>
-      </p:sp>
-      <p:sp>
-        <p:nvSpPr>
-          <p:cNvPr id="20" name="start step 2 circle"/>
+              <a:t>Each goal photo is compared with the 64 exploration photos AnyLoc finds most similar; the one with the most SuperGlue matches becomes the goal node. This was right in 12 of our 13 test mazes, against 9 with only 6 candidates.</a:t>
+            </a:r>
+            <a:endParaRPr lang="en-US" sz="1250" dirty="0"/>
+          </a:p>
+        </p:txBody>
+      </p:sp>
+      <p:sp>
+        <p:nvSpPr>
+          <p:cNvPr id="21" name="start step 2 circle"/>
           <p:cNvSpPr/>
           <p:nvPr/>
         </p:nvSpPr>
         <p:spPr>
           <a:xfrm>
-            <a:off x="548640" y="5809488"/>
+            <a:off x="548640" y="6024372"/>
             <a:ext cx="292608" cy="292608"/>
           </a:xfrm>
           <a:prstGeom prst="ellipse">
@@ -3086,13 +3463,13 @@
       </p:sp>
       <p:sp>
         <p:nvSpPr>
-          <p:cNvPr id="21" name="start step 2 number"/>
+          <p:cNvPr id="22" name="start step 2 number"/>
           <p:cNvSpPr txBox="1"/>
           <p:nvPr/>
         </p:nvSpPr>
         <p:spPr>
           <a:xfrm>
-            <a:off x="548640" y="5809488"/>
+            <a:off x="548640" y="6024372"/>
             <a:ext cx="292608" cy="292608"/>
           </a:xfrm>
           <a:prstGeom prst="rect">
@@ -3105,7 +3482,7 @@
           <a:bodyPr wrap="square" lIns="0" tIns="0" rIns="0" bIns="0" rtlCol="0" anchor="ctr"/>
           <a:lstStyle/>
           <a:p>
-            <a:pPr marL="0" indent="0" algn="ctr">
+            <a:pPr algn="ctr" indent="0" marL="0">
               <a:buNone/>
             </a:pPr>
             <a:r>
@@ -3122,14 +3499,14 @@
       </p:sp>
       <p:sp>
         <p:nvSpPr>
-          <p:cNvPr id="22" name="start step 2 text"/>
+          <p:cNvPr id="23" name="start step 2 text"/>
           <p:cNvSpPr txBox="1"/>
           <p:nvPr/>
         </p:nvSpPr>
         <p:spPr>
           <a:xfrm>
-            <a:off x="978408" y="5791200"/>
-            <a:ext cx="6702552" cy="252984"/>
+            <a:off x="978408" y="6006084"/>
+            <a:ext cx="6702552" cy="245364"/>
           </a:xfrm>
           <a:prstGeom prst="rect">
             <a:avLst/>
@@ -3141,32 +3518,141 @@
           <a:bodyPr wrap="square" lIns="0" tIns="0" rIns="0" bIns="0" rtlCol="0" anchor="t"/>
           <a:lstStyle/>
           <a:p>
-            <a:pPr marL="0" indent="0">
-              <a:buNone/>
-            </a:pPr>
-            <a:r>
-              <a:rPr lang="en-US" sz="1300" b="1" dirty="0">
+            <a:pPr indent="0" marL="0">
+              <a:buNone/>
+            </a:pPr>
+            <a:r>
+              <a:rPr lang="en-US" sz="1250" b="1" dirty="0">
                 <a:solidFill>
                   <a:schemeClr val="tx1"/>
                 </a:solidFill>
               </a:rPr>
-              <a:t>The route. </a:t>
-            </a:r>
-            <a:r>
-              <a:rPr lang="en-US" sz="1300" dirty="0">
+              <a:t>The route </a:t>
+            </a:r>
+            <a:pPr indent="0" marL="0">
+              <a:buNone/>
+            </a:pPr>
+            <a:r>
+              <a:rPr lang="en-US" sz="1250" i="1" dirty="0">
+                <a:solidFill>
+                  <a:schemeClr val="accent1"/>
+                </a:solidFill>
+              </a:rPr>
+              <a:t>(SPTM). </a:t>
+            </a:r>
+            <a:pPr indent="0" marL="0">
+              <a:buNone/>
+            </a:pPr>
+            <a:r>
+              <a:rPr lang="en-US" sz="1250" dirty="0">
                 <a:solidFill>
                   <a:schemeClr val="tx2"/>
                 </a:solidFill>
               </a:rPr>
               <a:t>Dijkstra finds the cheapest route, in steps, from every photo to the goal node.</a:t>
             </a:r>
-            <a:endParaRPr lang="en-US" sz="1300" dirty="0"/>
+            <a:endParaRPr lang="en-US" sz="1250" dirty="0"/>
           </a:p>
         </p:txBody>
       </p:sp>
       <p:pic>
         <p:nvPicPr>
-          <p:cNvPr id="23" name="photo map figure" descr="Local test maze 25 with its walls, the three exploration drives at their true positions in blue, green and purple, and the shortcut links the robot found between photos of one place in orange"/>
+          <p:cNvPr id="24" name="photo map figure" descr="Local test maze 25 with its walls, the three exploration drives at their true positions in blue, green and purple, and the shortcut links the robot found between photos of one place in orange">    </p:cNvPr>
+          <p:cNvPicPr>
+            <a:picLocks noChangeAspect="1"/>
+          </p:cNvPicPr>
+          <p:nvPr/>
+        </p:nvPicPr>
+        <p:blipFill>
+          <a:blip r:embed="rId1"/>
+          <a:stretch>
+            <a:fillRect/>
+          </a:stretch>
+        </p:blipFill>
+        <p:spPr>
+          <a:xfrm>
+            <a:off x="8229600" y="1371600"/>
+            <a:ext cx="2514600" cy="2514600"/>
+          </a:xfrm>
+          <a:prstGeom prst="rect">
+            <a:avLst/>
+          </a:prstGeom>
+        </p:spPr>
+      </p:pic>
+      <p:sp>
+        <p:nvSpPr>
+          <p:cNvPr id="25" name="photo map caption"/>
+          <p:cNvSpPr txBox="1"/>
+          <p:nvPr/>
+        </p:nvSpPr>
+        <p:spPr>
+          <a:xfrm>
+            <a:off x="8229600" y="3941064"/>
+            <a:ext cx="3429000" cy="566928"/>
+          </a:xfrm>
+          <a:prstGeom prst="rect">
+            <a:avLst/>
+          </a:prstGeom>
+          <a:noFill/>
+          <a:ln/>
+        </p:spPr>
+        <p:txBody>
+          <a:bodyPr wrap="square" lIns="0" tIns="0" rIns="0" bIns="0" rtlCol="0" anchor="t"/>
+          <a:lstStyle/>
+          <a:p>
+            <a:pPr indent="0" marL="0">
+              <a:buNone/>
+            </a:pPr>
+            <a:r>
+              <a:rPr lang="en-US" sz="1000" b="1" dirty="0">
+                <a:solidFill>
+                  <a:schemeClr val="tx1"/>
+                </a:solidFill>
+              </a:rPr>
+              <a:t>Steps 1–2 on local test maze 25. </a:t>
+            </a:r>
+            <a:pPr indent="0" marL="0">
+              <a:buNone/>
+            </a:pPr>
+            <a:r>
+              <a:rPr lang="en-US" sz="1000" dirty="0">
+                <a:solidFill>
+                  <a:schemeClr val="tx2"/>
+                </a:solidFill>
+              </a:rPr>
+              <a:t>The three drives (blue, green, purple) and the 480 shortcut links the robot found (orange): 466 of them (97%) join photos in the same corridor.</a:t>
+            </a:r>
+            <a:endParaRPr lang="en-US" sz="1000" dirty="0"/>
+          </a:p>
+        </p:txBody>
+      </p:sp>
+      <p:pic>
+        <p:nvPicPr>
+          <p:cNvPr id="26" name="goal example 1" descr="Local maze 25: the goal photo it is given">    </p:cNvPr>
+          <p:cNvPicPr>
+            <a:picLocks noChangeAspect="1"/>
+          </p:cNvPicPr>
+          <p:nvPr/>
+        </p:nvPicPr>
+        <p:blipFill>
+          <a:blip r:embed="rId2"/>
+          <a:stretch>
+            <a:fillRect/>
+          </a:stretch>
+        </p:blipFill>
+        <p:spPr>
+          <a:xfrm>
+            <a:off x="8229600" y="4572000"/>
+            <a:ext cx="1677924" cy="1258443"/>
+          </a:xfrm>
+          <a:prstGeom prst="rect">
+            <a:avLst/>
+          </a:prstGeom>
+        </p:spPr>
+      </p:pic>
+      <p:pic>
+        <p:nvPicPr>
+          <p:cNvPr id="27" name="goal example 2" descr="Local maze 25: the exploration photo it picks as the goal">    </p:cNvPr>
           <p:cNvPicPr>
             <a:picLocks noChangeAspect="1"/>
           </p:cNvPicPr>
@@ -3180,98 +3666,6 @@
         </p:blipFill>
         <p:spPr>
           <a:xfrm>
-            <a:off x="8229600" y="1371600"/>
-            <a:ext cx="2514600" cy="2514600"/>
-          </a:xfrm>
-          <a:prstGeom prst="rect">
-            <a:avLst/>
-          </a:prstGeom>
-        </p:spPr>
-      </p:pic>
-      <p:sp>
-        <p:nvSpPr>
-          <p:cNvPr id="24" name="photo map caption"/>
-          <p:cNvSpPr txBox="1"/>
-          <p:nvPr/>
-        </p:nvSpPr>
-        <p:spPr>
-          <a:xfrm>
-            <a:off x="8229600" y="3941064"/>
-            <a:ext cx="3429000" cy="566928"/>
-          </a:xfrm>
-          <a:prstGeom prst="rect">
-            <a:avLst/>
-          </a:prstGeom>
-          <a:noFill/>
-          <a:ln/>
-        </p:spPr>
-        <p:txBody>
-          <a:bodyPr wrap="square" lIns="0" tIns="0" rIns="0" bIns="0" rtlCol="0" anchor="t"/>
-          <a:lstStyle/>
-          <a:p>
-            <a:pPr marL="0" indent="0">
-              <a:buNone/>
-            </a:pPr>
-            <a:r>
-              <a:rPr lang="en-US" sz="1000" b="1" dirty="0">
-                <a:solidFill>
-                  <a:schemeClr val="tx1"/>
-                </a:solidFill>
-              </a:rPr>
-              <a:t>Steps 1–2 on local test maze 25. </a:t>
-            </a:r>
-            <a:r>
-              <a:rPr lang="en-US" sz="1000" dirty="0">
-                <a:solidFill>
-                  <a:schemeClr val="tx2"/>
-                </a:solidFill>
-              </a:rPr>
-              <a:t>The three drives (blue, green, purple) and the 480 shortcut links the robot found (orange): 466 of them (97%) join photos in the same corridor.</a:t>
-            </a:r>
-            <a:endParaRPr lang="en-US" sz="1000" dirty="0"/>
-          </a:p>
-        </p:txBody>
-      </p:sp>
-      <p:pic>
-        <p:nvPicPr>
-          <p:cNvPr id="25" name="goal example 1" descr="Local maze 25: the goal photo it is given"/>
-          <p:cNvPicPr>
-            <a:picLocks noChangeAspect="1"/>
-          </p:cNvPicPr>
-          <p:nvPr/>
-        </p:nvPicPr>
-        <p:blipFill>
-          <a:blip r:embed="rId4"/>
-          <a:stretch>
-            <a:fillRect/>
-          </a:stretch>
-        </p:blipFill>
-        <p:spPr>
-          <a:xfrm>
-            <a:off x="8229600" y="4572000"/>
-            <a:ext cx="1677924" cy="1258443"/>
-          </a:xfrm>
-          <a:prstGeom prst="rect">
-            <a:avLst/>
-          </a:prstGeom>
-        </p:spPr>
-      </p:pic>
-      <p:pic>
-        <p:nvPicPr>
-          <p:cNvPr id="26" name="goal example 2" descr="Local maze 25: the exploration photo it picks as the goal"/>
-          <p:cNvPicPr>
-            <a:picLocks noChangeAspect="1"/>
-          </p:cNvPicPr>
-          <p:nvPr/>
-        </p:nvPicPr>
-        <p:blipFill>
-          <a:blip r:embed="rId5"/>
-          <a:stretch>
-            <a:fillRect/>
-          </a:stretch>
-        </p:blipFill>
-        <p:spPr>
-          <a:xfrm>
             <a:off x="9980676" y="4572000"/>
             <a:ext cx="1677924" cy="1258443"/>
           </a:xfrm>
@@ -3282,7 +3676,7 @@
       </p:pic>
       <p:sp>
         <p:nvSpPr>
-          <p:cNvPr id="27" name="goal example caption"/>
+          <p:cNvPr id="28" name="goal example caption"/>
           <p:cNvSpPr txBox="1"/>
           <p:nvPr/>
         </p:nvSpPr>
@@ -3301,7 +3695,7 @@
           <a:bodyPr wrap="square" lIns="0" tIns="0" rIns="0" bIns="0" rtlCol="0" anchor="t"/>
           <a:lstStyle/>
           <a:p>
-            <a:pPr marL="0" indent="0">
+            <a:pPr indent="0" marL="0">
               <a:buNone/>
             </a:pPr>
             <a:r>
@@ -3312,6 +3706,9 @@
               </a:rPr>
               <a:t>Step 4. </a:t>
             </a:r>
+            <a:pPr indent="0" marL="0">
+              <a:buNone/>
+            </a:pPr>
             <a:r>
               <a:rPr lang="en-US" sz="1000" dirty="0">
                 <a:solidFill>
@@ -3326,7 +3723,7 @@
       </p:sp>
       <p:sp>
         <p:nvSpPr>
-          <p:cNvPr id="28" name="Slide Number Placeholder 0"/>
+          <p:cNvPr id="25" name="Slide Number Placeholder 0"/>
           <p:cNvSpPr>
             <a:spLocks noGrp="1"/>
           </p:cNvSpPr>
@@ -3344,7 +3741,7 @@
           </a:prstGeom>
           <a:extLst>
             <a:ext uri="{C572A759-6A51-4108-AA02-DFA0A04FC94B}">
-              <ma14:wrappingTextBoxFlag xmlns:ma14="http://schemas.microsoft.com/office/mac/drawingml/2011/main" xmlns="" val="0"/>
+              <ma14:wrappingTextBoxFlag xmlns:ma14="http://schemas.microsoft.com/office/mac/drawingml/2011/main" val="0"/>
             </a:ext>
           </a:extLst>
         </p:spPr>
@@ -3362,7 +3759,7 @@
           <a:p>
             <a:pPr algn="r"/>
             <a:fld id="{F7021451-1387-4CA6-816F-3879F97B5CBC}" type="slidenum">
-              <a:rPr lang="en-US" b="0"/>
+              <a:rPr b="0" lang="en-US"/>
               <a:t>3</a:t>
             </a:fld>
             <a:endParaRPr lang="en-US"/>
@@ -3415,11 +3812,11 @@
           <a:bodyPr wrap="square" lIns="0" tIns="0" rIns="0" bIns="0" rtlCol="0" anchor="ctr"/>
           <a:lstStyle/>
           <a:p>
-            <a:pPr marL="0" indent="0">
-              <a:buNone/>
-            </a:pPr>
-            <a:r>
-              <a:rPr lang="en-US" sz="1100" b="1" kern="0" spc="200" dirty="0">
+            <a:pPr indent="0" marL="0">
+              <a:buNone/>
+            </a:pPr>
+            <a:r>
+              <a:rPr lang="en-US" sz="1100" b="1" spc="200" kern="0" dirty="0">
                 <a:solidFill>
                   <a:schemeClr val="accent2"/>
                 </a:solidFill>
@@ -3433,11 +3830,9 @@
       <p:sp>
         <p:nvSpPr>
           <p:cNvPr id="3" name="Text 0"/>
-          <p:cNvSpPr>
-            <a:spLocks noGrp="1"/>
-          </p:cNvSpPr>
+          <p:cNvSpPr/>
           <p:nvPr>
-            <p:ph type="title" idx="100" hasCustomPrompt="1"/>
+            <p:ph idx="100" type="title" hasCustomPrompt="1"/>
           </p:nvPr>
         </p:nvSpPr>
         <p:spPr>
@@ -3455,7 +3850,7 @@
           <a:bodyPr wrap="square" lIns="0" tIns="0" rIns="0" bIns="0" rtlCol="0" anchor="ctr"/>
           <a:lstStyle/>
           <a:p>
-            <a:pPr marL="0" indent="0" algn="l">
+            <a:pPr algn="l" indent="0" marL="0">
               <a:buNone/>
             </a:pPr>
             <a:r>
@@ -3518,7 +3913,7 @@
           <a:bodyPr wrap="square" lIns="0" tIns="0" rIns="0" bIns="0" rtlCol="0" anchor="ctr"/>
           <a:lstStyle/>
           <a:p>
-            <a:pPr marL="0" indent="0">
+            <a:pPr indent="0" marL="0">
               <a:buNone/>
             </a:pPr>
             <a:r>
@@ -3579,7 +3974,7 @@
           <a:bodyPr wrap="square" lIns="0" tIns="0" rIns="0" bIns="0" rtlCol="0" anchor="ctr"/>
           <a:lstStyle/>
           <a:p>
-            <a:pPr marL="0" indent="0" algn="ctr">
+            <a:pPr algn="ctr" indent="0" marL="0">
               <a:buNone/>
             </a:pPr>
             <a:r>
@@ -3615,7 +4010,7 @@
           <a:bodyPr wrap="square" lIns="0" tIns="0" rIns="0" bIns="0" rtlCol="0" anchor="t"/>
           <a:lstStyle/>
           <a:p>
-            <a:pPr marL="0" indent="0">
+            <a:pPr indent="0" marL="0">
               <a:buNone/>
             </a:pPr>
             <a:r>
@@ -3626,13 +4021,27 @@
               </a:rPr>
               <a:t>Where am I? </a:t>
             </a:r>
+            <a:pPr indent="0" marL="0">
+              <a:buNone/>
+            </a:pPr>
+            <a:r>
+              <a:rPr lang="en-US" sz="1300" i="1" dirty="0">
+                <a:solidFill>
+                  <a:schemeClr val="accent2"/>
+                </a:solidFill>
+              </a:rPr>
+              <a:t>(SPTM localisation; AnyLoc replaces SPTM’s R network). </a:t>
+            </a:r>
+            <a:pPr indent="0" marL="0">
+              <a:buNone/>
+            </a:pPr>
             <a:r>
               <a:rPr lang="en-US" sz="1300" dirty="0">
                 <a:solidFill>
                   <a:schemeClr val="tx2"/>
                 </a:solidFill>
               </a:rPr>
-              <a:t>It compares the camera image with the exploration photos near its last position (AnyLoc). A jump to a far part of the map is believed only if 3 images in a row agree and SuperGlue confirms the match.</a:t>
+              <a:t>It finds the exploration photo that looks most like the camera image, searching near its last position first. A jump to a far part of the map needs 3 images in a row that agree and a SuperGlue check.</a:t>
             </a:r>
             <a:endParaRPr lang="en-US" sz="1300" dirty="0"/>
           </a:p>
@@ -3684,7 +4093,7 @@
           <a:bodyPr wrap="square" lIns="0" tIns="0" rIns="0" bIns="0" rtlCol="0" anchor="ctr"/>
           <a:lstStyle/>
           <a:p>
-            <a:pPr marL="0" indent="0" algn="ctr">
+            <a:pPr algn="ctr" indent="0" marL="0">
               <a:buNone/>
             </a:pPr>
             <a:r>
@@ -3708,7 +4117,7 @@
         <p:spPr>
           <a:xfrm>
             <a:off x="978408" y="2624328"/>
-            <a:ext cx="6885432" cy="252984"/>
+            <a:ext cx="6885432" cy="451104"/>
           </a:xfrm>
           <a:prstGeom prst="rect">
             <a:avLst/>
@@ -3720,7 +4129,7 @@
           <a:bodyPr wrap="square" lIns="0" tIns="0" rIns="0" bIns="0" rtlCol="0" anchor="t"/>
           <a:lstStyle/>
           <a:p>
-            <a:pPr marL="0" indent="0">
+            <a:pPr indent="0" marL="0">
               <a:buNone/>
             </a:pPr>
             <a:r>
@@ -3731,13 +4140,27 @@
               </a:rPr>
               <a:t>Where next? </a:t>
             </a:r>
+            <a:pPr indent="0" marL="0">
+              <a:buNone/>
+            </a:pPr>
+            <a:r>
+              <a:rPr lang="en-US" sz="1300" i="1" dirty="0">
+                <a:solidFill>
+                  <a:schemeClr val="accent2"/>
+                </a:solidFill>
+              </a:rPr>
+              <a:t>(SPTM waypoint). </a:t>
+            </a:r>
+            <a:pPr indent="0" marL="0">
+              <a:buNone/>
+            </a:pPr>
             <a:r>
               <a:rPr lang="en-US" sz="1300" dirty="0">
                 <a:solidFill>
                   <a:schemeClr val="tx2"/>
                 </a:solidFill>
               </a:rPr>
-              <a:t>It looks up the route from that photo and picks a waypoint photo a few steps ahead.</a:t>
+              <a:t>It picks, as its waypoint, the furthest photo ahead on its route that still looks reachable from the current view.</a:t>
             </a:r>
             <a:endParaRPr lang="en-US" sz="1300" dirty="0"/>
           </a:p>
@@ -3751,7 +4174,7 @@
         </p:nvSpPr>
         <p:spPr>
           <a:xfrm>
-            <a:off x="548640" y="3014472"/>
+            <a:off x="548640" y="3212592"/>
             <a:ext cx="292608" cy="292608"/>
           </a:xfrm>
           <a:prstGeom prst="ellipse">
@@ -3776,7 +4199,7 @@
         </p:nvSpPr>
         <p:spPr>
           <a:xfrm>
-            <a:off x="548640" y="3014472"/>
+            <a:off x="548640" y="3212592"/>
             <a:ext cx="292608" cy="292608"/>
           </a:xfrm>
           <a:prstGeom prst="rect">
@@ -3789,7 +4212,7 @@
           <a:bodyPr wrap="square" lIns="0" tIns="0" rIns="0" bIns="0" rtlCol="0" anchor="ctr"/>
           <a:lstStyle/>
           <a:p>
-            <a:pPr marL="0" indent="0" algn="ctr">
+            <a:pPr algn="ctr" indent="0" marL="0">
               <a:buNone/>
             </a:pPr>
             <a:r>
@@ -3812,7 +4235,7 @@
         </p:nvSpPr>
         <p:spPr>
           <a:xfrm>
-            <a:off x="978408" y="2996184"/>
+            <a:off x="978408" y="3194304"/>
             <a:ext cx="6885432" cy="847344"/>
           </a:xfrm>
           <a:prstGeom prst="rect">
@@ -3825,7 +4248,7 @@
           <a:bodyPr wrap="square" lIns="0" tIns="0" rIns="0" bIns="0" rtlCol="0" anchor="t"/>
           <a:lstStyle/>
           <a:p>
-            <a:pPr marL="0" indent="0">
+            <a:pPr indent="0" marL="0">
               <a:buNone/>
             </a:pPr>
             <a:r>
@@ -3834,15 +4257,29 @@
                   <a:schemeClr val="tx1"/>
                 </a:solidFill>
               </a:rPr>
-              <a:t>Turn and drive. </a:t>
-            </a:r>
+              <a:t>Turn and drive </a:t>
+            </a:r>
+            <a:pPr indent="0" marL="0">
+              <a:buNone/>
+            </a:pPr>
+            <a:r>
+              <a:rPr lang="en-US" sz="1300" i="1" dirty="0">
+                <a:solidFill>
+                  <a:schemeClr val="accent2"/>
+                </a:solidFill>
+              </a:rPr>
+              <a:t>(measured turn added; SPTM’s L network as fallback). </a:t>
+            </a:r>
+            <a:pPr indent="0" marL="0">
+              <a:buNone/>
+            </a:pPr>
             <a:r>
               <a:rPr lang="en-US" sz="1300" dirty="0">
                 <a:solidFill>
                   <a:schemeClr val="tx2"/>
                 </a:solidFill>
               </a:rPr>
-              <a:t>SuperGlue matches the camera image with the waypoint photo, and the essential matrix between them gives the angle to turn. It turns by that angle, then drives forward. If the waypoint is not in view it turns on the spot to find it; if nothing matches, the L network picks the move.</a:t>
+              <a:t>SuperGlue matches the camera image with the waypoint photo and the essential matrix gives the angle; it turns by that angle, then drives forward. If the waypoint is out of view it turns to find it; if nothing matches, the L network picks the move.</a:t>
             </a:r>
             <a:endParaRPr lang="en-US" sz="1300" dirty="0"/>
           </a:p>
@@ -3856,7 +4293,7 @@
         </p:nvSpPr>
         <p:spPr>
           <a:xfrm>
-            <a:off x="548640" y="3980688"/>
+            <a:off x="548640" y="4178808"/>
             <a:ext cx="292608" cy="292608"/>
           </a:xfrm>
           <a:prstGeom prst="ellipse">
@@ -3881,7 +4318,7 @@
         </p:nvSpPr>
         <p:spPr>
           <a:xfrm>
-            <a:off x="548640" y="3980688"/>
+            <a:off x="548640" y="4178808"/>
             <a:ext cx="292608" cy="292608"/>
           </a:xfrm>
           <a:prstGeom prst="rect">
@@ -3894,7 +4331,7 @@
           <a:bodyPr wrap="square" lIns="0" tIns="0" rIns="0" bIns="0" rtlCol="0" anchor="ctr"/>
           <a:lstStyle/>
           <a:p>
-            <a:pPr marL="0" indent="0" algn="ctr">
+            <a:pPr algn="ctr" indent="0" marL="0">
               <a:buNone/>
             </a:pPr>
             <a:r>
@@ -3917,7 +4354,7 @@
         </p:nvSpPr>
         <p:spPr>
           <a:xfrm>
-            <a:off x="978408" y="3962400"/>
+            <a:off x="978408" y="4160520"/>
             <a:ext cx="6885432" cy="451104"/>
           </a:xfrm>
           <a:prstGeom prst="rect">
@@ -3930,7 +4367,7 @@
           <a:bodyPr wrap="square" lIns="0" tIns="0" rIns="0" bIns="0" rtlCol="0" anchor="t"/>
           <a:lstStyle/>
           <a:p>
-            <a:pPr marL="0" indent="0">
+            <a:pPr indent="0" marL="0">
               <a:buNone/>
             </a:pPr>
             <a:r>
@@ -3939,8 +4376,22 @@
                   <a:schemeClr val="tx1"/>
                 </a:solidFill>
               </a:rPr>
-              <a:t>Backing out. </a:t>
-            </a:r>
+              <a:t>Backing out </a:t>
+            </a:r>
+            <a:pPr indent="0" marL="0">
+              <a:buNone/>
+            </a:pPr>
+            <a:r>
+              <a:rPr lang="en-US" sz="1300" i="1" dirty="0">
+                <a:solidFill>
+                  <a:schemeClr val="accent2"/>
+                </a:solidFill>
+              </a:rPr>
+              <a:t>(added). </a:t>
+            </a:r>
+            <a:pPr indent="0" marL="0">
+              <a:buNone/>
+            </a:pPr>
             <a:r>
               <a:rPr lang="en-US" sz="1300" dirty="0">
                 <a:solidFill>
@@ -3961,7 +4412,7 @@
         </p:nvSpPr>
         <p:spPr>
           <a:xfrm>
-            <a:off x="548640" y="4550664"/>
+            <a:off x="548640" y="4748784"/>
             <a:ext cx="292608" cy="292608"/>
           </a:xfrm>
           <a:prstGeom prst="ellipse">
@@ -3986,7 +4437,7 @@
         </p:nvSpPr>
         <p:spPr>
           <a:xfrm>
-            <a:off x="548640" y="4550664"/>
+            <a:off x="548640" y="4748784"/>
             <a:ext cx="292608" cy="292608"/>
           </a:xfrm>
           <a:prstGeom prst="rect">
@@ -3999,7 +4450,7 @@
           <a:bodyPr wrap="square" lIns="0" tIns="0" rIns="0" bIns="0" rtlCol="0" anchor="ctr"/>
           <a:lstStyle/>
           <a:p>
-            <a:pPr marL="0" indent="0" algn="ctr">
+            <a:pPr algn="ctr" indent="0" marL="0">
               <a:buNone/>
             </a:pPr>
             <a:r>
@@ -4022,7 +4473,7 @@
         </p:nvSpPr>
         <p:spPr>
           <a:xfrm>
-            <a:off x="978408" y="4532376"/>
+            <a:off x="978408" y="4730496"/>
             <a:ext cx="6885432" cy="649224"/>
           </a:xfrm>
           <a:prstGeom prst="rect">
@@ -4035,7 +4486,7 @@
           <a:bodyPr wrap="square" lIns="0" tIns="0" rIns="0" bIns="0" rtlCol="0" anchor="t"/>
           <a:lstStyle/>
           <a:p>
-            <a:pPr marL="0" indent="0">
+            <a:pPr indent="0" marL="0">
               <a:buNone/>
             </a:pPr>
             <a:r>
@@ -4044,15 +4495,29 @@
                   <a:schemeClr val="tx1"/>
                 </a:solidFill>
               </a:rPr>
-              <a:t>When stuck. </a:t>
-            </a:r>
+              <a:t>When stuck </a:t>
+            </a:r>
+            <a:pPr indent="0" marL="0">
+              <a:buNone/>
+            </a:pPr>
+            <a:r>
+              <a:rPr lang="en-US" sz="1300" i="1" dirty="0">
+                <a:solidFill>
+                  <a:schemeClr val="accent2"/>
+                </a:solidFill>
+              </a:rPr>
+              <a:t>(added). </a:t>
+            </a:r>
+            <a:pPr indent="0" marL="0">
+              <a:buNone/>
+            </a:pPr>
             <a:r>
               <a:rPr lang="en-US" sz="1300" dirty="0">
                 <a:solidFill>
                   <a:schemeClr val="tx2"/>
                 </a:solidFill>
               </a:rPr>
-              <a:t>If it believes it is at the same photo for 3 moves, it checks the next 5 route photos with SuperGlue. If it gets no closer for 150 steps, that stretch of the route is made more expensive and the route is planned again.</a:t>
+              <a:t>If it seems stuck on one photo for 3 moves, it checks the next 5 route photos with SuperGlue; after 150 steps without getting closer, that stretch costs more and the route is planned again.</a:t>
             </a:r>
             <a:endParaRPr lang="en-US" sz="1300" dirty="0"/>
           </a:p>
@@ -4066,7 +4531,7 @@
         </p:nvSpPr>
         <p:spPr>
           <a:xfrm>
-            <a:off x="548640" y="5318760"/>
+            <a:off x="548640" y="5516880"/>
             <a:ext cx="292608" cy="292608"/>
           </a:xfrm>
           <a:prstGeom prst="ellipse">
@@ -4091,7 +4556,7 @@
         </p:nvSpPr>
         <p:spPr>
           <a:xfrm>
-            <a:off x="548640" y="5318760"/>
+            <a:off x="548640" y="5516880"/>
             <a:ext cx="292608" cy="292608"/>
           </a:xfrm>
           <a:prstGeom prst="rect">
@@ -4104,7 +4569,7 @@
           <a:bodyPr wrap="square" lIns="0" tIns="0" rIns="0" bIns="0" rtlCol="0" anchor="ctr"/>
           <a:lstStyle/>
           <a:p>
-            <a:pPr marL="0" indent="0" algn="ctr">
+            <a:pPr algn="ctr" indent="0" marL="0">
               <a:buNone/>
             </a:pPr>
             <a:r>
@@ -4127,7 +4592,7 @@
         </p:nvSpPr>
         <p:spPr>
           <a:xfrm>
-            <a:off x="978408" y="5300472"/>
+            <a:off x="978408" y="5498592"/>
             <a:ext cx="6885432" cy="847344"/>
           </a:xfrm>
           <a:prstGeom prst="rect">
@@ -4140,7 +4605,7 @@
           <a:bodyPr wrap="square" lIns="0" tIns="0" rIns="0" bIns="0" rtlCol="0" anchor="t"/>
           <a:lstStyle/>
           <a:p>
-            <a:pPr marL="0" indent="0">
+            <a:pPr indent="0" marL="0">
               <a:buNone/>
             </a:pPr>
             <a:r>
@@ -4149,15 +4614,29 @@
                   <a:schemeClr val="tx1"/>
                 </a:solidFill>
               </a:rPr>
-              <a:t>The last metre. </a:t>
-            </a:r>
+              <a:t>The last metre </a:t>
+            </a:r>
+            <a:pPr indent="0" marL="0">
+              <a:buNone/>
+            </a:pPr>
+            <a:r>
+              <a:rPr lang="en-US" sz="1300" i="1" dirty="0">
+                <a:solidFill>
+                  <a:schemeClr val="accent2"/>
+                </a:solidFill>
+              </a:rPr>
+              <a:t>(added). </a:t>
+            </a:r>
+            <a:pPr indent="0" marL="0">
+              <a:buNone/>
+            </a:pPr>
             <a:r>
               <a:rPr lang="en-US" sz="1300" dirty="0">
                 <a:solidFill>
                   <a:schemeClr val="tx2"/>
                 </a:solidFill>
               </a:rPr>
-              <a:t>Within 3 photos of the goal it matches the camera image with the 4 goal photos directly. It turns until the front photo lines up, moves until the scene looks the same size, and checks in only after 3 readings in a row with 35 or more matched points (in our tests, correct check-ins had 43–122 and wrong ones 21–25).</a:t>
+              <a:t>Within 3 photos of the goal it matches the camera image with the 4 goal photos, turns until the front photo lines up, moves until the scene looks the same size, and checks in after 3 readings in a row with 35+ matched points (correct check-ins had 43–122, wrong ones 21–25).</a:t>
             </a:r>
             <a:endParaRPr lang="en-US" sz="1300" dirty="0"/>
           </a:p>
@@ -4165,7 +4644,102 @@
       </p:sp>
       <p:pic>
         <p:nvPicPr>
-          <p:cNvPr id="24" name="turn example matches" descr="Two maze photos side by side with green lines joining 20 of the 73 keypoints SuperGlue matched between them"/>
+          <p:cNvPr id="24" name="turn example matches" descr="Two maze photos side by side with green lines joining 20 of the 73 keypoints SuperGlue matched between them">    </p:cNvPr>
+          <p:cNvPicPr>
+            <a:picLocks noChangeAspect="1"/>
+          </p:cNvPicPr>
+          <p:nvPr/>
+        </p:nvPicPr>
+        <p:blipFill>
+          <a:blip r:embed="rId1"/>
+          <a:stretch>
+            <a:fillRect/>
+          </a:stretch>
+        </p:blipFill>
+        <p:spPr>
+          <a:xfrm>
+            <a:off x="8092440" y="1417320"/>
+            <a:ext cx="3566160" cy="924357"/>
+          </a:xfrm>
+          <a:prstGeom prst="rect">
+            <a:avLst/>
+          </a:prstGeom>
+        </p:spPr>
+      </p:pic>
+      <p:sp>
+        <p:nvSpPr>
+          <p:cNvPr id="25" name="turn example caption"/>
+          <p:cNvSpPr txBox="1"/>
+          <p:nvPr/>
+        </p:nvSpPr>
+        <p:spPr>
+          <a:xfrm>
+            <a:off x="8092440" y="2414829"/>
+            <a:ext cx="3566160" cy="731520"/>
+          </a:xfrm>
+          <a:prstGeom prst="rect">
+            <a:avLst/>
+          </a:prstGeom>
+          <a:noFill/>
+          <a:ln/>
+        </p:spPr>
+        <p:txBody>
+          <a:bodyPr wrap="square" lIns="0" tIns="0" rIns="0" bIns="0" rtlCol="0" anchor="t"/>
+          <a:lstStyle/>
+          <a:p>
+            <a:pPr indent="0" marL="0">
+              <a:buNone/>
+            </a:pPr>
+            <a:r>
+              <a:rPr lang="en-US" sz="1050" b="1" dirty="0">
+                <a:solidFill>
+                  <a:schemeClr val="tx1"/>
+                </a:solidFill>
+              </a:rPr>
+              <a:t>Step 3, turn and drive. </a:t>
+            </a:r>
+            <a:pPr indent="0" marL="0">
+              <a:buNone/>
+            </a:pPr>
+            <a:r>
+              <a:rPr lang="en-US" sz="1050" dirty="0">
+                <a:solidFill>
+                  <a:schemeClr val="tx2"/>
+                </a:solidFill>
+              </a:rPr>
+              <a:t>SuperGlue matches between a camera image (left) and a waypoint photo three photos further on (right). The essential matrix from these 73 matches gives the turn between them: 37°.</a:t>
+            </a:r>
+            <a:endParaRPr lang="en-US" sz="1050" dirty="0"/>
+          </a:p>
+        </p:txBody>
+      </p:sp>
+      <p:pic>
+        <p:nvPicPr>
+          <p:cNvPr id="26" name="last metre goal photo" descr="The goal photo the robot was given (front view)">    </p:cNvPr>
+          <p:cNvPicPr>
+            <a:picLocks noChangeAspect="1"/>
+          </p:cNvPicPr>
+          <p:nvPr/>
+        </p:nvPicPr>
+        <p:blipFill>
+          <a:blip r:embed="rId2"/>
+          <a:stretch>
+            <a:fillRect/>
+          </a:stretch>
+        </p:blipFill>
+        <p:spPr>
+          <a:xfrm>
+            <a:off x="8092440" y="3393237"/>
+            <a:ext cx="1741932" cy="1306449"/>
+          </a:xfrm>
+          <a:prstGeom prst="rect">
+            <a:avLst/>
+          </a:prstGeom>
+        </p:spPr>
+      </p:pic>
+      <p:pic>
+        <p:nvPicPr>
+          <p:cNvPr id="27" name="last metre camera" descr="The robot’s camera image when it checked in, 2 cm from the goal">    </p:cNvPr>
           <p:cNvPicPr>
             <a:picLocks noChangeAspect="1"/>
           </p:cNvPicPr>
@@ -4179,98 +4753,6 @@
         </p:blipFill>
         <p:spPr>
           <a:xfrm>
-            <a:off x="8092440" y="1417320"/>
-            <a:ext cx="3566160" cy="924357"/>
-          </a:xfrm>
-          <a:prstGeom prst="rect">
-            <a:avLst/>
-          </a:prstGeom>
-        </p:spPr>
-      </p:pic>
-      <p:sp>
-        <p:nvSpPr>
-          <p:cNvPr id="25" name="turn example caption"/>
-          <p:cNvSpPr txBox="1"/>
-          <p:nvPr/>
-        </p:nvSpPr>
-        <p:spPr>
-          <a:xfrm>
-            <a:off x="8092440" y="2414829"/>
-            <a:ext cx="3566160" cy="731520"/>
-          </a:xfrm>
-          <a:prstGeom prst="rect">
-            <a:avLst/>
-          </a:prstGeom>
-          <a:noFill/>
-          <a:ln/>
-        </p:spPr>
-        <p:txBody>
-          <a:bodyPr wrap="square" lIns="0" tIns="0" rIns="0" bIns="0" rtlCol="0" anchor="t"/>
-          <a:lstStyle/>
-          <a:p>
-            <a:pPr marL="0" indent="0">
-              <a:buNone/>
-            </a:pPr>
-            <a:r>
-              <a:rPr lang="en-US" sz="1050" b="1" dirty="0">
-                <a:solidFill>
-                  <a:schemeClr val="tx1"/>
-                </a:solidFill>
-              </a:rPr>
-              <a:t>Step 3, turn and drive. </a:t>
-            </a:r>
-            <a:r>
-              <a:rPr lang="en-US" sz="1050" dirty="0">
-                <a:solidFill>
-                  <a:schemeClr val="tx2"/>
-                </a:solidFill>
-              </a:rPr>
-              <a:t>SuperGlue matches between the camera image (left) and the waypoint photo (right). The essential matrix from these 73 matches gives the turn: 37°.</a:t>
-            </a:r>
-            <a:endParaRPr lang="en-US" sz="1050" dirty="0"/>
-          </a:p>
-        </p:txBody>
-      </p:sp>
-      <p:pic>
-        <p:nvPicPr>
-          <p:cNvPr id="26" name="last metre goal photo" descr="The goal photo the robot was given (front view)"/>
-          <p:cNvPicPr>
-            <a:picLocks noChangeAspect="1"/>
-          </p:cNvPicPr>
-          <p:nvPr/>
-        </p:nvPicPr>
-        <p:blipFill>
-          <a:blip r:embed="rId4"/>
-          <a:stretch>
-            <a:fillRect/>
-          </a:stretch>
-        </p:blipFill>
-        <p:spPr>
-          <a:xfrm>
-            <a:off x="8092440" y="3393237"/>
-            <a:ext cx="1741932" cy="1306449"/>
-          </a:xfrm>
-          <a:prstGeom prst="rect">
-            <a:avLst/>
-          </a:prstGeom>
-        </p:spPr>
-      </p:pic>
-      <p:pic>
-        <p:nvPicPr>
-          <p:cNvPr id="27" name="last metre camera" descr="The robot’s camera image when it checked in, 2 cm from the goal"/>
-          <p:cNvPicPr>
-            <a:picLocks noChangeAspect="1"/>
-          </p:cNvPicPr>
-          <p:nvPr/>
-        </p:nvPicPr>
-        <p:blipFill>
-          <a:blip r:embed="rId5"/>
-          <a:stretch>
-            <a:fillRect/>
-          </a:stretch>
-        </p:blipFill>
-        <p:spPr>
-          <a:xfrm>
             <a:off x="9916668" y="3393237"/>
             <a:ext cx="1741932" cy="1306449"/>
           </a:xfrm>
@@ -4300,7 +4782,7 @@
           <a:bodyPr wrap="square" lIns="0" tIns="0" rIns="0" bIns="0" rtlCol="0" anchor="t"/>
           <a:lstStyle/>
           <a:p>
-            <a:pPr marL="0" indent="0">
+            <a:pPr indent="0" marL="0">
               <a:buNone/>
             </a:pPr>
             <a:r>
@@ -4311,6 +4793,9 @@
               </a:rPr>
               <a:t>Step 6, the last metre. </a:t>
             </a:r>
+            <a:pPr indent="0" marL="0">
+              <a:buNone/>
+            </a:pPr>
             <a:r>
               <a:rPr lang="en-US" sz="1050" dirty="0">
                 <a:solidFill>
@@ -4344,7 +4829,7 @@
           <a:bodyPr wrap="square" lIns="0" tIns="0" rIns="0" bIns="0" rtlCol="0" anchor="ctr"/>
           <a:lstStyle/>
           <a:p>
-            <a:pPr marL="0" indent="0">
+            <a:pPr indent="0" marL="0">
               <a:buNone/>
             </a:pPr>
             <a:r>
@@ -4361,7 +4846,7 @@
       </p:sp>
       <p:sp>
         <p:nvSpPr>
-          <p:cNvPr id="30" name="Slide Number Placeholder 0"/>
+          <p:cNvPr id="25" name="Slide Number Placeholder 0"/>
           <p:cNvSpPr>
             <a:spLocks noGrp="1"/>
           </p:cNvSpPr>
@@ -4379,7 +4864,7 @@
           </a:prstGeom>
           <a:extLst>
             <a:ext uri="{C572A759-6A51-4108-AA02-DFA0A04FC94B}">
-              <ma14:wrappingTextBoxFlag xmlns:ma14="http://schemas.microsoft.com/office/mac/drawingml/2011/main" xmlns="" val="0"/>
+              <ma14:wrappingTextBoxFlag xmlns:ma14="http://schemas.microsoft.com/office/mac/drawingml/2011/main" val="0"/>
             </a:ext>
           </a:extLst>
         </p:spPr>
@@ -4397,7 +4882,7 @@
           <a:p>
             <a:pPr algn="r"/>
             <a:fld id="{F7021451-1387-4CA6-816F-3879F97B5CBC}" type="slidenum">
-              <a:rPr lang="en-US" b="0"/>
+              <a:rPr b="0" lang="en-US"/>
               <a:t>4</a:t>
             </a:fld>
             <a:endParaRPr lang="en-US"/>
@@ -4705,299 +5190,4 @@
     </a:ext>
   </a:extLst>
 </a:theme>
-</file>
-
-<file path=ppt/theme/theme2.xml><?xml version="1.0" encoding="utf-8"?>
-<a:theme xmlns:a="http://schemas.openxmlformats.org/drawingml/2006/main" name="Office Theme">
-  <a:themeElements>
-    <a:clrScheme name="Office">
-      <a:dk1>
-        <a:sysClr val="windowText" lastClr="000000"/>
-      </a:dk1>
-      <a:lt1>
-        <a:sysClr val="window" lastClr="FFFFFF"/>
-      </a:lt1>
-      <a:dk2>
-        <a:srgbClr val="44546A"/>
-      </a:dk2>
-      <a:lt2>
-        <a:srgbClr val="E7E6E6"/>
-      </a:lt2>
-      <a:accent1>
-        <a:srgbClr val="4472C4"/>
-      </a:accent1>
-      <a:accent2>
-        <a:srgbClr val="ED7D31"/>
-      </a:accent2>
-      <a:accent3>
-        <a:srgbClr val="A5A5A5"/>
-      </a:accent3>
-      <a:accent4>
-        <a:srgbClr val="FFC000"/>
-      </a:accent4>
-      <a:accent5>
-        <a:srgbClr val="5B9BD5"/>
-      </a:accent5>
-      <a:accent6>
-        <a:srgbClr val="70AD47"/>
-      </a:accent6>
-      <a:hlink>
-        <a:srgbClr val="0563C1"/>
-      </a:hlink>
-      <a:folHlink>
-        <a:srgbClr val="954F72"/>
-      </a:folHlink>
-    </a:clrScheme>
-    <a:fontScheme name="Office">
-      <a:majorFont>
-        <a:latin typeface="Calibri Light" panose="020F0302020204030204"/>
-        <a:ea typeface=""/>
-        <a:cs typeface=""/>
-        <a:font script="Jpan" typeface="游ゴシック Light"/>
-        <a:font script="Hang" typeface="맑은 고딕"/>
-        <a:font script="Hans" typeface="等线 Light"/>
-        <a:font script="Hant" typeface="新細明體"/>
-        <a:font script="Arab" typeface="Times New Roman"/>
-        <a:font script="Hebr" typeface="Times New Roman"/>
-        <a:font script="Thai" typeface="Angsana New"/>
-        <a:font script="Ethi" typeface="Nyala"/>
-        <a:font script="Beng" typeface="Vrinda"/>
-        <a:font script="Gujr" typeface="Shruti"/>
-        <a:font script="Khmr" typeface="MoolBoran"/>
-        <a:font script="Knda" typeface="Tunga"/>
-        <a:font script="Guru" typeface="Raavi"/>
-        <a:font script="Cans" typeface="Euphemia"/>
-        <a:font script="Cher" typeface="Plantagenet Cherokee"/>
-        <a:font script="Yiii" typeface="Microsoft Yi Baiti"/>
-        <a:font script="Tibt" typeface="Microsoft Himalaya"/>
-        <a:font script="Thaa" typeface="MV Boli"/>
-        <a:font script="Deva" typeface="Mangal"/>
-        <a:font script="Telu" typeface="Gautami"/>
-        <a:font script="Taml" typeface="Latha"/>
-        <a:font script="Syrc" typeface="Estrangelo Edessa"/>
-        <a:font script="Orya" typeface="Kalinga"/>
-        <a:font script="Mlym" typeface="Kartika"/>
-        <a:font script="Laoo" typeface="DokChampa"/>
-        <a:font script="Sinh" typeface="Iskoola Pota"/>
-        <a:font script="Mong" typeface="Mongolian Baiti"/>
-        <a:font script="Viet" typeface="Times New Roman"/>
-        <a:font script="Uigh" typeface="Microsoft Uighur"/>
-        <a:font script="Geor" typeface="Sylfaen"/>
-        <a:font script="Armn" typeface="Arial"/>
-        <a:font script="Bugi" typeface="Leelawadee UI"/>
-        <a:font script="Bopo" typeface="Microsoft JhengHei"/>
-        <a:font script="Java" typeface="Javanese Text"/>
-        <a:font script="Lisu" typeface="Segoe UI"/>
-        <a:font script="Mymr" typeface="Myanmar Text"/>
-        <a:font script="Nkoo" typeface="Ebrima"/>
-        <a:font script="Olck" typeface="Nirmala UI"/>
-        <a:font script="Osma" typeface="Ebrima"/>
-        <a:font script="Phag" typeface="Phagspa"/>
-        <a:font script="Syrn" typeface="Estrangelo Edessa"/>
-        <a:font script="Syrj" typeface="Estrangelo Edessa"/>
-        <a:font script="Syre" typeface="Estrangelo Edessa"/>
-        <a:font script="Sora" typeface="Nirmala UI"/>
-        <a:font script="Tale" typeface="Microsoft Tai Le"/>
-        <a:font script="Talu" typeface="Microsoft New Tai Lue"/>
-        <a:font script="Tfng" typeface="Ebrima"/>
-      </a:majorFont>
-      <a:minorFont>
-        <a:latin typeface="Calibri" panose="020F0502020204030204"/>
-        <a:ea typeface=""/>
-        <a:cs typeface=""/>
-        <a:font script="Jpan" typeface="游ゴシック"/>
-        <a:font script="Hang" typeface="맑은 고딕"/>
-        <a:font script="Hans" typeface="等线"/>
-        <a:font script="Hant" typeface="新細明體"/>
-        <a:font script="Arab" typeface="Arial"/>
-        <a:font script="Hebr" typeface="Arial"/>
-        <a:font script="Thai" typeface="Cordia New"/>
-        <a:font script="Ethi" typeface="Nyala"/>
-        <a:font script="Beng" typeface="Vrinda"/>
-        <a:font script="Gujr" typeface="Shruti"/>
-        <a:font script="Khmr" typeface="DaunPenh"/>
-        <a:font script="Knda" typeface="Tunga"/>
-        <a:font script="Guru" typeface="Raavi"/>
-        <a:font script="Cans" typeface="Euphemia"/>
-        <a:font script="Cher" typeface="Plantagenet Cherokee"/>
-        <a:font script="Yiii" typeface="Microsoft Yi Baiti"/>
-        <a:font script="Tibt" typeface="Microsoft Himalaya"/>
-        <a:font script="Thaa" typeface="MV Boli"/>
-        <a:font script="Deva" typeface="Mangal"/>
-        <a:font script="Telu" typeface="Gautami"/>
-        <a:font script="Taml" typeface="Latha"/>
-        <a:font script="Syrc" typeface="Estrangelo Edessa"/>
-        <a:font script="Orya" typeface="Kalinga"/>
-        <a:font script="Mlym" typeface="Kartika"/>
-        <a:font script="Laoo" typeface="DokChampa"/>
-        <a:font script="Sinh" typeface="Iskoola Pota"/>
-        <a:font script="Mong" typeface="Mongolian Baiti"/>
-        <a:font script="Viet" typeface="Arial"/>
-        <a:font script="Uigh" typeface="Microsoft Uighur"/>
-        <a:font script="Geor" typeface="Sylfaen"/>
-        <a:font script="Armn" typeface="Arial"/>
-        <a:font script="Bugi" typeface="Leelawadee UI"/>
-        <a:font script="Bopo" typeface="Microsoft JhengHei"/>
-        <a:font script="Java" typeface="Javanese Text"/>
-        <a:font script="Lisu" typeface="Segoe UI"/>
-        <a:font script="Mymr" typeface="Myanmar Text"/>
-        <a:font script="Nkoo" typeface="Ebrima"/>
-        <a:font script="Olck" typeface="Nirmala UI"/>
-        <a:font script="Osma" typeface="Ebrima"/>
-        <a:font script="Phag" typeface="Phagspa"/>
-        <a:font script="Syrn" typeface="Estrangelo Edessa"/>
-        <a:font script="Syrj" typeface="Estrangelo Edessa"/>
-        <a:font script="Syre" typeface="Estrangelo Edessa"/>
-        <a:font script="Sora" typeface="Nirmala UI"/>
-        <a:font script="Tale" typeface="Microsoft Tai Le"/>
-        <a:font script="Talu" typeface="Microsoft New Tai Lue"/>
-        <a:font script="Tfng" typeface="Ebrima"/>
-      </a:minorFont>
-    </a:fontScheme>
-    <a:fmtScheme name="Office">
-      <a:fillStyleLst>
-        <a:solidFill>
-          <a:schemeClr val="phClr"/>
-        </a:solidFill>
-        <a:gradFill rotWithShape="1">
-          <a:gsLst>
-            <a:gs pos="0">
-              <a:schemeClr val="phClr">
-                <a:lumMod val="110000"/>
-                <a:satMod val="105000"/>
-                <a:tint val="67000"/>
-              </a:schemeClr>
-            </a:gs>
-            <a:gs pos="50000">
-              <a:schemeClr val="phClr">
-                <a:lumMod val="105000"/>
-                <a:satMod val="103000"/>
-                <a:tint val="73000"/>
-              </a:schemeClr>
-            </a:gs>
-            <a:gs pos="100000">
-              <a:schemeClr val="phClr">
-                <a:lumMod val="105000"/>
-                <a:satMod val="109000"/>
-                <a:tint val="81000"/>
-              </a:schemeClr>
-            </a:gs>
-          </a:gsLst>
-          <a:lin ang="5400000" scaled="0"/>
-        </a:gradFill>
-        <a:gradFill rotWithShape="1">
-          <a:gsLst>
-            <a:gs pos="0">
-              <a:schemeClr val="phClr">
-                <a:satMod val="103000"/>
-                <a:lumMod val="102000"/>
-                <a:tint val="94000"/>
-              </a:schemeClr>
-            </a:gs>
-            <a:gs pos="50000">
-              <a:schemeClr val="phClr">
-                <a:satMod val="110000"/>
-                <a:lumMod val="100000"/>
-                <a:shade val="100000"/>
-              </a:schemeClr>
-            </a:gs>
-            <a:gs pos="100000">
-              <a:schemeClr val="phClr">
-                <a:lumMod val="99000"/>
-                <a:satMod val="120000"/>
-                <a:shade val="78000"/>
-              </a:schemeClr>
-            </a:gs>
-          </a:gsLst>
-          <a:lin ang="5400000" scaled="0"/>
-        </a:gradFill>
-      </a:fillStyleLst>
-      <a:lnStyleLst>
-        <a:ln w="6350" cap="flat" cmpd="sng" algn="ctr">
-          <a:solidFill>
-            <a:schemeClr val="phClr"/>
-          </a:solidFill>
-          <a:prstDash val="solid"/>
-          <a:miter lim="800000"/>
-        </a:ln>
-        <a:ln w="12700" cap="flat" cmpd="sng" algn="ctr">
-          <a:solidFill>
-            <a:schemeClr val="phClr"/>
-          </a:solidFill>
-          <a:prstDash val="solid"/>
-          <a:miter lim="800000"/>
-        </a:ln>
-        <a:ln w="19050" cap="flat" cmpd="sng" algn="ctr">
-          <a:solidFill>
-            <a:schemeClr val="phClr"/>
-          </a:solidFill>
-          <a:prstDash val="solid"/>
-          <a:miter lim="800000"/>
-        </a:ln>
-      </a:lnStyleLst>
-      <a:effectStyleLst>
-        <a:effectStyle>
-          <a:effectLst/>
-        </a:effectStyle>
-        <a:effectStyle>
-          <a:effectLst/>
-        </a:effectStyle>
-        <a:effectStyle>
-          <a:effectLst>
-            <a:outerShdw blurRad="57150" dist="19050" dir="5400000" algn="ctr" rotWithShape="0">
-              <a:srgbClr val="000000">
-                <a:alpha val="63000"/>
-              </a:srgbClr>
-            </a:outerShdw>
-          </a:effectLst>
-        </a:effectStyle>
-      </a:effectStyleLst>
-      <a:bgFillStyleLst>
-        <a:solidFill>
-          <a:schemeClr val="phClr"/>
-        </a:solidFill>
-        <a:solidFill>
-          <a:schemeClr val="phClr">
-            <a:tint val="95000"/>
-            <a:satMod val="170000"/>
-          </a:schemeClr>
-        </a:solidFill>
-        <a:gradFill rotWithShape="1">
-          <a:gsLst>
-            <a:gs pos="0">
-              <a:schemeClr val="phClr">
-                <a:tint val="93000"/>
-                <a:satMod val="150000"/>
-                <a:shade val="98000"/>
-                <a:lumMod val="102000"/>
-              </a:schemeClr>
-            </a:gs>
-            <a:gs pos="50000">
-              <a:schemeClr val="phClr">
-                <a:tint val="98000"/>
-                <a:satMod val="130000"/>
-                <a:shade val="90000"/>
-                <a:lumMod val="103000"/>
-              </a:schemeClr>
-            </a:gs>
-            <a:gs pos="100000">
-              <a:schemeClr val="phClr">
-                <a:shade val="63000"/>
-                <a:satMod val="120000"/>
-              </a:schemeClr>
-            </a:gs>
-          </a:gsLst>
-          <a:lin ang="5400000" scaled="0"/>
-        </a:gradFill>
-      </a:bgFillStyleLst>
-    </a:fmtScheme>
-  </a:themeElements>
-  <a:objectDefaults/>
-  <a:extraClrSchemeLst/>
-  <a:extLst>
-    <a:ext uri="{05A4C25C-085E-4340-85A3-A5531E510DB2}">
-      <thm15:themeFamily xmlns:thm15="http://schemas.microsoft.com/office/thememl/2012/main" name="Office Theme" id="{62F939B6-93AF-4DB8-9C6B-D6C7DFDC589F}" vid="{4A3C46E8-61CC-4603-A589-7422A47A8E4A}"/>
-    </a:ext>
-  </a:extLst>
-</a:theme>
 </file>
</xml_diff>